<commit_message>
Update the quick reference rule about CE numbers
Co-Authored-By: Claude Opus 5 <noreply@anthropic.com>
</commit_message>
<xml_diff>
--- a/docs/SHIC-Cost-Estimator-User-Manual.pptx
+++ b/docs/SHIC-Cost-Estimator-User-Manual.pptx
@@ -20171,6 +20171,643 @@
 </file>
 
 <file path=ppt/slides/slide23.xml><?xml version="1.0" encoding="utf-8"?>
+<p:sld xmlns:a="http://schemas.openxmlformats.org/drawingml/2006/main" xmlns:p="http://schemas.openxmlformats.org/presentationml/2006/main" xmlns:r="http://schemas.openxmlformats.org/officeDocument/2006/relationships">
+  <p:cSld>
+    <p:bg>
+      <p:bgPr>
+        <a:solidFill>
+          <a:srgbClr val="0D1117"/>
+        </a:solidFill>
+      </p:bgPr>
+    </p:bg>
+    <p:spTree>
+      <p:nvGrpSpPr>
+        <p:cNvPr id="1" name=""/>
+        <p:cNvGrpSpPr/>
+        <p:nvPr/>
+      </p:nvGrpSpPr>
+      <p:grpSpPr/>
+      <p:sp>
+        <p:nvSpPr>
+          <p:cNvPr id="2" name="Text 0"/>
+          <p:cNvSpPr/>
+          <p:nvPr/>
+        </p:nvSpPr>
+        <p:spPr>
+          <a:xfrm>
+            <a:off x="566928" y="384048"/>
+            <a:ext cx="8229600" cy="256032"/>
+          </a:xfrm>
+          <a:prstGeom prst="rect">
+            <a:avLst/>
+          </a:prstGeom>
+          <a:noFill/>
+          <a:ln/>
+        </p:spPr>
+        <p:txBody>
+          <a:bodyPr wrap="square" lIns="0" tIns="0" rIns="0" bIns="0" rtlCol="0" anchor="ctr"/>
+          <a:lstStyle/>
+          <a:p>
+            <a:pPr indent="0" marL="0">
+              <a:buNone/>
+            </a:pPr>
+            <a:r>
+              <a:rPr lang="en-US" sz="1100" b="1" spc="200" kern="0" dirty="0">
+                <a:solidFill>
+                  <a:srgbClr val="F0A429"/>
+                </a:solidFill>
+                <a:latin typeface="Arial" pitchFamily="34" charset="0"/>
+                <a:ea typeface="Arial" pitchFamily="34" charset="-122"/>
+                <a:cs typeface="Arial" pitchFamily="34" charset="-120"/>
+              </a:rPr>
+              <a:t>CE MONITORING · REQUESTS</a:t>
+            </a:r>
+            <a:endParaRPr lang="en-US" sz="1100" dirty="0"/>
+          </a:p>
+        </p:txBody>
+      </p:sp>
+      <p:sp>
+        <p:nvSpPr>
+          <p:cNvPr id="3" name="Text 1"/>
+          <p:cNvSpPr/>
+          <p:nvPr/>
+        </p:nvSpPr>
+        <p:spPr>
+          <a:xfrm>
+            <a:off x="566928" y="694944"/>
+            <a:ext cx="11055096" cy="566928"/>
+          </a:xfrm>
+          <a:prstGeom prst="rect">
+            <a:avLst/>
+          </a:prstGeom>
+          <a:noFill/>
+          <a:ln/>
+        </p:spPr>
+        <p:txBody>
+          <a:bodyPr wrap="square" lIns="0" tIns="0" rIns="0" bIns="0" rtlCol="0" anchor="ctr"/>
+          <a:lstStyle/>
+          <a:p>
+            <a:pPr indent="0" marL="0">
+              <a:buNone/>
+            </a:pPr>
+            <a:r>
+              <a:rPr lang="en-US" sz="3200" b="1" dirty="0">
+                <a:solidFill>
+                  <a:srgbClr val="E6EDF3"/>
+                </a:solidFill>
+                <a:latin typeface="Arial" pitchFamily="34" charset="0"/>
+                <a:ea typeface="Arial" pitchFamily="34" charset="-122"/>
+                <a:cs typeface="Arial" pitchFamily="34" charset="-120"/>
+              </a:rPr>
+              <a:t>Log it, assign it, attach it</a:t>
+            </a:r>
+            <a:endParaRPr lang="en-US" sz="3200" dirty="0"/>
+          </a:p>
+        </p:txBody>
+      </p:sp>
+      <p:sp>
+        <p:nvSpPr>
+          <p:cNvPr id="4" name="Text 2"/>
+          <p:cNvSpPr/>
+          <p:nvPr/>
+        </p:nvSpPr>
+        <p:spPr>
+          <a:xfrm>
+            <a:off x="566928" y="1298448"/>
+            <a:ext cx="10972800" cy="365760"/>
+          </a:xfrm>
+          <a:prstGeom prst="rect">
+            <a:avLst/>
+          </a:prstGeom>
+          <a:noFill/>
+          <a:ln/>
+        </p:spPr>
+        <p:txBody>
+          <a:bodyPr wrap="square" lIns="0" tIns="0" rIns="0" bIns="0" rtlCol="0" anchor="t"/>
+          <a:lstStyle/>
+          <a:p>
+            <a:pPr algn="l" indent="0" marL="0">
+              <a:lnSpc>
+                <a:spcPts val="2000"/>
+              </a:lnSpc>
+              <a:buNone/>
+            </a:pPr>
+            <a:r>
+              <a:rPr lang="en-US" sz="1400" dirty="0">
+                <a:solidFill>
+                  <a:srgbClr val="9AA4AF"/>
+                </a:solidFill>
+                <a:latin typeface="Calibri" pitchFamily="34" charset="0"/>
+                <a:ea typeface="Calibri" pitchFamily="34" charset="-122"/>
+                <a:cs typeface="Calibri" pitchFamily="34" charset="-120"/>
+              </a:rPr>
+              <a:t>A request goes on the list the day it arrives, so nothing is forgotten between receiving it and costing it.</a:t>
+            </a:r>
+            <a:endParaRPr lang="en-US" sz="1400" dirty="0"/>
+          </a:p>
+        </p:txBody>
+      </p:sp>
+      <p:sp>
+        <p:nvSpPr>
+          <p:cNvPr id="5" name="Shape 3"/>
+          <p:cNvSpPr/>
+          <p:nvPr/>
+        </p:nvSpPr>
+        <p:spPr>
+          <a:xfrm>
+            <a:off x="566928" y="1911096"/>
+            <a:ext cx="5532120" cy="3566160"/>
+          </a:xfrm>
+          <a:prstGeom prst="roundRect">
+            <a:avLst>
+              <a:gd name="adj" fmla="val 2051"/>
+            </a:avLst>
+          </a:prstGeom>
+          <a:solidFill>
+            <a:srgbClr val="1C2128"/>
+          </a:solidFill>
+          <a:ln w="12700">
+            <a:solidFill>
+              <a:srgbClr val="30363D"/>
+            </a:solidFill>
+            <a:prstDash val="solid"/>
+          </a:ln>
+          <a:effectLst>
+            <a:outerShdw sx="100000" sy="100000" kx="0" ky="0" algn="bl" rotWithShape="0" blurRad="152400" dist="38100" dir="5400000">
+              <a:srgbClr val="000000">
+                <a:alpha val="45000"/>
+              </a:srgbClr>
+            </a:outerShdw>
+          </a:effectLst>
+        </p:spPr>
+        <p:txBody>
+          <a:bodyPr/>
+          <a:p/>
+        </p:txBody>
+      </p:sp>
+      <p:sp>
+        <p:nvSpPr>
+          <p:cNvPr id="6" name="Text 4"/>
+          <p:cNvSpPr/>
+          <p:nvPr/>
+        </p:nvSpPr>
+        <p:spPr>
+          <a:xfrm>
+            <a:off x="841248" y="2121408"/>
+            <a:ext cx="4937760" cy="329184"/>
+          </a:xfrm>
+          <a:prstGeom prst="rect">
+            <a:avLst/>
+          </a:prstGeom>
+          <a:noFill/>
+          <a:ln/>
+        </p:spPr>
+        <p:txBody>
+          <a:bodyPr wrap="square" lIns="0" tIns="0" rIns="0" bIns="0" rtlCol="0" anchor="ctr"/>
+          <a:lstStyle/>
+          <a:p>
+            <a:pPr indent="0" marL="0">
+              <a:buNone/>
+            </a:pPr>
+            <a:r>
+              <a:rPr lang="en-US" sz="1700" b="1" dirty="0">
+                <a:solidFill>
+                  <a:srgbClr val="A78BFA"/>
+                </a:solidFill>
+                <a:latin typeface="Arial" pitchFamily="34" charset="0"/>
+                <a:ea typeface="Arial" pitchFamily="34" charset="-122"/>
+                <a:cs typeface="Arial" pitchFamily="34" charset="-120"/>
+              </a:rPr>
+              <a:t>Logging a request</a:t>
+            </a:r>
+            <a:endParaRPr lang="en-US" sz="1700" dirty="0"/>
+          </a:p>
+        </p:txBody>
+      </p:sp>
+      <p:sp>
+        <p:nvSpPr>
+          <p:cNvPr id="7" name="Text 5"/>
+          <p:cNvSpPr/>
+          <p:nvPr/>
+        </p:nvSpPr>
+        <p:spPr>
+          <a:xfrm>
+            <a:off x="841248" y="2578608"/>
+            <a:ext cx="4983480" cy="2651760"/>
+          </a:xfrm>
+          <a:prstGeom prst="rect">
+            <a:avLst/>
+          </a:prstGeom>
+          <a:noFill/>
+          <a:ln/>
+        </p:spPr>
+        <p:txBody>
+          <a:bodyPr wrap="square" lIns="0" tIns="0" rIns="0" bIns="0" rtlCol="0" anchor="t"/>
+          <a:lstStyle/>
+          <a:p>
+            <a:pPr marL="342900" indent="-342900">
+              <a:lnSpc>
+                <a:spcPts val="1600"/>
+              </a:lnSpc>
+              <a:spcAft>
+                <a:spcPts val="900"/>
+              </a:spcAft>
+              <a:buSzPct val="100000"/>
+              <a:buChar char="●"/>
+            </a:pPr>
+            <a:r>
+              <a:rPr lang="en-US" sz="1200" dirty="0">
+                <a:solidFill>
+                  <a:srgbClr val="E6EDF3"/>
+                </a:solidFill>
+                <a:latin typeface="Calibri" pitchFamily="34" charset="0"/>
+                <a:ea typeface="Calibri" pitchFamily="34" charset="-122"/>
+                <a:cs typeface="Calibri" pitchFamily="34" charset="-120"/>
+              </a:rPr>
+              <a:t>Press + New Request. The next free CE number is suggested</a:t>
+            </a:r>
+            <a:endParaRPr lang="en-US" sz="1200" dirty="0"/>
+          </a:p>
+          <a:p>
+            <a:pPr marL="342900" indent="-342900">
+              <a:lnSpc>
+                <a:spcPts val="1600"/>
+              </a:lnSpc>
+              <a:spcAft>
+                <a:spcPts val="900"/>
+              </a:spcAft>
+              <a:buSzPct val="100000"/>
+              <a:buChar char="●"/>
+            </a:pPr>
+            <a:r>
+              <a:rPr lang="en-US" sz="1200" dirty="0">
+                <a:solidFill>
+                  <a:srgbClr val="E6EDF3"/>
+                </a:solidFill>
+                <a:latin typeface="Calibri" pitchFamily="34" charset="0"/>
+                <a:ea typeface="Calibri" pitchFamily="34" charset="-122"/>
+                <a:cs typeface="Calibri" pitchFamily="34" charset="-120"/>
+              </a:rPr>
+              <a:t>Customer and Assigned to are required; add type, discipline, job title, date received, deadline and remarks</a:t>
+            </a:r>
+            <a:endParaRPr lang="en-US" sz="1200" dirty="0"/>
+          </a:p>
+          <a:p>
+            <a:pPr marL="342900" indent="-342900">
+              <a:lnSpc>
+                <a:spcPts val="1600"/>
+              </a:lnSpc>
+              <a:spcAft>
+                <a:spcPts val="900"/>
+              </a:spcAft>
+              <a:buSzPct val="100000"/>
+              <a:buChar char="●"/>
+            </a:pPr>
+            <a:r>
+              <a:rPr lang="en-US" sz="1200" dirty="0">
+                <a:solidFill>
+                  <a:srgbClr val="E6EDF3"/>
+                </a:solidFill>
+                <a:latin typeface="Calibri" pitchFamily="34" charset="0"/>
+                <a:ea typeface="Calibri" pitchFamily="34" charset="-122"/>
+                <a:cs typeface="Calibri" pitchFamily="34" charset="-120"/>
+              </a:rPr>
+              <a:t>The attachments panel opens next — upload the TOR, drawings and client email</a:t>
+            </a:r>
+            <a:endParaRPr lang="en-US" sz="1200" dirty="0"/>
+          </a:p>
+          <a:p>
+            <a:pPr marL="342900" indent="-342900">
+              <a:lnSpc>
+                <a:spcPts val="1600"/>
+              </a:lnSpc>
+              <a:spcAft>
+                <a:spcPts val="900"/>
+              </a:spcAft>
+              <a:buSzPct val="100000"/>
+              <a:buChar char="●"/>
+            </a:pPr>
+            <a:r>
+              <a:rPr lang="en-US" sz="1200" dirty="0">
+                <a:solidFill>
+                  <a:srgbClr val="E6EDF3"/>
+                </a:solidFill>
+                <a:latin typeface="Calibri" pitchFamily="34" charset="0"/>
+                <a:ea typeface="Calibri" pitchFamily="34" charset="-122"/>
+                <a:cs typeface="Calibri" pitchFamily="34" charset="-120"/>
+              </a:rPr>
+              <a:t>It shows as a Pending row badged REQUEST, with you as Received By</a:t>
+            </a:r>
+            <a:endParaRPr lang="en-US" sz="1200" dirty="0"/>
+          </a:p>
+          <a:p>
+            <a:pPr marL="342900" indent="-342900">
+              <a:lnSpc>
+                <a:spcPts val="1600"/>
+              </a:lnSpc>
+              <a:spcAft>
+                <a:spcPts val="900"/>
+              </a:spcAft>
+              <a:buSzPct val="100000"/>
+              <a:buChar char="●"/>
+            </a:pPr>
+            <a:r>
+              <a:rPr lang="en-US" sz="1200" dirty="0">
+                <a:solidFill>
+                  <a:srgbClr val="E6EDF3"/>
+                </a:solidFill>
+                <a:latin typeface="Calibri" pitchFamily="34" charset="0"/>
+                <a:ea typeface="Calibri" pitchFamily="34" charset="-122"/>
+                <a:cs typeface="Calibri" pitchFamily="34" charset="-120"/>
+              </a:rPr>
+              <a:t>👤 Assign on any row hands it to someone else. Pick from the list</a:t>
+            </a:r>
+            <a:endParaRPr lang="en-US" sz="1200" dirty="0"/>
+          </a:p>
+        </p:txBody>
+      </p:sp>
+      <p:sp>
+        <p:nvSpPr>
+          <p:cNvPr id="8" name="Shape 6"/>
+          <p:cNvSpPr/>
+          <p:nvPr/>
+        </p:nvSpPr>
+        <p:spPr>
+          <a:xfrm>
+            <a:off x="6400800" y="1911096"/>
+            <a:ext cx="5221224" cy="3566160"/>
+          </a:xfrm>
+          <a:prstGeom prst="roundRect">
+            <a:avLst>
+              <a:gd name="adj" fmla="val 2051"/>
+            </a:avLst>
+          </a:prstGeom>
+          <a:solidFill>
+            <a:srgbClr val="1C2128"/>
+          </a:solidFill>
+          <a:ln w="12700">
+            <a:solidFill>
+              <a:srgbClr val="30363D"/>
+            </a:solidFill>
+            <a:prstDash val="solid"/>
+          </a:ln>
+          <a:effectLst>
+            <a:outerShdw sx="100000" sy="100000" kx="0" ky="0" algn="bl" rotWithShape="0" blurRad="152400" dist="38100" dir="5400000">
+              <a:srgbClr val="000000">
+                <a:alpha val="45000"/>
+              </a:srgbClr>
+            </a:outerShdw>
+          </a:effectLst>
+        </p:spPr>
+        <p:txBody>
+          <a:bodyPr/>
+          <a:p/>
+        </p:txBody>
+      </p:sp>
+      <p:sp>
+        <p:nvSpPr>
+          <p:cNvPr id="9" name="Text 7"/>
+          <p:cNvSpPr/>
+          <p:nvPr/>
+        </p:nvSpPr>
+        <p:spPr>
+          <a:xfrm>
+            <a:off x="6675120" y="2121408"/>
+            <a:ext cx="4663440" cy="329184"/>
+          </a:xfrm>
+          <a:prstGeom prst="rect">
+            <a:avLst/>
+          </a:prstGeom>
+          <a:noFill/>
+          <a:ln/>
+        </p:spPr>
+        <p:txBody>
+          <a:bodyPr wrap="square" lIns="0" tIns="0" rIns="0" bIns="0" rtlCol="0" anchor="ctr"/>
+          <a:lstStyle/>
+          <a:p>
+            <a:pPr indent="0" marL="0">
+              <a:buNone/>
+            </a:pPr>
+            <a:r>
+              <a:rPr lang="en-US" sz="1700" b="1" dirty="0">
+                <a:solidFill>
+                  <a:srgbClr val="F0A429"/>
+                </a:solidFill>
+                <a:latin typeface="Arial" pitchFamily="34" charset="0"/>
+                <a:ea typeface="Arial" pitchFamily="34" charset="-122"/>
+                <a:cs typeface="Arial" pitchFamily="34" charset="-120"/>
+              </a:rPr>
+              <a:t>Working on it</a:t>
+            </a:r>
+            <a:endParaRPr lang="en-US" sz="1700" dirty="0"/>
+          </a:p>
+        </p:txBody>
+      </p:sp>
+      <p:sp>
+        <p:nvSpPr>
+          <p:cNvPr id="10" name="Text 8"/>
+          <p:cNvSpPr/>
+          <p:nvPr/>
+        </p:nvSpPr>
+        <p:spPr>
+          <a:xfrm>
+            <a:off x="6675120" y="2578608"/>
+            <a:ext cx="4709160" cy="2651760"/>
+          </a:xfrm>
+          <a:prstGeom prst="rect">
+            <a:avLst/>
+          </a:prstGeom>
+          <a:noFill/>
+          <a:ln/>
+        </p:spPr>
+        <p:txBody>
+          <a:bodyPr wrap="square" lIns="0" tIns="0" rIns="0" bIns="0" rtlCol="0" anchor="t"/>
+          <a:lstStyle/>
+          <a:p>
+            <a:pPr marL="342900" indent="-342900">
+              <a:lnSpc>
+                <a:spcPts val="1600"/>
+              </a:lnSpc>
+              <a:spcAft>
+                <a:spcPts val="900"/>
+              </a:spcAft>
+              <a:buSzPct val="100000"/>
+              <a:buChar char="●"/>
+            </a:pPr>
+            <a:r>
+              <a:rPr lang="en-US" sz="1200" dirty="0">
+                <a:solidFill>
+                  <a:srgbClr val="E6EDF3"/>
+                </a:solidFill>
+                <a:latin typeface="Calibri" pitchFamily="34" charset="0"/>
+                <a:ea typeface="Calibri" pitchFamily="34" charset="-122"/>
+                <a:cs typeface="Calibri" pitchFamily="34" charset="-120"/>
+              </a:rPr>
+              <a:t>👤 Assigned to me shows only your CEs and requests</a:t>
+            </a:r>
+            <a:endParaRPr lang="en-US" sz="1200" dirty="0"/>
+          </a:p>
+          <a:p>
+            <a:pPr marL="342900" indent="-342900">
+              <a:lnSpc>
+                <a:spcPts val="1600"/>
+              </a:lnSpc>
+              <a:spcAft>
+                <a:spcPts val="900"/>
+              </a:spcAft>
+              <a:buSzPct val="100000"/>
+              <a:buChar char="●"/>
+            </a:pPr>
+            <a:r>
+              <a:rPr lang="en-US" sz="1200" dirty="0">
+                <a:solidFill>
+                  <a:srgbClr val="E6EDF3"/>
+                </a:solidFill>
+                <a:latin typeface="Calibri" pitchFamily="34" charset="0"/>
+                <a:ea typeface="Calibri" pitchFamily="34" charset="-122"/>
+                <a:cs typeface="Calibri" pitchFamily="34" charset="-120"/>
+              </a:rPr>
+              <a:t>Load the request, build the estimate, and Save under the SAME number — it replaces the request and keeps its files</a:t>
+            </a:r>
+            <a:endParaRPr lang="en-US" sz="1200" dirty="0"/>
+          </a:p>
+          <a:p>
+            <a:pPr marL="342900" indent="-342900">
+              <a:lnSpc>
+                <a:spcPts val="1600"/>
+              </a:lnSpc>
+              <a:spcAft>
+                <a:spcPts val="900"/>
+              </a:spcAft>
+              <a:buSzPct val="100000"/>
+              <a:buChar char="●"/>
+            </a:pPr>
+            <a:r>
+              <a:rPr lang="en-US" sz="1200" dirty="0">
+                <a:solidFill>
+                  <a:srgbClr val="E6EDF3"/>
+                </a:solidFill>
+                <a:latin typeface="Calibri" pitchFamily="34" charset="0"/>
+                <a:ea typeface="Calibri" pitchFamily="34" charset="-122"/>
+                <a:cs typeface="Calibri" pitchFamily="34" charset="-120"/>
+              </a:rPr>
+              <a:t>That is the only save over an existing number allowed without Revise, and only for that number</a:t>
+            </a:r>
+            <a:endParaRPr lang="en-US" sz="1200" dirty="0"/>
+          </a:p>
+          <a:p>
+            <a:pPr marL="342900" indent="-342900">
+              <a:lnSpc>
+                <a:spcPts val="1600"/>
+              </a:lnSpc>
+              <a:spcAft>
+                <a:spcPts val="900"/>
+              </a:spcAft>
+              <a:buSzPct val="100000"/>
+              <a:buChar char="●"/>
+            </a:pPr>
+            <a:r>
+              <a:rPr lang="en-US" sz="1200" dirty="0">
+                <a:solidFill>
+                  <a:srgbClr val="E6EDF3"/>
+                </a:solidFill>
+                <a:latin typeface="Calibri" pitchFamily="34" charset="0"/>
+                <a:ea typeface="Calibri" pitchFamily="34" charset="-122"/>
+                <a:cs typeface="Calibri" pitchFamily="34" charset="-120"/>
+              </a:rPr>
+              <a:t>Assigned to me matches your name, so a nickname typed in the Estimator field will not be found</a:t>
+            </a:r>
+            <a:endParaRPr lang="en-US" sz="1200" dirty="0"/>
+          </a:p>
+        </p:txBody>
+      </p:sp>
+      <p:sp>
+        <p:nvSpPr>
+          <p:cNvPr id="11" name="Text 9"/>
+          <p:cNvSpPr/>
+          <p:nvPr/>
+        </p:nvSpPr>
+        <p:spPr>
+          <a:xfrm>
+            <a:off x="566928" y="6437376"/>
+            <a:ext cx="5486400" cy="237744"/>
+          </a:xfrm>
+          <a:prstGeom prst="rect">
+            <a:avLst/>
+          </a:prstGeom>
+          <a:noFill/>
+          <a:ln/>
+        </p:spPr>
+        <p:txBody>
+          <a:bodyPr wrap="square" lIns="0" tIns="0" rIns="0" bIns="0" rtlCol="0" anchor="ctr"/>
+          <a:lstStyle/>
+          <a:p>
+            <a:pPr indent="0" marL="0">
+              <a:buNone/>
+            </a:pPr>
+            <a:r>
+              <a:rPr lang="en-US" sz="900" dirty="0">
+                <a:solidFill>
+                  <a:srgbClr val="6E7681"/>
+                </a:solidFill>
+                <a:latin typeface="Calibri" pitchFamily="34" charset="0"/>
+                <a:ea typeface="Calibri" pitchFamily="34" charset="-122"/>
+                <a:cs typeface="Calibri" pitchFamily="34" charset="-120"/>
+              </a:rPr>
+              <a:t>SHIC Cost Estimator — End-User Manual</a:t>
+            </a:r>
+            <a:endParaRPr lang="en-US" sz="900" dirty="0"/>
+          </a:p>
+        </p:txBody>
+      </p:sp>
+      <p:sp>
+        <p:nvSpPr>
+          <p:cNvPr id="12" name="Text 10"/>
+          <p:cNvSpPr/>
+          <p:nvPr/>
+        </p:nvSpPr>
+        <p:spPr>
+          <a:xfrm>
+            <a:off x="10981944" y="6437376"/>
+            <a:ext cx="640080" cy="237744"/>
+          </a:xfrm>
+          <a:prstGeom prst="rect">
+            <a:avLst/>
+          </a:prstGeom>
+          <a:noFill/>
+          <a:ln/>
+        </p:spPr>
+        <p:txBody>
+          <a:bodyPr wrap="square" lIns="0" tIns="0" rIns="0" bIns="0" rtlCol="0" anchor="ctr"/>
+          <a:lstStyle/>
+          <a:p>
+            <a:pPr algn="r" indent="0" marL="0">
+              <a:buNone/>
+            </a:pPr>
+            <a:r>
+              <a:rPr lang="en-US" sz="900" dirty="0">
+                <a:solidFill>
+                  <a:srgbClr val="6E7681"/>
+                </a:solidFill>
+                <a:latin typeface="Calibri" pitchFamily="34" charset="0"/>
+                <a:ea typeface="Calibri" pitchFamily="34" charset="-122"/>
+                <a:cs typeface="Calibri" pitchFamily="34" charset="-120"/>
+              </a:rPr>
+              <a:t>23</a:t>
+            </a:r>
+            <a:endParaRPr lang="en-US" sz="900" dirty="0"/>
+          </a:p>
+        </p:txBody>
+      </p:sp>
+    </p:spTree>
+  </p:cSld>
+  <p:clrMapOvr>
+    <a:masterClrMapping/>
+  </p:clrMapOvr>
+</p:sld>
+</file>
+
+<file path=ppt/slides/slide24.xml><?xml version="1.0" encoding="utf-8"?>
 <p:sld xmlns:a="http://schemas.openxmlformats.org/drawingml/2006/main" xmlns:r="http://schemas.openxmlformats.org/officeDocument/2006/relationships" xmlns:p="http://schemas.openxmlformats.org/presentationml/2006/main">
   <p:cSld name="Slide 18">
     <p:bg>
@@ -21080,7 +21717,7 @@
 </p:sld>
 </file>
 
-<file path=ppt/slides/slide24.xml><?xml version="1.0" encoding="utf-8"?>
+<file path=ppt/slides/slide25.xml><?xml version="1.0" encoding="utf-8"?>
 <p:sld xmlns:a="http://schemas.openxmlformats.org/drawingml/2006/main" xmlns:r="http://schemas.openxmlformats.org/officeDocument/2006/relationships" xmlns:p="http://schemas.openxmlformats.org/presentationml/2006/main">
   <p:cSld name="Slide 19">
     <p:bg>
@@ -22218,7 +22855,7 @@
 </p:sld>
 </file>
 
-<file path=ppt/slides/slide25.xml><?xml version="1.0" encoding="utf-8"?>
+<file path=ppt/slides/slide26.xml><?xml version="1.0" encoding="utf-8"?>
 <p:sld xmlns:a="http://schemas.openxmlformats.org/drawingml/2006/main" xmlns:r="http://schemas.openxmlformats.org/officeDocument/2006/relationships" xmlns:p="http://schemas.openxmlformats.org/presentationml/2006/main">
   <p:cSld name="Slide 20">
     <p:bg>
@@ -22886,7 +23523,7 @@
 </p:sld>
 </file>
 
-<file path=ppt/slides/slide26.xml><?xml version="1.0" encoding="utf-8"?>
+<file path=ppt/slides/slide27.xml><?xml version="1.0" encoding="utf-8"?>
 <p:sld xmlns:a="http://schemas.openxmlformats.org/drawingml/2006/main" xmlns:r="http://schemas.openxmlformats.org/officeDocument/2006/relationships" xmlns:p="http://schemas.openxmlformats.org/presentationml/2006/main">
   <p:cSld name="Slide 21">
     <p:bg>
@@ -23177,7 +23814,7 @@
                 <a:ea typeface="Calibri" pitchFamily="34" charset="-122"/>
                 <a:cs typeface="Calibri" pitchFamily="34" charset="-120"/>
               </a:rPr>
-              <a:t>A CE Number can only be used once</a:t>
+              <a:t>A CE Number is used once, except to save over a request</a:t>
             </a:r>
             <a:endParaRPr lang="en-US" sz="1150" dirty="0"/>
           </a:p>
@@ -23890,643 +24527,6 @@
                 <a:cs typeface="Calibri" pitchFamily="34" charset="-120"/>
               </a:rPr>
               <a:t>27</a:t>
-            </a:r>
-            <a:endParaRPr lang="en-US" sz="900" dirty="0"/>
-          </a:p>
-        </p:txBody>
-      </p:sp>
-    </p:spTree>
-  </p:cSld>
-  <p:clrMapOvr>
-    <a:masterClrMapping/>
-  </p:clrMapOvr>
-</p:sld>
-</file>
-
-<file path=ppt/slides/slide27.xml><?xml version="1.0" encoding="utf-8"?>
-<p:sld xmlns:a="http://schemas.openxmlformats.org/drawingml/2006/main" xmlns:p="http://schemas.openxmlformats.org/presentationml/2006/main" xmlns:r="http://schemas.openxmlformats.org/officeDocument/2006/relationships">
-  <p:cSld>
-    <p:bg>
-      <p:bgPr>
-        <a:solidFill>
-          <a:srgbClr val="0D1117"/>
-        </a:solidFill>
-      </p:bgPr>
-    </p:bg>
-    <p:spTree>
-      <p:nvGrpSpPr>
-        <p:cNvPr id="1" name=""/>
-        <p:cNvGrpSpPr/>
-        <p:nvPr/>
-      </p:nvGrpSpPr>
-      <p:grpSpPr/>
-      <p:sp>
-        <p:nvSpPr>
-          <p:cNvPr id="2" name="Text 0"/>
-          <p:cNvSpPr/>
-          <p:nvPr/>
-        </p:nvSpPr>
-        <p:spPr>
-          <a:xfrm>
-            <a:off x="566928" y="384048"/>
-            <a:ext cx="8229600" cy="256032"/>
-          </a:xfrm>
-          <a:prstGeom prst="rect">
-            <a:avLst/>
-          </a:prstGeom>
-          <a:noFill/>
-          <a:ln/>
-        </p:spPr>
-        <p:txBody>
-          <a:bodyPr wrap="square" lIns="0" tIns="0" rIns="0" bIns="0" rtlCol="0" anchor="ctr"/>
-          <a:lstStyle/>
-          <a:p>
-            <a:pPr indent="0" marL="0">
-              <a:buNone/>
-            </a:pPr>
-            <a:r>
-              <a:rPr lang="en-US" sz="1100" b="1" spc="200" kern="0" dirty="0">
-                <a:solidFill>
-                  <a:srgbClr val="F0A429"/>
-                </a:solidFill>
-                <a:latin typeface="Arial" pitchFamily="34" charset="0"/>
-                <a:ea typeface="Arial" pitchFamily="34" charset="-122"/>
-                <a:cs typeface="Arial" pitchFamily="34" charset="-120"/>
-              </a:rPr>
-              <a:t>CE MONITORING · REQUESTS</a:t>
-            </a:r>
-            <a:endParaRPr lang="en-US" sz="1100" dirty="0"/>
-          </a:p>
-        </p:txBody>
-      </p:sp>
-      <p:sp>
-        <p:nvSpPr>
-          <p:cNvPr id="3" name="Text 1"/>
-          <p:cNvSpPr/>
-          <p:nvPr/>
-        </p:nvSpPr>
-        <p:spPr>
-          <a:xfrm>
-            <a:off x="566928" y="694944"/>
-            <a:ext cx="11055096" cy="566928"/>
-          </a:xfrm>
-          <a:prstGeom prst="rect">
-            <a:avLst/>
-          </a:prstGeom>
-          <a:noFill/>
-          <a:ln/>
-        </p:spPr>
-        <p:txBody>
-          <a:bodyPr wrap="square" lIns="0" tIns="0" rIns="0" bIns="0" rtlCol="0" anchor="ctr"/>
-          <a:lstStyle/>
-          <a:p>
-            <a:pPr indent="0" marL="0">
-              <a:buNone/>
-            </a:pPr>
-            <a:r>
-              <a:rPr lang="en-US" sz="3200" b="1" dirty="0">
-                <a:solidFill>
-                  <a:srgbClr val="E6EDF3"/>
-                </a:solidFill>
-                <a:latin typeface="Arial" pitchFamily="34" charset="0"/>
-                <a:ea typeface="Arial" pitchFamily="34" charset="-122"/>
-                <a:cs typeface="Arial" pitchFamily="34" charset="-120"/>
-              </a:rPr>
-              <a:t>Log it, assign it, attach it</a:t>
-            </a:r>
-            <a:endParaRPr lang="en-US" sz="3200" dirty="0"/>
-          </a:p>
-        </p:txBody>
-      </p:sp>
-      <p:sp>
-        <p:nvSpPr>
-          <p:cNvPr id="4" name="Text 2"/>
-          <p:cNvSpPr/>
-          <p:nvPr/>
-        </p:nvSpPr>
-        <p:spPr>
-          <a:xfrm>
-            <a:off x="566928" y="1298448"/>
-            <a:ext cx="10972800" cy="365760"/>
-          </a:xfrm>
-          <a:prstGeom prst="rect">
-            <a:avLst/>
-          </a:prstGeom>
-          <a:noFill/>
-          <a:ln/>
-        </p:spPr>
-        <p:txBody>
-          <a:bodyPr wrap="square" lIns="0" tIns="0" rIns="0" bIns="0" rtlCol="0" anchor="t"/>
-          <a:lstStyle/>
-          <a:p>
-            <a:pPr algn="l" indent="0" marL="0">
-              <a:lnSpc>
-                <a:spcPts val="2000"/>
-              </a:lnSpc>
-              <a:buNone/>
-            </a:pPr>
-            <a:r>
-              <a:rPr lang="en-US" sz="1400" dirty="0">
-                <a:solidFill>
-                  <a:srgbClr val="9AA4AF"/>
-                </a:solidFill>
-                <a:latin typeface="Calibri" pitchFamily="34" charset="0"/>
-                <a:ea typeface="Calibri" pitchFamily="34" charset="-122"/>
-                <a:cs typeface="Calibri" pitchFamily="34" charset="-120"/>
-              </a:rPr>
-              <a:t>A request goes on the list the day it arrives, so nothing is forgotten between receiving it and costing it.</a:t>
-            </a:r>
-            <a:endParaRPr lang="en-US" sz="1400" dirty="0"/>
-          </a:p>
-        </p:txBody>
-      </p:sp>
-      <p:sp>
-        <p:nvSpPr>
-          <p:cNvPr id="5" name="Shape 3"/>
-          <p:cNvSpPr/>
-          <p:nvPr/>
-        </p:nvSpPr>
-        <p:spPr>
-          <a:xfrm>
-            <a:off x="566928" y="1911096"/>
-            <a:ext cx="5532120" cy="3566160"/>
-          </a:xfrm>
-          <a:prstGeom prst="roundRect">
-            <a:avLst>
-              <a:gd name="adj" fmla="val 2051"/>
-            </a:avLst>
-          </a:prstGeom>
-          <a:solidFill>
-            <a:srgbClr val="1C2128"/>
-          </a:solidFill>
-          <a:ln w="12700">
-            <a:solidFill>
-              <a:srgbClr val="30363D"/>
-            </a:solidFill>
-            <a:prstDash val="solid"/>
-          </a:ln>
-          <a:effectLst>
-            <a:outerShdw sx="100000" sy="100000" kx="0" ky="0" algn="bl" rotWithShape="0" blurRad="152400" dist="38100" dir="5400000">
-              <a:srgbClr val="000000">
-                <a:alpha val="45000"/>
-              </a:srgbClr>
-            </a:outerShdw>
-          </a:effectLst>
-        </p:spPr>
-        <p:txBody>
-          <a:bodyPr/>
-          <a:p/>
-        </p:txBody>
-      </p:sp>
-      <p:sp>
-        <p:nvSpPr>
-          <p:cNvPr id="6" name="Text 4"/>
-          <p:cNvSpPr/>
-          <p:nvPr/>
-        </p:nvSpPr>
-        <p:spPr>
-          <a:xfrm>
-            <a:off x="841248" y="2121408"/>
-            <a:ext cx="4937760" cy="329184"/>
-          </a:xfrm>
-          <a:prstGeom prst="rect">
-            <a:avLst/>
-          </a:prstGeom>
-          <a:noFill/>
-          <a:ln/>
-        </p:spPr>
-        <p:txBody>
-          <a:bodyPr wrap="square" lIns="0" tIns="0" rIns="0" bIns="0" rtlCol="0" anchor="ctr"/>
-          <a:lstStyle/>
-          <a:p>
-            <a:pPr indent="0" marL="0">
-              <a:buNone/>
-            </a:pPr>
-            <a:r>
-              <a:rPr lang="en-US" sz="1700" b="1" dirty="0">
-                <a:solidFill>
-                  <a:srgbClr val="A78BFA"/>
-                </a:solidFill>
-                <a:latin typeface="Arial" pitchFamily="34" charset="0"/>
-                <a:ea typeface="Arial" pitchFamily="34" charset="-122"/>
-                <a:cs typeface="Arial" pitchFamily="34" charset="-120"/>
-              </a:rPr>
-              <a:t>Logging a request</a:t>
-            </a:r>
-            <a:endParaRPr lang="en-US" sz="1700" dirty="0"/>
-          </a:p>
-        </p:txBody>
-      </p:sp>
-      <p:sp>
-        <p:nvSpPr>
-          <p:cNvPr id="7" name="Text 5"/>
-          <p:cNvSpPr/>
-          <p:nvPr/>
-        </p:nvSpPr>
-        <p:spPr>
-          <a:xfrm>
-            <a:off x="841248" y="2578608"/>
-            <a:ext cx="4983480" cy="2651760"/>
-          </a:xfrm>
-          <a:prstGeom prst="rect">
-            <a:avLst/>
-          </a:prstGeom>
-          <a:noFill/>
-          <a:ln/>
-        </p:spPr>
-        <p:txBody>
-          <a:bodyPr wrap="square" lIns="0" tIns="0" rIns="0" bIns="0" rtlCol="0" anchor="t"/>
-          <a:lstStyle/>
-          <a:p>
-            <a:pPr marL="342900" indent="-342900">
-              <a:lnSpc>
-                <a:spcPts val="1600"/>
-              </a:lnSpc>
-              <a:spcAft>
-                <a:spcPts val="900"/>
-              </a:spcAft>
-              <a:buSzPct val="100000"/>
-              <a:buChar char="●"/>
-            </a:pPr>
-            <a:r>
-              <a:rPr lang="en-US" sz="1200" dirty="0">
-                <a:solidFill>
-                  <a:srgbClr val="E6EDF3"/>
-                </a:solidFill>
-                <a:latin typeface="Calibri" pitchFamily="34" charset="0"/>
-                <a:ea typeface="Calibri" pitchFamily="34" charset="-122"/>
-                <a:cs typeface="Calibri" pitchFamily="34" charset="-120"/>
-              </a:rPr>
-              <a:t>Press + New Request. The next free CE number is suggested</a:t>
-            </a:r>
-            <a:endParaRPr lang="en-US" sz="1200" dirty="0"/>
-          </a:p>
-          <a:p>
-            <a:pPr marL="342900" indent="-342900">
-              <a:lnSpc>
-                <a:spcPts val="1600"/>
-              </a:lnSpc>
-              <a:spcAft>
-                <a:spcPts val="900"/>
-              </a:spcAft>
-              <a:buSzPct val="100000"/>
-              <a:buChar char="●"/>
-            </a:pPr>
-            <a:r>
-              <a:rPr lang="en-US" sz="1200" dirty="0">
-                <a:solidFill>
-                  <a:srgbClr val="E6EDF3"/>
-                </a:solidFill>
-                <a:latin typeface="Calibri" pitchFamily="34" charset="0"/>
-                <a:ea typeface="Calibri" pitchFamily="34" charset="-122"/>
-                <a:cs typeface="Calibri" pitchFamily="34" charset="-120"/>
-              </a:rPr>
-              <a:t>Customer and Assigned to are required; add type, discipline, job title, date received, deadline and remarks</a:t>
-            </a:r>
-            <a:endParaRPr lang="en-US" sz="1200" dirty="0"/>
-          </a:p>
-          <a:p>
-            <a:pPr marL="342900" indent="-342900">
-              <a:lnSpc>
-                <a:spcPts val="1600"/>
-              </a:lnSpc>
-              <a:spcAft>
-                <a:spcPts val="900"/>
-              </a:spcAft>
-              <a:buSzPct val="100000"/>
-              <a:buChar char="●"/>
-            </a:pPr>
-            <a:r>
-              <a:rPr lang="en-US" sz="1200" dirty="0">
-                <a:solidFill>
-                  <a:srgbClr val="E6EDF3"/>
-                </a:solidFill>
-                <a:latin typeface="Calibri" pitchFamily="34" charset="0"/>
-                <a:ea typeface="Calibri" pitchFamily="34" charset="-122"/>
-                <a:cs typeface="Calibri" pitchFamily="34" charset="-120"/>
-              </a:rPr>
-              <a:t>The attachments panel opens next — upload the TOR, drawings and client email</a:t>
-            </a:r>
-            <a:endParaRPr lang="en-US" sz="1200" dirty="0"/>
-          </a:p>
-          <a:p>
-            <a:pPr marL="342900" indent="-342900">
-              <a:lnSpc>
-                <a:spcPts val="1600"/>
-              </a:lnSpc>
-              <a:spcAft>
-                <a:spcPts val="900"/>
-              </a:spcAft>
-              <a:buSzPct val="100000"/>
-              <a:buChar char="●"/>
-            </a:pPr>
-            <a:r>
-              <a:rPr lang="en-US" sz="1200" dirty="0">
-                <a:solidFill>
-                  <a:srgbClr val="E6EDF3"/>
-                </a:solidFill>
-                <a:latin typeface="Calibri" pitchFamily="34" charset="0"/>
-                <a:ea typeface="Calibri" pitchFamily="34" charset="-122"/>
-                <a:cs typeface="Calibri" pitchFamily="34" charset="-120"/>
-              </a:rPr>
-              <a:t>It shows as a Pending row badged REQUEST, with you as Received By</a:t>
-            </a:r>
-            <a:endParaRPr lang="en-US" sz="1200" dirty="0"/>
-          </a:p>
-          <a:p>
-            <a:pPr marL="342900" indent="-342900">
-              <a:lnSpc>
-                <a:spcPts val="1600"/>
-              </a:lnSpc>
-              <a:spcAft>
-                <a:spcPts val="900"/>
-              </a:spcAft>
-              <a:buSzPct val="100000"/>
-              <a:buChar char="●"/>
-            </a:pPr>
-            <a:r>
-              <a:rPr lang="en-US" sz="1200" dirty="0">
-                <a:solidFill>
-                  <a:srgbClr val="E6EDF3"/>
-                </a:solidFill>
-                <a:latin typeface="Calibri" pitchFamily="34" charset="0"/>
-                <a:ea typeface="Calibri" pitchFamily="34" charset="-122"/>
-                <a:cs typeface="Calibri" pitchFamily="34" charset="-120"/>
-              </a:rPr>
-              <a:t>👤 Assign on any row hands it to someone else. Pick from the list</a:t>
-            </a:r>
-            <a:endParaRPr lang="en-US" sz="1200" dirty="0"/>
-          </a:p>
-        </p:txBody>
-      </p:sp>
-      <p:sp>
-        <p:nvSpPr>
-          <p:cNvPr id="8" name="Shape 6"/>
-          <p:cNvSpPr/>
-          <p:nvPr/>
-        </p:nvSpPr>
-        <p:spPr>
-          <a:xfrm>
-            <a:off x="6400800" y="1911096"/>
-            <a:ext cx="5221224" cy="3566160"/>
-          </a:xfrm>
-          <a:prstGeom prst="roundRect">
-            <a:avLst>
-              <a:gd name="adj" fmla="val 2051"/>
-            </a:avLst>
-          </a:prstGeom>
-          <a:solidFill>
-            <a:srgbClr val="1C2128"/>
-          </a:solidFill>
-          <a:ln w="12700">
-            <a:solidFill>
-              <a:srgbClr val="30363D"/>
-            </a:solidFill>
-            <a:prstDash val="solid"/>
-          </a:ln>
-          <a:effectLst>
-            <a:outerShdw sx="100000" sy="100000" kx="0" ky="0" algn="bl" rotWithShape="0" blurRad="152400" dist="38100" dir="5400000">
-              <a:srgbClr val="000000">
-                <a:alpha val="45000"/>
-              </a:srgbClr>
-            </a:outerShdw>
-          </a:effectLst>
-        </p:spPr>
-        <p:txBody>
-          <a:bodyPr/>
-          <a:p/>
-        </p:txBody>
-      </p:sp>
-      <p:sp>
-        <p:nvSpPr>
-          <p:cNvPr id="9" name="Text 7"/>
-          <p:cNvSpPr/>
-          <p:nvPr/>
-        </p:nvSpPr>
-        <p:spPr>
-          <a:xfrm>
-            <a:off x="6675120" y="2121408"/>
-            <a:ext cx="4663440" cy="329184"/>
-          </a:xfrm>
-          <a:prstGeom prst="rect">
-            <a:avLst/>
-          </a:prstGeom>
-          <a:noFill/>
-          <a:ln/>
-        </p:spPr>
-        <p:txBody>
-          <a:bodyPr wrap="square" lIns="0" tIns="0" rIns="0" bIns="0" rtlCol="0" anchor="ctr"/>
-          <a:lstStyle/>
-          <a:p>
-            <a:pPr indent="0" marL="0">
-              <a:buNone/>
-            </a:pPr>
-            <a:r>
-              <a:rPr lang="en-US" sz="1700" b="1" dirty="0">
-                <a:solidFill>
-                  <a:srgbClr val="F0A429"/>
-                </a:solidFill>
-                <a:latin typeface="Arial" pitchFamily="34" charset="0"/>
-                <a:ea typeface="Arial" pitchFamily="34" charset="-122"/>
-                <a:cs typeface="Arial" pitchFamily="34" charset="-120"/>
-              </a:rPr>
-              <a:t>Working on it</a:t>
-            </a:r>
-            <a:endParaRPr lang="en-US" sz="1700" dirty="0"/>
-          </a:p>
-        </p:txBody>
-      </p:sp>
-      <p:sp>
-        <p:nvSpPr>
-          <p:cNvPr id="10" name="Text 8"/>
-          <p:cNvSpPr/>
-          <p:nvPr/>
-        </p:nvSpPr>
-        <p:spPr>
-          <a:xfrm>
-            <a:off x="6675120" y="2578608"/>
-            <a:ext cx="4709160" cy="2651760"/>
-          </a:xfrm>
-          <a:prstGeom prst="rect">
-            <a:avLst/>
-          </a:prstGeom>
-          <a:noFill/>
-          <a:ln/>
-        </p:spPr>
-        <p:txBody>
-          <a:bodyPr wrap="square" lIns="0" tIns="0" rIns="0" bIns="0" rtlCol="0" anchor="t"/>
-          <a:lstStyle/>
-          <a:p>
-            <a:pPr marL="342900" indent="-342900">
-              <a:lnSpc>
-                <a:spcPts val="1600"/>
-              </a:lnSpc>
-              <a:spcAft>
-                <a:spcPts val="900"/>
-              </a:spcAft>
-              <a:buSzPct val="100000"/>
-              <a:buChar char="●"/>
-            </a:pPr>
-            <a:r>
-              <a:rPr lang="en-US" sz="1200" dirty="0">
-                <a:solidFill>
-                  <a:srgbClr val="E6EDF3"/>
-                </a:solidFill>
-                <a:latin typeface="Calibri" pitchFamily="34" charset="0"/>
-                <a:ea typeface="Calibri" pitchFamily="34" charset="-122"/>
-                <a:cs typeface="Calibri" pitchFamily="34" charset="-120"/>
-              </a:rPr>
-              <a:t>👤 Assigned to me shows only your CEs and requests</a:t>
-            </a:r>
-            <a:endParaRPr lang="en-US" sz="1200" dirty="0"/>
-          </a:p>
-          <a:p>
-            <a:pPr marL="342900" indent="-342900">
-              <a:lnSpc>
-                <a:spcPts val="1600"/>
-              </a:lnSpc>
-              <a:spcAft>
-                <a:spcPts val="900"/>
-              </a:spcAft>
-              <a:buSzPct val="100000"/>
-              <a:buChar char="●"/>
-            </a:pPr>
-            <a:r>
-              <a:rPr lang="en-US" sz="1200" dirty="0">
-                <a:solidFill>
-                  <a:srgbClr val="E6EDF3"/>
-                </a:solidFill>
-                <a:latin typeface="Calibri" pitchFamily="34" charset="0"/>
-                <a:ea typeface="Calibri" pitchFamily="34" charset="-122"/>
-                <a:cs typeface="Calibri" pitchFamily="34" charset="-120"/>
-              </a:rPr>
-              <a:t>Load the request, build the estimate, and Save under the SAME number — it replaces the request and keeps its files</a:t>
-            </a:r>
-            <a:endParaRPr lang="en-US" sz="1200" dirty="0"/>
-          </a:p>
-          <a:p>
-            <a:pPr marL="342900" indent="-342900">
-              <a:lnSpc>
-                <a:spcPts val="1600"/>
-              </a:lnSpc>
-              <a:spcAft>
-                <a:spcPts val="900"/>
-              </a:spcAft>
-              <a:buSzPct val="100000"/>
-              <a:buChar char="●"/>
-            </a:pPr>
-            <a:r>
-              <a:rPr lang="en-US" sz="1200" dirty="0">
-                <a:solidFill>
-                  <a:srgbClr val="E6EDF3"/>
-                </a:solidFill>
-                <a:latin typeface="Calibri" pitchFamily="34" charset="0"/>
-                <a:ea typeface="Calibri" pitchFamily="34" charset="-122"/>
-                <a:cs typeface="Calibri" pitchFamily="34" charset="-120"/>
-              </a:rPr>
-              <a:t>That is the only save over an existing number allowed without Revise, and only for that number</a:t>
-            </a:r>
-            <a:endParaRPr lang="en-US" sz="1200" dirty="0"/>
-          </a:p>
-          <a:p>
-            <a:pPr marL="342900" indent="-342900">
-              <a:lnSpc>
-                <a:spcPts val="1600"/>
-              </a:lnSpc>
-              <a:spcAft>
-                <a:spcPts val="900"/>
-              </a:spcAft>
-              <a:buSzPct val="100000"/>
-              <a:buChar char="●"/>
-            </a:pPr>
-            <a:r>
-              <a:rPr lang="en-US" sz="1200" dirty="0">
-                <a:solidFill>
-                  <a:srgbClr val="E6EDF3"/>
-                </a:solidFill>
-                <a:latin typeface="Calibri" pitchFamily="34" charset="0"/>
-                <a:ea typeface="Calibri" pitchFamily="34" charset="-122"/>
-                <a:cs typeface="Calibri" pitchFamily="34" charset="-120"/>
-              </a:rPr>
-              <a:t>Assigned to me matches your name, so a nickname typed in the Estimator field will not be found</a:t>
-            </a:r>
-            <a:endParaRPr lang="en-US" sz="1200" dirty="0"/>
-          </a:p>
-        </p:txBody>
-      </p:sp>
-      <p:sp>
-        <p:nvSpPr>
-          <p:cNvPr id="11" name="Text 9"/>
-          <p:cNvSpPr/>
-          <p:nvPr/>
-        </p:nvSpPr>
-        <p:spPr>
-          <a:xfrm>
-            <a:off x="566928" y="6437376"/>
-            <a:ext cx="5486400" cy="237744"/>
-          </a:xfrm>
-          <a:prstGeom prst="rect">
-            <a:avLst/>
-          </a:prstGeom>
-          <a:noFill/>
-          <a:ln/>
-        </p:spPr>
-        <p:txBody>
-          <a:bodyPr wrap="square" lIns="0" tIns="0" rIns="0" bIns="0" rtlCol="0" anchor="ctr"/>
-          <a:lstStyle/>
-          <a:p>
-            <a:pPr indent="0" marL="0">
-              <a:buNone/>
-            </a:pPr>
-            <a:r>
-              <a:rPr lang="en-US" sz="900" dirty="0">
-                <a:solidFill>
-                  <a:srgbClr val="6E7681"/>
-                </a:solidFill>
-                <a:latin typeface="Calibri" pitchFamily="34" charset="0"/>
-                <a:ea typeface="Calibri" pitchFamily="34" charset="-122"/>
-                <a:cs typeface="Calibri" pitchFamily="34" charset="-120"/>
-              </a:rPr>
-              <a:t>SHIC Cost Estimator — End-User Manual</a:t>
-            </a:r>
-            <a:endParaRPr lang="en-US" sz="900" dirty="0"/>
-          </a:p>
-        </p:txBody>
-      </p:sp>
-      <p:sp>
-        <p:nvSpPr>
-          <p:cNvPr id="12" name="Text 10"/>
-          <p:cNvSpPr/>
-          <p:nvPr/>
-        </p:nvSpPr>
-        <p:spPr>
-          <a:xfrm>
-            <a:off x="10981944" y="6437376"/>
-            <a:ext cx="640080" cy="237744"/>
-          </a:xfrm>
-          <a:prstGeom prst="rect">
-            <a:avLst/>
-          </a:prstGeom>
-          <a:noFill/>
-          <a:ln/>
-        </p:spPr>
-        <p:txBody>
-          <a:bodyPr wrap="square" lIns="0" tIns="0" rIns="0" bIns="0" rtlCol="0" anchor="ctr"/>
-          <a:lstStyle/>
-          <a:p>
-            <a:pPr algn="r" indent="0" marL="0">
-              <a:buNone/>
-            </a:pPr>
-            <a:r>
-              <a:rPr lang="en-US" sz="900" dirty="0">
-                <a:solidFill>
-                  <a:srgbClr val="6E7681"/>
-                </a:solidFill>
-                <a:latin typeface="Calibri" pitchFamily="34" charset="0"/>
-                <a:ea typeface="Calibri" pitchFamily="34" charset="-122"/>
-                <a:cs typeface="Calibri" pitchFamily="34" charset="-120"/>
-              </a:rPr>
-              <a:t>23</a:t>
             </a:r>
             <a:endParaRPr lang="en-US" sz="900" dirty="0"/>
           </a:p>

</xml_diff>

<commit_message>
Update the manual for builds 166-183
Co-Authored-By: Claude Opus 5 <noreply@anthropic.com>
</commit_message>
<xml_diff>
--- a/docs/SHIC-Cost-Estimator-User-Manual.pptx
+++ b/docs/SHIC-Cost-Estimator-User-Manual.pptx
@@ -16,6 +16,8 @@
     <p:sldId id="264" r:id="rId10"/>
     <p:sldId id="280" r:id="rId31"/>
     <p:sldId id="265" r:id="rId11"/>
+    <p:sldId id="283" r:id="rId34"/>
+    <p:sldId id="284" r:id="rId35"/>
     <p:sldId id="266" r:id="rId12"/>
     <p:sldId id="277" r:id="rId28"/>
     <p:sldId id="278" r:id="rId29"/>
@@ -1956,6 +1958,146 @@
           <a:p>
             <a:r>
               <a:t>Walk through the handoff. The person receiving requests logs them with + New Request, attaches the documents, and assigns an estimator. The estimator filters on Assigned to me, loads the request and saves the finished CE over it under the same number. Reassign with the Assign button on the row, and always pick from the list, because Assigned to me matches by name.</a:t>
+            </a:r>
+          </a:p>
+        </p:txBody>
+      </p:sp>
+      <p:sp>
+        <p:nvSpPr>
+          <p:cNvPr id="4" name="Slide Number Placeholder 3"/>
+          <p:cNvSpPr>
+            <a:spLocks noGrp="1"/>
+          </p:cNvSpPr>
+          <p:nvPr>
+            <p:ph type="sldNum" idx="5" sz="quarter"/>
+          </p:nvPr>
+        </p:nvSpPr>
+        <p:spPr/>
+      </p:sp>
+    </p:spTree>
+  </p:cSld>
+  <p:clrMapOvr>
+    <a:masterClrMapping/>
+  </p:clrMapOvr>
+</p:notes>
+</file>
+
+<file path=ppt/notesSlides/notesSlide26.xml><?xml version="1.0" encoding="utf-8"?>
+<p:notes xmlns:a="http://schemas.openxmlformats.org/drawingml/2006/main" xmlns:p="http://schemas.openxmlformats.org/presentationml/2006/main" xmlns:r="http://schemas.openxmlformats.org/officeDocument/2006/relationships">
+  <p:cSld>
+    <p:spTree>
+      <p:nvGrpSpPr>
+        <p:cNvPr id="1" name=""/>
+        <p:cNvGrpSpPr/>
+        <p:nvPr/>
+      </p:nvGrpSpPr>
+      <p:grpSpPr>
+        <a:xfrm>
+          <a:off x="0" y="0"/>
+          <a:ext cx="0" cy="0"/>
+          <a:chOff x="0" y="0"/>
+          <a:chExt cx="0" cy="0"/>
+        </a:xfrm>
+      </p:grpSpPr>
+      <p:sp>
+        <p:nvSpPr>
+          <p:cNvPr id="2" name="Slide Image Placeholder 1"/>
+          <p:cNvSpPr>
+            <a:spLocks noGrp="1"/>
+          </p:cNvSpPr>
+          <p:nvPr>
+            <p:ph type="sldImg" idx="2"/>
+          </p:nvPr>
+        </p:nvSpPr>
+        <p:spPr/>
+      </p:sp>
+      <p:sp>
+        <p:nvSpPr>
+          <p:cNvPr id="3" name="Notes Placeholder 2"/>
+          <p:cNvSpPr>
+            <a:spLocks noGrp="1"/>
+          </p:cNvSpPr>
+          <p:nvPr>
+            <p:ph type="body" idx="3" sz="quarter"/>
+          </p:nvPr>
+        </p:nvSpPr>
+        <p:spPr/>
+        <p:txBody>
+          <a:bodyPr/>
+          <a:lstStyle/>
+          <a:p>
+            <a:r>
+              <a:t>Mobilization and demobilization now carry manpower as well as expenses. Press Crew from SOW Breakdown and the crew is built from the Manpower tab, one line per role, counted the way Benefits counts heads. It stays linked: change the manpower and the lines follow, except where you have typed a pax or a rate. On the printed CE they are rows A and B, and their bill prints before manpower.</a:t>
+            </a:r>
+          </a:p>
+        </p:txBody>
+      </p:sp>
+      <p:sp>
+        <p:nvSpPr>
+          <p:cNvPr id="4" name="Slide Number Placeholder 3"/>
+          <p:cNvSpPr>
+            <a:spLocks noGrp="1"/>
+          </p:cNvSpPr>
+          <p:nvPr>
+            <p:ph type="sldNum" idx="5" sz="quarter"/>
+          </p:nvPr>
+        </p:nvSpPr>
+        <p:spPr/>
+      </p:sp>
+    </p:spTree>
+  </p:cSld>
+  <p:clrMapOvr>
+    <a:masterClrMapping/>
+  </p:clrMapOvr>
+</p:notes>
+</file>
+
+<file path=ppt/notesSlides/notesSlide27.xml><?xml version="1.0" encoding="utf-8"?>
+<p:notes xmlns:a="http://schemas.openxmlformats.org/drawingml/2006/main" xmlns:p="http://schemas.openxmlformats.org/presentationml/2006/main" xmlns:r="http://schemas.openxmlformats.org/officeDocument/2006/relationships">
+  <p:cSld>
+    <p:spTree>
+      <p:nvGrpSpPr>
+        <p:cNvPr id="1" name=""/>
+        <p:cNvGrpSpPr/>
+        <p:nvPr/>
+      </p:nvGrpSpPr>
+      <p:grpSpPr>
+        <a:xfrm>
+          <a:off x="0" y="0"/>
+          <a:ext cx="0" cy="0"/>
+          <a:chOff x="0" y="0"/>
+          <a:chExt cx="0" cy="0"/>
+        </a:xfrm>
+      </p:grpSpPr>
+      <p:sp>
+        <p:nvSpPr>
+          <p:cNvPr id="2" name="Slide Image Placeholder 1"/>
+          <p:cNvSpPr>
+            <a:spLocks noGrp="1"/>
+          </p:cNvSpPr>
+          <p:nvPr>
+            <p:ph type="sldImg" idx="2"/>
+          </p:nvPr>
+        </p:nvSpPr>
+        <p:spPr/>
+      </p:sp>
+      <p:sp>
+        <p:nvSpPr>
+          <p:cNvPr id="3" name="Notes Placeholder 2"/>
+          <p:cNvSpPr>
+            <a:spLocks noGrp="1"/>
+          </p:cNvSpPr>
+          <p:nvPr>
+            <p:ph type="body" idx="3" sz="quarter"/>
+          </p:nvPr>
+        </p:nvSpPr>
+        <p:spPr/>
+        <p:txBody>
+          <a:bodyPr/>
+          <a:lstStyle/>
+          <a:p>
+            <a:r>
+              <a:t>Food allowance is paid at three rates. Each role belongs to one of them, set once on the Manpower masterlist. The app counts the heads in each group: for mobilization and demobilization, the people who travel; for accommodation, the whole crew over the days each shift works, listed as sub-items. When the allowance changes, update the three Masterlist items and use Sync meal rates on any CE you are requoting.</a:t>
             </a:r>
           </a:p>
         </p:txBody>
@@ -3778,7 +3920,7 @@
                 <a:ea typeface="Calibri" pitchFamily="34" charset="-122"/>
                 <a:cs typeface="Calibri" pitchFamily="34" charset="-120"/>
               </a:rPr>
-              <a:t>Hover SIL &amp; ECC: the ₱30 ECC is charged per person on each shift entry</a:t>
+              <a:t>Hover SIL &amp; ECC for the ₱30 ECC. The last row gives Total manpower — the headcount</a:t>
             </a:r>
             <a:endParaRPr lang="en-US" sz="1200" dirty="0"/>
           </a:p>
@@ -7292,7 +7434,7 @@
                 <a:ea typeface="Calibri" pitchFamily="34" charset="-122"/>
                 <a:cs typeface="Calibri" pitchFamily="34" charset="-120"/>
               </a:rPr>
-              <a:t>12</a:t>
+              <a:t>14</a:t>
             </a:r>
             <a:endParaRPr lang="en-US" sz="900" dirty="0"/>
           </a:p>
@@ -8726,7 +8868,7 @@
                 <a:ea typeface="Calibri" pitchFamily="34" charset="-122"/>
                 <a:cs typeface="Calibri" pitchFamily="34" charset="-120"/>
               </a:rPr>
-              <a:t>13</a:t>
+              <a:t>15</a:t>
             </a:r>
             <a:endParaRPr lang="en-US" sz="900" dirty="0"/>
           </a:p>
@@ -10160,7 +10302,7 @@
                 <a:ea typeface="Calibri" pitchFamily="34" charset="-122"/>
                 <a:cs typeface="Calibri" pitchFamily="34" charset="-120"/>
               </a:rPr>
-              <a:t>14</a:t>
+              <a:t>16</a:t>
             </a:r>
             <a:endParaRPr lang="en-US" sz="900" dirty="0"/>
           </a:p>
@@ -11516,7 +11658,7 @@
                 <a:ea typeface="Calibri" pitchFamily="34" charset="-122"/>
                 <a:cs typeface="Calibri" pitchFamily="34" charset="-120"/>
               </a:rPr>
-              <a:t>Each line takes a description, quantity, unit and cost — the same as any other resource. Mobilisation and demobilisation vehicles are entered separately on the Summary tab for on-site jobs.</a:t>
+              <a:t>Each line takes a description, quantity, unit, days and cost — blank days counts as 1. Food allowance for the stay can be counted from the crew (see Food allowance). Mobilisation and demobilisation are at the top of the Manpower tab.</a:t>
             </a:r>
             <a:endParaRPr lang="en-US" sz="1150" dirty="0"/>
           </a:p>
@@ -11594,7 +11736,7 @@
                 <a:ea typeface="Calibri" pitchFamily="34" charset="-122"/>
                 <a:cs typeface="Calibri" pitchFamily="34" charset="-120"/>
               </a:rPr>
-              <a:t>15</a:t>
+              <a:t>17</a:t>
             </a:r>
             <a:endParaRPr lang="en-US" sz="900" dirty="0"/>
           </a:p>
@@ -13622,7 +13764,7 @@
                 <a:ea typeface="Calibri" pitchFamily="34" charset="-122"/>
                 <a:cs typeface="Calibri" pitchFamily="34" charset="-120"/>
               </a:rPr>
-              <a:t>16</a:t>
+              <a:t>18</a:t>
             </a:r>
             <a:endParaRPr lang="en-US" sz="900" dirty="0"/>
           </a:p>
@@ -14259,7 +14401,7 @@
                 <a:ea typeface="Calibri" pitchFamily="34" charset="-122"/>
                 <a:cs typeface="Calibri" pitchFamily="34" charset="-120"/>
               </a:rPr>
-              <a:t>17</a:t>
+              <a:t>19</a:t>
             </a:r>
             <a:endParaRPr lang="en-US" sz="900" dirty="0"/>
           </a:p>
@@ -14998,7 +15140,7 @@
                 <a:ea typeface="Calibri" pitchFamily="34" charset="-122"/>
                 <a:cs typeface="Calibri" pitchFamily="34" charset="-120"/>
               </a:rPr>
-              <a:t>18</a:t>
+              <a:t>20</a:t>
             </a:r>
             <a:endParaRPr lang="en-US" sz="900" dirty="0"/>
           </a:p>
@@ -16252,7 +16394,7 @@
                 <a:ea typeface="Calibri" pitchFamily="34" charset="-122"/>
                 <a:cs typeface="Calibri" pitchFamily="34" charset="-120"/>
               </a:rPr>
-              <a:t>19</a:t>
+              <a:t>21</a:t>
             </a:r>
             <a:endParaRPr lang="en-US" sz="900" dirty="0"/>
           </a:p>
@@ -17747,7 +17889,7 @@
                 <a:ea typeface="Calibri" pitchFamily="34" charset="-122"/>
                 <a:cs typeface="Calibri" pitchFamily="34" charset="-120"/>
               </a:rPr>
-              <a:t>Notes print as a numbered list, with breakdown notes labelled by scope number</a:t>
+              <a:t>Left and right margins are 0.25 in — keep Chrome’s Margins on Default</a:t>
             </a:r>
             <a:endParaRPr lang="en-US" sz="1150" dirty="0"/>
           </a:p>
@@ -17849,7 +17991,7 @@
                 <a:ea typeface="Calibri" pitchFamily="34" charset="-122"/>
                 <a:cs typeface="Calibri" pitchFamily="34" charset="-120"/>
               </a:rPr>
-              <a:t>20</a:t>
+              <a:t>22</a:t>
             </a:r>
             <a:endParaRPr lang="en-US" sz="900" dirty="0"/>
           </a:p>
@@ -19536,7 +19678,7 @@
                 <a:ea typeface="Calibri" pitchFamily="34" charset="-122"/>
                 <a:cs typeface="Calibri" pitchFamily="34" charset="-120"/>
               </a:rPr>
-              <a:t>21</a:t>
+              <a:t>23</a:t>
             </a:r>
             <a:endParaRPr lang="en-US" sz="900" dirty="0"/>
           </a:p>
@@ -20156,7 +20298,7 @@
                 <a:ea typeface="Calibri" pitchFamily="34" charset="-122"/>
                 <a:cs typeface="Calibri" pitchFamily="34" charset="-120"/>
               </a:rPr>
-              <a:t>22</a:t>
+              <a:t>24</a:t>
             </a:r>
             <a:endParaRPr lang="en-US" sz="900" dirty="0"/>
           </a:p>
@@ -20643,7 +20785,7 @@
                 <a:ea typeface="Calibri" pitchFamily="34" charset="-122"/>
                 <a:cs typeface="Calibri" pitchFamily="34" charset="-120"/>
               </a:rPr>
-              <a:t>👤 Assigned to me shows only your CEs and requests</a:t>
+              <a:t>👤 Assigned to me shows your CEs and requests — including ones someone else logged for you</a:t>
             </a:r>
             <a:endParaRPr lang="en-US" sz="1200" dirty="0"/>
           </a:p>
@@ -20793,7 +20935,7 @@
                 <a:ea typeface="Calibri" pitchFamily="34" charset="-122"/>
                 <a:cs typeface="Calibri" pitchFamily="34" charset="-120"/>
               </a:rPr>
-              <a:t>23</a:t>
+              <a:t>25</a:t>
             </a:r>
             <a:endParaRPr lang="en-US" sz="900" dirty="0"/>
           </a:p>
@@ -21703,7 +21845,7 @@
                 <a:ea typeface="Calibri" pitchFamily="34" charset="-122"/>
                 <a:cs typeface="Calibri" pitchFamily="34" charset="-120"/>
               </a:rPr>
-              <a:t>24</a:t>
+              <a:t>26</a:t>
             </a:r>
             <a:endParaRPr lang="en-US" sz="900" dirty="0"/>
           </a:p>
@@ -22841,7 +22983,7 @@
                 <a:ea typeface="Calibri" pitchFamily="34" charset="-122"/>
                 <a:cs typeface="Calibri" pitchFamily="34" charset="-120"/>
               </a:rPr>
-              <a:t>25</a:t>
+              <a:t>27</a:t>
             </a:r>
             <a:endParaRPr lang="en-US" sz="900" dirty="0"/>
           </a:p>
@@ -23509,7 +23651,7 @@
                 <a:ea typeface="Calibri" pitchFamily="34" charset="-122"/>
                 <a:cs typeface="Calibri" pitchFamily="34" charset="-120"/>
               </a:rPr>
-              <a:t>26</a:t>
+              <a:t>28</a:t>
             </a:r>
             <a:endParaRPr lang="en-US" sz="900" dirty="0"/>
           </a:p>
@@ -23814,7 +23956,7 @@
                 <a:ea typeface="Calibri" pitchFamily="34" charset="-122"/>
                 <a:cs typeface="Calibri" pitchFamily="34" charset="-120"/>
               </a:rPr>
-              <a:t>A CE Number is used once, except to save over a request</a:t>
+              <a:t>CE numbers: one sequence for SHIC and SY3</a:t>
             </a:r>
             <a:endParaRPr lang="en-US" sz="1150" dirty="0"/>
           </a:p>
@@ -24526,7 +24668,1233 @@
                 <a:ea typeface="Calibri" pitchFamily="34" charset="-122"/>
                 <a:cs typeface="Calibri" pitchFamily="34" charset="-120"/>
               </a:rPr>
-              <a:t>27</a:t>
+              <a:t>29</a:t>
+            </a:r>
+            <a:endParaRPr lang="en-US" sz="900" dirty="0"/>
+          </a:p>
+        </p:txBody>
+      </p:sp>
+    </p:spTree>
+  </p:cSld>
+  <p:clrMapOvr>
+    <a:masterClrMapping/>
+  </p:clrMapOvr>
+</p:sld>
+</file>
+
+<file path=ppt/slides/slide28.xml><?xml version="1.0" encoding="utf-8"?>
+<p:sld xmlns:a="http://schemas.openxmlformats.org/drawingml/2006/main" xmlns:p="http://schemas.openxmlformats.org/presentationml/2006/main" xmlns:r="http://schemas.openxmlformats.org/officeDocument/2006/relationships">
+  <p:cSld>
+    <p:bg>
+      <p:bgPr>
+        <a:solidFill>
+          <a:srgbClr val="0D1117"/>
+        </a:solidFill>
+      </p:bgPr>
+    </p:bg>
+    <p:spTree>
+      <p:nvGrpSpPr>
+        <p:cNvPr id="1" name=""/>
+        <p:cNvGrpSpPr/>
+        <p:nvPr/>
+      </p:nvGrpSpPr>
+      <p:grpSpPr/>
+      <p:sp>
+        <p:nvSpPr>
+          <p:cNvPr id="2" name="Text 0"/>
+          <p:cNvSpPr/>
+          <p:nvPr/>
+        </p:nvSpPr>
+        <p:spPr>
+          <a:xfrm>
+            <a:off x="566928" y="384048"/>
+            <a:ext cx="8229600" cy="256032"/>
+          </a:xfrm>
+          <a:prstGeom prst="rect">
+            <a:avLst/>
+          </a:prstGeom>
+          <a:noFill/>
+          <a:ln/>
+        </p:spPr>
+        <p:txBody>
+          <a:bodyPr wrap="square" lIns="0" tIns="0" rIns="0" bIns="0" rtlCol="0" anchor="ctr"/>
+          <a:lstStyle/>
+          <a:p>
+            <a:pPr indent="0" marL="0">
+              <a:buNone/>
+            </a:pPr>
+            <a:r>
+              <a:rPr lang="en-US" sz="1100" b="1" spc="200" kern="0" dirty="0">
+                <a:solidFill>
+                  <a:srgbClr val="F0A429"/>
+                </a:solidFill>
+                <a:latin typeface="Arial" pitchFamily="34" charset="0"/>
+                <a:ea typeface="Arial" pitchFamily="34" charset="-122"/>
+                <a:cs typeface="Arial" pitchFamily="34" charset="-120"/>
+              </a:rPr>
+              <a:t>STEP 4 · MOBILIZATION &amp; DEMOBILIZATION</a:t>
+            </a:r>
+            <a:endParaRPr lang="en-US" sz="1100" dirty="0"/>
+          </a:p>
+        </p:txBody>
+      </p:sp>
+      <p:sp>
+        <p:nvSpPr>
+          <p:cNvPr id="3" name="Text 1"/>
+          <p:cNvSpPr/>
+          <p:nvPr/>
+        </p:nvSpPr>
+        <p:spPr>
+          <a:xfrm>
+            <a:off x="566928" y="694944"/>
+            <a:ext cx="11055096" cy="566928"/>
+          </a:xfrm>
+          <a:prstGeom prst="rect">
+            <a:avLst/>
+          </a:prstGeom>
+          <a:noFill/>
+          <a:ln/>
+        </p:spPr>
+        <p:txBody>
+          <a:bodyPr wrap="square" lIns="0" tIns="0" rIns="0" bIns="0" rtlCol="0" anchor="ctr"/>
+          <a:lstStyle/>
+          <a:p>
+            <a:pPr indent="0" marL="0">
+              <a:buNone/>
+            </a:pPr>
+            <a:r>
+              <a:rPr lang="en-US" sz="3200" b="1" dirty="0">
+                <a:solidFill>
+                  <a:srgbClr val="E6EDF3"/>
+                </a:solidFill>
+                <a:latin typeface="Arial" pitchFamily="34" charset="0"/>
+                <a:ea typeface="Arial" pitchFamily="34" charset="-122"/>
+                <a:cs typeface="Arial" pitchFamily="34" charset="-120"/>
+              </a:rPr>
+              <a:t>The crew that travels, and what it costs</a:t>
+            </a:r>
+            <a:endParaRPr lang="en-US" sz="3200" dirty="0"/>
+          </a:p>
+        </p:txBody>
+      </p:sp>
+      <p:sp>
+        <p:nvSpPr>
+          <p:cNvPr id="4" name="Text 2"/>
+          <p:cNvSpPr/>
+          <p:nvPr/>
+        </p:nvSpPr>
+        <p:spPr>
+          <a:xfrm>
+            <a:off x="566928" y="1298448"/>
+            <a:ext cx="10972800" cy="365760"/>
+          </a:xfrm>
+          <a:prstGeom prst="rect">
+            <a:avLst/>
+          </a:prstGeom>
+          <a:noFill/>
+          <a:ln/>
+        </p:spPr>
+        <p:txBody>
+          <a:bodyPr wrap="square" lIns="0" tIns="0" rIns="0" bIns="0" rtlCol="0" anchor="t"/>
+          <a:lstStyle/>
+          <a:p>
+            <a:pPr algn="l" indent="0" marL="0">
+              <a:lnSpc>
+                <a:spcPts val="2000"/>
+              </a:lnSpc>
+              <a:buNone/>
+            </a:pPr>
+            <a:r>
+              <a:rPr lang="en-US" sz="1400" dirty="0">
+                <a:solidFill>
+                  <a:srgbClr val="9AA4AF"/>
+                </a:solidFill>
+                <a:latin typeface="Calibri" pitchFamily="34" charset="0"/>
+                <a:ea typeface="Calibri" pitchFamily="34" charset="-122"/>
+                <a:cs typeface="Calibri" pitchFamily="34" charset="-120"/>
+              </a:rPr>
+              <a:t>On-site CEs have two cards at the top of the Manpower tab. Each has a manpower table, then its expense lines.</a:t>
+            </a:r>
+            <a:endParaRPr lang="en-US" sz="1400" dirty="0"/>
+          </a:p>
+        </p:txBody>
+      </p:sp>
+      <p:sp>
+        <p:nvSpPr>
+          <p:cNvPr id="5" name="Shape 3"/>
+          <p:cNvSpPr/>
+          <p:nvPr/>
+        </p:nvSpPr>
+        <p:spPr>
+          <a:xfrm>
+            <a:off x="566928" y="1911096"/>
+            <a:ext cx="5532120" cy="3566160"/>
+          </a:xfrm>
+          <a:prstGeom prst="roundRect">
+            <a:avLst>
+              <a:gd name="adj" fmla="val 2051"/>
+            </a:avLst>
+          </a:prstGeom>
+          <a:solidFill>
+            <a:srgbClr val="1C2128"/>
+          </a:solidFill>
+          <a:ln w="12700">
+            <a:solidFill>
+              <a:srgbClr val="30363D"/>
+            </a:solidFill>
+            <a:prstDash val="solid"/>
+          </a:ln>
+          <a:effectLst>
+            <a:outerShdw sx="100000" sy="100000" kx="0" ky="0" algn="bl" rotWithShape="0" blurRad="152400" dist="38100" dir="5400000">
+              <a:srgbClr val="000000">
+                <a:alpha val="45000"/>
+              </a:srgbClr>
+            </a:outerShdw>
+          </a:effectLst>
+        </p:spPr>
+        <p:txBody>
+          <a:bodyPr/>
+          <a:p/>
+        </p:txBody>
+      </p:sp>
+      <p:sp>
+        <p:nvSpPr>
+          <p:cNvPr id="6" name="Text 4"/>
+          <p:cNvSpPr/>
+          <p:nvPr/>
+        </p:nvSpPr>
+        <p:spPr>
+          <a:xfrm>
+            <a:off x="841248" y="2121408"/>
+            <a:ext cx="4937760" cy="329184"/>
+          </a:xfrm>
+          <a:prstGeom prst="rect">
+            <a:avLst/>
+          </a:prstGeom>
+          <a:noFill/>
+          <a:ln/>
+        </p:spPr>
+        <p:txBody>
+          <a:bodyPr wrap="square" lIns="0" tIns="0" rIns="0" bIns="0" rtlCol="0" anchor="ctr"/>
+          <a:lstStyle/>
+          <a:p>
+            <a:pPr indent="0" marL="0">
+              <a:buNone/>
+            </a:pPr>
+            <a:r>
+              <a:rPr lang="en-US" sz="1700" b="1" dirty="0">
+                <a:solidFill>
+                  <a:srgbClr val="A78BFA"/>
+                </a:solidFill>
+                <a:latin typeface="Arial" pitchFamily="34" charset="0"/>
+                <a:ea typeface="Arial" pitchFamily="34" charset="-122"/>
+                <a:cs typeface="Arial" pitchFamily="34" charset="-120"/>
+              </a:rPr>
+              <a:t>Manpower, linked to the SOW Breakdown</a:t>
+            </a:r>
+            <a:endParaRPr lang="en-US" sz="1700" dirty="0"/>
+          </a:p>
+        </p:txBody>
+      </p:sp>
+      <p:sp>
+        <p:nvSpPr>
+          <p:cNvPr id="7" name="Text 5"/>
+          <p:cNvSpPr/>
+          <p:nvPr/>
+        </p:nvSpPr>
+        <p:spPr>
+          <a:xfrm>
+            <a:off x="841248" y="2578608"/>
+            <a:ext cx="4983480" cy="2651760"/>
+          </a:xfrm>
+          <a:prstGeom prst="rect">
+            <a:avLst/>
+          </a:prstGeom>
+          <a:noFill/>
+          <a:ln/>
+        </p:spPr>
+        <p:txBody>
+          <a:bodyPr wrap="square" lIns="0" tIns="0" rIns="0" bIns="0" rtlCol="0" anchor="t"/>
+          <a:lstStyle/>
+          <a:p>
+            <a:pPr marL="342900" indent="-342900">
+              <a:lnSpc>
+                <a:spcPts val="1600"/>
+              </a:lnSpc>
+              <a:spcAft>
+                <a:spcPts val="900"/>
+              </a:spcAft>
+              <a:buSzPct val="100000"/>
+              <a:buChar char="●"/>
+            </a:pPr>
+            <a:r>
+              <a:rPr lang="en-US" sz="1200" dirty="0">
+                <a:solidFill>
+                  <a:srgbClr val="E6EDF3"/>
+                </a:solidFill>
+                <a:latin typeface="Calibri" pitchFamily="34" charset="0"/>
+                <a:ea typeface="Calibri" pitchFamily="34" charset="-122"/>
+                <a:cs typeface="Calibri" pitchFamily="34" charset="-120"/>
+              </a:rPr>
+              <a:t>⟳ Crew from SOW Breakdown adds one SOW-tagged line per role and keeps it in step with the Manpower tab</a:t>
+            </a:r>
+            <a:endParaRPr lang="en-US" sz="1200" dirty="0"/>
+          </a:p>
+          <a:p>
+            <a:pPr marL="342900" indent="-342900">
+              <a:lnSpc>
+                <a:spcPts val="1600"/>
+              </a:lnSpc>
+              <a:spcAft>
+                <a:spcPts val="900"/>
+              </a:spcAft>
+              <a:buSzPct val="100000"/>
+              <a:buChar char="●"/>
+            </a:pPr>
+            <a:r>
+              <a:rPr lang="en-US" sz="1200" dirty="0">
+                <a:solidFill>
+                  <a:srgbClr val="E6EDF3"/>
+                </a:solidFill>
+                <a:latin typeface="Calibri" pitchFamily="34" charset="0"/>
+                <a:ea typeface="Calibri" pitchFamily="34" charset="-122"/>
+                <a:cs typeface="Calibri" pitchFamily="34" charset="-120"/>
+              </a:rPr>
+              <a:t>PAX is the most on any day shift plus any night shift — 4 welders on two tasks is 4, not 8</a:t>
+            </a:r>
+            <a:endParaRPr lang="en-US" sz="1200" dirty="0"/>
+          </a:p>
+          <a:p>
+            <a:pPr marL="342900" indent="-342900">
+              <a:lnSpc>
+                <a:spcPts val="1600"/>
+              </a:lnSpc>
+              <a:spcAft>
+                <a:spcPts val="900"/>
+              </a:spcAft>
+              <a:buSzPct val="100000"/>
+              <a:buChar char="●"/>
+            </a:pPr>
+            <a:r>
+              <a:rPr lang="en-US" sz="1200" dirty="0">
+                <a:solidFill>
+                  <a:srgbClr val="E6EDF3"/>
+                </a:solidFill>
+                <a:latin typeface="Calibri" pitchFamily="34" charset="0"/>
+                <a:ea typeface="Calibri" pitchFamily="34" charset="-122"/>
+                <a:cs typeface="Calibri" pitchFamily="34" charset="-120"/>
+              </a:rPr>
+              <a:t>Type over Pax or Rate if travel differs (orange box); ↺ follows the crew again. Days and OT are yours</a:t>
+            </a:r>
+            <a:endParaRPr lang="en-US" sz="1200" dirty="0"/>
+          </a:p>
+          <a:p>
+            <a:pPr marL="342900" indent="-342900">
+              <a:lnSpc>
+                <a:spcPts val="1600"/>
+              </a:lnSpc>
+              <a:spcAft>
+                <a:spcPts val="900"/>
+              </a:spcAft>
+              <a:buSzPct val="100000"/>
+              <a:buChar char="●"/>
+            </a:pPr>
+            <a:r>
+              <a:rPr lang="en-US" sz="1200" dirty="0">
+                <a:solidFill>
+                  <a:srgbClr val="E6EDF3"/>
+                </a:solidFill>
+                <a:latin typeface="Calibri" pitchFamily="34" charset="0"/>
+                <a:ea typeface="Calibri" pitchFamily="34" charset="-122"/>
+                <a:cs typeface="Calibri" pitchFamily="34" charset="-120"/>
+              </a:rPr>
+              <a:t>+ Add Manpower for anyone who is not on the Manpower tab</a:t>
+            </a:r>
+            <a:endParaRPr lang="en-US" sz="1200" dirty="0"/>
+          </a:p>
+        </p:txBody>
+      </p:sp>
+      <p:sp>
+        <p:nvSpPr>
+          <p:cNvPr id="8" name="Shape 6"/>
+          <p:cNvSpPr/>
+          <p:nvPr/>
+        </p:nvSpPr>
+        <p:spPr>
+          <a:xfrm>
+            <a:off x="6400800" y="1911096"/>
+            <a:ext cx="5221224" cy="3566160"/>
+          </a:xfrm>
+          <a:prstGeom prst="roundRect">
+            <a:avLst>
+              <a:gd name="adj" fmla="val 2051"/>
+            </a:avLst>
+          </a:prstGeom>
+          <a:solidFill>
+            <a:srgbClr val="1C2128"/>
+          </a:solidFill>
+          <a:ln w="12700">
+            <a:solidFill>
+              <a:srgbClr val="30363D"/>
+            </a:solidFill>
+            <a:prstDash val="solid"/>
+          </a:ln>
+          <a:effectLst>
+            <a:outerShdw sx="100000" sy="100000" kx="0" ky="0" algn="bl" rotWithShape="0" blurRad="152400" dist="38100" dir="5400000">
+              <a:srgbClr val="000000">
+                <a:alpha val="45000"/>
+              </a:srgbClr>
+            </a:outerShdw>
+          </a:effectLst>
+        </p:spPr>
+        <p:txBody>
+          <a:bodyPr/>
+          <a:p/>
+        </p:txBody>
+      </p:sp>
+      <p:sp>
+        <p:nvSpPr>
+          <p:cNvPr id="9" name="Text 7"/>
+          <p:cNvSpPr/>
+          <p:nvPr/>
+        </p:nvSpPr>
+        <p:spPr>
+          <a:xfrm>
+            <a:off x="6675120" y="2121408"/>
+            <a:ext cx="4663440" cy="329184"/>
+          </a:xfrm>
+          <a:prstGeom prst="rect">
+            <a:avLst/>
+          </a:prstGeom>
+          <a:noFill/>
+          <a:ln/>
+        </p:spPr>
+        <p:txBody>
+          <a:bodyPr wrap="square" lIns="0" tIns="0" rIns="0" bIns="0" rtlCol="0" anchor="ctr"/>
+          <a:lstStyle/>
+          <a:p>
+            <a:pPr indent="0" marL="0">
+              <a:buNone/>
+            </a:pPr>
+            <a:r>
+              <a:rPr lang="en-US" sz="1700" b="1" dirty="0">
+                <a:solidFill>
+                  <a:srgbClr val="F0A429"/>
+                </a:solidFill>
+                <a:latin typeface="Arial" pitchFamily="34" charset="0"/>
+                <a:ea typeface="Arial" pitchFamily="34" charset="-122"/>
+                <a:cs typeface="Arial" pitchFamily="34" charset="-120"/>
+              </a:rPr>
+              <a:t>On the printed CE</a:t>
+            </a:r>
+            <a:endParaRPr lang="en-US" sz="1700" dirty="0"/>
+          </a:p>
+        </p:txBody>
+      </p:sp>
+      <p:sp>
+        <p:nvSpPr>
+          <p:cNvPr id="10" name="Text 8"/>
+          <p:cNvSpPr/>
+          <p:nvPr/>
+        </p:nvSpPr>
+        <p:spPr>
+          <a:xfrm>
+            <a:off x="6675120" y="2578608"/>
+            <a:ext cx="4709160" cy="2651760"/>
+          </a:xfrm>
+          <a:prstGeom prst="rect">
+            <a:avLst/>
+          </a:prstGeom>
+          <a:noFill/>
+          <a:ln/>
+        </p:spPr>
+        <p:txBody>
+          <a:bodyPr wrap="square" lIns="0" tIns="0" rIns="0" bIns="0" rtlCol="0" anchor="t"/>
+          <a:lstStyle/>
+          <a:p>
+            <a:pPr marL="342900" indent="-342900">
+              <a:lnSpc>
+                <a:spcPts val="1600"/>
+              </a:lnSpc>
+              <a:spcAft>
+                <a:spcPts val="900"/>
+              </a:spcAft>
+              <a:buSzPct val="100000"/>
+              <a:buChar char="●"/>
+            </a:pPr>
+            <a:r>
+              <a:rPr lang="en-US" sz="1200" dirty="0">
+                <a:solidFill>
+                  <a:srgbClr val="E6EDF3"/>
+                </a:solidFill>
+                <a:latin typeface="Calibri" pitchFamily="34" charset="0"/>
+                <a:ea typeface="Calibri" pitchFamily="34" charset="-122"/>
+                <a:cs typeface="Calibri" pitchFamily="34" charset="-120"/>
+              </a:rPr>
+              <a:t>MOBILIZATION and DEMOBILIZATION are rows A and B of the cost summary</a:t>
+            </a:r>
+            <a:endParaRPr lang="en-US" sz="1200" dirty="0"/>
+          </a:p>
+          <a:p>
+            <a:pPr marL="342900" indent="-342900">
+              <a:lnSpc>
+                <a:spcPts val="1600"/>
+              </a:lnSpc>
+              <a:spcAft>
+                <a:spcPts val="900"/>
+              </a:spcAft>
+              <a:buSzPct val="100000"/>
+              <a:buChar char="●"/>
+            </a:pPr>
+            <a:r>
+              <a:rPr lang="en-US" sz="1200" dirty="0">
+                <a:solidFill>
+                  <a:srgbClr val="E6EDF3"/>
+                </a:solidFill>
+                <a:latin typeface="Calibri" pitchFamily="34" charset="0"/>
+                <a:ea typeface="Calibri" pitchFamily="34" charset="-122"/>
+                <a:cs typeface="Calibri" pitchFamily="34" charset="-120"/>
+              </a:rPr>
+              <a:t>Their section prints first: manpower with a SUB TOTAL of pax, then the charges</a:t>
+            </a:r>
+            <a:endParaRPr lang="en-US" sz="1200" dirty="0"/>
+          </a:p>
+          <a:p>
+            <a:pPr marL="342900" indent="-342900">
+              <a:lnSpc>
+                <a:spcPts val="1600"/>
+              </a:lnSpc>
+              <a:spcAft>
+                <a:spcPts val="900"/>
+              </a:spcAft>
+              <a:buSzPct val="100000"/>
+              <a:buChar char="●"/>
+            </a:pPr>
+            <a:r>
+              <a:rPr lang="en-US" sz="1200" dirty="0">
+                <a:solidFill>
+                  <a:srgbClr val="E6EDF3"/>
+                </a:solidFill>
+                <a:latin typeface="Calibri" pitchFamily="34" charset="0"/>
+                <a:ea typeface="Calibri" pitchFamily="34" charset="-122"/>
+                <a:cs typeface="Calibri" pitchFamily="34" charset="-120"/>
+              </a:rPr>
+              <a:t>Every manpower SUB TOTAL shows pax; C.7 ends with TOTAL MANPOWER</a:t>
+            </a:r>
+            <a:endParaRPr lang="en-US" sz="1200" dirty="0"/>
+          </a:p>
+          <a:p>
+            <a:pPr marL="342900" indent="-342900">
+              <a:lnSpc>
+                <a:spcPts val="1600"/>
+              </a:lnSpc>
+              <a:spcAft>
+                <a:spcPts val="900"/>
+              </a:spcAft>
+              <a:buSzPct val="100000"/>
+              <a:buChar char="●"/>
+            </a:pPr>
+            <a:r>
+              <a:rPr lang="en-US" sz="1200" dirty="0">
+                <a:solidFill>
+                  <a:srgbClr val="E6EDF3"/>
+                </a:solidFill>
+                <a:latin typeface="Calibri" pitchFamily="34" charset="0"/>
+                <a:ea typeface="Calibri" pitchFamily="34" charset="-122"/>
+                <a:cs typeface="Calibri" pitchFamily="34" charset="-120"/>
+              </a:rPr>
+              <a:t>Both Excel exports carry a Mobilization sheet</a:t>
+            </a:r>
+            <a:endParaRPr lang="en-US" sz="1200" dirty="0"/>
+          </a:p>
+        </p:txBody>
+      </p:sp>
+      <p:sp>
+        <p:nvSpPr>
+          <p:cNvPr id="11" name="Text 9"/>
+          <p:cNvSpPr/>
+          <p:nvPr/>
+        </p:nvSpPr>
+        <p:spPr>
+          <a:xfrm>
+            <a:off x="566928" y="6437376"/>
+            <a:ext cx="5486400" cy="237744"/>
+          </a:xfrm>
+          <a:prstGeom prst="rect">
+            <a:avLst/>
+          </a:prstGeom>
+          <a:noFill/>
+          <a:ln/>
+        </p:spPr>
+        <p:txBody>
+          <a:bodyPr wrap="square" lIns="0" tIns="0" rIns="0" bIns="0" rtlCol="0" anchor="ctr"/>
+          <a:lstStyle/>
+          <a:p>
+            <a:pPr indent="0" marL="0">
+              <a:buNone/>
+            </a:pPr>
+            <a:r>
+              <a:rPr lang="en-US" sz="900" dirty="0">
+                <a:solidFill>
+                  <a:srgbClr val="6E7681"/>
+                </a:solidFill>
+                <a:latin typeface="Calibri" pitchFamily="34" charset="0"/>
+                <a:ea typeface="Calibri" pitchFamily="34" charset="-122"/>
+                <a:cs typeface="Calibri" pitchFamily="34" charset="-120"/>
+              </a:rPr>
+              <a:t>SHIC Cost Estimator — End-User Manual</a:t>
+            </a:r>
+            <a:endParaRPr lang="en-US" sz="900" dirty="0"/>
+          </a:p>
+        </p:txBody>
+      </p:sp>
+      <p:sp>
+        <p:nvSpPr>
+          <p:cNvPr id="12" name="Text 10"/>
+          <p:cNvSpPr/>
+          <p:nvPr/>
+        </p:nvSpPr>
+        <p:spPr>
+          <a:xfrm>
+            <a:off x="10981944" y="6437376"/>
+            <a:ext cx="640080" cy="237744"/>
+          </a:xfrm>
+          <a:prstGeom prst="rect">
+            <a:avLst/>
+          </a:prstGeom>
+          <a:noFill/>
+          <a:ln/>
+        </p:spPr>
+        <p:txBody>
+          <a:bodyPr wrap="square" lIns="0" tIns="0" rIns="0" bIns="0" rtlCol="0" anchor="ctr"/>
+          <a:lstStyle/>
+          <a:p>
+            <a:pPr algn="r" indent="0" marL="0">
+              <a:buNone/>
+            </a:pPr>
+            <a:r>
+              <a:rPr lang="en-US" sz="900" dirty="0">
+                <a:solidFill>
+                  <a:srgbClr val="6E7681"/>
+                </a:solidFill>
+                <a:latin typeface="Calibri" pitchFamily="34" charset="0"/>
+                <a:ea typeface="Calibri" pitchFamily="34" charset="-122"/>
+                <a:cs typeface="Calibri" pitchFamily="34" charset="-120"/>
+              </a:rPr>
+              <a:t>12</a:t>
+            </a:r>
+            <a:endParaRPr lang="en-US" sz="900" dirty="0"/>
+          </a:p>
+        </p:txBody>
+      </p:sp>
+    </p:spTree>
+  </p:cSld>
+  <p:clrMapOvr>
+    <a:masterClrMapping/>
+  </p:clrMapOvr>
+</p:sld>
+</file>
+
+<file path=ppt/slides/slide29.xml><?xml version="1.0" encoding="utf-8"?>
+<p:sld xmlns:a="http://schemas.openxmlformats.org/drawingml/2006/main" xmlns:p="http://schemas.openxmlformats.org/presentationml/2006/main" xmlns:r="http://schemas.openxmlformats.org/officeDocument/2006/relationships">
+  <p:cSld>
+    <p:bg>
+      <p:bgPr>
+        <a:solidFill>
+          <a:srgbClr val="0D1117"/>
+        </a:solidFill>
+      </p:bgPr>
+    </p:bg>
+    <p:spTree>
+      <p:nvGrpSpPr>
+        <p:cNvPr id="1" name=""/>
+        <p:cNvGrpSpPr/>
+        <p:nvPr/>
+      </p:nvGrpSpPr>
+      <p:grpSpPr/>
+      <p:sp>
+        <p:nvSpPr>
+          <p:cNvPr id="2" name="Text 0"/>
+          <p:cNvSpPr/>
+          <p:nvPr/>
+        </p:nvSpPr>
+        <p:spPr>
+          <a:xfrm>
+            <a:off x="566928" y="384048"/>
+            <a:ext cx="8229600" cy="256032"/>
+          </a:xfrm>
+          <a:prstGeom prst="rect">
+            <a:avLst/>
+          </a:prstGeom>
+          <a:noFill/>
+          <a:ln/>
+        </p:spPr>
+        <p:txBody>
+          <a:bodyPr wrap="square" lIns="0" tIns="0" rIns="0" bIns="0" rtlCol="0" anchor="ctr"/>
+          <a:lstStyle/>
+          <a:p>
+            <a:pPr indent="0" marL="0">
+              <a:buNone/>
+            </a:pPr>
+            <a:r>
+              <a:rPr lang="en-US" sz="1100" b="1" spc="200" kern="0" dirty="0">
+                <a:solidFill>
+                  <a:srgbClr val="F0A429"/>
+                </a:solidFill>
+                <a:latin typeface="Arial" pitchFamily="34" charset="0"/>
+                <a:ea typeface="Arial" pitchFamily="34" charset="-122"/>
+                <a:cs typeface="Arial" pitchFamily="34" charset="-120"/>
+              </a:rPr>
+              <a:t>STEP 4 · FOOD ALLOWANCE</a:t>
+            </a:r>
+            <a:endParaRPr lang="en-US" sz="1100" dirty="0"/>
+          </a:p>
+        </p:txBody>
+      </p:sp>
+      <p:sp>
+        <p:nvSpPr>
+          <p:cNvPr id="3" name="Text 1"/>
+          <p:cNvSpPr/>
+          <p:nvPr/>
+        </p:nvSpPr>
+        <p:spPr>
+          <a:xfrm>
+            <a:off x="566928" y="694944"/>
+            <a:ext cx="11055096" cy="566928"/>
+          </a:xfrm>
+          <a:prstGeom prst="rect">
+            <a:avLst/>
+          </a:prstGeom>
+          <a:noFill/>
+          <a:ln/>
+        </p:spPr>
+        <p:txBody>
+          <a:bodyPr wrap="square" lIns="0" tIns="0" rIns="0" bIns="0" rtlCol="0" anchor="ctr"/>
+          <a:lstStyle/>
+          <a:p>
+            <a:pPr indent="0" marL="0">
+              <a:buNone/>
+            </a:pPr>
+            <a:r>
+              <a:rPr lang="en-US" sz="3200" b="1" dirty="0">
+                <a:solidFill>
+                  <a:srgbClr val="E6EDF3"/>
+                </a:solidFill>
+                <a:latin typeface="Arial" pitchFamily="34" charset="0"/>
+                <a:ea typeface="Arial" pitchFamily="34" charset="-122"/>
+                <a:cs typeface="Arial" pitchFamily="34" charset="-120"/>
+              </a:rPr>
+              <a:t>Three rates, counted from the crew</a:t>
+            </a:r>
+            <a:endParaRPr lang="en-US" sz="3200" dirty="0"/>
+          </a:p>
+        </p:txBody>
+      </p:sp>
+      <p:sp>
+        <p:nvSpPr>
+          <p:cNvPr id="4" name="Text 2"/>
+          <p:cNvSpPr/>
+          <p:nvPr/>
+        </p:nvSpPr>
+        <p:spPr>
+          <a:xfrm>
+            <a:off x="566928" y="1298448"/>
+            <a:ext cx="10972800" cy="365760"/>
+          </a:xfrm>
+          <a:prstGeom prst="rect">
+            <a:avLst/>
+          </a:prstGeom>
+          <a:noFill/>
+          <a:ln/>
+        </p:spPr>
+        <p:txBody>
+          <a:bodyPr wrap="square" lIns="0" tIns="0" rIns="0" bIns="0" rtlCol="0" anchor="t"/>
+          <a:lstStyle/>
+          <a:p>
+            <a:pPr algn="l" indent="0" marL="0">
+              <a:lnSpc>
+                <a:spcPts val="2000"/>
+              </a:lnSpc>
+              <a:buNone/>
+            </a:pPr>
+            <a:r>
+              <a:rPr lang="en-US" sz="1400" dirty="0">
+                <a:solidFill>
+                  <a:srgbClr val="9AA4AF"/>
+                </a:solidFill>
+                <a:latin typeface="Calibri" pitchFamily="34" charset="0"/>
+                <a:ea typeface="Calibri" pitchFamily="34" charset="-122"/>
+                <a:cs typeface="Calibri" pitchFamily="34" charset="-120"/>
+              </a:rPr>
+              <a:t>Project manager, admin and skilled manpower are paid different meal allowances. The app counts heads for each rate.</a:t>
+            </a:r>
+            <a:endParaRPr lang="en-US" sz="1400" dirty="0"/>
+          </a:p>
+        </p:txBody>
+      </p:sp>
+      <p:sp>
+        <p:nvSpPr>
+          <p:cNvPr id="5" name="Shape 3"/>
+          <p:cNvSpPr/>
+          <p:nvPr/>
+        </p:nvSpPr>
+        <p:spPr>
+          <a:xfrm>
+            <a:off x="566928" y="1911096"/>
+            <a:ext cx="5532120" cy="3566160"/>
+          </a:xfrm>
+          <a:prstGeom prst="roundRect">
+            <a:avLst>
+              <a:gd name="adj" fmla="val 2051"/>
+            </a:avLst>
+          </a:prstGeom>
+          <a:solidFill>
+            <a:srgbClr val="1C2128"/>
+          </a:solidFill>
+          <a:ln w="12700">
+            <a:solidFill>
+              <a:srgbClr val="30363D"/>
+            </a:solidFill>
+            <a:prstDash val="solid"/>
+          </a:ln>
+          <a:effectLst>
+            <a:outerShdw sx="100000" sy="100000" kx="0" ky="0" algn="bl" rotWithShape="0" blurRad="152400" dist="38100" dir="5400000">
+              <a:srgbClr val="000000">
+                <a:alpha val="45000"/>
+              </a:srgbClr>
+            </a:outerShdw>
+          </a:effectLst>
+        </p:spPr>
+        <p:txBody>
+          <a:bodyPr/>
+          <a:p/>
+        </p:txBody>
+      </p:sp>
+      <p:sp>
+        <p:nvSpPr>
+          <p:cNvPr id="6" name="Text 4"/>
+          <p:cNvSpPr/>
+          <p:nvPr/>
+        </p:nvSpPr>
+        <p:spPr>
+          <a:xfrm>
+            <a:off x="841248" y="2121408"/>
+            <a:ext cx="4937760" cy="329184"/>
+          </a:xfrm>
+          <a:prstGeom prst="rect">
+            <a:avLst/>
+          </a:prstGeom>
+          <a:noFill/>
+          <a:ln/>
+        </p:spPr>
+        <p:txBody>
+          <a:bodyPr wrap="square" lIns="0" tIns="0" rIns="0" bIns="0" rtlCol="0" anchor="ctr"/>
+          <a:lstStyle/>
+          <a:p>
+            <a:pPr indent="0" marL="0">
+              <a:buNone/>
+            </a:pPr>
+            <a:r>
+              <a:rPr lang="en-US" sz="1700" b="1" dirty="0">
+                <a:solidFill>
+                  <a:srgbClr val="A78BFA"/>
+                </a:solidFill>
+                <a:latin typeface="Arial" pitchFamily="34" charset="0"/>
+                <a:ea typeface="Arial" pitchFamily="34" charset="-122"/>
+                <a:cs typeface="Arial" pitchFamily="34" charset="-120"/>
+              </a:rPr>
+              <a:t>Where it is counted</a:t>
+            </a:r>
+            <a:endParaRPr lang="en-US" sz="1700" dirty="0"/>
+          </a:p>
+        </p:txBody>
+      </p:sp>
+      <p:sp>
+        <p:nvSpPr>
+          <p:cNvPr id="7" name="Text 5"/>
+          <p:cNvSpPr/>
+          <p:nvPr/>
+        </p:nvSpPr>
+        <p:spPr>
+          <a:xfrm>
+            <a:off x="841248" y="2578608"/>
+            <a:ext cx="4983480" cy="2651760"/>
+          </a:xfrm>
+          <a:prstGeom prst="rect">
+            <a:avLst/>
+          </a:prstGeom>
+          <a:noFill/>
+          <a:ln/>
+        </p:spPr>
+        <p:txBody>
+          <a:bodyPr wrap="square" lIns="0" tIns="0" rIns="0" bIns="0" rtlCol="0" anchor="t"/>
+          <a:lstStyle/>
+          <a:p>
+            <a:pPr marL="342900" indent="-342900">
+              <a:lnSpc>
+                <a:spcPts val="1600"/>
+              </a:lnSpc>
+              <a:spcAft>
+                <a:spcPts val="900"/>
+              </a:spcAft>
+              <a:buSzPct val="100000"/>
+              <a:buChar char="●"/>
+            </a:pPr>
+            <a:r>
+              <a:rPr lang="en-US" sz="1200" dirty="0">
+                <a:solidFill>
+                  <a:srgbClr val="E6EDF3"/>
+                </a:solidFill>
+                <a:latin typeface="Calibri" pitchFamily="34" charset="0"/>
+                <a:ea typeface="Calibri" pitchFamily="34" charset="-122"/>
+                <a:cs typeface="Calibri" pitchFamily="34" charset="-120"/>
+              </a:rPr>
+              <a:t>Mob / Demob: added with the crew — the pax who travel × the travel days</a:t>
+            </a:r>
+            <a:endParaRPr lang="en-US" sz="1200" dirty="0"/>
+          </a:p>
+          <a:p>
+            <a:pPr marL="342900" indent="-342900">
+              <a:lnSpc>
+                <a:spcPts val="1600"/>
+              </a:lnSpc>
+              <a:spcAft>
+                <a:spcPts val="900"/>
+              </a:spcAft>
+              <a:buSzPct val="100000"/>
+              <a:buChar char="●"/>
+            </a:pPr>
+            <a:r>
+              <a:rPr lang="en-US" sz="1200" dirty="0">
+                <a:solidFill>
+                  <a:srgbClr val="E6EDF3"/>
+                </a:solidFill>
+                <a:latin typeface="Calibri" pitchFamily="34" charset="0"/>
+                <a:ea typeface="Calibri" pitchFamily="34" charset="-122"/>
+                <a:cs typeface="Calibri" pitchFamily="34" charset="-120"/>
+              </a:rPr>
+              <a:t>Accommodation: 🍽 Food allowance from crew — each role and shift a sub-item, pax × days worked</a:t>
+            </a:r>
+            <a:endParaRPr lang="en-US" sz="1200" dirty="0"/>
+          </a:p>
+          <a:p>
+            <a:pPr marL="342900" indent="-342900">
+              <a:lnSpc>
+                <a:spcPts val="1600"/>
+              </a:lnSpc>
+              <a:spcAft>
+                <a:spcPts val="900"/>
+              </a:spcAft>
+              <a:buSzPct val="100000"/>
+              <a:buChar char="●"/>
+            </a:pPr>
+            <a:r>
+              <a:rPr lang="en-US" sz="1200" dirty="0">
+                <a:solidFill>
+                  <a:srgbClr val="E6EDF3"/>
+                </a:solidFill>
+                <a:latin typeface="Calibri" pitchFamily="34" charset="0"/>
+                <a:ea typeface="Calibri" pitchFamily="34" charset="-122"/>
+                <a:cs typeface="Calibri" pitchFamily="34" charset="-120"/>
+              </a:rPr>
+              <a:t>Lines tagged CREW follow the Manpower; delete them to stop</a:t>
+            </a:r>
+            <a:endParaRPr lang="en-US" sz="1200" dirty="0"/>
+          </a:p>
+          <a:p>
+            <a:pPr marL="342900" indent="-342900">
+              <a:lnSpc>
+                <a:spcPts val="1600"/>
+              </a:lnSpc>
+              <a:spcAft>
+                <a:spcPts val="900"/>
+              </a:spcAft>
+              <a:buSzPct val="100000"/>
+              <a:buChar char="●"/>
+            </a:pPr>
+            <a:r>
+              <a:rPr lang="en-US" sz="1200" dirty="0">
+                <a:solidFill>
+                  <a:srgbClr val="E6EDF3"/>
+                </a:solidFill>
+                <a:latin typeface="Calibri" pitchFamily="34" charset="0"/>
+                <a:ea typeface="Calibri" pitchFamily="34" charset="-122"/>
+                <a:cs typeface="Calibri" pitchFamily="34" charset="-120"/>
+              </a:rPr>
+              <a:t>Each role’s rate is set in the Masterlist Food Allowance column; Auto guesses from the name</a:t>
+            </a:r>
+            <a:endParaRPr lang="en-US" sz="1200" dirty="0"/>
+          </a:p>
+        </p:txBody>
+      </p:sp>
+      <p:sp>
+        <p:nvSpPr>
+          <p:cNvPr id="8" name="Shape 6"/>
+          <p:cNvSpPr/>
+          <p:nvPr/>
+        </p:nvSpPr>
+        <p:spPr>
+          <a:xfrm>
+            <a:off x="6400800" y="1911096"/>
+            <a:ext cx="5221224" cy="3566160"/>
+          </a:xfrm>
+          <a:prstGeom prst="roundRect">
+            <a:avLst>
+              <a:gd name="adj" fmla="val 2051"/>
+            </a:avLst>
+          </a:prstGeom>
+          <a:solidFill>
+            <a:srgbClr val="1C2128"/>
+          </a:solidFill>
+          <a:ln w="12700">
+            <a:solidFill>
+              <a:srgbClr val="30363D"/>
+            </a:solidFill>
+            <a:prstDash val="solid"/>
+          </a:ln>
+          <a:effectLst>
+            <a:outerShdw sx="100000" sy="100000" kx="0" ky="0" algn="bl" rotWithShape="0" blurRad="152400" dist="38100" dir="5400000">
+              <a:srgbClr val="000000">
+                <a:alpha val="45000"/>
+              </a:srgbClr>
+            </a:outerShdw>
+          </a:effectLst>
+        </p:spPr>
+        <p:txBody>
+          <a:bodyPr/>
+          <a:p/>
+        </p:txBody>
+      </p:sp>
+      <p:sp>
+        <p:nvSpPr>
+          <p:cNvPr id="9" name="Text 7"/>
+          <p:cNvSpPr/>
+          <p:nvPr/>
+        </p:nvSpPr>
+        <p:spPr>
+          <a:xfrm>
+            <a:off x="6675120" y="2121408"/>
+            <a:ext cx="4663440" cy="329184"/>
+          </a:xfrm>
+          <a:prstGeom prst="rect">
+            <a:avLst/>
+          </a:prstGeom>
+          <a:noFill/>
+          <a:ln/>
+        </p:spPr>
+        <p:txBody>
+          <a:bodyPr wrap="square" lIns="0" tIns="0" rIns="0" bIns="0" rtlCol="0" anchor="ctr"/>
+          <a:lstStyle/>
+          <a:p>
+            <a:pPr indent="0" marL="0">
+              <a:buNone/>
+            </a:pPr>
+            <a:r>
+              <a:rPr lang="en-US" sz="1700" b="1" dirty="0">
+                <a:solidFill>
+                  <a:srgbClr val="F0A429"/>
+                </a:solidFill>
+                <a:latin typeface="Arial" pitchFamily="34" charset="0"/>
+                <a:ea typeface="Arial" pitchFamily="34" charset="-122"/>
+                <a:cs typeface="Arial" pitchFamily="34" charset="-120"/>
+              </a:rPr>
+              <a:t>Keeping the rates right</a:t>
+            </a:r>
+            <a:endParaRPr lang="en-US" sz="1700" dirty="0"/>
+          </a:p>
+        </p:txBody>
+      </p:sp>
+      <p:sp>
+        <p:nvSpPr>
+          <p:cNvPr id="10" name="Text 8"/>
+          <p:cNvSpPr/>
+          <p:nvPr/>
+        </p:nvSpPr>
+        <p:spPr>
+          <a:xfrm>
+            <a:off x="6675120" y="2578608"/>
+            <a:ext cx="4709160" cy="2651760"/>
+          </a:xfrm>
+          <a:prstGeom prst="rect">
+            <a:avLst/>
+          </a:prstGeom>
+          <a:noFill/>
+          <a:ln/>
+        </p:spPr>
+        <p:txBody>
+          <a:bodyPr wrap="square" lIns="0" tIns="0" rIns="0" bIns="0" rtlCol="0" anchor="t"/>
+          <a:lstStyle/>
+          <a:p>
+            <a:pPr marL="342900" indent="-342900">
+              <a:lnSpc>
+                <a:spcPts val="1600"/>
+              </a:lnSpc>
+              <a:spcAft>
+                <a:spcPts val="900"/>
+              </a:spcAft>
+              <a:buSzPct val="100000"/>
+              <a:buChar char="●"/>
+            </a:pPr>
+            <a:r>
+              <a:rPr lang="en-US" sz="1200" dirty="0">
+                <a:solidFill>
+                  <a:srgbClr val="E6EDF3"/>
+                </a:solidFill>
+                <a:latin typeface="Calibri" pitchFamily="34" charset="0"/>
+                <a:ea typeface="Calibri" pitchFamily="34" charset="-122"/>
+                <a:cs typeface="Calibri" pitchFamily="34" charset="-120"/>
+              </a:rPr>
+              <a:t>Rates are the Masterlist → Miscellaneous items MEAL ALLOWANCE (PM), (ADMIN), (SKILLED MANPOWER)</a:t>
+            </a:r>
+            <a:endParaRPr lang="en-US" sz="1200" dirty="0"/>
+          </a:p>
+          <a:p>
+            <a:pPr marL="342900" indent="-342900">
+              <a:lnSpc>
+                <a:spcPts val="1600"/>
+              </a:lnSpc>
+              <a:spcAft>
+                <a:spcPts val="900"/>
+              </a:spcAft>
+              <a:buSzPct val="100000"/>
+              <a:buChar char="●"/>
+            </a:pPr>
+            <a:r>
+              <a:rPr lang="en-US" sz="1200" dirty="0">
+                <a:solidFill>
+                  <a:srgbClr val="E6EDF3"/>
+                </a:solidFill>
+                <a:latin typeface="Calibri" pitchFamily="34" charset="0"/>
+                <a:ea typeface="Calibri" pitchFamily="34" charset="-122"/>
+                <a:cs typeface="Calibri" pitchFamily="34" charset="-120"/>
+              </a:rPr>
+              <a:t>A new line takes today’s rate; a saved CE keeps what it was quoted at</a:t>
+            </a:r>
+            <a:endParaRPr lang="en-US" sz="1200" dirty="0"/>
+          </a:p>
+          <a:p>
+            <a:pPr marL="342900" indent="-342900">
+              <a:lnSpc>
+                <a:spcPts val="1600"/>
+              </a:lnSpc>
+              <a:spcAft>
+                <a:spcPts val="900"/>
+              </a:spcAft>
+              <a:buSzPct val="100000"/>
+              <a:buChar char="●"/>
+            </a:pPr>
+            <a:r>
+              <a:rPr lang="en-US" sz="1200" dirty="0">
+                <a:solidFill>
+                  <a:srgbClr val="E6EDF3"/>
+                </a:solidFill>
+                <a:latin typeface="Calibri" pitchFamily="34" charset="0"/>
+                <a:ea typeface="Calibri" pitchFamily="34" charset="-122"/>
+                <a:cs typeface="Calibri" pitchFamily="34" charset="-120"/>
+              </a:rPr>
+              <a:t>↺ Sync meal rates moves every meal line on the open CE to the current rate</a:t>
+            </a:r>
+            <a:endParaRPr lang="en-US" sz="1200" dirty="0"/>
+          </a:p>
+          <a:p>
+            <a:pPr marL="342900" indent="-342900">
+              <a:lnSpc>
+                <a:spcPts val="1600"/>
+              </a:lnSpc>
+              <a:spcAft>
+                <a:spcPts val="900"/>
+              </a:spcAft>
+              <a:buSzPct val="100000"/>
+              <a:buChar char="●"/>
+            </a:pPr>
+            <a:r>
+              <a:rPr lang="en-US" sz="1200" dirty="0">
+                <a:solidFill>
+                  <a:srgbClr val="E6EDF3"/>
+                </a:solidFill>
+                <a:latin typeface="Calibri" pitchFamily="34" charset="0"/>
+                <a:ea typeface="Calibri" pitchFamily="34" charset="-122"/>
+                <a:cs typeface="Calibri" pitchFamily="34" charset="-120"/>
+              </a:rPr>
+              <a:t>The Food Allowance column is in the Masterlist template and import</a:t>
+            </a:r>
+            <a:endParaRPr lang="en-US" sz="1200" dirty="0"/>
+          </a:p>
+        </p:txBody>
+      </p:sp>
+      <p:sp>
+        <p:nvSpPr>
+          <p:cNvPr id="11" name="Text 9"/>
+          <p:cNvSpPr/>
+          <p:nvPr/>
+        </p:nvSpPr>
+        <p:spPr>
+          <a:xfrm>
+            <a:off x="566928" y="6437376"/>
+            <a:ext cx="5486400" cy="237744"/>
+          </a:xfrm>
+          <a:prstGeom prst="rect">
+            <a:avLst/>
+          </a:prstGeom>
+          <a:noFill/>
+          <a:ln/>
+        </p:spPr>
+        <p:txBody>
+          <a:bodyPr wrap="square" lIns="0" tIns="0" rIns="0" bIns="0" rtlCol="0" anchor="ctr"/>
+          <a:lstStyle/>
+          <a:p>
+            <a:pPr indent="0" marL="0">
+              <a:buNone/>
+            </a:pPr>
+            <a:r>
+              <a:rPr lang="en-US" sz="900" dirty="0">
+                <a:solidFill>
+                  <a:srgbClr val="6E7681"/>
+                </a:solidFill>
+                <a:latin typeface="Calibri" pitchFamily="34" charset="0"/>
+                <a:ea typeface="Calibri" pitchFamily="34" charset="-122"/>
+                <a:cs typeface="Calibri" pitchFamily="34" charset="-120"/>
+              </a:rPr>
+              <a:t>SHIC Cost Estimator — End-User Manual</a:t>
+            </a:r>
+            <a:endParaRPr lang="en-US" sz="900" dirty="0"/>
+          </a:p>
+        </p:txBody>
+      </p:sp>
+      <p:sp>
+        <p:nvSpPr>
+          <p:cNvPr id="12" name="Text 10"/>
+          <p:cNvSpPr/>
+          <p:nvPr/>
+        </p:nvSpPr>
+        <p:spPr>
+          <a:xfrm>
+            <a:off x="10981944" y="6437376"/>
+            <a:ext cx="640080" cy="237744"/>
+          </a:xfrm>
+          <a:prstGeom prst="rect">
+            <a:avLst/>
+          </a:prstGeom>
+          <a:noFill/>
+          <a:ln/>
+        </p:spPr>
+        <p:txBody>
+          <a:bodyPr wrap="square" lIns="0" tIns="0" rIns="0" bIns="0" rtlCol="0" anchor="ctr"/>
+          <a:lstStyle/>
+          <a:p>
+            <a:pPr algn="r" indent="0" marL="0">
+              <a:buNone/>
+            </a:pPr>
+            <a:r>
+              <a:rPr lang="en-US" sz="900" dirty="0">
+                <a:solidFill>
+                  <a:srgbClr val="6E7681"/>
+                </a:solidFill>
+                <a:latin typeface="Calibri" pitchFamily="34" charset="0"/>
+                <a:ea typeface="Calibri" pitchFamily="34" charset="-122"/>
+                <a:cs typeface="Calibri" pitchFamily="34" charset="-120"/>
+              </a:rPr>
+              <a:t>13</a:t>
             </a:r>
             <a:endParaRPr lang="en-US" sz="900" dirty="0"/>
           </a:p>
@@ -35275,7 +36643,7 @@
                 <a:ea typeface="Calibri" pitchFamily="34" charset="-122"/>
                 <a:cs typeface="Calibri" pitchFamily="34" charset="-120"/>
               </a:rPr>
-              <a:t>Every row shows which scope task it belongs to, so two rows for one role are explained rather than mysterious — they are different crews on different tasks. Change a row’s task here or in SOW Breakdown. Row Total is pay plus overtime; benefits land in the grand total.</a:t>
+              <a:t>Every row shows which scope task it belongs to, so two rows for one role are explained. Rows are numbered, and each shift ends with a SUB TOTAL of pax and cost. Row Total is pay plus overtime; benefits land in the grand total.</a:t>
             </a:r>
             <a:endParaRPr lang="en-US" sz="1150" dirty="0"/>
           </a:p>

</xml_diff>

<commit_message>
Update the manual for build 189
Co-Authored-By: Claude Opus 5 <noreply@anthropic.com>
</commit_message>
<xml_diff>
--- a/docs/SHIC-Cost-Estimator-User-Manual.pptx
+++ b/docs/SHIC-Cost-Estimator-User-Manual.pptx
@@ -3920,7 +3920,31 @@
                 <a:ea typeface="Calibri" pitchFamily="34" charset="-122"/>
                 <a:cs typeface="Calibri" pitchFamily="34" charset="-120"/>
               </a:rPr>
-              <a:t>Hover SIL &amp; ECC for the ₱30 ECC. The last row gives Total manpower — the headcount</a:t>
+              <a:t>ECC is ₱30 per person per month (26 working days, rounded up), shared across the role’s shifts — hover SIL &amp; ECC to see it. Older CEs keep ₱30 per shift line</a:t>
+            </a:r>
+            <a:endParaRPr lang="en-US" sz="1200" dirty="0"/>
+          </a:p>
+          <a:p>
+            <a:pPr marL="342900" indent="-342900">
+              <a:lnSpc>
+                <a:spcPts val="1600"/>
+              </a:lnSpc>
+              <a:spcAft>
+                <a:spcPts val="900"/>
+              </a:spcAft>
+              <a:buSzPct val="100000"/>
+              <a:buChar char="●"/>
+            </a:pPr>
+            <a:r>
+              <a:rPr lang="en-US" sz="1200" dirty="0">
+                <a:solidFill>
+                  <a:srgbClr val="E6EDF3"/>
+                </a:solidFill>
+                <a:latin typeface="Calibri" pitchFamily="34" charset="0"/>
+                <a:ea typeface="Calibri" pitchFamily="34" charset="-122"/>
+                <a:cs typeface="Calibri" pitchFamily="34" charset="-120"/>
+              </a:rPr>
+              <a:t>The last row gives Total manpower — the headcount</a:t>
             </a:r>
             <a:endParaRPr lang="en-US" sz="1200" dirty="0"/>
           </a:p>

</xml_diff>

<commit_message>
Update the manual for builds 190-191
Co-Authored-By: Claude Opus 5 <noreply@anthropic.com>
</commit_message>
<xml_diff>
--- a/docs/SHIC-Cost-Estimator-User-Manual.pptx
+++ b/docs/SHIC-Cost-Estimator-User-Manual.pptx
@@ -8273,7 +8273,7 @@
                 <a:ea typeface="Calibri" pitchFamily="34" charset="-122"/>
                 <a:cs typeface="Calibri" pitchFamily="34" charset="-120"/>
               </a:rPr>
-              <a:t>Pick an item and its rate and unit come with it. Always prefer this over typing.</a:t>
+              <a:t>Pick an item and its rate and unit come with it. Not on it yet? ＋ Add to Masterlist under the row (or ＋ Masterlist in the header) adds it for everyone.</a:t>
             </a:r>
             <a:endParaRPr lang="en-US" sz="1100" dirty="0"/>
           </a:p>
@@ -8630,7 +8630,7 @@
                 <a:ea typeface="Calibri" pitchFamily="34" charset="-122"/>
                 <a:cs typeface="Calibri" pitchFamily="34" charset="-120"/>
               </a:rPr>
-              <a:t>62 units grouped by kind — Pcs, Box, Can, Gallon, Drum, Kg, sq.m, L.M. and more. An unusual unit from an imported file is kept as it was.</a:t>
+              <a:t>62 units grouped by kind — Pcs, Box, Gallon, Kg and more. ↺ Sync UOM sets each row to the Masterlist item’s unit; costs do not change.</a:t>
             </a:r>
             <a:endParaRPr lang="en-US" sz="1100" dirty="0"/>
           </a:p>

</xml_diff>

<commit_message>
Update the manual for builds 194-200
Co-Authored-By: Claude Opus 5 <noreply@anthropic.com>
</commit_message>
<xml_diff>
--- a/docs/SHIC-Cost-Estimator-User-Manual.pptx
+++ b/docs/SHIC-Cost-Estimator-User-Manual.pptx
@@ -17720,7 +17720,7 @@
                 <a:ea typeface="Calibri" pitchFamily="34" charset="-122"/>
                 <a:cs typeface="Calibri" pitchFamily="34" charset="-120"/>
               </a:rPr>
-              <a:t>Parks unfinished work and shares it with the team. A draft DOES show in CE Monitoring as open work, and can still be edited. Saving the CE clears it.</a:t>
+              <a:t>Parks unfinished work for the team; it shows in CE Monitoring and saving clears it. Only its owner or an admin can delete one, after a warning.</a:t>
             </a:r>
             <a:endParaRPr lang="en-US" sz="1150" dirty="0"/>
           </a:p>
@@ -18873,7 +18873,7 @@
                 <a:ea typeface="Calibri" pitchFamily="34" charset="-122"/>
                 <a:cs typeface="Calibri" pitchFamily="34" charset="-120"/>
               </a:rPr>
-              <a:t>Both write the SAME document as a formatted Excel workbook — one sheet per printed page, same headings and columns, with the black section bars and borders of the master CE. Figures arrive as numbers, so a column still totals.</a:t>
+              <a:t>Both write the CE as a formatted Excel workbook, figures as numbers. Title bars take the company colour — green SY3, orange Synercore; change it in Admin → Companies → Header Bar Color.</a:t>
             </a:r>
             <a:endParaRPr lang="en-US" sz="1150" dirty="0"/>
           </a:p>
@@ -19115,7 +19115,7 @@
                 <a:ea typeface="Calibri" pitchFamily="34" charset="-122"/>
                 <a:cs typeface="Calibri" pitchFamily="34" charset="-120"/>
               </a:rPr>
-              <a:t>The AOT column is total overtime hours — your per-day figure multiplied by the days</a:t>
+              <a:t>OT HRS/DAY is what you typed; AOT is that × the days</a:t>
             </a:r>
             <a:endParaRPr lang="en-US" sz="1150" dirty="0"/>
           </a:p>
@@ -20713,7 +20713,7 @@
                 <a:ea typeface="Arial" pitchFamily="34" charset="-122"/>
                 <a:cs typeface="Arial" pitchFamily="34" charset="-120"/>
               </a:rPr>
-              <a:t>Load · 🖨 CE · ⬇ xlsx</a:t>
+              <a:t>Load · 👁 View · 🖨 CE · ⬇ xlsx</a:t>
             </a:r>
             <a:endParaRPr lang="en-US" sz="1350" dirty="0"/>
           </a:p>
@@ -20755,7 +20755,7 @@
                 <a:ea typeface="Calibri" pitchFamily="34" charset="-122"/>
                 <a:cs typeface="Calibri" pitchFamily="34" charset="-120"/>
               </a:rPr>
-              <a:t>Open a CE, or print one. 🖨 CE and ⬇ xlsx produce its documents in a new tab, leaving the CE you are working on untouched. Clone and Revise copy it.</a:t>
+              <a:t>👁 View shows a saved CE right here, read-only — ideal for approvers. 🖨 CE and ⬇ xlsx open it in a new tab. None of them touch the CE you have open.</a:t>
             </a:r>
             <a:endParaRPr lang="en-US" sz="1100" dirty="0"/>
           </a:p>
@@ -20874,7 +20874,7 @@
                 <a:ea typeface="Calibri" pitchFamily="34" charset="-122"/>
                 <a:cs typeface="Calibri" pitchFamily="34" charset="-120"/>
               </a:rPr>
-              <a:t>A CE is one row, at its newest revision — "+2 rev" opens the older ones, and counts and totals include the job once. Tick two CEs to compare them side by side.</a:t>
+              <a:t>A CE is one row at its newest revision; "+2 rev" opens older ones. ⚖ Diff on a revision compares it with its base, section by section, Mob/Demob included.</a:t>
             </a:r>
             <a:endParaRPr lang="en-US" sz="1100" dirty="0"/>
           </a:p>

</xml_diff>

<commit_message>
Update the manual for builds 201-202
Co-Authored-By: Claude Opus 5 <noreply@anthropic.com>
</commit_message>
<xml_diff>
--- a/docs/SHIC-Cost-Estimator-User-Manual.pptx
+++ b/docs/SHIC-Cost-Estimator-User-Manual.pptx
@@ -20475,7 +20475,7 @@
                 <a:ea typeface="Arial" pitchFamily="34" charset="-122"/>
                 <a:cs typeface="Arial" pitchFamily="34" charset="-120"/>
               </a:rPr>
-              <a:t>Status · with history</a:t>
+              <a:t>Status · Remarks · with history</a:t>
             </a:r>
             <a:endParaRPr lang="en-US" sz="1350" dirty="0"/>
           </a:p>
@@ -20517,7 +20517,7 @@
                 <a:ea typeface="Calibri" pitchFamily="34" charset="-122"/>
                 <a:cs typeface="Calibri" pitchFamily="34" charset="-120"/>
               </a:rPr>
-              <a:t>Press Status on a row to change it and see the trail — every change, who made it and when. Customer, job title, dates, received by and remarks are edited in place.</a:t>
+              <a:t>⚑ Status and 💬 Remarks each keep a trail: every change or remark, who and when; the column shows the latest. ✎ Edit covers customer, job title and dates.</a:t>
             </a:r>
             <a:endParaRPr lang="en-US" sz="1100" dirty="0"/>
           </a:p>

</xml_diff>

<commit_message>
Manual: builds 203-216 (My Work, Approvals, tool power switch, Masterlist Trash)
Co-Authored-By: Claude Opus 5 <noreply@anthropic.com>
</commit_message>
<xml_diff>
--- a/docs/SHIC-Cost-Estimator-User-Manual.pptx
+++ b/docs/SHIC-Cost-Estimator-User-Manual.pptx
@@ -8,6 +8,7 @@
     <p:sldId id="256" r:id="rId2"/>
     <p:sldId id="257" r:id="rId3"/>
     <p:sldId id="258" r:id="rId4"/>
+    <p:sldId id="285" r:id="rId36"/>
     <p:sldId id="259" r:id="rId5"/>
     <p:sldId id="260" r:id="rId6"/>
     <p:sldId id="261" r:id="rId7"/>
@@ -27,6 +28,7 @@
     <p:sldId id="269" r:id="rId15"/>
     <p:sldId id="270" r:id="rId16"/>
     <p:sldId id="271" r:id="rId17"/>
+    <p:sldId id="286" r:id="rId37"/>
     <p:sldId id="272" r:id="rId18"/>
     <p:sldId id="279" r:id="rId30"/>
     <p:sldId id="282" r:id="rId33"/>
@@ -4217,7 +4219,7 @@
                 <a:ea typeface="Calibri" pitchFamily="34" charset="-122"/>
                 <a:cs typeface="Calibri" pitchFamily="34" charset="-120"/>
               </a:rPr>
-              <a:t>10</a:t>
+              <a:t>11</a:t>
             </a:r>
             <a:endParaRPr lang="en-US" sz="900" dirty="0"/>
           </a:p>
@@ -6024,7 +6026,7 @@
                 <a:ea typeface="Calibri" pitchFamily="34" charset="-122"/>
                 <a:cs typeface="Calibri" pitchFamily="34" charset="-120"/>
               </a:rPr>
-              <a:t>11</a:t>
+              <a:t>12</a:t>
             </a:r>
             <a:endParaRPr lang="en-US" sz="900" dirty="0"/>
           </a:p>
@@ -6661,7 +6663,7 @@
                 <a:ea typeface="Calibri" pitchFamily="34" charset="-122"/>
                 <a:cs typeface="Calibri" pitchFamily="34" charset="-120"/>
               </a:rPr>
-              <a:t>12</a:t>
+              <a:t>13</a:t>
             </a:r>
             <a:endParaRPr lang="en-US" sz="900" dirty="0"/>
           </a:p>
@@ -7274,7 +7276,7 @@
                 <a:ea typeface="Calibri" pitchFamily="34" charset="-122"/>
                 <a:cs typeface="Calibri" pitchFamily="34" charset="-120"/>
               </a:rPr>
-              <a:t>13</a:t>
+              <a:t>14</a:t>
             </a:r>
             <a:endParaRPr lang="en-US" sz="900" dirty="0"/>
           </a:p>
@@ -8708,7 +8710,7 @@
                 <a:ea typeface="Calibri" pitchFamily="34" charset="-122"/>
                 <a:cs typeface="Calibri" pitchFamily="34" charset="-120"/>
               </a:rPr>
-              <a:t>14</a:t>
+              <a:t>15</a:t>
             </a:r>
             <a:endParaRPr lang="en-US" sz="900" dirty="0"/>
           </a:p>
@@ -10142,7 +10144,7 @@
                 <a:ea typeface="Calibri" pitchFamily="34" charset="-122"/>
                 <a:cs typeface="Calibri" pitchFamily="34" charset="-120"/>
               </a:rPr>
-              <a:t>15</a:t>
+              <a:t>16</a:t>
             </a:r>
             <a:endParaRPr lang="en-US" sz="900" dirty="0"/>
           </a:p>
@@ -10784,7 +10786,7 @@
                 <a:ea typeface="Calibri" pitchFamily="34" charset="-122"/>
                 <a:cs typeface="Calibri" pitchFamily="34" charset="-120"/>
               </a:rPr>
-              <a:t>An onsite job runs on the client’s supply, so nothing is charged for power there. The three power columns appear on a Shopworks CE and nowhere else.</a:t>
+              <a:t>Onsite jobs run on the client’s supply, so power is never charged there. The columns show on Shopworks CEs while an admin has ⚡ Tool Power ON.</a:t>
             </a:r>
             <a:endParaRPr lang="en-US" sz="1150" dirty="0"/>
           </a:p>
@@ -11576,7 +11578,7 @@
                 <a:ea typeface="Calibri" pitchFamily="34" charset="-122"/>
                 <a:cs typeface="Calibri" pitchFamily="34" charset="-120"/>
               </a:rPr>
-              <a:t>16</a:t>
+              <a:t>17</a:t>
             </a:r>
             <a:endParaRPr lang="en-US" sz="900" dirty="0"/>
           </a:p>
@@ -13010,7 +13012,7 @@
                 <a:ea typeface="Calibri" pitchFamily="34" charset="-122"/>
                 <a:cs typeface="Calibri" pitchFamily="34" charset="-120"/>
               </a:rPr>
-              <a:t>17</a:t>
+              <a:t>18</a:t>
             </a:r>
             <a:endParaRPr lang="en-US" sz="900" dirty="0"/>
           </a:p>
@@ -14726,7 +14728,7 @@
                 <a:ea typeface="Calibri" pitchFamily="34" charset="-122"/>
                 <a:cs typeface="Calibri" pitchFamily="34" charset="-120"/>
               </a:rPr>
-              <a:t>Filled from the CE Defaults preset for this CE type and discipline, with your name in Prepared By. A signature drawn on screen is saved with the CE.</a:t>
+              <a:t>Filled from the CE Defaults preset. Link a line to a user and give it a Step to route it for approval in the app (see Approvals). Unlinked lines are signed by hand as before.</a:t>
             </a:r>
             <a:endParaRPr lang="en-US" sz="1100" dirty="0"/>
           </a:p>
@@ -14765,7 +14767,7 @@
                 <a:ea typeface="Calibri" pitchFamily="34" charset="-122"/>
                 <a:cs typeface="Calibri" pitchFamily="34" charset="-120"/>
               </a:rPr>
-              <a:t>Unit price = total ÷ the Quantity you set on Project Info.</a:t>
+              <a:t>Unit price = (total − costs charged once per job, e.g. transport) ÷ Quantity. The once-per-job total shows under it.</a:t>
             </a:r>
             <a:endParaRPr lang="en-US" sz="1150" dirty="0"/>
           </a:p>
@@ -15038,7 +15040,7 @@
                 <a:ea typeface="Calibri" pitchFamily="34" charset="-122"/>
                 <a:cs typeface="Calibri" pitchFamily="34" charset="-120"/>
               </a:rPr>
-              <a:t>18</a:t>
+              <a:t>19</a:t>
             </a:r>
             <a:endParaRPr lang="en-US" sz="900" dirty="0"/>
           </a:p>
@@ -15675,7 +15677,7 @@
                 <a:ea typeface="Calibri" pitchFamily="34" charset="-122"/>
                 <a:cs typeface="Calibri" pitchFamily="34" charset="-120"/>
               </a:rPr>
-              <a:t>19</a:t>
+              <a:t>20</a:t>
             </a:r>
             <a:endParaRPr lang="en-US" sz="900" dirty="0"/>
           </a:p>
@@ -17271,7 +17273,7 @@
                 <a:ea typeface="Calibri" pitchFamily="34" charset="-122"/>
                 <a:cs typeface="Calibri" pitchFamily="34" charset="-120"/>
               </a:rPr>
-              <a:t>20</a:t>
+              <a:t>21</a:t>
             </a:r>
             <a:endParaRPr lang="en-US" sz="900" dirty="0"/>
           </a:p>
@@ -17531,7 +17533,7 @@
                 <a:ea typeface="Calibri" pitchFamily="34" charset="-122"/>
                 <a:cs typeface="Calibri" pitchFamily="34" charset="-120"/>
               </a:rPr>
-              <a:t>Stores the CE and shares it with the team. The CE Number must be unique.</a:t>
+              <a:t>Stores the CE and shares it with the team. The CE Number must be unique, and Discipline is required. On the Summary the Keep group reads Resume Work · Draft · Save · Revise; hover any button for what it does.</a:t>
             </a:r>
             <a:endParaRPr lang="en-US" sz="1150" dirty="0"/>
           </a:p>
@@ -18525,7 +18527,7 @@
                 <a:ea typeface="Calibri" pitchFamily="34" charset="-122"/>
                 <a:cs typeface="Calibri" pitchFamily="34" charset="-120"/>
               </a:rPr>
-              <a:t>21</a:t>
+              <a:t>22</a:t>
             </a:r>
             <a:endParaRPr lang="en-US" sz="900" dirty="0"/>
           </a:p>
@@ -18754,7 +18756,7 @@
                 <a:ea typeface="Calibri" pitchFamily="34" charset="-122"/>
                 <a:cs typeface="Calibri" pitchFamily="34" charset="-120"/>
               </a:rPr>
-              <a:t>Opens the official SHIC form in a print window: cover, cost summary, manpower loading, resources, scope of work and signature blocks. Print it or save as PDF.</a:t>
+              <a:t>Opens the official SHIC form to print or save as PDF. 👁 Preview shows it in one window without the print dialog. Both work offline.</a:t>
             </a:r>
             <a:endParaRPr lang="en-US" sz="1150" dirty="0"/>
           </a:p>
@@ -19265,7 +19267,7 @@
                 <a:ea typeface="Calibri" pitchFamily="34" charset="-122"/>
                 <a:cs typeface="Calibri" pitchFamily="34" charset="-120"/>
               </a:rPr>
-              <a:t>22</a:t>
+              <a:t>23</a:t>
             </a:r>
             <a:endParaRPr lang="en-US" sz="900" dirty="0"/>
           </a:p>
@@ -20755,7 +20757,7 @@
                 <a:ea typeface="Calibri" pitchFamily="34" charset="-122"/>
                 <a:cs typeface="Calibri" pitchFamily="34" charset="-120"/>
               </a:rPr>
-              <a:t>👁 View shows a saved CE right here, read-only — ideal for approvers. 🖨 CE and ⬇ xlsx open it in a new tab. None of them touch the CE you have open.</a:t>
+              <a:t>Buttons are grouped by row: Status · Remarks · Assign, then View · Load · Edit, then CE · xlsx · 📎. 👁 View also works on drafts; ⬇ xlsx downloads without opening a tab. ✍ Awaiting my signature filters to CEs waiting on you.</a:t>
             </a:r>
             <a:endParaRPr lang="en-US" sz="1100" dirty="0"/>
           </a:p>
@@ -20952,7 +20954,7 @@
                 <a:ea typeface="Calibri" pitchFamily="34" charset="-122"/>
                 <a:cs typeface="Calibri" pitchFamily="34" charset="-120"/>
               </a:rPr>
-              <a:t>23</a:t>
+              <a:t>25</a:t>
             </a:r>
             <a:endParaRPr lang="en-US" sz="900" dirty="0"/>
           </a:p>
@@ -21572,7 +21574,7 @@
                 <a:ea typeface="Calibri" pitchFamily="34" charset="-122"/>
                 <a:cs typeface="Calibri" pitchFamily="34" charset="-120"/>
               </a:rPr>
-              <a:t>24</a:t>
+              <a:t>26</a:t>
             </a:r>
             <a:endParaRPr lang="en-US" sz="900" dirty="0"/>
           </a:p>
@@ -22209,7 +22211,7 @@
                 <a:ea typeface="Calibri" pitchFamily="34" charset="-122"/>
                 <a:cs typeface="Calibri" pitchFamily="34" charset="-120"/>
               </a:rPr>
-              <a:t>25</a:t>
+              <a:t>27</a:t>
             </a:r>
             <a:endParaRPr lang="en-US" sz="900" dirty="0"/>
           </a:p>
@@ -23119,7 +23121,7 @@
                 <a:ea typeface="Calibri" pitchFamily="34" charset="-122"/>
                 <a:cs typeface="Calibri" pitchFamily="34" charset="-120"/>
               </a:rPr>
-              <a:t>26</a:t>
+              <a:t>28</a:t>
             </a:r>
             <a:endParaRPr lang="en-US" sz="900" dirty="0"/>
           </a:p>
@@ -24338,7 +24340,7 @@
                 <a:ea typeface="Calibri" pitchFamily="34" charset="-122"/>
                 <a:cs typeface="Calibri" pitchFamily="34" charset="-120"/>
               </a:rPr>
-              <a:t>27</a:t>
+              <a:t>29</a:t>
             </a:r>
             <a:endParaRPr lang="en-US" sz="900" dirty="0"/>
           </a:p>
@@ -24856,7 +24858,7 @@
                 <a:ea typeface="Calibri" pitchFamily="34" charset="-122"/>
                 <a:cs typeface="Calibri" pitchFamily="34" charset="-120"/>
               </a:rPr>
-              <a:t>Tools also carry unit price, service life, projects per year, maintenance and a power rating in kW — press 💲 on a row to work all three tier prices out from them</a:t>
+              <a:t>Tools also carry cost, life, maintenance and kW — 💲 works out the tier prices</a:t>
             </a:r>
             <a:endParaRPr lang="en-US" sz="1200" dirty="0"/>
           </a:p>
@@ -24880,7 +24882,7 @@
                 <a:ea typeface="Calibri" pitchFamily="34" charset="-122"/>
                 <a:cs typeface="Calibri" pitchFamily="34" charset="-120"/>
               </a:rPr>
-              <a:t>Download the template to bulk-upload rates. The tools sheet takes the four tier figures and Power (kW), and reads the maintained workbook's own headings</a:t>
+              <a:t>Download the template to bulk-upload rates, tier figures and Power (kW) included</a:t>
             </a:r>
             <a:endParaRPr lang="en-US" sz="1200" dirty="0"/>
           </a:p>
@@ -24932,6 +24934,30 @@
             </a:r>
             <a:endParaRPr lang="en-US" sz="1200" dirty="0"/>
           </a:p>
+          <a:p>
+            <a:pPr marL="342900" indent="-342900">
+              <a:lnSpc>
+                <a:spcPts val="1600"/>
+              </a:lnSpc>
+              <a:spcAft>
+                <a:spcPts val="900"/>
+              </a:spcAft>
+              <a:buSzPct val="100000"/>
+              <a:buChar char="●"/>
+            </a:pPr>
+            <a:r>
+              <a:rPr lang="en-US" sz="1200" dirty="0">
+                <a:solidFill>
+                  <a:srgbClr val="E6EDF3"/>
+                </a:solidFill>
+                <a:latin typeface="Calibri" pitchFamily="34" charset="0"/>
+                <a:ea typeface="Calibri" pitchFamily="34" charset="-122"/>
+                <a:cs typeface="Calibri" pitchFamily="34" charset="-120"/>
+              </a:rPr>
+              <a:t>The red x asks first; deleted items go to 🗑 Trash for 30 days to Restore</a:t>
+            </a:r>
+            <a:endParaRPr lang="en-US" sz="1200" dirty="0"/>
+          </a:p>
         </p:txBody>
       </p:sp>
       <p:sp>
@@ -25006,7 +25032,7 @@
                 <a:ea typeface="Calibri" pitchFamily="34" charset="-122"/>
                 <a:cs typeface="Calibri" pitchFamily="34" charset="-120"/>
               </a:rPr>
-              <a:t>28</a:t>
+              <a:t>30</a:t>
             </a:r>
             <a:endParaRPr lang="en-US" sz="900" dirty="0"/>
           </a:p>
@@ -26023,7 +26049,7 @@
                 <a:ea typeface="Calibri" pitchFamily="34" charset="-122"/>
                 <a:cs typeface="Calibri" pitchFamily="34" charset="-120"/>
               </a:rPr>
-              <a:t>29</a:t>
+              <a:t>31</a:t>
             </a:r>
             <a:endParaRPr lang="en-US" sz="900" dirty="0"/>
           </a:p>
@@ -26175,7 +26201,7 @@
                 <a:ea typeface="Calibri" pitchFamily="34" charset="-122"/>
                 <a:cs typeface="Calibri" pitchFamily="34" charset="-120"/>
               </a:rPr>
-              <a:t>Work left to right. You can jump around, but each tab assumes the one before it is filled in.</a:t>
+              <a:t>The app opens on 🏠 My Work — your to-do list. Then work the tabs left to right; each assumes the one before it is filled in.</a:t>
             </a:r>
             <a:endParaRPr lang="en-US" sz="1400" dirty="0"/>
           </a:p>
@@ -28132,6 +28158,1304 @@
                 <a:cs typeface="Calibri" pitchFamily="34" charset="-120"/>
               </a:rPr>
               <a:t>3</a:t>
+            </a:r>
+            <a:endParaRPr lang="en-US" sz="900" dirty="0"/>
+          </a:p>
+        </p:txBody>
+      </p:sp>
+    </p:spTree>
+  </p:cSld>
+  <p:clrMapOvr>
+    <a:masterClrMapping/>
+  </p:clrMapOvr>
+</p:sld>
+</file>
+
+<file path=ppt/slides/slide30.xml><?xml version="1.0" encoding="utf-8"?>
+<p:sld xmlns:a="http://schemas.openxmlformats.org/drawingml/2006/main" xmlns:p="http://schemas.openxmlformats.org/presentationml/2006/main" xmlns:r="http://schemas.openxmlformats.org/officeDocument/2006/relationships">
+  <p:cSld>
+    <p:bg>
+      <p:bgPr>
+        <a:solidFill>
+          <a:srgbClr val="0D1117"/>
+        </a:solidFill>
+      </p:bgPr>
+    </p:bg>
+    <p:spTree>
+      <p:nvGrpSpPr>
+        <p:cNvPr id="1" name=""/>
+        <p:cNvGrpSpPr/>
+        <p:nvPr/>
+      </p:nvGrpSpPr>
+      <p:grpSpPr/>
+      <p:sp>
+        <p:nvSpPr>
+          <p:cNvPr id="2" name="Text 0"/>
+          <p:cNvSpPr/>
+          <p:nvPr/>
+        </p:nvSpPr>
+        <p:spPr>
+          <a:xfrm>
+            <a:off x="566928" y="384048"/>
+            <a:ext cx="8229600" cy="256032"/>
+          </a:xfrm>
+          <a:prstGeom prst="rect">
+            <a:avLst/>
+          </a:prstGeom>
+          <a:noFill/>
+          <a:ln/>
+        </p:spPr>
+        <p:txBody>
+          <a:bodyPr wrap="square" lIns="0" tIns="0" rIns="0" bIns="0" rtlCol="0" anchor="ctr"/>
+          <a:lstStyle/>
+          <a:p>
+            <a:pPr indent="0" marL="0">
+              <a:buNone/>
+            </a:pPr>
+            <a:r>
+              <a:rPr lang="en-US" sz="1100" b="1" spc="200" kern="0" dirty="0">
+                <a:solidFill>
+                  <a:srgbClr val="F0A429"/>
+                </a:solidFill>
+                <a:latin typeface="Arial" pitchFamily="34" charset="0"/>
+                <a:ea typeface="Arial" pitchFamily="34" charset="-122"/>
+                <a:cs typeface="Arial" pitchFamily="34" charset="-120"/>
+              </a:rPr>
+              <a:t>START HERE · MY WORK</a:t>
+            </a:r>
+            <a:endParaRPr lang="en-US" sz="1100" dirty="0"/>
+          </a:p>
+        </p:txBody>
+      </p:sp>
+      <p:sp>
+        <p:nvSpPr>
+          <p:cNvPr id="3" name="Text 1"/>
+          <p:cNvSpPr/>
+          <p:nvPr/>
+        </p:nvSpPr>
+        <p:spPr>
+          <a:xfrm>
+            <a:off x="566928" y="694944"/>
+            <a:ext cx="11055096" cy="566928"/>
+          </a:xfrm>
+          <a:prstGeom prst="rect">
+            <a:avLst/>
+          </a:prstGeom>
+          <a:noFill/>
+          <a:ln/>
+        </p:spPr>
+        <p:txBody>
+          <a:bodyPr wrap="square" lIns="0" tIns="0" rIns="0" bIns="0" rtlCol="0" anchor="ctr"/>
+          <a:lstStyle/>
+          <a:p>
+            <a:pPr indent="0" marL="0">
+              <a:buNone/>
+            </a:pPr>
+            <a:r>
+              <a:rPr lang="en-US" sz="3200" b="1" dirty="0">
+                <a:solidFill>
+                  <a:srgbClr val="E6EDF3"/>
+                </a:solidFill>
+                <a:latin typeface="Arial" pitchFamily="34" charset="0"/>
+                <a:ea typeface="Arial" pitchFamily="34" charset="-122"/>
+                <a:cs typeface="Arial" pitchFamily="34" charset="-120"/>
+              </a:rPr>
+              <a:t>Everything waiting on you</a:t>
+            </a:r>
+            <a:endParaRPr lang="en-US" sz="3200" dirty="0"/>
+          </a:p>
+        </p:txBody>
+      </p:sp>
+      <p:sp>
+        <p:nvSpPr>
+          <p:cNvPr id="4" name="Text 2"/>
+          <p:cNvSpPr/>
+          <p:nvPr/>
+        </p:nvSpPr>
+        <p:spPr>
+          <a:xfrm>
+            <a:off x="566928" y="1298448"/>
+            <a:ext cx="10972800" cy="365760"/>
+          </a:xfrm>
+          <a:prstGeom prst="rect">
+            <a:avLst/>
+          </a:prstGeom>
+          <a:noFill/>
+          <a:ln/>
+        </p:spPr>
+        <p:txBody>
+          <a:bodyPr wrap="square" lIns="0" tIns="0" rIns="0" bIns="0" rtlCol="0" anchor="t"/>
+          <a:lstStyle/>
+          <a:p>
+            <a:pPr algn="l" indent="0" marL="0">
+              <a:lnSpc>
+                <a:spcPts val="2000"/>
+              </a:lnSpc>
+              <a:buNone/>
+            </a:pPr>
+            <a:r>
+              <a:rPr lang="en-US" sz="1400" dirty="0">
+                <a:solidFill>
+                  <a:srgbClr val="9AA4AF"/>
+                </a:solidFill>
+                <a:latin typeface="Calibri" pitchFamily="34" charset="0"/>
+                <a:ea typeface="Calibri" pitchFamily="34" charset="-122"/>
+                <a:cs typeface="Calibri" pitchFamily="34" charset="-120"/>
+              </a:rPr>
+              <a:t>The first tab, and where the app opens. It lists only what concerns you, newest revision of each CE only.</a:t>
+            </a:r>
+            <a:endParaRPr lang="en-US" sz="1400" dirty="0"/>
+          </a:p>
+        </p:txBody>
+      </p:sp>
+      <p:sp>
+        <p:nvSpPr>
+          <p:cNvPr id="5" name="Shape 3"/>
+          <p:cNvSpPr/>
+          <p:nvPr/>
+        </p:nvSpPr>
+        <p:spPr>
+          <a:xfrm>
+            <a:off x="566928" y="1911096"/>
+            <a:ext cx="5532120" cy="3566160"/>
+          </a:xfrm>
+          <a:prstGeom prst="roundRect">
+            <a:avLst>
+              <a:gd name="adj" fmla="val 2051"/>
+            </a:avLst>
+          </a:prstGeom>
+          <a:solidFill>
+            <a:srgbClr val="1C2128"/>
+          </a:solidFill>
+          <a:ln w="12700">
+            <a:solidFill>
+              <a:srgbClr val="30363D"/>
+            </a:solidFill>
+            <a:prstDash val="solid"/>
+          </a:ln>
+          <a:effectLst>
+            <a:outerShdw sx="100000" sy="100000" kx="0" ky="0" algn="bl" rotWithShape="0" blurRad="152400" dist="38100" dir="5400000">
+              <a:srgbClr val="000000">
+                <a:alpha val="45000"/>
+              </a:srgbClr>
+            </a:outerShdw>
+          </a:effectLst>
+        </p:spPr>
+        <p:txBody>
+          <a:bodyPr/>
+          <a:p/>
+        </p:txBody>
+      </p:sp>
+      <p:sp>
+        <p:nvSpPr>
+          <p:cNvPr id="6" name="Text 4"/>
+          <p:cNvSpPr/>
+          <p:nvPr/>
+        </p:nvSpPr>
+        <p:spPr>
+          <a:xfrm>
+            <a:off x="841248" y="2121408"/>
+            <a:ext cx="4937760" cy="329184"/>
+          </a:xfrm>
+          <a:prstGeom prst="rect">
+            <a:avLst/>
+          </a:prstGeom>
+          <a:noFill/>
+          <a:ln/>
+        </p:spPr>
+        <p:txBody>
+          <a:bodyPr wrap="square" lIns="0" tIns="0" rIns="0" bIns="0" rtlCol="0" anchor="ctr"/>
+          <a:lstStyle/>
+          <a:p>
+            <a:pPr indent="0" marL="0">
+              <a:buNone/>
+            </a:pPr>
+            <a:r>
+              <a:rPr lang="en-US" sz="1700" b="1" dirty="0">
+                <a:solidFill>
+                  <a:srgbClr val="A78BFA"/>
+                </a:solidFill>
+                <a:latin typeface="Arial" pitchFamily="34" charset="0"/>
+                <a:ea typeface="Arial" pitchFamily="34" charset="-122"/>
+                <a:cs typeface="Arial" pitchFamily="34" charset="-120"/>
+              </a:rPr>
+              <a:t>The numbers across the top</a:t>
+            </a:r>
+            <a:endParaRPr lang="en-US" sz="1700" dirty="0"/>
+          </a:p>
+        </p:txBody>
+      </p:sp>
+      <p:sp>
+        <p:nvSpPr>
+          <p:cNvPr id="7" name="Text 5"/>
+          <p:cNvSpPr/>
+          <p:nvPr/>
+        </p:nvSpPr>
+        <p:spPr>
+          <a:xfrm>
+            <a:off x="841248" y="2578608"/>
+            <a:ext cx="4983480" cy="2651760"/>
+          </a:xfrm>
+          <a:prstGeom prst="rect">
+            <a:avLst/>
+          </a:prstGeom>
+          <a:noFill/>
+          <a:ln/>
+        </p:spPr>
+        <p:txBody>
+          <a:bodyPr wrap="square" lIns="0" tIns="0" rIns="0" bIns="0" rtlCol="0" anchor="t"/>
+          <a:lstStyle/>
+          <a:p>
+            <a:pPr marL="342900" indent="-342900">
+              <a:lnSpc>
+                <a:spcPts val="1600"/>
+              </a:lnSpc>
+              <a:spcAft>
+                <a:spcPts val="900"/>
+              </a:spcAft>
+              <a:buSzPct val="100000"/>
+              <a:buChar char="●"/>
+            </a:pPr>
+            <a:r>
+              <a:rPr lang="en-US" sz="1200" dirty="0">
+                <a:solidFill>
+                  <a:srgbClr val="E6EDF3"/>
+                </a:solidFill>
+                <a:latin typeface="Calibri" pitchFamily="34" charset="0"/>
+                <a:ea typeface="Calibri" pitchFamily="34" charset="-122"/>
+                <a:cs typeface="Calibri" pitchFamily="34" charset="-120"/>
+              </a:rPr>
+              <a:t>Awaiting my signature — approvals routed to you</a:t>
+            </a:r>
+            <a:endParaRPr lang="en-US" sz="1200" dirty="0"/>
+          </a:p>
+          <a:p>
+            <a:pPr marL="342900" indent="-342900">
+              <a:lnSpc>
+                <a:spcPts val="1600"/>
+              </a:lnSpc>
+              <a:spcAft>
+                <a:spcPts val="900"/>
+              </a:spcAft>
+              <a:buSzPct val="100000"/>
+              <a:buChar char="●"/>
+            </a:pPr>
+            <a:r>
+              <a:rPr lang="en-US" sz="1200" dirty="0">
+                <a:solidFill>
+                  <a:srgbClr val="E6EDF3"/>
+                </a:solidFill>
+                <a:latin typeface="Calibri" pitchFamily="34" charset="0"/>
+                <a:ea typeface="Calibri" pitchFamily="34" charset="-122"/>
+                <a:cs typeface="Calibri" pitchFamily="34" charset="-120"/>
+              </a:rPr>
+              <a:t>Open CEs assigned — with how many are overdue or due within 3 days</a:t>
+            </a:r>
+            <a:endParaRPr lang="en-US" sz="1200" dirty="0"/>
+          </a:p>
+          <a:p>
+            <a:pPr marL="342900" indent="-342900">
+              <a:lnSpc>
+                <a:spcPts val="1600"/>
+              </a:lnSpc>
+              <a:spcAft>
+                <a:spcPts val="900"/>
+              </a:spcAft>
+              <a:buSzPct val="100000"/>
+              <a:buChar char="●"/>
+            </a:pPr>
+            <a:r>
+              <a:rPr lang="en-US" sz="1200" dirty="0">
+                <a:solidFill>
+                  <a:srgbClr val="E6EDF3"/>
+                </a:solidFill>
+                <a:latin typeface="Calibri" pitchFamily="34" charset="0"/>
+                <a:ea typeface="Calibri" pitchFamily="34" charset="-122"/>
+                <a:cs typeface="Calibri" pitchFamily="34" charset="-120"/>
+              </a:rPr>
+              <a:t>Returned to me — CEs an approver sent back</a:t>
+            </a:r>
+            <a:endParaRPr lang="en-US" sz="1200" dirty="0"/>
+          </a:p>
+          <a:p>
+            <a:pPr marL="342900" indent="-342900">
+              <a:lnSpc>
+                <a:spcPts val="1600"/>
+              </a:lnSpc>
+              <a:spcAft>
+                <a:spcPts val="900"/>
+              </a:spcAft>
+              <a:buSzPct val="100000"/>
+              <a:buChar char="●"/>
+            </a:pPr>
+            <a:r>
+              <a:rPr lang="en-US" sz="1200" dirty="0">
+                <a:solidFill>
+                  <a:srgbClr val="E6EDF3"/>
+                </a:solidFill>
+                <a:latin typeface="Calibri" pitchFamily="34" charset="0"/>
+                <a:ea typeface="Calibri" pitchFamily="34" charset="-122"/>
+                <a:cs typeface="Calibri" pitchFamily="34" charset="-120"/>
+              </a:rPr>
+              <a:t>Submitted this month, with value · On-time rate (red under 80%) · Won this year</a:t>
+            </a:r>
+            <a:endParaRPr lang="en-US" sz="1200" dirty="0"/>
+          </a:p>
+        </p:txBody>
+      </p:sp>
+      <p:sp>
+        <p:nvSpPr>
+          <p:cNvPr id="8" name="Shape 6"/>
+          <p:cNvSpPr/>
+          <p:nvPr/>
+        </p:nvSpPr>
+        <p:spPr>
+          <a:xfrm>
+            <a:off x="6400800" y="1911096"/>
+            <a:ext cx="5221224" cy="3566160"/>
+          </a:xfrm>
+          <a:prstGeom prst="roundRect">
+            <a:avLst>
+              <a:gd name="adj" fmla="val 2051"/>
+            </a:avLst>
+          </a:prstGeom>
+          <a:solidFill>
+            <a:srgbClr val="1C2128"/>
+          </a:solidFill>
+          <a:ln w="12700">
+            <a:solidFill>
+              <a:srgbClr val="30363D"/>
+            </a:solidFill>
+            <a:prstDash val="solid"/>
+          </a:ln>
+          <a:effectLst>
+            <a:outerShdw sx="100000" sy="100000" kx="0" ky="0" algn="bl" rotWithShape="0" blurRad="152400" dist="38100" dir="5400000">
+              <a:srgbClr val="000000">
+                <a:alpha val="45000"/>
+              </a:srgbClr>
+            </a:outerShdw>
+          </a:effectLst>
+        </p:spPr>
+        <p:txBody>
+          <a:bodyPr/>
+          <a:p/>
+        </p:txBody>
+      </p:sp>
+      <p:sp>
+        <p:nvSpPr>
+          <p:cNvPr id="9" name="Text 7"/>
+          <p:cNvSpPr/>
+          <p:nvPr/>
+        </p:nvSpPr>
+        <p:spPr>
+          <a:xfrm>
+            <a:off x="6675120" y="2121408"/>
+            <a:ext cx="4663440" cy="329184"/>
+          </a:xfrm>
+          <a:prstGeom prst="rect">
+            <a:avLst/>
+          </a:prstGeom>
+          <a:noFill/>
+          <a:ln/>
+        </p:spPr>
+        <p:txBody>
+          <a:bodyPr wrap="square" lIns="0" tIns="0" rIns="0" bIns="0" rtlCol="0" anchor="ctr"/>
+          <a:lstStyle/>
+          <a:p>
+            <a:pPr indent="0" marL="0">
+              <a:buNone/>
+            </a:pPr>
+            <a:r>
+              <a:rPr lang="en-US" sz="1700" b="1" dirty="0">
+                <a:solidFill>
+                  <a:srgbClr val="F0A429"/>
+                </a:solidFill>
+                <a:latin typeface="Arial" pitchFamily="34" charset="0"/>
+                <a:ea typeface="Arial" pitchFamily="34" charset="-122"/>
+                <a:cs typeface="Arial" pitchFamily="34" charset="-120"/>
+              </a:rPr>
+              <a:t>The lists</a:t>
+            </a:r>
+            <a:endParaRPr lang="en-US" sz="1700" dirty="0"/>
+          </a:p>
+        </p:txBody>
+      </p:sp>
+      <p:sp>
+        <p:nvSpPr>
+          <p:cNvPr id="10" name="Text 8"/>
+          <p:cNvSpPr/>
+          <p:nvPr/>
+        </p:nvSpPr>
+        <p:spPr>
+          <a:xfrm>
+            <a:off x="6675120" y="2578608"/>
+            <a:ext cx="4709160" cy="2651760"/>
+          </a:xfrm>
+          <a:prstGeom prst="rect">
+            <a:avLst/>
+          </a:prstGeom>
+          <a:noFill/>
+          <a:ln/>
+        </p:spPr>
+        <p:txBody>
+          <a:bodyPr wrap="square" lIns="0" tIns="0" rIns="0" bIns="0" rtlCol="0" anchor="t"/>
+          <a:lstStyle/>
+          <a:p>
+            <a:pPr marL="342900" indent="-342900">
+              <a:lnSpc>
+                <a:spcPts val="1600"/>
+              </a:lnSpc>
+              <a:spcAft>
+                <a:spcPts val="900"/>
+              </a:spcAft>
+              <a:buSzPct val="100000"/>
+              <a:buChar char="●"/>
+            </a:pPr>
+            <a:r>
+              <a:rPr lang="en-US" sz="1200" dirty="0">
+                <a:solidFill>
+                  <a:srgbClr val="E6EDF3"/>
+                </a:solidFill>
+                <a:latin typeface="Calibri" pitchFamily="34" charset="0"/>
+                <a:ea typeface="Calibri" pitchFamily="34" charset="-122"/>
+                <a:cs typeface="Calibri" pitchFamily="34" charset="-120"/>
+              </a:rPr>
+              <a:t>✍ For my approval — 👁 View, then Approve &amp; Sign or Return</a:t>
+            </a:r>
+            <a:endParaRPr lang="en-US" sz="1200" dirty="0"/>
+          </a:p>
+          <a:p>
+            <a:pPr marL="342900" indent="-342900">
+              <a:lnSpc>
+                <a:spcPts val="1600"/>
+              </a:lnSpc>
+              <a:spcAft>
+                <a:spcPts val="900"/>
+              </a:spcAft>
+              <a:buSzPct val="100000"/>
+              <a:buChar char="●"/>
+            </a:pPr>
+            <a:r>
+              <a:rPr lang="en-US" sz="1200" dirty="0">
+                <a:solidFill>
+                  <a:srgbClr val="E6EDF3"/>
+                </a:solidFill>
+                <a:latin typeface="Calibri" pitchFamily="34" charset="0"/>
+                <a:ea typeface="Calibri" pitchFamily="34" charset="-122"/>
+                <a:cs typeface="Calibri" pitchFamily="34" charset="-120"/>
+              </a:rPr>
+              <a:t>↩ Returned to me — Load it, fix it, submit again</a:t>
+            </a:r>
+            <a:endParaRPr lang="en-US" sz="1200" dirty="0"/>
+          </a:p>
+          <a:p>
+            <a:pPr marL="342900" indent="-342900">
+              <a:lnSpc>
+                <a:spcPts val="1600"/>
+              </a:lnSpc>
+              <a:spcAft>
+                <a:spcPts val="900"/>
+              </a:spcAft>
+              <a:buSzPct val="100000"/>
+              <a:buChar char="●"/>
+            </a:pPr>
+            <a:r>
+              <a:rPr lang="en-US" sz="1200" dirty="0">
+                <a:solidFill>
+                  <a:srgbClr val="E6EDF3"/>
+                </a:solidFill>
+                <a:latin typeface="Calibri" pitchFamily="34" charset="0"/>
+                <a:ea typeface="Calibri" pitchFamily="34" charset="-122"/>
+                <a:cs typeface="Calibri" pitchFamily="34" charset="-120"/>
+              </a:rPr>
+              <a:t>📂 My open CEs — most urgent first, with the deadline countdown</a:t>
+            </a:r>
+            <a:endParaRPr lang="en-US" sz="1200" dirty="0"/>
+          </a:p>
+          <a:p>
+            <a:pPr marL="342900" indent="-342900">
+              <a:lnSpc>
+                <a:spcPts val="1600"/>
+              </a:lnSpc>
+              <a:spcAft>
+                <a:spcPts val="900"/>
+              </a:spcAft>
+              <a:buSzPct val="100000"/>
+              <a:buChar char="●"/>
+            </a:pPr>
+            <a:r>
+              <a:rPr lang="en-US" sz="1200" dirty="0">
+                <a:solidFill>
+                  <a:srgbClr val="E6EDF3"/>
+                </a:solidFill>
+                <a:latin typeface="Calibri" pitchFamily="34" charset="0"/>
+                <a:ea typeface="Calibri" pitchFamily="34" charset="-122"/>
+                <a:cs typeface="Calibri" pitchFamily="34" charset="-120"/>
+              </a:rPr>
+              <a:t>📝 My drafts — Resume · ⏳ My CEs in approval — who it waits on</a:t>
+            </a:r>
+            <a:endParaRPr lang="en-US" sz="1200" dirty="0"/>
+          </a:p>
+          <a:p>
+            <a:pPr marL="342900" indent="-342900">
+              <a:lnSpc>
+                <a:spcPts val="1600"/>
+              </a:lnSpc>
+              <a:spcAft>
+                <a:spcPts val="900"/>
+              </a:spcAft>
+              <a:buSzPct val="100000"/>
+              <a:buChar char="●"/>
+            </a:pPr>
+            <a:r>
+              <a:rPr lang="en-US" sz="1200" dirty="0">
+                <a:solidFill>
+                  <a:srgbClr val="E6EDF3"/>
+                </a:solidFill>
+                <a:latin typeface="Calibri" pitchFamily="34" charset="0"/>
+                <a:ea typeface="Calibri" pitchFamily="34" charset="-122"/>
+                <a:cs typeface="Calibri" pitchFamily="34" charset="-120"/>
+              </a:rPr>
+              <a:t>🔎 For review — CEs at For Approval that are not routed for signing</a:t>
+            </a:r>
+            <a:endParaRPr lang="en-US" sz="1200" dirty="0"/>
+          </a:p>
+        </p:txBody>
+      </p:sp>
+      <p:sp>
+        <p:nvSpPr>
+          <p:cNvPr id="11" name="Text 9"/>
+          <p:cNvSpPr/>
+          <p:nvPr/>
+        </p:nvSpPr>
+        <p:spPr>
+          <a:xfrm>
+            <a:off x="566928" y="6437376"/>
+            <a:ext cx="5486400" cy="237744"/>
+          </a:xfrm>
+          <a:prstGeom prst="rect">
+            <a:avLst/>
+          </a:prstGeom>
+          <a:noFill/>
+          <a:ln/>
+        </p:spPr>
+        <p:txBody>
+          <a:bodyPr wrap="square" lIns="0" tIns="0" rIns="0" bIns="0" rtlCol="0" anchor="ctr"/>
+          <a:lstStyle/>
+          <a:p>
+            <a:pPr indent="0" marL="0">
+              <a:buNone/>
+            </a:pPr>
+            <a:r>
+              <a:rPr lang="en-US" sz="900" dirty="0">
+                <a:solidFill>
+                  <a:srgbClr val="6E7681"/>
+                </a:solidFill>
+                <a:latin typeface="Calibri" pitchFamily="34" charset="0"/>
+                <a:ea typeface="Calibri" pitchFamily="34" charset="-122"/>
+                <a:cs typeface="Calibri" pitchFamily="34" charset="-120"/>
+              </a:rPr>
+              <a:t>SHIC Cost Estimator — End-User Manual</a:t>
+            </a:r>
+            <a:endParaRPr lang="en-US" sz="900" dirty="0"/>
+          </a:p>
+        </p:txBody>
+      </p:sp>
+      <p:sp>
+        <p:nvSpPr>
+          <p:cNvPr id="12" name="Text 10"/>
+          <p:cNvSpPr/>
+          <p:nvPr/>
+        </p:nvSpPr>
+        <p:spPr>
+          <a:xfrm>
+            <a:off x="10981944" y="6437376"/>
+            <a:ext cx="640080" cy="237744"/>
+          </a:xfrm>
+          <a:prstGeom prst="rect">
+            <a:avLst/>
+          </a:prstGeom>
+          <a:noFill/>
+          <a:ln/>
+        </p:spPr>
+        <p:txBody>
+          <a:bodyPr wrap="square" lIns="0" tIns="0" rIns="0" bIns="0" rtlCol="0" anchor="ctr"/>
+          <a:lstStyle/>
+          <a:p>
+            <a:pPr algn="r" indent="0" marL="0">
+              <a:buNone/>
+            </a:pPr>
+            <a:r>
+              <a:rPr lang="en-US" sz="900" dirty="0">
+                <a:solidFill>
+                  <a:srgbClr val="6E7681"/>
+                </a:solidFill>
+                <a:latin typeface="Calibri" pitchFamily="34" charset="0"/>
+                <a:ea typeface="Calibri" pitchFamily="34" charset="-122"/>
+                <a:cs typeface="Calibri" pitchFamily="34" charset="-120"/>
+              </a:rPr>
+              <a:t>4</a:t>
+            </a:r>
+            <a:endParaRPr lang="en-US" sz="900" dirty="0"/>
+          </a:p>
+        </p:txBody>
+      </p:sp>
+    </p:spTree>
+  </p:cSld>
+  <p:clrMapOvr>
+    <a:masterClrMapping/>
+  </p:clrMapOvr>
+</p:sld>
+</file>
+
+<file path=ppt/slides/slide31.xml><?xml version="1.0" encoding="utf-8"?>
+<p:sld xmlns:a="http://schemas.openxmlformats.org/drawingml/2006/main" xmlns:p="http://schemas.openxmlformats.org/presentationml/2006/main" xmlns:r="http://schemas.openxmlformats.org/officeDocument/2006/relationships">
+  <p:cSld>
+    <p:bg>
+      <p:bgPr>
+        <a:solidFill>
+          <a:srgbClr val="0D1117"/>
+        </a:solidFill>
+      </p:bgPr>
+    </p:bg>
+    <p:spTree>
+      <p:nvGrpSpPr>
+        <p:cNvPr id="1" name=""/>
+        <p:cNvGrpSpPr/>
+        <p:nvPr/>
+      </p:nvGrpSpPr>
+      <p:grpSpPr/>
+      <p:sp>
+        <p:nvSpPr>
+          <p:cNvPr id="2" name="Text 0"/>
+          <p:cNvSpPr/>
+          <p:nvPr/>
+        </p:nvSpPr>
+        <p:spPr>
+          <a:xfrm>
+            <a:off x="566928" y="384048"/>
+            <a:ext cx="8229600" cy="256032"/>
+          </a:xfrm>
+          <a:prstGeom prst="rect">
+            <a:avLst/>
+          </a:prstGeom>
+          <a:noFill/>
+          <a:ln/>
+        </p:spPr>
+        <p:txBody>
+          <a:bodyPr wrap="square" lIns="0" tIns="0" rIns="0" bIns="0" rtlCol="0" anchor="ctr"/>
+          <a:lstStyle/>
+          <a:p>
+            <a:pPr indent="0" marL="0">
+              <a:buNone/>
+            </a:pPr>
+            <a:r>
+              <a:rPr lang="en-US" sz="1100" b="1" spc="200" kern="0" dirty="0">
+                <a:solidFill>
+                  <a:srgbClr val="F0A429"/>
+                </a:solidFill>
+                <a:latin typeface="Arial" pitchFamily="34" charset="0"/>
+                <a:ea typeface="Arial" pitchFamily="34" charset="-122"/>
+                <a:cs typeface="Arial" pitchFamily="34" charset="-120"/>
+              </a:rPr>
+              <a:t>STEP 9 · APPROVALS</a:t>
+            </a:r>
+            <a:endParaRPr lang="en-US" sz="1100" dirty="0"/>
+          </a:p>
+        </p:txBody>
+      </p:sp>
+      <p:sp>
+        <p:nvSpPr>
+          <p:cNvPr id="3" name="Text 1"/>
+          <p:cNvSpPr/>
+          <p:nvPr/>
+        </p:nvSpPr>
+        <p:spPr>
+          <a:xfrm>
+            <a:off x="566928" y="694944"/>
+            <a:ext cx="11055096" cy="566928"/>
+          </a:xfrm>
+          <a:prstGeom prst="rect">
+            <a:avLst/>
+          </a:prstGeom>
+          <a:noFill/>
+          <a:ln/>
+        </p:spPr>
+        <p:txBody>
+          <a:bodyPr wrap="square" lIns="0" tIns="0" rIns="0" bIns="0" rtlCol="0" anchor="ctr"/>
+          <a:lstStyle/>
+          <a:p>
+            <a:pPr indent="0" marL="0">
+              <a:buNone/>
+            </a:pPr>
+            <a:r>
+              <a:rPr lang="en-US" sz="3200" b="1" dirty="0">
+                <a:solidFill>
+                  <a:srgbClr val="E6EDF3"/>
+                </a:solidFill>
+                <a:latin typeface="Arial" pitchFamily="34" charset="0"/>
+                <a:ea typeface="Arial" pitchFamily="34" charset="-122"/>
+                <a:cs typeface="Arial" pitchFamily="34" charset="-120"/>
+              </a:rPr>
+              <a:t>Review and sign in the app</a:t>
+            </a:r>
+            <a:endParaRPr lang="en-US" sz="3200" dirty="0"/>
+          </a:p>
+        </p:txBody>
+      </p:sp>
+      <p:sp>
+        <p:nvSpPr>
+          <p:cNvPr id="4" name="Text 2"/>
+          <p:cNvSpPr/>
+          <p:nvPr/>
+        </p:nvSpPr>
+        <p:spPr>
+          <a:xfrm>
+            <a:off x="566928" y="1298448"/>
+            <a:ext cx="10972800" cy="365760"/>
+          </a:xfrm>
+          <a:prstGeom prst="rect">
+            <a:avLst/>
+          </a:prstGeom>
+          <a:noFill/>
+          <a:ln/>
+        </p:spPr>
+        <p:txBody>
+          <a:bodyPr wrap="square" lIns="0" tIns="0" rIns="0" bIns="0" rtlCol="0" anchor="t"/>
+          <a:lstStyle/>
+          <a:p>
+            <a:pPr algn="l" indent="0" marL="0">
+              <a:lnSpc>
+                <a:spcPts val="2000"/>
+              </a:lnSpc>
+              <a:buNone/>
+            </a:pPr>
+            <a:r>
+              <a:rPr lang="en-US" sz="1400" dirty="0">
+                <a:solidFill>
+                  <a:srgbClr val="9AA4AF"/>
+                </a:solidFill>
+                <a:latin typeface="Calibri" pitchFamily="34" charset="0"/>
+                <a:ea typeface="Calibri" pitchFamily="34" charset="-122"/>
+                <a:cs typeface="Calibri" pitchFamily="34" charset="-120"/>
+              </a:rPr>
+              <a:t>Approvers read and sign the CE without loading it. Every signature is stamped with who signed and when.</a:t>
+            </a:r>
+            <a:endParaRPr lang="en-US" sz="1400" dirty="0"/>
+          </a:p>
+        </p:txBody>
+      </p:sp>
+      <p:sp>
+        <p:nvSpPr>
+          <p:cNvPr id="5" name="Shape 3"/>
+          <p:cNvSpPr/>
+          <p:nvPr/>
+        </p:nvSpPr>
+        <p:spPr>
+          <a:xfrm>
+            <a:off x="566928" y="1911096"/>
+            <a:ext cx="5532120" cy="3566160"/>
+          </a:xfrm>
+          <a:prstGeom prst="roundRect">
+            <a:avLst>
+              <a:gd name="adj" fmla="val 2051"/>
+            </a:avLst>
+          </a:prstGeom>
+          <a:solidFill>
+            <a:srgbClr val="1C2128"/>
+          </a:solidFill>
+          <a:ln w="12700">
+            <a:solidFill>
+              <a:srgbClr val="30363D"/>
+            </a:solidFill>
+            <a:prstDash val="solid"/>
+          </a:ln>
+          <a:effectLst>
+            <a:outerShdw sx="100000" sy="100000" kx="0" ky="0" algn="bl" rotWithShape="0" blurRad="152400" dist="38100" dir="5400000">
+              <a:srgbClr val="000000">
+                <a:alpha val="45000"/>
+              </a:srgbClr>
+            </a:outerShdw>
+          </a:effectLst>
+        </p:spPr>
+        <p:txBody>
+          <a:bodyPr/>
+          <a:p/>
+        </p:txBody>
+      </p:sp>
+      <p:sp>
+        <p:nvSpPr>
+          <p:cNvPr id="6" name="Text 4"/>
+          <p:cNvSpPr/>
+          <p:nvPr/>
+        </p:nvSpPr>
+        <p:spPr>
+          <a:xfrm>
+            <a:off x="841248" y="2121408"/>
+            <a:ext cx="4937760" cy="329184"/>
+          </a:xfrm>
+          <a:prstGeom prst="rect">
+            <a:avLst/>
+          </a:prstGeom>
+          <a:noFill/>
+          <a:ln/>
+        </p:spPr>
+        <p:txBody>
+          <a:bodyPr wrap="square" lIns="0" tIns="0" rIns="0" bIns="0" rtlCol="0" anchor="ctr"/>
+          <a:lstStyle/>
+          <a:p>
+            <a:pPr indent="0" marL="0">
+              <a:buNone/>
+            </a:pPr>
+            <a:r>
+              <a:rPr lang="en-US" sz="1700" b="1" dirty="0">
+                <a:solidFill>
+                  <a:srgbClr val="A78BFA"/>
+                </a:solidFill>
+                <a:latin typeface="Arial" pitchFamily="34" charset="0"/>
+                <a:ea typeface="Arial" pitchFamily="34" charset="-122"/>
+                <a:cs typeface="Arial" pitchFamily="34" charset="-120"/>
+              </a:rPr>
+              <a:t>Routing it (Summary → Signatories)</a:t>
+            </a:r>
+            <a:endParaRPr lang="en-US" sz="1700" dirty="0"/>
+          </a:p>
+        </p:txBody>
+      </p:sp>
+      <p:sp>
+        <p:nvSpPr>
+          <p:cNvPr id="7" name="Text 5"/>
+          <p:cNvSpPr/>
+          <p:nvPr/>
+        </p:nvSpPr>
+        <p:spPr>
+          <a:xfrm>
+            <a:off x="841248" y="2578608"/>
+            <a:ext cx="4983480" cy="2651760"/>
+          </a:xfrm>
+          <a:prstGeom prst="rect">
+            <a:avLst/>
+          </a:prstGeom>
+          <a:noFill/>
+          <a:ln/>
+        </p:spPr>
+        <p:txBody>
+          <a:bodyPr wrap="square" lIns="0" tIns="0" rIns="0" bIns="0" rtlCol="0" anchor="t"/>
+          <a:lstStyle/>
+          <a:p>
+            <a:pPr marL="342900" indent="-342900">
+              <a:lnSpc>
+                <a:spcPts val="1600"/>
+              </a:lnSpc>
+              <a:spcAft>
+                <a:spcPts val="900"/>
+              </a:spcAft>
+              <a:buSzPct val="100000"/>
+              <a:buChar char="●"/>
+            </a:pPr>
+            <a:r>
+              <a:rPr lang="en-US" sz="1200" dirty="0">
+                <a:solidFill>
+                  <a:srgbClr val="E6EDF3"/>
+                </a:solidFill>
+                <a:latin typeface="Calibri" pitchFamily="34" charset="0"/>
+                <a:ea typeface="Calibri" pitchFamily="34" charset="-122"/>
+                <a:cs typeface="Calibri" pitchFamily="34" charset="-120"/>
+              </a:rPr>
+              <a:t>Link each signatory line to a user account; give it a Step</a:t>
+            </a:r>
+            <a:endParaRPr lang="en-US" sz="1200" dirty="0"/>
+          </a:p>
+          <a:p>
+            <a:pPr marL="342900" indent="-342900">
+              <a:lnSpc>
+                <a:spcPts val="1600"/>
+              </a:lnSpc>
+              <a:spcAft>
+                <a:spcPts val="900"/>
+              </a:spcAft>
+              <a:buSzPct val="100000"/>
+              <a:buChar char="●"/>
+            </a:pPr>
+            <a:r>
+              <a:rPr lang="en-US" sz="1200" dirty="0">
+                <a:solidFill>
+                  <a:srgbClr val="E6EDF3"/>
+                </a:solidFill>
+                <a:latin typeface="Calibri" pitchFamily="34" charset="0"/>
+                <a:ea typeface="Calibri" pitchFamily="34" charset="-122"/>
+                <a:cs typeface="Calibri" pitchFamily="34" charset="-120"/>
+              </a:rPr>
+              <a:t>Same step = sign at the same time; the next step opens when all have signed</a:t>
+            </a:r>
+            <a:endParaRPr lang="en-US" sz="1200" dirty="0"/>
+          </a:p>
+          <a:p>
+            <a:pPr marL="342900" indent="-342900">
+              <a:lnSpc>
+                <a:spcPts val="1600"/>
+              </a:lnSpc>
+              <a:spcAft>
+                <a:spcPts val="900"/>
+              </a:spcAft>
+              <a:buSzPct val="100000"/>
+              <a:buChar char="●"/>
+            </a:pPr>
+            <a:r>
+              <a:rPr lang="en-US" sz="1200" dirty="0">
+                <a:solidFill>
+                  <a:srgbClr val="E6EDF3"/>
+                </a:solidFill>
+                <a:latin typeface="Calibri" pitchFamily="34" charset="0"/>
+                <a:ea typeface="Calibri" pitchFamily="34" charset="-122"/>
+                <a:cs typeface="Calibri" pitchFamily="34" charset="-120"/>
+              </a:rPr>
+              <a:t>One after another · All at once set the steps for you</a:t>
+            </a:r>
+            <a:endParaRPr lang="en-US" sz="1200" dirty="0"/>
+          </a:p>
+          <a:p>
+            <a:pPr marL="342900" indent="-342900">
+              <a:lnSpc>
+                <a:spcPts val="1600"/>
+              </a:lnSpc>
+              <a:spcAft>
+                <a:spcPts val="900"/>
+              </a:spcAft>
+              <a:buSzPct val="100000"/>
+              <a:buChar char="●"/>
+            </a:pPr>
+            <a:r>
+              <a:rPr lang="en-US" sz="1200" dirty="0">
+                <a:solidFill>
+                  <a:srgbClr val="E6EDF3"/>
+                </a:solidFill>
+                <a:latin typeface="Calibri" pitchFamily="34" charset="0"/>
+                <a:ea typeface="Calibri" pitchFamily="34" charset="-122"/>
+                <a:cs typeface="Calibri" pitchFamily="34" charset="-120"/>
+              </a:rPr>
+              <a:t>📤 Submit for approval saves it and sets Monitoring to For Approval</a:t>
+            </a:r>
+            <a:endParaRPr lang="en-US" sz="1200" dirty="0"/>
+          </a:p>
+          <a:p>
+            <a:pPr marL="342900" indent="-342900">
+              <a:lnSpc>
+                <a:spcPts val="1600"/>
+              </a:lnSpc>
+              <a:spcAft>
+                <a:spcPts val="900"/>
+              </a:spcAft>
+              <a:buSzPct val="100000"/>
+              <a:buChar char="●"/>
+            </a:pPr>
+            <a:r>
+              <a:rPr lang="en-US" sz="1200" dirty="0">
+                <a:solidFill>
+                  <a:srgbClr val="E6EDF3"/>
+                </a:solidFill>
+                <a:latin typeface="Calibri" pitchFamily="34" charset="0"/>
+                <a:ea typeface="Calibri" pitchFamily="34" charset="-122"/>
+                <a:cs typeface="Calibri" pitchFamily="34" charset="-120"/>
+              </a:rPr>
+              <a:t>Withdraw (submitter or admin) takes it back and clears signatures</a:t>
+            </a:r>
+            <a:endParaRPr lang="en-US" sz="1200" dirty="0"/>
+          </a:p>
+        </p:txBody>
+      </p:sp>
+      <p:sp>
+        <p:nvSpPr>
+          <p:cNvPr id="8" name="Shape 6"/>
+          <p:cNvSpPr/>
+          <p:nvPr/>
+        </p:nvSpPr>
+        <p:spPr>
+          <a:xfrm>
+            <a:off x="6400800" y="1911096"/>
+            <a:ext cx="5221224" cy="3566160"/>
+          </a:xfrm>
+          <a:prstGeom prst="roundRect">
+            <a:avLst>
+              <a:gd name="adj" fmla="val 2051"/>
+            </a:avLst>
+          </a:prstGeom>
+          <a:solidFill>
+            <a:srgbClr val="1C2128"/>
+          </a:solidFill>
+          <a:ln w="12700">
+            <a:solidFill>
+              <a:srgbClr val="30363D"/>
+            </a:solidFill>
+            <a:prstDash val="solid"/>
+          </a:ln>
+          <a:effectLst>
+            <a:outerShdw sx="100000" sy="100000" kx="0" ky="0" algn="bl" rotWithShape="0" blurRad="152400" dist="38100" dir="5400000">
+              <a:srgbClr val="000000">
+                <a:alpha val="45000"/>
+              </a:srgbClr>
+            </a:outerShdw>
+          </a:effectLst>
+        </p:spPr>
+        <p:txBody>
+          <a:bodyPr/>
+          <a:p/>
+        </p:txBody>
+      </p:sp>
+      <p:sp>
+        <p:nvSpPr>
+          <p:cNvPr id="9" name="Text 7"/>
+          <p:cNvSpPr/>
+          <p:nvPr/>
+        </p:nvSpPr>
+        <p:spPr>
+          <a:xfrm>
+            <a:off x="6675120" y="2121408"/>
+            <a:ext cx="4663440" cy="329184"/>
+          </a:xfrm>
+          <a:prstGeom prst="rect">
+            <a:avLst/>
+          </a:prstGeom>
+          <a:noFill/>
+          <a:ln/>
+        </p:spPr>
+        <p:txBody>
+          <a:bodyPr wrap="square" lIns="0" tIns="0" rIns="0" bIns="0" rtlCol="0" anchor="ctr"/>
+          <a:lstStyle/>
+          <a:p>
+            <a:pPr indent="0" marL="0">
+              <a:buNone/>
+            </a:pPr>
+            <a:r>
+              <a:rPr lang="en-US" sz="1700" b="1" dirty="0">
+                <a:solidFill>
+                  <a:srgbClr val="F0A429"/>
+                </a:solidFill>
+                <a:latin typeface="Arial" pitchFamily="34" charset="0"/>
+                <a:ea typeface="Arial" pitchFamily="34" charset="-122"/>
+                <a:cs typeface="Arial" pitchFamily="34" charset="-120"/>
+              </a:rPr>
+              <a:t>Signing it</a:t>
+            </a:r>
+            <a:endParaRPr lang="en-US" sz="1700" dirty="0"/>
+          </a:p>
+        </p:txBody>
+      </p:sp>
+      <p:sp>
+        <p:nvSpPr>
+          <p:cNvPr id="10" name="Text 8"/>
+          <p:cNvSpPr/>
+          <p:nvPr/>
+        </p:nvSpPr>
+        <p:spPr>
+          <a:xfrm>
+            <a:off x="6675120" y="2578608"/>
+            <a:ext cx="4709160" cy="2651760"/>
+          </a:xfrm>
+          <a:prstGeom prst="rect">
+            <a:avLst/>
+          </a:prstGeom>
+          <a:noFill/>
+          <a:ln/>
+        </p:spPr>
+        <p:txBody>
+          <a:bodyPr wrap="square" lIns="0" tIns="0" rIns="0" bIns="0" rtlCol="0" anchor="t"/>
+          <a:lstStyle/>
+          <a:p>
+            <a:pPr marL="342900" indent="-342900">
+              <a:lnSpc>
+                <a:spcPts val="1600"/>
+              </a:lnSpc>
+              <a:spcAft>
+                <a:spcPts val="900"/>
+              </a:spcAft>
+              <a:buSzPct val="100000"/>
+              <a:buChar char="●"/>
+            </a:pPr>
+            <a:r>
+              <a:rPr lang="en-US" sz="1200" dirty="0">
+                <a:solidFill>
+                  <a:srgbClr val="E6EDF3"/>
+                </a:solidFill>
+                <a:latin typeface="Calibri" pitchFamily="34" charset="0"/>
+                <a:ea typeface="Calibri" pitchFamily="34" charset="-122"/>
+                <a:cs typeface="Calibri" pitchFamily="34" charset="-120"/>
+              </a:rPr>
+              <a:t>From My Work or ✍ Awaiting my signature: 👁 View → ✍ Approve &amp; Sign</a:t>
+            </a:r>
+            <a:endParaRPr lang="en-US" sz="1200" dirty="0"/>
+          </a:p>
+          <a:p>
+            <a:pPr marL="342900" indent="-342900">
+              <a:lnSpc>
+                <a:spcPts val="1600"/>
+              </a:lnSpc>
+              <a:spcAft>
+                <a:spcPts val="900"/>
+              </a:spcAft>
+              <a:buSzPct val="100000"/>
+              <a:buChar char="●"/>
+            </a:pPr>
+            <a:r>
+              <a:rPr lang="en-US" sz="1200" dirty="0">
+                <a:solidFill>
+                  <a:srgbClr val="E6EDF3"/>
+                </a:solidFill>
+                <a:latin typeface="Calibri" pitchFamily="34" charset="0"/>
+                <a:ea typeface="Calibri" pitchFamily="34" charset="-122"/>
+                <a:cs typeface="Calibri" pitchFamily="34" charset="-120"/>
+              </a:rPr>
+              <a:t>Draw your signature; it is watermarked “E-SIGNED · name” with date, time and CE number</a:t>
+            </a:r>
+            <a:endParaRPr lang="en-US" sz="1200" dirty="0"/>
+          </a:p>
+          <a:p>
+            <a:pPr marL="342900" indent="-342900">
+              <a:lnSpc>
+                <a:spcPts val="1600"/>
+              </a:lnSpc>
+              <a:spcAft>
+                <a:spcPts val="900"/>
+              </a:spcAft>
+              <a:buSzPct val="100000"/>
+              <a:buChar char="●"/>
+            </a:pPr>
+            <a:r>
+              <a:rPr lang="en-US" sz="1200" dirty="0">
+                <a:solidFill>
+                  <a:srgbClr val="E6EDF3"/>
+                </a:solidFill>
+                <a:latin typeface="Calibri" pitchFamily="34" charset="0"/>
+                <a:ea typeface="Calibri" pitchFamily="34" charset="-122"/>
+                <a:cs typeface="Calibri" pitchFamily="34" charset="-120"/>
+              </a:rPr>
+              <a:t>The printed CE shows “e-signed” and the time under each name</a:t>
+            </a:r>
+            <a:endParaRPr lang="en-US" sz="1200" dirty="0"/>
+          </a:p>
+          <a:p>
+            <a:pPr marL="342900" indent="-342900">
+              <a:lnSpc>
+                <a:spcPts val="1600"/>
+              </a:lnSpc>
+              <a:spcAft>
+                <a:spcPts val="900"/>
+              </a:spcAft>
+              <a:buSzPct val="100000"/>
+              <a:buChar char="●"/>
+            </a:pPr>
+            <a:r>
+              <a:rPr lang="en-US" sz="1200" dirty="0">
+                <a:solidFill>
+                  <a:srgbClr val="E6EDF3"/>
+                </a:solidFill>
+                <a:latin typeface="Calibri" pitchFamily="34" charset="0"/>
+                <a:ea typeface="Calibri" pitchFamily="34" charset="-122"/>
+                <a:cs typeface="Calibri" pitchFamily="34" charset="-120"/>
+              </a:rPr>
+              <a:t>↩ Return needs a comment — it goes to Remarks and clears the signatures</a:t>
+            </a:r>
+            <a:endParaRPr lang="en-US" sz="1200" dirty="0"/>
+          </a:p>
+          <a:p>
+            <a:pPr marL="342900" indent="-342900">
+              <a:lnSpc>
+                <a:spcPts val="1600"/>
+              </a:lnSpc>
+              <a:spcAft>
+                <a:spcPts val="900"/>
+              </a:spcAft>
+              <a:buSzPct val="100000"/>
+              <a:buChar char="●"/>
+            </a:pPr>
+            <a:r>
+              <a:rPr lang="en-US" sz="1200" dirty="0">
+                <a:solidFill>
+                  <a:srgbClr val="E6EDF3"/>
+                </a:solidFill>
+                <a:latin typeface="Calibri" pitchFamily="34" charset="0"/>
+                <a:ea typeface="Calibri" pitchFamily="34" charset="-122"/>
+                <a:cs typeface="Calibri" pitchFamily="34" charset="-120"/>
+              </a:rPr>
+              <a:t>Change the figures after submitting and every signature is cleared; it restarts at step 1</a:t>
+            </a:r>
+            <a:endParaRPr lang="en-US" sz="1200" dirty="0"/>
+          </a:p>
+        </p:txBody>
+      </p:sp>
+      <p:sp>
+        <p:nvSpPr>
+          <p:cNvPr id="11" name="Text 9"/>
+          <p:cNvSpPr/>
+          <p:nvPr/>
+        </p:nvSpPr>
+        <p:spPr>
+          <a:xfrm>
+            <a:off x="566928" y="6437376"/>
+            <a:ext cx="5486400" cy="237744"/>
+          </a:xfrm>
+          <a:prstGeom prst="rect">
+            <a:avLst/>
+          </a:prstGeom>
+          <a:noFill/>
+          <a:ln/>
+        </p:spPr>
+        <p:txBody>
+          <a:bodyPr wrap="square" lIns="0" tIns="0" rIns="0" bIns="0" rtlCol="0" anchor="ctr"/>
+          <a:lstStyle/>
+          <a:p>
+            <a:pPr indent="0" marL="0">
+              <a:buNone/>
+            </a:pPr>
+            <a:r>
+              <a:rPr lang="en-US" sz="900" dirty="0">
+                <a:solidFill>
+                  <a:srgbClr val="6E7681"/>
+                </a:solidFill>
+                <a:latin typeface="Calibri" pitchFamily="34" charset="0"/>
+                <a:ea typeface="Calibri" pitchFamily="34" charset="-122"/>
+                <a:cs typeface="Calibri" pitchFamily="34" charset="-120"/>
+              </a:rPr>
+              <a:t>SHIC Cost Estimator — End-User Manual</a:t>
+            </a:r>
+            <a:endParaRPr lang="en-US" sz="900" dirty="0"/>
+          </a:p>
+        </p:txBody>
+      </p:sp>
+      <p:sp>
+        <p:nvSpPr>
+          <p:cNvPr id="12" name="Text 10"/>
+          <p:cNvSpPr/>
+          <p:nvPr/>
+        </p:nvSpPr>
+        <p:spPr>
+          <a:xfrm>
+            <a:off x="10981944" y="6437376"/>
+            <a:ext cx="640080" cy="237744"/>
+          </a:xfrm>
+          <a:prstGeom prst="rect">
+            <a:avLst/>
+          </a:prstGeom>
+          <a:noFill/>
+          <a:ln/>
+        </p:spPr>
+        <p:txBody>
+          <a:bodyPr wrap="square" lIns="0" tIns="0" rIns="0" bIns="0" rtlCol="0" anchor="ctr"/>
+          <a:lstStyle/>
+          <a:p>
+            <a:pPr algn="r" indent="0" marL="0">
+              <a:buNone/>
+            </a:pPr>
+            <a:r>
+              <a:rPr lang="en-US" sz="900" dirty="0">
+                <a:solidFill>
+                  <a:srgbClr val="6E7681"/>
+                </a:solidFill>
+                <a:latin typeface="Calibri" pitchFamily="34" charset="0"/>
+                <a:ea typeface="Calibri" pitchFamily="34" charset="-122"/>
+                <a:cs typeface="Calibri" pitchFamily="34" charset="-120"/>
+              </a:rPr>
+              <a:t>24</a:t>
             </a:r>
             <a:endParaRPr lang="en-US" sz="900" dirty="0"/>
           </a:p>
@@ -28908,7 +30232,7 @@
                 <a:ea typeface="Arial" pitchFamily="34" charset="-122"/>
                 <a:cs typeface="Arial" pitchFamily="34" charset="-120"/>
               </a:rPr>
-              <a:t>4</a:t>
+              <a:t>5</a:t>
             </a:r>
             <a:endParaRPr lang="en-US" sz="1300" dirty="0"/>
           </a:p>
@@ -29357,7 +30681,7 @@
                 <a:ea typeface="Calibri" pitchFamily="34" charset="-122"/>
                 <a:cs typeface="Calibri" pitchFamily="34" charset="-120"/>
               </a:rPr>
-              <a:t>4</a:t>
+              <a:t>5</a:t>
             </a:r>
             <a:endParaRPr lang="en-US" sz="900" dirty="0"/>
           </a:p>
@@ -30892,7 +32216,7 @@
                 <a:ea typeface="Calibri" pitchFamily="34" charset="-122"/>
                 <a:cs typeface="Calibri" pitchFamily="34" charset="-120"/>
               </a:rPr>
-              <a:t>5</a:t>
+              <a:t>6</a:t>
             </a:r>
             <a:endParaRPr lang="en-US" sz="900" dirty="0"/>
           </a:p>
@@ -32225,7 +33549,7 @@
                 <a:ea typeface="Calibri" pitchFamily="34" charset="-122"/>
                 <a:cs typeface="Calibri" pitchFamily="34" charset="-120"/>
               </a:rPr>
-              <a:t>6</a:t>
+              <a:t>7</a:t>
             </a:r>
             <a:endParaRPr lang="en-US" sz="900" dirty="0"/>
           </a:p>
@@ -33728,7 +35052,7 @@
                 <a:ea typeface="Calibri" pitchFamily="34" charset="-122"/>
                 <a:cs typeface="Calibri" pitchFamily="34" charset="-120"/>
               </a:rPr>
-              <a:t>7</a:t>
+              <a:t>8</a:t>
             </a:r>
             <a:endParaRPr lang="en-US" sz="900" dirty="0"/>
           </a:p>
@@ -35251,7 +36575,7 @@
                 <a:ea typeface="Calibri" pitchFamily="34" charset="-122"/>
                 <a:cs typeface="Calibri" pitchFamily="34" charset="-120"/>
               </a:rPr>
-              <a:t>8</a:t>
+              <a:t>9</a:t>
             </a:r>
             <a:endParaRPr lang="en-US" sz="900" dirty="0"/>
           </a:p>
@@ -37207,7 +38531,7 @@
                 <a:ea typeface="Calibri" pitchFamily="34" charset="-122"/>
                 <a:cs typeface="Calibri" pitchFamily="34" charset="-120"/>
               </a:rPr>
-              <a:t>9</a:t>
+              <a:t>10</a:t>
             </a:r>
             <a:endParaRPr lang="en-US" sz="900" dirty="0"/>
           </a:p>

</xml_diff>

<commit_message>
Manual: builds 219-234 -- My Work badge, approvals on saved CEs, any edit clears signatures, offline and sign-in pop-ups, SOW Breakdown Masterlist picker, printed CE header/footer and signatory rows, new Themes and backgrounds slide
Co-Authored-By: Claude Opus 5 <noreply@anthropic.com>
</commit_message>
<xml_diff>
--- a/docs/SHIC-Cost-Estimator-User-Manual.pptx
+++ b/docs/SHIC-Cost-Estimator-User-Manual.pptx
@@ -35,6 +35,7 @@
     <p:sldId id="273" r:id="rId19"/>
     <p:sldId id="274" r:id="rId20"/>
     <p:sldId id="275" r:id="rId21"/>
+    <p:sldId id="287" r:id="rId38"/>
     <p:sldId id="276" r:id="rId22"/>
   </p:sldIdLst>
   <p:notesMasterIdLst>
@@ -21073,7 +21074,7 @@
                 <a:ea typeface="Calibri" pitchFamily="34" charset="-122"/>
                 <a:cs typeface="Calibri" pitchFamily="34" charset="-120"/>
               </a:rPr>
-              <a:t>OT HRS/DAY is what you typed; AOT is that × the days</a:t>
+              <a:t>Every page: logo and Document No. at the top; Document No. and Page X of Y at the foot</a:t>
             </a:r>
             <a:endParaRPr lang="en-US" sz="1150" dirty="0"/>
           </a:p>
@@ -21097,7 +21098,7 @@
                 <a:ea typeface="Calibri" pitchFamily="34" charset="-122"/>
                 <a:cs typeface="Calibri" pitchFamily="34" charset="-120"/>
               </a:rPr>
-              <a:t>SELLING PRICE only appears when the margin is not zero</a:t>
+              <a:t>Signatories print four to a row, so signatures stay full size</a:t>
             </a:r>
             <a:endParaRPr lang="en-US" sz="1150" dirty="0"/>
           </a:p>
@@ -21121,7 +21122,7 @@
                 <a:ea typeface="Calibri" pitchFamily="34" charset="-122"/>
                 <a:cs typeface="Calibri" pitchFamily="34" charset="-120"/>
               </a:rPr>
-              <a:t>Left and right margins are 0.25 in — keep Chrome’s Margins on Default</a:t>
+              <a:t>CE TYPE on the left under each title bar; CE No. and date on the right</a:t>
             </a:r>
             <a:endParaRPr lang="en-US" sz="1150" dirty="0"/>
           </a:p>
@@ -21145,7 +21146,31 @@
                 <a:ea typeface="Calibri" pitchFamily="34" charset="-122"/>
                 <a:cs typeface="Calibri" pitchFamily="34" charset="-120"/>
               </a:rPr>
-              <a:t>Tools show BASIS — "per project", "5 days", "24 hrs" — in place of DAYS</a:t>
+              <a:t>SELLING PRICE only appears when the margin is not zero</a:t>
+            </a:r>
+            <a:endParaRPr lang="en-US" sz="1150" dirty="0"/>
+          </a:p>
+          <a:p>
+            <a:pPr marL="342900" indent="-342900">
+              <a:lnSpc>
+                <a:spcPts val="1500"/>
+              </a:lnSpc>
+              <a:spcAft>
+                <a:spcPts val="900"/>
+              </a:spcAft>
+              <a:buSzPct val="100000"/>
+              <a:buChar char="●"/>
+            </a:pPr>
+            <a:r>
+              <a:rPr lang="en-US" sz="1150" dirty="0">
+                <a:solidFill>
+                  <a:srgbClr val="E6EDF3"/>
+                </a:solidFill>
+                <a:latin typeface="Calibri" pitchFamily="34" charset="0"/>
+                <a:ea typeface="Calibri" pitchFamily="34" charset="-122"/>
+                <a:cs typeface="Calibri" pitchFamily="34" charset="-120"/>
+              </a:rPr>
+              <a:t>In the print dialog set Margins to None — each page carries its own</a:t>
             </a:r>
             <a:endParaRPr lang="en-US" sz="1150" dirty="0"/>
           </a:p>
@@ -21539,7 +21564,7 @@
                 <a:ea typeface="Calibri" pitchFamily="34" charset="-122"/>
                 <a:cs typeface="Calibri" pitchFamily="34" charset="-120"/>
               </a:rPr>
-              <a:t>One after another · All at once set the steps for you</a:t>
+              <a:t>📤 Submit for approval works on a new or an already-saved CE</a:t>
             </a:r>
             <a:endParaRPr lang="en-US" sz="1200" dirty="0"/>
           </a:p>
@@ -21563,7 +21588,7 @@
                 <a:ea typeface="Calibri" pitchFamily="34" charset="-122"/>
                 <a:cs typeface="Calibri" pitchFamily="34" charset="-120"/>
               </a:rPr>
-              <a:t>📤 Submit for approval saves it and sets Monitoring to For Approval</a:t>
+              <a:t>Approvers see a red count on 🏠 My Work and a notice when it arrives</a:t>
             </a:r>
             <a:endParaRPr lang="en-US" sz="1200" dirty="0"/>
           </a:p>
@@ -21587,7 +21612,7 @@
                 <a:ea typeface="Calibri" pitchFamily="34" charset="-122"/>
                 <a:cs typeface="Calibri" pitchFamily="34" charset="-120"/>
               </a:rPr>
-              <a:t>Withdraw (submitter or admin) takes it back and clears signatures</a:t>
+              <a:t>Withdraw (submitter or admin) takes it back; route it again on the same number</a:t>
             </a:r>
             <a:endParaRPr lang="en-US" sz="1200" dirty="0"/>
           </a:p>
@@ -21710,7 +21735,7 @@
                 <a:ea typeface="Calibri" pitchFamily="34" charset="-122"/>
                 <a:cs typeface="Calibri" pitchFamily="34" charset="-120"/>
               </a:rPr>
-              <a:t>Set it up once: ✍ My Signature (top bar) — draw or upload an image; saved to your account</a:t>
+              <a:t>Set it up once: ✍ My Signature (top bar) — draw or upload; saved to your account</a:t>
             </a:r>
             <a:endParaRPr lang="en-US" sz="1200" dirty="0"/>
           </a:p>
@@ -21734,7 +21759,7 @@
                 <a:ea typeface="Calibri" pitchFamily="34" charset="-122"/>
                 <a:cs typeface="Calibri" pitchFamily="34" charset="-120"/>
               </a:rPr>
-              <a:t>From My Work or ✍ Awaiting my signature: 👁 View → ✍ Approve &amp; Sign — your saved signature is already on the pad</a:t>
+              <a:t>From My Work: 👁 View → ✍ Approve &amp; Sign — your saved signature is already on the pad</a:t>
             </a:r>
             <a:endParaRPr lang="en-US" sz="1200" dirty="0"/>
           </a:p>
@@ -21758,7 +21783,7 @@
                 <a:ea typeface="Calibri" pitchFamily="34" charset="-122"/>
                 <a:cs typeface="Calibri" pitchFamily="34" charset="-120"/>
               </a:rPr>
-              <a:t>Stamped with “E-SIGNED · name”, your name, title, date, time and CE number</a:t>
+              <a:t>Stamped with “E-SIGNED · name”, title, date, time and CE number</a:t>
             </a:r>
             <a:endParaRPr lang="en-US" sz="1200" dirty="0"/>
           </a:p>
@@ -21782,7 +21807,7 @@
                 <a:ea typeface="Calibri" pitchFamily="34" charset="-122"/>
                 <a:cs typeface="Calibri" pitchFamily="34" charset="-120"/>
               </a:rPr>
-              <a:t>The printed CE names who actually signed, with “e-signed” and the time</a:t>
+              <a:t>↩ Return needs a comment</a:t>
             </a:r>
             <a:endParaRPr lang="en-US" sz="1200" dirty="0"/>
           </a:p>
@@ -21806,7 +21831,7 @@
                 <a:ea typeface="Calibri" pitchFamily="34" charset="-122"/>
                 <a:cs typeface="Calibri" pitchFamily="34" charset="-120"/>
               </a:rPr>
-              <a:t>↩ Return needs a comment; changing the figures clears every signature</a:t>
+              <a:t>ANY saved edit — figures, scope, notes, a line — clears every signature, hand-drawn too</a:t>
             </a:r>
             <a:endParaRPr lang="en-US" sz="1200" dirty="0"/>
           </a:p>
@@ -25167,7 +25192,7 @@
                 <a:ea typeface="Calibri" pitchFamily="34" charset="-122"/>
                 <a:cs typeface="Calibri" pitchFamily="34" charset="-120"/>
               </a:rPr>
-              <a:t>Every tab still works. Rates, the Scope Library and your saved CEs are already stored in this browser.</a:t>
+              <a:t>Every tab still works. A pop-up says you are offline, so nobody works believing it reached the team. Rates and saved CEs are stored in this browser.</a:t>
             </a:r>
             <a:endParaRPr lang="en-US" sz="1100" dirty="0"/>
           </a:p>
@@ -26119,7 +26144,7 @@
                 <a:ea typeface="Calibri" pitchFamily="34" charset="-122"/>
                 <a:cs typeface="Calibri" pitchFamily="34" charset="-120"/>
               </a:rPr>
-              <a:t>Press ⚠ Sign in to Microsoft in the top bar, beside Set AI Key.</a:t>
+              <a:t>A pop-up offers Sign in to Microsoft; later, use ⚠ Sign in to Microsoft in the top bar.</a:t>
             </a:r>
             <a:endParaRPr lang="en-US" sz="1150" dirty="0"/>
           </a:p>
@@ -26689,7 +26714,7 @@
                 <a:ea typeface="Calibri" pitchFamily="34" charset="-122"/>
                 <a:cs typeface="Calibri" pitchFamily="34" charset="-120"/>
               </a:rPr>
-              <a:t>Run Push All Local Data to SharePoint from the Users tab.</a:t>
+              <a:t>Run Push All Local Data to SharePoint from the Users tab. "Save was interrupted" on opening: the saver does this, or saves it again.</a:t>
             </a:r>
             <a:endParaRPr lang="en-US" sz="1150" dirty="0"/>
           </a:p>
@@ -30774,6 +30799,595 @@
                 <a:ea typeface="Calibri" pitchFamily="34" charset="-122"/>
                 <a:cs typeface="Calibri" pitchFamily="34" charset="-120"/>
               </a:rPr>
+              <a:t>32</a:t>
+            </a:r>
+            <a:endParaRPr lang="en-US" sz="900" dirty="0"/>
+          </a:p>
+        </p:txBody>
+      </p:sp>
+    </p:spTree>
+  </p:cSld>
+  <p:clrMapOvr>
+    <a:masterClrMapping/>
+  </p:clrMapOvr>
+</p:sld>
+</file>
+
+<file path=ppt/slides/slide32.xml><?xml version="1.0" encoding="utf-8"?>
+<p:sld xmlns:a="http://schemas.openxmlformats.org/drawingml/2006/main" xmlns:p="http://schemas.openxmlformats.org/presentationml/2006/main" xmlns:r="http://schemas.openxmlformats.org/officeDocument/2006/relationships">
+  <p:cSld>
+    <p:bg>
+      <p:bgPr>
+        <a:solidFill>
+          <a:srgbClr val="0D1117"/>
+        </a:solidFill>
+      </p:bgPr>
+    </p:bg>
+    <p:spTree>
+      <p:nvGrpSpPr>
+        <p:cNvPr id="1" name=""/>
+        <p:cNvGrpSpPr/>
+        <p:nvPr/>
+      </p:nvGrpSpPr>
+      <p:grpSpPr/>
+      <p:sp>
+        <p:nvSpPr>
+          <p:cNvPr id="2" name="Text 0"/>
+          <p:cNvSpPr/>
+          <p:nvPr/>
+        </p:nvSpPr>
+        <p:spPr>
+          <a:xfrm>
+            <a:off x="566928" y="384048"/>
+            <a:ext cx="8229600" cy="256032"/>
+          </a:xfrm>
+          <a:prstGeom prst="rect">
+            <a:avLst/>
+          </a:prstGeom>
+          <a:noFill/>
+          <a:ln/>
+        </p:spPr>
+        <p:txBody>
+          <a:bodyPr wrap="square" lIns="0" tIns="0" rIns="0" bIns="0" rtlCol="0" anchor="ctr"/>
+          <a:lstStyle/>
+          <a:p>
+            <a:pPr indent="0" marL="0">
+              <a:buNone/>
+            </a:pPr>
+            <a:r>
+              <a:rPr lang="en-US" sz="1100" b="1" spc="200" kern="0" dirty="0">
+                <a:solidFill>
+                  <a:srgbClr val="F0A429"/>
+                </a:solidFill>
+                <a:latin typeface="Arial" pitchFamily="34" charset="0"/>
+                <a:ea typeface="Arial" pitchFamily="34" charset="-122"/>
+                <a:cs typeface="Arial" pitchFamily="34" charset="-120"/>
+              </a:rPr>
+              <a:t>MAKE IT YOURS</a:t>
+            </a:r>
+            <a:endParaRPr lang="en-US" sz="1100" dirty="0"/>
+          </a:p>
+        </p:txBody>
+      </p:sp>
+      <p:sp>
+        <p:nvSpPr>
+          <p:cNvPr id="3" name="Text 1"/>
+          <p:cNvSpPr/>
+          <p:nvPr/>
+        </p:nvSpPr>
+        <p:spPr>
+          <a:xfrm>
+            <a:off x="566928" y="694944"/>
+            <a:ext cx="11055096" cy="566928"/>
+          </a:xfrm>
+          <a:prstGeom prst="rect">
+            <a:avLst/>
+          </a:prstGeom>
+          <a:noFill/>
+          <a:ln/>
+        </p:spPr>
+        <p:txBody>
+          <a:bodyPr wrap="square" lIns="0" tIns="0" rIns="0" bIns="0" rtlCol="0" anchor="ctr"/>
+          <a:lstStyle/>
+          <a:p>
+            <a:pPr indent="0" marL="0">
+              <a:buNone/>
+            </a:pPr>
+            <a:r>
+              <a:rPr lang="en-US" sz="3200" b="1" dirty="0">
+                <a:solidFill>
+                  <a:srgbClr val="E6EDF3"/>
+                </a:solidFill>
+                <a:latin typeface="Arial" pitchFamily="34" charset="0"/>
+                <a:ea typeface="Arial" pitchFamily="34" charset="-122"/>
+                <a:cs typeface="Arial" pitchFamily="34" charset="-120"/>
+              </a:rPr>
+              <a:t>Themes and backgrounds</a:t>
+            </a:r>
+            <a:endParaRPr lang="en-US" sz="3200" dirty="0"/>
+          </a:p>
+        </p:txBody>
+      </p:sp>
+      <p:sp>
+        <p:nvSpPr>
+          <p:cNvPr id="4" name="Text 2"/>
+          <p:cNvSpPr/>
+          <p:nvPr/>
+        </p:nvSpPr>
+        <p:spPr>
+          <a:xfrm>
+            <a:off x="566928" y="1298448"/>
+            <a:ext cx="10972800" cy="365760"/>
+          </a:xfrm>
+          <a:prstGeom prst="rect">
+            <a:avLst/>
+          </a:prstGeom>
+          <a:noFill/>
+          <a:ln/>
+        </p:spPr>
+        <p:txBody>
+          <a:bodyPr wrap="square" lIns="0" tIns="0" rIns="0" bIns="0" rtlCol="0" anchor="t"/>
+          <a:lstStyle/>
+          <a:p>
+            <a:pPr algn="l" indent="0" marL="0">
+              <a:lnSpc>
+                <a:spcPts val="2000"/>
+              </a:lnSpc>
+              <a:buNone/>
+            </a:pPr>
+            <a:r>
+              <a:rPr lang="en-US" sz="1400" dirty="0">
+                <a:solidFill>
+                  <a:srgbClr val="9AA4AF"/>
+                </a:solidFill>
+                <a:latin typeface="Calibri" pitchFamily="34" charset="0"/>
+                <a:ea typeface="Calibri" pitchFamily="34" charset="-122"/>
+                <a:cs typeface="Calibri" pitchFamily="34" charset="-120"/>
+              </a:rPr>
+              <a:t>Press 🎨 in the top bar. The choice is kept in your browser only; printed CEs and exports never change.</a:t>
+            </a:r>
+            <a:endParaRPr lang="en-US" sz="1400" dirty="0"/>
+          </a:p>
+        </p:txBody>
+      </p:sp>
+      <p:sp>
+        <p:nvSpPr>
+          <p:cNvPr id="5" name="Shape 3"/>
+          <p:cNvSpPr/>
+          <p:nvPr/>
+        </p:nvSpPr>
+        <p:spPr>
+          <a:xfrm>
+            <a:off x="566928" y="1911096"/>
+            <a:ext cx="5532120" cy="3566160"/>
+          </a:xfrm>
+          <a:prstGeom prst="roundRect">
+            <a:avLst>
+              <a:gd name="adj" fmla="val 2051"/>
+            </a:avLst>
+          </a:prstGeom>
+          <a:solidFill>
+            <a:srgbClr val="1C2128"/>
+          </a:solidFill>
+          <a:ln w="12700">
+            <a:solidFill>
+              <a:srgbClr val="30363D"/>
+            </a:solidFill>
+            <a:prstDash val="solid"/>
+          </a:ln>
+          <a:effectLst>
+            <a:outerShdw sx="100000" sy="100000" kx="0" ky="0" algn="bl" rotWithShape="0" blurRad="152400" dist="38100" dir="5400000">
+              <a:srgbClr val="000000">
+                <a:alpha val="45000"/>
+              </a:srgbClr>
+            </a:outerShdw>
+          </a:effectLst>
+        </p:spPr>
+        <p:txBody>
+          <a:bodyPr/>
+          <a:p/>
+        </p:txBody>
+      </p:sp>
+      <p:sp>
+        <p:nvSpPr>
+          <p:cNvPr id="6" name="Text 4"/>
+          <p:cNvSpPr/>
+          <p:nvPr/>
+        </p:nvSpPr>
+        <p:spPr>
+          <a:xfrm>
+            <a:off x="841248" y="2121408"/>
+            <a:ext cx="4937760" cy="329184"/>
+          </a:xfrm>
+          <a:prstGeom prst="rect">
+            <a:avLst/>
+          </a:prstGeom>
+          <a:noFill/>
+          <a:ln/>
+        </p:spPr>
+        <p:txBody>
+          <a:bodyPr wrap="square" lIns="0" tIns="0" rIns="0" bIns="0" rtlCol="0" anchor="ctr"/>
+          <a:lstStyle/>
+          <a:p>
+            <a:pPr indent="0" marL="0">
+              <a:buNone/>
+            </a:pPr>
+            <a:r>
+              <a:rPr lang="en-US" sz="1700" b="1" dirty="0">
+                <a:solidFill>
+                  <a:srgbClr val="A78BFA"/>
+                </a:solidFill>
+                <a:latin typeface="Arial" pitchFamily="34" charset="0"/>
+                <a:ea typeface="Arial" pitchFamily="34" charset="-122"/>
+                <a:cs typeface="Arial" pitchFamily="34" charset="-120"/>
+              </a:rPr>
+              <a:t>Theme</a:t>
+            </a:r>
+            <a:endParaRPr lang="en-US" sz="1700" dirty="0"/>
+          </a:p>
+        </p:txBody>
+      </p:sp>
+      <p:sp>
+        <p:nvSpPr>
+          <p:cNvPr id="7" name="Text 5"/>
+          <p:cNvSpPr/>
+          <p:nvPr/>
+        </p:nvSpPr>
+        <p:spPr>
+          <a:xfrm>
+            <a:off x="841248" y="2578608"/>
+            <a:ext cx="4983480" cy="2651760"/>
+          </a:xfrm>
+          <a:prstGeom prst="rect">
+            <a:avLst/>
+          </a:prstGeom>
+          <a:noFill/>
+          <a:ln/>
+        </p:spPr>
+        <p:txBody>
+          <a:bodyPr wrap="square" lIns="0" tIns="0" rIns="0" bIns="0" rtlCol="0" anchor="t"/>
+          <a:lstStyle/>
+          <a:p>
+            <a:pPr marL="342900" indent="-342900">
+              <a:lnSpc>
+                <a:spcPts val="1600"/>
+              </a:lnSpc>
+              <a:spcAft>
+                <a:spcPts val="900"/>
+              </a:spcAft>
+              <a:buSzPct val="100000"/>
+              <a:buChar char="●"/>
+            </a:pPr>
+            <a:r>
+              <a:rPr lang="en-US" sz="1200" dirty="0">
+                <a:solidFill>
+                  <a:srgbClr val="E6EDF3"/>
+                </a:solidFill>
+                <a:latin typeface="Calibri" pitchFamily="34" charset="0"/>
+                <a:ea typeface="Calibri" pitchFamily="34" charset="-122"/>
+                <a:cs typeface="Calibri" pitchFamily="34" charset="-120"/>
+              </a:rPr>
+              <a:t>Ten palettes: Dark Slate, Executive Light, Ocean, Forest, Nebula, Graphite, Sunset, Lavender, Sakura, Mint</a:t>
+            </a:r>
+            <a:endParaRPr lang="en-US" sz="1200" dirty="0"/>
+          </a:p>
+          <a:p>
+            <a:pPr marL="342900" indent="-342900">
+              <a:lnSpc>
+                <a:spcPts val="1600"/>
+              </a:lnSpc>
+              <a:spcAft>
+                <a:spcPts val="900"/>
+              </a:spcAft>
+              <a:buSzPct val="100000"/>
+              <a:buChar char="●"/>
+            </a:pPr>
+            <a:r>
+              <a:rPr lang="en-US" sz="1200" dirty="0">
+                <a:solidFill>
+                  <a:srgbClr val="E6EDF3"/>
+                </a:solidFill>
+                <a:latin typeface="Calibri" pitchFamily="34" charset="0"/>
+                <a:ea typeface="Calibri" pitchFamily="34" charset="-122"/>
+                <a:cs typeface="Calibri" pitchFamily="34" charset="-120"/>
+              </a:rPr>
+              <a:t>Executive Light is softened — easier on the eyes than plain white</a:t>
+            </a:r>
+            <a:endParaRPr lang="en-US" sz="1200" dirty="0"/>
+          </a:p>
+          <a:p>
+            <a:pPr marL="342900" indent="-342900">
+              <a:lnSpc>
+                <a:spcPts val="1600"/>
+              </a:lnSpc>
+              <a:spcAft>
+                <a:spcPts val="900"/>
+              </a:spcAft>
+              <a:buSzPct val="100000"/>
+              <a:buChar char="●"/>
+            </a:pPr>
+            <a:r>
+              <a:rPr lang="en-US" sz="1200" dirty="0">
+                <a:solidFill>
+                  <a:srgbClr val="E6EDF3"/>
+                </a:solidFill>
+                <a:latin typeface="Calibri" pitchFamily="34" charset="0"/>
+                <a:ea typeface="Calibri" pitchFamily="34" charset="-122"/>
+                <a:cs typeface="Calibri" pitchFamily="34" charset="-120"/>
+              </a:rPr>
+              <a:t>Pick again at any time; nothing on the CE changes</a:t>
+            </a:r>
+            <a:endParaRPr lang="en-US" sz="1200" dirty="0"/>
+          </a:p>
+        </p:txBody>
+      </p:sp>
+      <p:sp>
+        <p:nvSpPr>
+          <p:cNvPr id="8" name="Shape 6"/>
+          <p:cNvSpPr/>
+          <p:nvPr/>
+        </p:nvSpPr>
+        <p:spPr>
+          <a:xfrm>
+            <a:off x="6400800" y="1911096"/>
+            <a:ext cx="5221224" cy="3566160"/>
+          </a:xfrm>
+          <a:prstGeom prst="roundRect">
+            <a:avLst>
+              <a:gd name="adj" fmla="val 2051"/>
+            </a:avLst>
+          </a:prstGeom>
+          <a:solidFill>
+            <a:srgbClr val="1C2128"/>
+          </a:solidFill>
+          <a:ln w="12700">
+            <a:solidFill>
+              <a:srgbClr val="30363D"/>
+            </a:solidFill>
+            <a:prstDash val="solid"/>
+          </a:ln>
+          <a:effectLst>
+            <a:outerShdw sx="100000" sy="100000" kx="0" ky="0" algn="bl" rotWithShape="0" blurRad="152400" dist="38100" dir="5400000">
+              <a:srgbClr val="000000">
+                <a:alpha val="45000"/>
+              </a:srgbClr>
+            </a:outerShdw>
+          </a:effectLst>
+        </p:spPr>
+        <p:txBody>
+          <a:bodyPr/>
+          <a:p/>
+        </p:txBody>
+      </p:sp>
+      <p:sp>
+        <p:nvSpPr>
+          <p:cNvPr id="9" name="Text 7"/>
+          <p:cNvSpPr/>
+          <p:nvPr/>
+        </p:nvSpPr>
+        <p:spPr>
+          <a:xfrm>
+            <a:off x="6675120" y="2121408"/>
+            <a:ext cx="4663440" cy="329184"/>
+          </a:xfrm>
+          <a:prstGeom prst="rect">
+            <a:avLst/>
+          </a:prstGeom>
+          <a:noFill/>
+          <a:ln/>
+        </p:spPr>
+        <p:txBody>
+          <a:bodyPr wrap="square" lIns="0" tIns="0" rIns="0" bIns="0" rtlCol="0" anchor="ctr"/>
+          <a:lstStyle/>
+          <a:p>
+            <a:pPr indent="0" marL="0">
+              <a:buNone/>
+            </a:pPr>
+            <a:r>
+              <a:rPr lang="en-US" sz="1700" b="1" dirty="0">
+                <a:solidFill>
+                  <a:srgbClr val="F0A429"/>
+                </a:solidFill>
+                <a:latin typeface="Arial" pitchFamily="34" charset="0"/>
+                <a:ea typeface="Arial" pitchFamily="34" charset="-122"/>
+                <a:cs typeface="Arial" pitchFamily="34" charset="-120"/>
+              </a:rPr>
+              <a:t>Background</a:t>
+            </a:r>
+            <a:endParaRPr lang="en-US" sz="1700" dirty="0"/>
+          </a:p>
+        </p:txBody>
+      </p:sp>
+      <p:sp>
+        <p:nvSpPr>
+          <p:cNvPr id="10" name="Text 8"/>
+          <p:cNvSpPr/>
+          <p:nvPr/>
+        </p:nvSpPr>
+        <p:spPr>
+          <a:xfrm>
+            <a:off x="6675120" y="2578608"/>
+            <a:ext cx="4709160" cy="2651760"/>
+          </a:xfrm>
+          <a:prstGeom prst="rect">
+            <a:avLst/>
+          </a:prstGeom>
+          <a:noFill/>
+          <a:ln/>
+        </p:spPr>
+        <p:txBody>
+          <a:bodyPr wrap="square" lIns="0" tIns="0" rIns="0" bIns="0" rtlCol="0" anchor="t"/>
+          <a:lstStyle/>
+          <a:p>
+            <a:pPr marL="342900" indent="-342900">
+              <a:lnSpc>
+                <a:spcPts val="1600"/>
+              </a:lnSpc>
+              <a:spcAft>
+                <a:spcPts val="900"/>
+              </a:spcAft>
+              <a:buSzPct val="100000"/>
+              <a:buChar char="●"/>
+            </a:pPr>
+            <a:r>
+              <a:rPr lang="en-US" sz="1200" dirty="0">
+                <a:solidFill>
+                  <a:srgbClr val="E6EDF3"/>
+                </a:solidFill>
+                <a:latin typeface="Calibri" pitchFamily="34" charset="0"/>
+                <a:ea typeface="Calibri" pitchFamily="34" charset="-122"/>
+                <a:cs typeface="Calibri" pitchFamily="34" charset="-120"/>
+              </a:rPr>
+              <a:t>Six gradients, or ⬆ Photo to use your own picture</a:t>
+            </a:r>
+            <a:endParaRPr lang="en-US" sz="1200" dirty="0"/>
+          </a:p>
+          <a:p>
+            <a:pPr marL="342900" indent="-342900">
+              <a:lnSpc>
+                <a:spcPts val="1600"/>
+              </a:lnSpc>
+              <a:spcAft>
+                <a:spcPts val="900"/>
+              </a:spcAft>
+              <a:buSzPct val="100000"/>
+              <a:buChar char="●"/>
+            </a:pPr>
+            <a:r>
+              <a:rPr lang="en-US" sz="1200" dirty="0">
+                <a:solidFill>
+                  <a:srgbClr val="E6EDF3"/>
+                </a:solidFill>
+                <a:latin typeface="Calibri" pitchFamily="34" charset="0"/>
+                <a:ea typeface="Calibri" pitchFamily="34" charset="-122"/>
+                <a:cs typeface="Calibri" pitchFamily="34" charset="-120"/>
+              </a:rPr>
+              <a:t>Soften fades the background so text stays readable</a:t>
+            </a:r>
+            <a:endParaRPr lang="en-US" sz="1200" dirty="0"/>
+          </a:p>
+          <a:p>
+            <a:pPr marL="342900" indent="-342900">
+              <a:lnSpc>
+                <a:spcPts val="1600"/>
+              </a:lnSpc>
+              <a:spcAft>
+                <a:spcPts val="900"/>
+              </a:spcAft>
+              <a:buSzPct val="100000"/>
+              <a:buChar char="●"/>
+            </a:pPr>
+            <a:r>
+              <a:rPr lang="en-US" sz="1200" dirty="0">
+                <a:solidFill>
+                  <a:srgbClr val="E6EDF3"/>
+                </a:solidFill>
+                <a:latin typeface="Calibri" pitchFamily="34" charset="0"/>
+                <a:ea typeface="Calibri" pitchFamily="34" charset="-122"/>
+                <a:cs typeface="Calibri" pitchFamily="34" charset="-120"/>
+              </a:rPr>
+              <a:t>Cards and tables stay solid on top of it</a:t>
+            </a:r>
+            <a:endParaRPr lang="en-US" sz="1200" dirty="0"/>
+          </a:p>
+          <a:p>
+            <a:pPr marL="342900" indent="-342900">
+              <a:lnSpc>
+                <a:spcPts val="1600"/>
+              </a:lnSpc>
+              <a:spcAft>
+                <a:spcPts val="900"/>
+              </a:spcAft>
+              <a:buSzPct val="100000"/>
+              <a:buChar char="●"/>
+            </a:pPr>
+            <a:r>
+              <a:rPr lang="en-US" sz="1200" dirty="0">
+                <a:solidFill>
+                  <a:srgbClr val="E6EDF3"/>
+                </a:solidFill>
+                <a:latin typeface="Calibri" pitchFamily="34" charset="0"/>
+                <a:ea typeface="Calibri" pitchFamily="34" charset="-122"/>
+                <a:cs typeface="Calibri" pitchFamily="34" charset="-120"/>
+              </a:rPr>
+              <a:t>None puts the plain canvas back</a:t>
+            </a:r>
+            <a:endParaRPr lang="en-US" sz="1200" dirty="0"/>
+          </a:p>
+        </p:txBody>
+      </p:sp>
+      <p:sp>
+        <p:nvSpPr>
+          <p:cNvPr id="11" name="Text 9"/>
+          <p:cNvSpPr/>
+          <p:nvPr/>
+        </p:nvSpPr>
+        <p:spPr>
+          <a:xfrm>
+            <a:off x="566928" y="6437376"/>
+            <a:ext cx="5486400" cy="237744"/>
+          </a:xfrm>
+          <a:prstGeom prst="rect">
+            <a:avLst/>
+          </a:prstGeom>
+          <a:noFill/>
+          <a:ln/>
+        </p:spPr>
+        <p:txBody>
+          <a:bodyPr wrap="square" lIns="0" tIns="0" rIns="0" bIns="0" rtlCol="0" anchor="ctr"/>
+          <a:lstStyle/>
+          <a:p>
+            <a:pPr indent="0" marL="0">
+              <a:buNone/>
+            </a:pPr>
+            <a:r>
+              <a:rPr lang="en-US" sz="900" dirty="0">
+                <a:solidFill>
+                  <a:srgbClr val="6E7681"/>
+                </a:solidFill>
+                <a:latin typeface="Calibri" pitchFamily="34" charset="0"/>
+                <a:ea typeface="Calibri" pitchFamily="34" charset="-122"/>
+                <a:cs typeface="Calibri" pitchFamily="34" charset="-120"/>
+              </a:rPr>
+              <a:t>SHIC Cost Estimator — End-User Manual</a:t>
+            </a:r>
+            <a:endParaRPr lang="en-US" sz="900" dirty="0"/>
+          </a:p>
+        </p:txBody>
+      </p:sp>
+      <p:sp>
+        <p:nvSpPr>
+          <p:cNvPr id="12" name="Text 10"/>
+          <p:cNvSpPr/>
+          <p:nvPr/>
+        </p:nvSpPr>
+        <p:spPr>
+          <a:xfrm>
+            <a:off x="10981944" y="6437376"/>
+            <a:ext cx="640080" cy="237744"/>
+          </a:xfrm>
+          <a:prstGeom prst="rect">
+            <a:avLst/>
+          </a:prstGeom>
+          <a:noFill/>
+          <a:ln/>
+        </p:spPr>
+        <p:txBody>
+          <a:bodyPr wrap="square" lIns="0" tIns="0" rIns="0" bIns="0" rtlCol="0" anchor="ctr"/>
+          <a:lstStyle/>
+          <a:p>
+            <a:pPr algn="r" indent="0" marL="0">
+              <a:buNone/>
+            </a:pPr>
+            <a:r>
+              <a:rPr lang="en-US" sz="900" dirty="0">
+                <a:solidFill>
+                  <a:srgbClr val="6E7681"/>
+                </a:solidFill>
+                <a:latin typeface="Calibri" pitchFamily="34" charset="0"/>
+                <a:ea typeface="Calibri" pitchFamily="34" charset="-122"/>
+                <a:cs typeface="Calibri" pitchFamily="34" charset="-120"/>
+              </a:rPr>
               <a:t>31</a:t>
             </a:r>
             <a:endParaRPr lang="en-US" sz="900" dirty="0"/>
@@ -30919,7 +31533,7 @@
                 <a:ea typeface="Calibri" pitchFamily="34" charset="-122"/>
                 <a:cs typeface="Calibri" pitchFamily="34" charset="-120"/>
               </a:rPr>
-              <a:t>The first tab, and where the app opens. It lists only what concerns you, newest revision of each CE only.</a:t>
+              <a:t>The first tab, and where the app opens. A red number on the tab — and in the window title — counts what waits on you, from any tab.</a:t>
             </a:r>
             <a:endParaRPr lang="en-US" sz="1400" dirty="0"/>
           </a:p>
@@ -31333,7 +31947,7 @@
                 <a:ea typeface="Calibri" pitchFamily="34" charset="-122"/>
                 <a:cs typeface="Calibri" pitchFamily="34" charset="-120"/>
               </a:rPr>
-              <a:t>🔎 For review — CEs at For Approval that are not routed for signing</a:t>
+              <a:t>A new item mid-session pops up a notice; the badge always matches the lists</a:t>
             </a:r>
             <a:endParaRPr lang="en-US" sz="1200" dirty="0"/>
           </a:p>
@@ -38096,7 +38710,7 @@
                 <a:ea typeface="Calibri" pitchFamily="34" charset="-122"/>
                 <a:cs typeface="Calibri" pitchFamily="34" charset="-120"/>
               </a:rPr>
-              <a:t>Rows not linked to a step appear in an amber panel below. Tick several and file them at once.</a:t>
+              <a:t>Rows not linked to a step appear in an amber panel below. Tick several and file them at once. Descriptions pick from the Masterlist, rate and unit included.</a:t>
             </a:r>
             <a:endParaRPr lang="en-US" sz="1100" dirty="0"/>
           </a:p>

</xml_diff>

<commit_message>
Monitoring status Revised, kept in step with the printed REVISED document state; manual troubleshooting cards tightened so Toasts clears the footer
Co-Authored-By: Claude Opus 5 <noreply@anthropic.com>
</commit_message>
<xml_diff>
--- a/docs/SHIC-Cost-Estimator-User-Manual.pptx
+++ b/docs/SHIC-Cost-Estimator-User-Manual.pptx
@@ -25969,7 +25969,7 @@
         <p:spPr>
           <a:xfrm>
             <a:off x="566928" y="1408176"/>
-            <a:ext cx="11055096" cy="914400"/>
+            <a:ext cx="11055096" cy="822960"/>
           </a:xfrm>
           <a:prstGeom prst="roundRect">
             <a:avLst>
@@ -26006,7 +26006,7 @@
         </p:nvSpPr>
         <p:spPr>
           <a:xfrm>
-            <a:off x="822960" y="1700784"/>
+            <a:off x="822960" y="1655064"/>
             <a:ext cx="310896" cy="310896"/>
           </a:xfrm>
           <a:prstGeom prst="ellipse">
@@ -26035,7 +26035,7 @@
         </p:nvSpPr>
         <p:spPr>
           <a:xfrm>
-            <a:off x="1280160" y="1517904"/>
+            <a:off x="1280160" y="1472184"/>
             <a:ext cx="3840480" cy="310896"/>
           </a:xfrm>
           <a:prstGeom prst="rect">
@@ -26074,7 +26074,7 @@
         </p:nvSpPr>
         <p:spPr>
           <a:xfrm>
-            <a:off x="1280160" y="1847088"/>
+            <a:off x="1280160" y="1801368"/>
             <a:ext cx="4663440" cy="402336"/>
           </a:xfrm>
           <a:prstGeom prst="rect">
@@ -26116,7 +26116,7 @@
         </p:nvSpPr>
         <p:spPr>
           <a:xfrm>
-            <a:off x="6236208" y="1517904"/>
+            <a:off x="6236208" y="1472184"/>
             <a:ext cx="5120640" cy="731520"/>
           </a:xfrm>
           <a:prstGeom prst="rect">
@@ -26158,8 +26158,8 @@
         </p:nvSpPr>
         <p:spPr>
           <a:xfrm>
-            <a:off x="566928" y="2450592"/>
-            <a:ext cx="11055096" cy="914400"/>
+            <a:off x="566928" y="2359152"/>
+            <a:ext cx="11055096" cy="822960"/>
           </a:xfrm>
           <a:prstGeom prst="roundRect">
             <a:avLst>
@@ -26196,7 +26196,7 @@
         </p:nvSpPr>
         <p:spPr>
           <a:xfrm>
-            <a:off x="822960" y="2743200"/>
+            <a:off x="822960" y="2606040"/>
             <a:ext cx="310896" cy="310896"/>
           </a:xfrm>
           <a:prstGeom prst="ellipse">
@@ -26225,7 +26225,7 @@
         </p:nvSpPr>
         <p:spPr>
           <a:xfrm>
-            <a:off x="1280160" y="2560320"/>
+            <a:off x="1280160" y="2423160"/>
             <a:ext cx="3840480" cy="310896"/>
           </a:xfrm>
           <a:prstGeom prst="rect">
@@ -26264,7 +26264,7 @@
         </p:nvSpPr>
         <p:spPr>
           <a:xfrm>
-            <a:off x="1280160" y="2889504"/>
+            <a:off x="1280160" y="2752344"/>
             <a:ext cx="4663440" cy="402336"/>
           </a:xfrm>
           <a:prstGeom prst="rect">
@@ -26306,7 +26306,7 @@
         </p:nvSpPr>
         <p:spPr>
           <a:xfrm>
-            <a:off x="6236208" y="2560320"/>
+            <a:off x="6236208" y="2423160"/>
             <a:ext cx="5120640" cy="731520"/>
           </a:xfrm>
           <a:prstGeom prst="rect">
@@ -26348,8 +26348,8 @@
         </p:nvSpPr>
         <p:spPr>
           <a:xfrm>
-            <a:off x="566928" y="3493008"/>
-            <a:ext cx="11055096" cy="914400"/>
+            <a:off x="566928" y="3310128"/>
+            <a:ext cx="11055096" cy="822960"/>
           </a:xfrm>
           <a:prstGeom prst="roundRect">
             <a:avLst>
@@ -26386,7 +26386,7 @@
         </p:nvSpPr>
         <p:spPr>
           <a:xfrm>
-            <a:off x="822960" y="3785616"/>
+            <a:off x="822960" y="3557016"/>
             <a:ext cx="310896" cy="310896"/>
           </a:xfrm>
           <a:prstGeom prst="ellipse">
@@ -26415,7 +26415,7 @@
         </p:nvSpPr>
         <p:spPr>
           <a:xfrm>
-            <a:off x="1280160" y="3602736"/>
+            <a:off x="1280160" y="3374136"/>
             <a:ext cx="3840480" cy="310896"/>
           </a:xfrm>
           <a:prstGeom prst="rect">
@@ -26454,7 +26454,7 @@
         </p:nvSpPr>
         <p:spPr>
           <a:xfrm>
-            <a:off x="1280160" y="3931920"/>
+            <a:off x="1280160" y="3703320"/>
             <a:ext cx="4663440" cy="402336"/>
           </a:xfrm>
           <a:prstGeom prst="rect">
@@ -26496,7 +26496,7 @@
         </p:nvSpPr>
         <p:spPr>
           <a:xfrm>
-            <a:off x="6236208" y="3602736"/>
+            <a:off x="6236208" y="3374136"/>
             <a:ext cx="5120640" cy="731520"/>
           </a:xfrm>
           <a:prstGeom prst="rect">
@@ -26538,8 +26538,8 @@
         </p:nvSpPr>
         <p:spPr>
           <a:xfrm>
-            <a:off x="566928" y="4535424"/>
-            <a:ext cx="11055096" cy="914400"/>
+            <a:off x="566928" y="4261104"/>
+            <a:ext cx="11055096" cy="822960"/>
           </a:xfrm>
           <a:prstGeom prst="roundRect">
             <a:avLst>
@@ -26576,7 +26576,7 @@
         </p:nvSpPr>
         <p:spPr>
           <a:xfrm>
-            <a:off x="822960" y="4828032"/>
+            <a:off x="822960" y="4507992"/>
             <a:ext cx="310896" cy="310896"/>
           </a:xfrm>
           <a:prstGeom prst="ellipse">
@@ -26605,7 +26605,7 @@
         </p:nvSpPr>
         <p:spPr>
           <a:xfrm>
-            <a:off x="1280160" y="4645152"/>
+            <a:off x="1280160" y="4325112"/>
             <a:ext cx="3840480" cy="310896"/>
           </a:xfrm>
           <a:prstGeom prst="rect">
@@ -26644,7 +26644,7 @@
         </p:nvSpPr>
         <p:spPr>
           <a:xfrm>
-            <a:off x="1280160" y="4974336"/>
+            <a:off x="1280160" y="4654296"/>
             <a:ext cx="4663440" cy="402336"/>
           </a:xfrm>
           <a:prstGeom prst="rect">
@@ -26686,7 +26686,7 @@
         </p:nvSpPr>
         <p:spPr>
           <a:xfrm>
-            <a:off x="6236208" y="4645152"/>
+            <a:off x="6236208" y="4325112"/>
             <a:ext cx="5120640" cy="731520"/>
           </a:xfrm>
           <a:prstGeom prst="rect">
@@ -26728,8 +26728,8 @@
         </p:nvSpPr>
         <p:spPr>
           <a:xfrm>
-            <a:off x="566928" y="5632704"/>
-            <a:ext cx="11055096" cy="914400"/>
+            <a:off x="566928" y="5266944"/>
+            <a:ext cx="11055096" cy="822960"/>
           </a:xfrm>
           <a:prstGeom prst="roundRect">
             <a:avLst>
@@ -26766,7 +26766,7 @@
         </p:nvSpPr>
         <p:spPr>
           <a:xfrm>
-            <a:off x="1280160" y="5742432"/>
+            <a:off x="1280160" y="5330952"/>
             <a:ext cx="3840480" cy="274320"/>
           </a:xfrm>
           <a:prstGeom prst="rect">
@@ -26805,7 +26805,7 @@
         </p:nvSpPr>
         <p:spPr>
           <a:xfrm>
-            <a:off x="822960" y="5925312"/>
+            <a:off x="822960" y="5513832"/>
             <a:ext cx="310896" cy="310896"/>
           </a:xfrm>
           <a:prstGeom prst="ellipse">
@@ -26834,7 +26834,7 @@
         </p:nvSpPr>
         <p:spPr>
           <a:xfrm>
-            <a:off x="1280160" y="6053328"/>
+            <a:off x="1280160" y="5641848"/>
             <a:ext cx="4663440" cy="402336"/>
           </a:xfrm>
           <a:prstGeom prst="rect">
@@ -26876,7 +26876,7 @@
         </p:nvSpPr>
         <p:spPr>
           <a:xfrm>
-            <a:off x="6236208" y="5742432"/>
+            <a:off x="6236208" y="5330952"/>
             <a:ext cx="5120640" cy="731520"/>
           </a:xfrm>
           <a:prstGeom prst="rect">
@@ -29797,6 +29797,595 @@
 </file>
 
 <file path=ppt/slides/slide31.xml><?xml version="1.0" encoding="utf-8"?>
+<p:sld xmlns:a="http://schemas.openxmlformats.org/drawingml/2006/main" xmlns:p="http://schemas.openxmlformats.org/presentationml/2006/main" xmlns:r="http://schemas.openxmlformats.org/officeDocument/2006/relationships">
+  <p:cSld>
+    <p:bg>
+      <p:bgPr>
+        <a:solidFill>
+          <a:srgbClr val="0D1117"/>
+        </a:solidFill>
+      </p:bgPr>
+    </p:bg>
+    <p:spTree>
+      <p:nvGrpSpPr>
+        <p:cNvPr id="1" name=""/>
+        <p:cNvGrpSpPr/>
+        <p:nvPr/>
+      </p:nvGrpSpPr>
+      <p:grpSpPr/>
+      <p:sp>
+        <p:nvSpPr>
+          <p:cNvPr id="2" name="Text 0"/>
+          <p:cNvSpPr/>
+          <p:nvPr/>
+        </p:nvSpPr>
+        <p:spPr>
+          <a:xfrm>
+            <a:off x="566928" y="384048"/>
+            <a:ext cx="8229600" cy="256032"/>
+          </a:xfrm>
+          <a:prstGeom prst="rect">
+            <a:avLst/>
+          </a:prstGeom>
+          <a:noFill/>
+          <a:ln/>
+        </p:spPr>
+        <p:txBody>
+          <a:bodyPr wrap="square" lIns="0" tIns="0" rIns="0" bIns="0" rtlCol="0" anchor="ctr"/>
+          <a:lstStyle/>
+          <a:p>
+            <a:pPr indent="0" marL="0">
+              <a:buNone/>
+            </a:pPr>
+            <a:r>
+              <a:rPr lang="en-US" sz="1100" b="1" spc="200" kern="0" dirty="0">
+                <a:solidFill>
+                  <a:srgbClr val="F0A429"/>
+                </a:solidFill>
+                <a:latin typeface="Arial" pitchFamily="34" charset="0"/>
+                <a:ea typeface="Arial" pitchFamily="34" charset="-122"/>
+                <a:cs typeface="Arial" pitchFamily="34" charset="-120"/>
+              </a:rPr>
+              <a:t>MAKE IT YOURS</a:t>
+            </a:r>
+            <a:endParaRPr lang="en-US" sz="1100" dirty="0"/>
+          </a:p>
+        </p:txBody>
+      </p:sp>
+      <p:sp>
+        <p:nvSpPr>
+          <p:cNvPr id="3" name="Text 1"/>
+          <p:cNvSpPr/>
+          <p:nvPr/>
+        </p:nvSpPr>
+        <p:spPr>
+          <a:xfrm>
+            <a:off x="566928" y="694944"/>
+            <a:ext cx="11055096" cy="566928"/>
+          </a:xfrm>
+          <a:prstGeom prst="rect">
+            <a:avLst/>
+          </a:prstGeom>
+          <a:noFill/>
+          <a:ln/>
+        </p:spPr>
+        <p:txBody>
+          <a:bodyPr wrap="square" lIns="0" tIns="0" rIns="0" bIns="0" rtlCol="0" anchor="ctr"/>
+          <a:lstStyle/>
+          <a:p>
+            <a:pPr indent="0" marL="0">
+              <a:buNone/>
+            </a:pPr>
+            <a:r>
+              <a:rPr lang="en-US" sz="3200" b="1" dirty="0">
+                <a:solidFill>
+                  <a:srgbClr val="E6EDF3"/>
+                </a:solidFill>
+                <a:latin typeface="Arial" pitchFamily="34" charset="0"/>
+                <a:ea typeface="Arial" pitchFamily="34" charset="-122"/>
+                <a:cs typeface="Arial" pitchFamily="34" charset="-120"/>
+              </a:rPr>
+              <a:t>Themes and backgrounds</a:t>
+            </a:r>
+            <a:endParaRPr lang="en-US" sz="3200" dirty="0"/>
+          </a:p>
+        </p:txBody>
+      </p:sp>
+      <p:sp>
+        <p:nvSpPr>
+          <p:cNvPr id="4" name="Text 2"/>
+          <p:cNvSpPr/>
+          <p:nvPr/>
+        </p:nvSpPr>
+        <p:spPr>
+          <a:xfrm>
+            <a:off x="566928" y="1298448"/>
+            <a:ext cx="10972800" cy="365760"/>
+          </a:xfrm>
+          <a:prstGeom prst="rect">
+            <a:avLst/>
+          </a:prstGeom>
+          <a:noFill/>
+          <a:ln/>
+        </p:spPr>
+        <p:txBody>
+          <a:bodyPr wrap="square" lIns="0" tIns="0" rIns="0" bIns="0" rtlCol="0" anchor="t"/>
+          <a:lstStyle/>
+          <a:p>
+            <a:pPr algn="l" indent="0" marL="0">
+              <a:lnSpc>
+                <a:spcPts val="2000"/>
+              </a:lnSpc>
+              <a:buNone/>
+            </a:pPr>
+            <a:r>
+              <a:rPr lang="en-US" sz="1400" dirty="0">
+                <a:solidFill>
+                  <a:srgbClr val="9AA4AF"/>
+                </a:solidFill>
+                <a:latin typeface="Calibri" pitchFamily="34" charset="0"/>
+                <a:ea typeface="Calibri" pitchFamily="34" charset="-122"/>
+                <a:cs typeface="Calibri" pitchFamily="34" charset="-120"/>
+              </a:rPr>
+              <a:t>Press 🎨 in the top bar. The choice is kept in your browser only; printed CEs and exports never change.</a:t>
+            </a:r>
+            <a:endParaRPr lang="en-US" sz="1400" dirty="0"/>
+          </a:p>
+        </p:txBody>
+      </p:sp>
+      <p:sp>
+        <p:nvSpPr>
+          <p:cNvPr id="5" name="Shape 3"/>
+          <p:cNvSpPr/>
+          <p:nvPr/>
+        </p:nvSpPr>
+        <p:spPr>
+          <a:xfrm>
+            <a:off x="566928" y="1911096"/>
+            <a:ext cx="5532120" cy="3566160"/>
+          </a:xfrm>
+          <a:prstGeom prst="roundRect">
+            <a:avLst>
+              <a:gd name="adj" fmla="val 2051"/>
+            </a:avLst>
+          </a:prstGeom>
+          <a:solidFill>
+            <a:srgbClr val="1C2128"/>
+          </a:solidFill>
+          <a:ln w="12700">
+            <a:solidFill>
+              <a:srgbClr val="30363D"/>
+            </a:solidFill>
+            <a:prstDash val="solid"/>
+          </a:ln>
+          <a:effectLst>
+            <a:outerShdw sx="100000" sy="100000" kx="0" ky="0" algn="bl" rotWithShape="0" blurRad="152400" dist="38100" dir="5400000">
+              <a:srgbClr val="000000">
+                <a:alpha val="45000"/>
+              </a:srgbClr>
+            </a:outerShdw>
+          </a:effectLst>
+        </p:spPr>
+        <p:txBody>
+          <a:bodyPr/>
+          <a:p/>
+        </p:txBody>
+      </p:sp>
+      <p:sp>
+        <p:nvSpPr>
+          <p:cNvPr id="6" name="Text 4"/>
+          <p:cNvSpPr/>
+          <p:nvPr/>
+        </p:nvSpPr>
+        <p:spPr>
+          <a:xfrm>
+            <a:off x="841248" y="2121408"/>
+            <a:ext cx="4937760" cy="329184"/>
+          </a:xfrm>
+          <a:prstGeom prst="rect">
+            <a:avLst/>
+          </a:prstGeom>
+          <a:noFill/>
+          <a:ln/>
+        </p:spPr>
+        <p:txBody>
+          <a:bodyPr wrap="square" lIns="0" tIns="0" rIns="0" bIns="0" rtlCol="0" anchor="ctr"/>
+          <a:lstStyle/>
+          <a:p>
+            <a:pPr indent="0" marL="0">
+              <a:buNone/>
+            </a:pPr>
+            <a:r>
+              <a:rPr lang="en-US" sz="1700" b="1" dirty="0">
+                <a:solidFill>
+                  <a:srgbClr val="A78BFA"/>
+                </a:solidFill>
+                <a:latin typeface="Arial" pitchFamily="34" charset="0"/>
+                <a:ea typeface="Arial" pitchFamily="34" charset="-122"/>
+                <a:cs typeface="Arial" pitchFamily="34" charset="-120"/>
+              </a:rPr>
+              <a:t>Theme</a:t>
+            </a:r>
+            <a:endParaRPr lang="en-US" sz="1700" dirty="0"/>
+          </a:p>
+        </p:txBody>
+      </p:sp>
+      <p:sp>
+        <p:nvSpPr>
+          <p:cNvPr id="7" name="Text 5"/>
+          <p:cNvSpPr/>
+          <p:nvPr/>
+        </p:nvSpPr>
+        <p:spPr>
+          <a:xfrm>
+            <a:off x="841248" y="2578608"/>
+            <a:ext cx="4983480" cy="2651760"/>
+          </a:xfrm>
+          <a:prstGeom prst="rect">
+            <a:avLst/>
+          </a:prstGeom>
+          <a:noFill/>
+          <a:ln/>
+        </p:spPr>
+        <p:txBody>
+          <a:bodyPr wrap="square" lIns="0" tIns="0" rIns="0" bIns="0" rtlCol="0" anchor="t"/>
+          <a:lstStyle/>
+          <a:p>
+            <a:pPr marL="342900" indent="-342900">
+              <a:lnSpc>
+                <a:spcPts val="1600"/>
+              </a:lnSpc>
+              <a:spcAft>
+                <a:spcPts val="900"/>
+              </a:spcAft>
+              <a:buSzPct val="100000"/>
+              <a:buChar char="●"/>
+            </a:pPr>
+            <a:r>
+              <a:rPr lang="en-US" sz="1200" dirty="0">
+                <a:solidFill>
+                  <a:srgbClr val="E6EDF3"/>
+                </a:solidFill>
+                <a:latin typeface="Calibri" pitchFamily="34" charset="0"/>
+                <a:ea typeface="Calibri" pitchFamily="34" charset="-122"/>
+                <a:cs typeface="Calibri" pitchFamily="34" charset="-120"/>
+              </a:rPr>
+              <a:t>Ten palettes: Dark Slate, Executive Light, Ocean, Forest, Nebula, Graphite, Sunset, Lavender, Sakura, Mint</a:t>
+            </a:r>
+            <a:endParaRPr lang="en-US" sz="1200" dirty="0"/>
+          </a:p>
+          <a:p>
+            <a:pPr marL="342900" indent="-342900">
+              <a:lnSpc>
+                <a:spcPts val="1600"/>
+              </a:lnSpc>
+              <a:spcAft>
+                <a:spcPts val="900"/>
+              </a:spcAft>
+              <a:buSzPct val="100000"/>
+              <a:buChar char="●"/>
+            </a:pPr>
+            <a:r>
+              <a:rPr lang="en-US" sz="1200" dirty="0">
+                <a:solidFill>
+                  <a:srgbClr val="E6EDF3"/>
+                </a:solidFill>
+                <a:latin typeface="Calibri" pitchFamily="34" charset="0"/>
+                <a:ea typeface="Calibri" pitchFamily="34" charset="-122"/>
+                <a:cs typeface="Calibri" pitchFamily="34" charset="-120"/>
+              </a:rPr>
+              <a:t>Executive Light is softened — easier on the eyes than plain white</a:t>
+            </a:r>
+            <a:endParaRPr lang="en-US" sz="1200" dirty="0"/>
+          </a:p>
+          <a:p>
+            <a:pPr marL="342900" indent="-342900">
+              <a:lnSpc>
+                <a:spcPts val="1600"/>
+              </a:lnSpc>
+              <a:spcAft>
+                <a:spcPts val="900"/>
+              </a:spcAft>
+              <a:buSzPct val="100000"/>
+              <a:buChar char="●"/>
+            </a:pPr>
+            <a:r>
+              <a:rPr lang="en-US" sz="1200" dirty="0">
+                <a:solidFill>
+                  <a:srgbClr val="E6EDF3"/>
+                </a:solidFill>
+                <a:latin typeface="Calibri" pitchFamily="34" charset="0"/>
+                <a:ea typeface="Calibri" pitchFamily="34" charset="-122"/>
+                <a:cs typeface="Calibri" pitchFamily="34" charset="-120"/>
+              </a:rPr>
+              <a:t>Pick again at any time; nothing on the CE changes</a:t>
+            </a:r>
+            <a:endParaRPr lang="en-US" sz="1200" dirty="0"/>
+          </a:p>
+        </p:txBody>
+      </p:sp>
+      <p:sp>
+        <p:nvSpPr>
+          <p:cNvPr id="8" name="Shape 6"/>
+          <p:cNvSpPr/>
+          <p:nvPr/>
+        </p:nvSpPr>
+        <p:spPr>
+          <a:xfrm>
+            <a:off x="6400800" y="1911096"/>
+            <a:ext cx="5221224" cy="3566160"/>
+          </a:xfrm>
+          <a:prstGeom prst="roundRect">
+            <a:avLst>
+              <a:gd name="adj" fmla="val 2051"/>
+            </a:avLst>
+          </a:prstGeom>
+          <a:solidFill>
+            <a:srgbClr val="1C2128"/>
+          </a:solidFill>
+          <a:ln w="12700">
+            <a:solidFill>
+              <a:srgbClr val="30363D"/>
+            </a:solidFill>
+            <a:prstDash val="solid"/>
+          </a:ln>
+          <a:effectLst>
+            <a:outerShdw sx="100000" sy="100000" kx="0" ky="0" algn="bl" rotWithShape="0" blurRad="152400" dist="38100" dir="5400000">
+              <a:srgbClr val="000000">
+                <a:alpha val="45000"/>
+              </a:srgbClr>
+            </a:outerShdw>
+          </a:effectLst>
+        </p:spPr>
+        <p:txBody>
+          <a:bodyPr/>
+          <a:p/>
+        </p:txBody>
+      </p:sp>
+      <p:sp>
+        <p:nvSpPr>
+          <p:cNvPr id="9" name="Text 7"/>
+          <p:cNvSpPr/>
+          <p:nvPr/>
+        </p:nvSpPr>
+        <p:spPr>
+          <a:xfrm>
+            <a:off x="6675120" y="2121408"/>
+            <a:ext cx="4663440" cy="329184"/>
+          </a:xfrm>
+          <a:prstGeom prst="rect">
+            <a:avLst/>
+          </a:prstGeom>
+          <a:noFill/>
+          <a:ln/>
+        </p:spPr>
+        <p:txBody>
+          <a:bodyPr wrap="square" lIns="0" tIns="0" rIns="0" bIns="0" rtlCol="0" anchor="ctr"/>
+          <a:lstStyle/>
+          <a:p>
+            <a:pPr indent="0" marL="0">
+              <a:buNone/>
+            </a:pPr>
+            <a:r>
+              <a:rPr lang="en-US" sz="1700" b="1" dirty="0">
+                <a:solidFill>
+                  <a:srgbClr val="F0A429"/>
+                </a:solidFill>
+                <a:latin typeface="Arial" pitchFamily="34" charset="0"/>
+                <a:ea typeface="Arial" pitchFamily="34" charset="-122"/>
+                <a:cs typeface="Arial" pitchFamily="34" charset="-120"/>
+              </a:rPr>
+              <a:t>Background</a:t>
+            </a:r>
+            <a:endParaRPr lang="en-US" sz="1700" dirty="0"/>
+          </a:p>
+        </p:txBody>
+      </p:sp>
+      <p:sp>
+        <p:nvSpPr>
+          <p:cNvPr id="10" name="Text 8"/>
+          <p:cNvSpPr/>
+          <p:nvPr/>
+        </p:nvSpPr>
+        <p:spPr>
+          <a:xfrm>
+            <a:off x="6675120" y="2578608"/>
+            <a:ext cx="4709160" cy="2651760"/>
+          </a:xfrm>
+          <a:prstGeom prst="rect">
+            <a:avLst/>
+          </a:prstGeom>
+          <a:noFill/>
+          <a:ln/>
+        </p:spPr>
+        <p:txBody>
+          <a:bodyPr wrap="square" lIns="0" tIns="0" rIns="0" bIns="0" rtlCol="0" anchor="t"/>
+          <a:lstStyle/>
+          <a:p>
+            <a:pPr marL="342900" indent="-342900">
+              <a:lnSpc>
+                <a:spcPts val="1600"/>
+              </a:lnSpc>
+              <a:spcAft>
+                <a:spcPts val="900"/>
+              </a:spcAft>
+              <a:buSzPct val="100000"/>
+              <a:buChar char="●"/>
+            </a:pPr>
+            <a:r>
+              <a:rPr lang="en-US" sz="1200" dirty="0">
+                <a:solidFill>
+                  <a:srgbClr val="E6EDF3"/>
+                </a:solidFill>
+                <a:latin typeface="Calibri" pitchFamily="34" charset="0"/>
+                <a:ea typeface="Calibri" pitchFamily="34" charset="-122"/>
+                <a:cs typeface="Calibri" pitchFamily="34" charset="-120"/>
+              </a:rPr>
+              <a:t>Six gradients, or ⬆ Photo to use your own picture</a:t>
+            </a:r>
+            <a:endParaRPr lang="en-US" sz="1200" dirty="0"/>
+          </a:p>
+          <a:p>
+            <a:pPr marL="342900" indent="-342900">
+              <a:lnSpc>
+                <a:spcPts val="1600"/>
+              </a:lnSpc>
+              <a:spcAft>
+                <a:spcPts val="900"/>
+              </a:spcAft>
+              <a:buSzPct val="100000"/>
+              <a:buChar char="●"/>
+            </a:pPr>
+            <a:r>
+              <a:rPr lang="en-US" sz="1200" dirty="0">
+                <a:solidFill>
+                  <a:srgbClr val="E6EDF3"/>
+                </a:solidFill>
+                <a:latin typeface="Calibri" pitchFamily="34" charset="0"/>
+                <a:ea typeface="Calibri" pitchFamily="34" charset="-122"/>
+                <a:cs typeface="Calibri" pitchFamily="34" charset="-120"/>
+              </a:rPr>
+              <a:t>Soften fades the background so text stays readable</a:t>
+            </a:r>
+            <a:endParaRPr lang="en-US" sz="1200" dirty="0"/>
+          </a:p>
+          <a:p>
+            <a:pPr marL="342900" indent="-342900">
+              <a:lnSpc>
+                <a:spcPts val="1600"/>
+              </a:lnSpc>
+              <a:spcAft>
+                <a:spcPts val="900"/>
+              </a:spcAft>
+              <a:buSzPct val="100000"/>
+              <a:buChar char="●"/>
+            </a:pPr>
+            <a:r>
+              <a:rPr lang="en-US" sz="1200" dirty="0">
+                <a:solidFill>
+                  <a:srgbClr val="E6EDF3"/>
+                </a:solidFill>
+                <a:latin typeface="Calibri" pitchFamily="34" charset="0"/>
+                <a:ea typeface="Calibri" pitchFamily="34" charset="-122"/>
+                <a:cs typeface="Calibri" pitchFamily="34" charset="-120"/>
+              </a:rPr>
+              <a:t>Cards and tables stay solid on top of it</a:t>
+            </a:r>
+            <a:endParaRPr lang="en-US" sz="1200" dirty="0"/>
+          </a:p>
+          <a:p>
+            <a:pPr marL="342900" indent="-342900">
+              <a:lnSpc>
+                <a:spcPts val="1600"/>
+              </a:lnSpc>
+              <a:spcAft>
+                <a:spcPts val="900"/>
+              </a:spcAft>
+              <a:buSzPct val="100000"/>
+              <a:buChar char="●"/>
+            </a:pPr>
+            <a:r>
+              <a:rPr lang="en-US" sz="1200" dirty="0">
+                <a:solidFill>
+                  <a:srgbClr val="E6EDF3"/>
+                </a:solidFill>
+                <a:latin typeface="Calibri" pitchFamily="34" charset="0"/>
+                <a:ea typeface="Calibri" pitchFamily="34" charset="-122"/>
+                <a:cs typeface="Calibri" pitchFamily="34" charset="-120"/>
+              </a:rPr>
+              <a:t>None puts the plain canvas back</a:t>
+            </a:r>
+            <a:endParaRPr lang="en-US" sz="1200" dirty="0"/>
+          </a:p>
+        </p:txBody>
+      </p:sp>
+      <p:sp>
+        <p:nvSpPr>
+          <p:cNvPr id="11" name="Text 9"/>
+          <p:cNvSpPr/>
+          <p:nvPr/>
+        </p:nvSpPr>
+        <p:spPr>
+          <a:xfrm>
+            <a:off x="566928" y="6437376"/>
+            <a:ext cx="5486400" cy="237744"/>
+          </a:xfrm>
+          <a:prstGeom prst="rect">
+            <a:avLst/>
+          </a:prstGeom>
+          <a:noFill/>
+          <a:ln/>
+        </p:spPr>
+        <p:txBody>
+          <a:bodyPr wrap="square" lIns="0" tIns="0" rIns="0" bIns="0" rtlCol="0" anchor="ctr"/>
+          <a:lstStyle/>
+          <a:p>
+            <a:pPr indent="0" marL="0">
+              <a:buNone/>
+            </a:pPr>
+            <a:r>
+              <a:rPr lang="en-US" sz="900" dirty="0">
+                <a:solidFill>
+                  <a:srgbClr val="6E7681"/>
+                </a:solidFill>
+                <a:latin typeface="Calibri" pitchFamily="34" charset="0"/>
+                <a:ea typeface="Calibri" pitchFamily="34" charset="-122"/>
+                <a:cs typeface="Calibri" pitchFamily="34" charset="-120"/>
+              </a:rPr>
+              <a:t>SHIC Cost Estimator — End-User Manual</a:t>
+            </a:r>
+            <a:endParaRPr lang="en-US" sz="900" dirty="0"/>
+          </a:p>
+        </p:txBody>
+      </p:sp>
+      <p:sp>
+        <p:nvSpPr>
+          <p:cNvPr id="12" name="Text 10"/>
+          <p:cNvSpPr/>
+          <p:nvPr/>
+        </p:nvSpPr>
+        <p:spPr>
+          <a:xfrm>
+            <a:off x="10981944" y="6437376"/>
+            <a:ext cx="640080" cy="237744"/>
+          </a:xfrm>
+          <a:prstGeom prst="rect">
+            <a:avLst/>
+          </a:prstGeom>
+          <a:noFill/>
+          <a:ln/>
+        </p:spPr>
+        <p:txBody>
+          <a:bodyPr wrap="square" lIns="0" tIns="0" rIns="0" bIns="0" rtlCol="0" anchor="ctr"/>
+          <a:lstStyle/>
+          <a:p>
+            <a:pPr algn="r" indent="0" marL="0">
+              <a:buNone/>
+            </a:pPr>
+            <a:r>
+              <a:rPr lang="en-US" sz="900" dirty="0">
+                <a:solidFill>
+                  <a:srgbClr val="6E7681"/>
+                </a:solidFill>
+                <a:latin typeface="Calibri" pitchFamily="34" charset="0"/>
+                <a:ea typeface="Calibri" pitchFamily="34" charset="-122"/>
+                <a:cs typeface="Calibri" pitchFamily="34" charset="-120"/>
+              </a:rPr>
+              <a:t>31</a:t>
+            </a:r>
+            <a:endParaRPr lang="en-US" sz="900" dirty="0"/>
+          </a:p>
+        </p:txBody>
+      </p:sp>
+    </p:spTree>
+  </p:cSld>
+  <p:clrMapOvr>
+    <a:masterClrMapping/>
+  </p:clrMapOvr>
+</p:sld>
+</file>
+
+<file path=ppt/slides/slide32.xml><?xml version="1.0" encoding="utf-8"?>
 <p:sld xmlns:a="http://schemas.openxmlformats.org/drawingml/2006/main" xmlns:r="http://schemas.openxmlformats.org/officeDocument/2006/relationships" xmlns:p="http://schemas.openxmlformats.org/presentationml/2006/main">
   <p:cSld name="Slide 21">
     <p:bg>
@@ -30800,595 +31389,6 @@
                 <a:cs typeface="Calibri" pitchFamily="34" charset="-120"/>
               </a:rPr>
               <a:t>32</a:t>
-            </a:r>
-            <a:endParaRPr lang="en-US" sz="900" dirty="0"/>
-          </a:p>
-        </p:txBody>
-      </p:sp>
-    </p:spTree>
-  </p:cSld>
-  <p:clrMapOvr>
-    <a:masterClrMapping/>
-  </p:clrMapOvr>
-</p:sld>
-</file>
-
-<file path=ppt/slides/slide32.xml><?xml version="1.0" encoding="utf-8"?>
-<p:sld xmlns:a="http://schemas.openxmlformats.org/drawingml/2006/main" xmlns:p="http://schemas.openxmlformats.org/presentationml/2006/main" xmlns:r="http://schemas.openxmlformats.org/officeDocument/2006/relationships">
-  <p:cSld>
-    <p:bg>
-      <p:bgPr>
-        <a:solidFill>
-          <a:srgbClr val="0D1117"/>
-        </a:solidFill>
-      </p:bgPr>
-    </p:bg>
-    <p:spTree>
-      <p:nvGrpSpPr>
-        <p:cNvPr id="1" name=""/>
-        <p:cNvGrpSpPr/>
-        <p:nvPr/>
-      </p:nvGrpSpPr>
-      <p:grpSpPr/>
-      <p:sp>
-        <p:nvSpPr>
-          <p:cNvPr id="2" name="Text 0"/>
-          <p:cNvSpPr/>
-          <p:nvPr/>
-        </p:nvSpPr>
-        <p:spPr>
-          <a:xfrm>
-            <a:off x="566928" y="384048"/>
-            <a:ext cx="8229600" cy="256032"/>
-          </a:xfrm>
-          <a:prstGeom prst="rect">
-            <a:avLst/>
-          </a:prstGeom>
-          <a:noFill/>
-          <a:ln/>
-        </p:spPr>
-        <p:txBody>
-          <a:bodyPr wrap="square" lIns="0" tIns="0" rIns="0" bIns="0" rtlCol="0" anchor="ctr"/>
-          <a:lstStyle/>
-          <a:p>
-            <a:pPr indent="0" marL="0">
-              <a:buNone/>
-            </a:pPr>
-            <a:r>
-              <a:rPr lang="en-US" sz="1100" b="1" spc="200" kern="0" dirty="0">
-                <a:solidFill>
-                  <a:srgbClr val="F0A429"/>
-                </a:solidFill>
-                <a:latin typeface="Arial" pitchFamily="34" charset="0"/>
-                <a:ea typeface="Arial" pitchFamily="34" charset="-122"/>
-                <a:cs typeface="Arial" pitchFamily="34" charset="-120"/>
-              </a:rPr>
-              <a:t>MAKE IT YOURS</a:t>
-            </a:r>
-            <a:endParaRPr lang="en-US" sz="1100" dirty="0"/>
-          </a:p>
-        </p:txBody>
-      </p:sp>
-      <p:sp>
-        <p:nvSpPr>
-          <p:cNvPr id="3" name="Text 1"/>
-          <p:cNvSpPr/>
-          <p:nvPr/>
-        </p:nvSpPr>
-        <p:spPr>
-          <a:xfrm>
-            <a:off x="566928" y="694944"/>
-            <a:ext cx="11055096" cy="566928"/>
-          </a:xfrm>
-          <a:prstGeom prst="rect">
-            <a:avLst/>
-          </a:prstGeom>
-          <a:noFill/>
-          <a:ln/>
-        </p:spPr>
-        <p:txBody>
-          <a:bodyPr wrap="square" lIns="0" tIns="0" rIns="0" bIns="0" rtlCol="0" anchor="ctr"/>
-          <a:lstStyle/>
-          <a:p>
-            <a:pPr indent="0" marL="0">
-              <a:buNone/>
-            </a:pPr>
-            <a:r>
-              <a:rPr lang="en-US" sz="3200" b="1" dirty="0">
-                <a:solidFill>
-                  <a:srgbClr val="E6EDF3"/>
-                </a:solidFill>
-                <a:latin typeface="Arial" pitchFamily="34" charset="0"/>
-                <a:ea typeface="Arial" pitchFamily="34" charset="-122"/>
-                <a:cs typeface="Arial" pitchFamily="34" charset="-120"/>
-              </a:rPr>
-              <a:t>Themes and backgrounds</a:t>
-            </a:r>
-            <a:endParaRPr lang="en-US" sz="3200" dirty="0"/>
-          </a:p>
-        </p:txBody>
-      </p:sp>
-      <p:sp>
-        <p:nvSpPr>
-          <p:cNvPr id="4" name="Text 2"/>
-          <p:cNvSpPr/>
-          <p:nvPr/>
-        </p:nvSpPr>
-        <p:spPr>
-          <a:xfrm>
-            <a:off x="566928" y="1298448"/>
-            <a:ext cx="10972800" cy="365760"/>
-          </a:xfrm>
-          <a:prstGeom prst="rect">
-            <a:avLst/>
-          </a:prstGeom>
-          <a:noFill/>
-          <a:ln/>
-        </p:spPr>
-        <p:txBody>
-          <a:bodyPr wrap="square" lIns="0" tIns="0" rIns="0" bIns="0" rtlCol="0" anchor="t"/>
-          <a:lstStyle/>
-          <a:p>
-            <a:pPr algn="l" indent="0" marL="0">
-              <a:lnSpc>
-                <a:spcPts val="2000"/>
-              </a:lnSpc>
-              <a:buNone/>
-            </a:pPr>
-            <a:r>
-              <a:rPr lang="en-US" sz="1400" dirty="0">
-                <a:solidFill>
-                  <a:srgbClr val="9AA4AF"/>
-                </a:solidFill>
-                <a:latin typeface="Calibri" pitchFamily="34" charset="0"/>
-                <a:ea typeface="Calibri" pitchFamily="34" charset="-122"/>
-                <a:cs typeface="Calibri" pitchFamily="34" charset="-120"/>
-              </a:rPr>
-              <a:t>Press 🎨 in the top bar. The choice is kept in your browser only; printed CEs and exports never change.</a:t>
-            </a:r>
-            <a:endParaRPr lang="en-US" sz="1400" dirty="0"/>
-          </a:p>
-        </p:txBody>
-      </p:sp>
-      <p:sp>
-        <p:nvSpPr>
-          <p:cNvPr id="5" name="Shape 3"/>
-          <p:cNvSpPr/>
-          <p:nvPr/>
-        </p:nvSpPr>
-        <p:spPr>
-          <a:xfrm>
-            <a:off x="566928" y="1911096"/>
-            <a:ext cx="5532120" cy="3566160"/>
-          </a:xfrm>
-          <a:prstGeom prst="roundRect">
-            <a:avLst>
-              <a:gd name="adj" fmla="val 2051"/>
-            </a:avLst>
-          </a:prstGeom>
-          <a:solidFill>
-            <a:srgbClr val="1C2128"/>
-          </a:solidFill>
-          <a:ln w="12700">
-            <a:solidFill>
-              <a:srgbClr val="30363D"/>
-            </a:solidFill>
-            <a:prstDash val="solid"/>
-          </a:ln>
-          <a:effectLst>
-            <a:outerShdw sx="100000" sy="100000" kx="0" ky="0" algn="bl" rotWithShape="0" blurRad="152400" dist="38100" dir="5400000">
-              <a:srgbClr val="000000">
-                <a:alpha val="45000"/>
-              </a:srgbClr>
-            </a:outerShdw>
-          </a:effectLst>
-        </p:spPr>
-        <p:txBody>
-          <a:bodyPr/>
-          <a:p/>
-        </p:txBody>
-      </p:sp>
-      <p:sp>
-        <p:nvSpPr>
-          <p:cNvPr id="6" name="Text 4"/>
-          <p:cNvSpPr/>
-          <p:nvPr/>
-        </p:nvSpPr>
-        <p:spPr>
-          <a:xfrm>
-            <a:off x="841248" y="2121408"/>
-            <a:ext cx="4937760" cy="329184"/>
-          </a:xfrm>
-          <a:prstGeom prst="rect">
-            <a:avLst/>
-          </a:prstGeom>
-          <a:noFill/>
-          <a:ln/>
-        </p:spPr>
-        <p:txBody>
-          <a:bodyPr wrap="square" lIns="0" tIns="0" rIns="0" bIns="0" rtlCol="0" anchor="ctr"/>
-          <a:lstStyle/>
-          <a:p>
-            <a:pPr indent="0" marL="0">
-              <a:buNone/>
-            </a:pPr>
-            <a:r>
-              <a:rPr lang="en-US" sz="1700" b="1" dirty="0">
-                <a:solidFill>
-                  <a:srgbClr val="A78BFA"/>
-                </a:solidFill>
-                <a:latin typeface="Arial" pitchFamily="34" charset="0"/>
-                <a:ea typeface="Arial" pitchFamily="34" charset="-122"/>
-                <a:cs typeface="Arial" pitchFamily="34" charset="-120"/>
-              </a:rPr>
-              <a:t>Theme</a:t>
-            </a:r>
-            <a:endParaRPr lang="en-US" sz="1700" dirty="0"/>
-          </a:p>
-        </p:txBody>
-      </p:sp>
-      <p:sp>
-        <p:nvSpPr>
-          <p:cNvPr id="7" name="Text 5"/>
-          <p:cNvSpPr/>
-          <p:nvPr/>
-        </p:nvSpPr>
-        <p:spPr>
-          <a:xfrm>
-            <a:off x="841248" y="2578608"/>
-            <a:ext cx="4983480" cy="2651760"/>
-          </a:xfrm>
-          <a:prstGeom prst="rect">
-            <a:avLst/>
-          </a:prstGeom>
-          <a:noFill/>
-          <a:ln/>
-        </p:spPr>
-        <p:txBody>
-          <a:bodyPr wrap="square" lIns="0" tIns="0" rIns="0" bIns="0" rtlCol="0" anchor="t"/>
-          <a:lstStyle/>
-          <a:p>
-            <a:pPr marL="342900" indent="-342900">
-              <a:lnSpc>
-                <a:spcPts val="1600"/>
-              </a:lnSpc>
-              <a:spcAft>
-                <a:spcPts val="900"/>
-              </a:spcAft>
-              <a:buSzPct val="100000"/>
-              <a:buChar char="●"/>
-            </a:pPr>
-            <a:r>
-              <a:rPr lang="en-US" sz="1200" dirty="0">
-                <a:solidFill>
-                  <a:srgbClr val="E6EDF3"/>
-                </a:solidFill>
-                <a:latin typeface="Calibri" pitchFamily="34" charset="0"/>
-                <a:ea typeface="Calibri" pitchFamily="34" charset="-122"/>
-                <a:cs typeface="Calibri" pitchFamily="34" charset="-120"/>
-              </a:rPr>
-              <a:t>Ten palettes: Dark Slate, Executive Light, Ocean, Forest, Nebula, Graphite, Sunset, Lavender, Sakura, Mint</a:t>
-            </a:r>
-            <a:endParaRPr lang="en-US" sz="1200" dirty="0"/>
-          </a:p>
-          <a:p>
-            <a:pPr marL="342900" indent="-342900">
-              <a:lnSpc>
-                <a:spcPts val="1600"/>
-              </a:lnSpc>
-              <a:spcAft>
-                <a:spcPts val="900"/>
-              </a:spcAft>
-              <a:buSzPct val="100000"/>
-              <a:buChar char="●"/>
-            </a:pPr>
-            <a:r>
-              <a:rPr lang="en-US" sz="1200" dirty="0">
-                <a:solidFill>
-                  <a:srgbClr val="E6EDF3"/>
-                </a:solidFill>
-                <a:latin typeface="Calibri" pitchFamily="34" charset="0"/>
-                <a:ea typeface="Calibri" pitchFamily="34" charset="-122"/>
-                <a:cs typeface="Calibri" pitchFamily="34" charset="-120"/>
-              </a:rPr>
-              <a:t>Executive Light is softened — easier on the eyes than plain white</a:t>
-            </a:r>
-            <a:endParaRPr lang="en-US" sz="1200" dirty="0"/>
-          </a:p>
-          <a:p>
-            <a:pPr marL="342900" indent="-342900">
-              <a:lnSpc>
-                <a:spcPts val="1600"/>
-              </a:lnSpc>
-              <a:spcAft>
-                <a:spcPts val="900"/>
-              </a:spcAft>
-              <a:buSzPct val="100000"/>
-              <a:buChar char="●"/>
-            </a:pPr>
-            <a:r>
-              <a:rPr lang="en-US" sz="1200" dirty="0">
-                <a:solidFill>
-                  <a:srgbClr val="E6EDF3"/>
-                </a:solidFill>
-                <a:latin typeface="Calibri" pitchFamily="34" charset="0"/>
-                <a:ea typeface="Calibri" pitchFamily="34" charset="-122"/>
-                <a:cs typeface="Calibri" pitchFamily="34" charset="-120"/>
-              </a:rPr>
-              <a:t>Pick again at any time; nothing on the CE changes</a:t>
-            </a:r>
-            <a:endParaRPr lang="en-US" sz="1200" dirty="0"/>
-          </a:p>
-        </p:txBody>
-      </p:sp>
-      <p:sp>
-        <p:nvSpPr>
-          <p:cNvPr id="8" name="Shape 6"/>
-          <p:cNvSpPr/>
-          <p:nvPr/>
-        </p:nvSpPr>
-        <p:spPr>
-          <a:xfrm>
-            <a:off x="6400800" y="1911096"/>
-            <a:ext cx="5221224" cy="3566160"/>
-          </a:xfrm>
-          <a:prstGeom prst="roundRect">
-            <a:avLst>
-              <a:gd name="adj" fmla="val 2051"/>
-            </a:avLst>
-          </a:prstGeom>
-          <a:solidFill>
-            <a:srgbClr val="1C2128"/>
-          </a:solidFill>
-          <a:ln w="12700">
-            <a:solidFill>
-              <a:srgbClr val="30363D"/>
-            </a:solidFill>
-            <a:prstDash val="solid"/>
-          </a:ln>
-          <a:effectLst>
-            <a:outerShdw sx="100000" sy="100000" kx="0" ky="0" algn="bl" rotWithShape="0" blurRad="152400" dist="38100" dir="5400000">
-              <a:srgbClr val="000000">
-                <a:alpha val="45000"/>
-              </a:srgbClr>
-            </a:outerShdw>
-          </a:effectLst>
-        </p:spPr>
-        <p:txBody>
-          <a:bodyPr/>
-          <a:p/>
-        </p:txBody>
-      </p:sp>
-      <p:sp>
-        <p:nvSpPr>
-          <p:cNvPr id="9" name="Text 7"/>
-          <p:cNvSpPr/>
-          <p:nvPr/>
-        </p:nvSpPr>
-        <p:spPr>
-          <a:xfrm>
-            <a:off x="6675120" y="2121408"/>
-            <a:ext cx="4663440" cy="329184"/>
-          </a:xfrm>
-          <a:prstGeom prst="rect">
-            <a:avLst/>
-          </a:prstGeom>
-          <a:noFill/>
-          <a:ln/>
-        </p:spPr>
-        <p:txBody>
-          <a:bodyPr wrap="square" lIns="0" tIns="0" rIns="0" bIns="0" rtlCol="0" anchor="ctr"/>
-          <a:lstStyle/>
-          <a:p>
-            <a:pPr indent="0" marL="0">
-              <a:buNone/>
-            </a:pPr>
-            <a:r>
-              <a:rPr lang="en-US" sz="1700" b="1" dirty="0">
-                <a:solidFill>
-                  <a:srgbClr val="F0A429"/>
-                </a:solidFill>
-                <a:latin typeface="Arial" pitchFamily="34" charset="0"/>
-                <a:ea typeface="Arial" pitchFamily="34" charset="-122"/>
-                <a:cs typeface="Arial" pitchFamily="34" charset="-120"/>
-              </a:rPr>
-              <a:t>Background</a:t>
-            </a:r>
-            <a:endParaRPr lang="en-US" sz="1700" dirty="0"/>
-          </a:p>
-        </p:txBody>
-      </p:sp>
-      <p:sp>
-        <p:nvSpPr>
-          <p:cNvPr id="10" name="Text 8"/>
-          <p:cNvSpPr/>
-          <p:nvPr/>
-        </p:nvSpPr>
-        <p:spPr>
-          <a:xfrm>
-            <a:off x="6675120" y="2578608"/>
-            <a:ext cx="4709160" cy="2651760"/>
-          </a:xfrm>
-          <a:prstGeom prst="rect">
-            <a:avLst/>
-          </a:prstGeom>
-          <a:noFill/>
-          <a:ln/>
-        </p:spPr>
-        <p:txBody>
-          <a:bodyPr wrap="square" lIns="0" tIns="0" rIns="0" bIns="0" rtlCol="0" anchor="t"/>
-          <a:lstStyle/>
-          <a:p>
-            <a:pPr marL="342900" indent="-342900">
-              <a:lnSpc>
-                <a:spcPts val="1600"/>
-              </a:lnSpc>
-              <a:spcAft>
-                <a:spcPts val="900"/>
-              </a:spcAft>
-              <a:buSzPct val="100000"/>
-              <a:buChar char="●"/>
-            </a:pPr>
-            <a:r>
-              <a:rPr lang="en-US" sz="1200" dirty="0">
-                <a:solidFill>
-                  <a:srgbClr val="E6EDF3"/>
-                </a:solidFill>
-                <a:latin typeface="Calibri" pitchFamily="34" charset="0"/>
-                <a:ea typeface="Calibri" pitchFamily="34" charset="-122"/>
-                <a:cs typeface="Calibri" pitchFamily="34" charset="-120"/>
-              </a:rPr>
-              <a:t>Six gradients, or ⬆ Photo to use your own picture</a:t>
-            </a:r>
-            <a:endParaRPr lang="en-US" sz="1200" dirty="0"/>
-          </a:p>
-          <a:p>
-            <a:pPr marL="342900" indent="-342900">
-              <a:lnSpc>
-                <a:spcPts val="1600"/>
-              </a:lnSpc>
-              <a:spcAft>
-                <a:spcPts val="900"/>
-              </a:spcAft>
-              <a:buSzPct val="100000"/>
-              <a:buChar char="●"/>
-            </a:pPr>
-            <a:r>
-              <a:rPr lang="en-US" sz="1200" dirty="0">
-                <a:solidFill>
-                  <a:srgbClr val="E6EDF3"/>
-                </a:solidFill>
-                <a:latin typeface="Calibri" pitchFamily="34" charset="0"/>
-                <a:ea typeface="Calibri" pitchFamily="34" charset="-122"/>
-                <a:cs typeface="Calibri" pitchFamily="34" charset="-120"/>
-              </a:rPr>
-              <a:t>Soften fades the background so text stays readable</a:t>
-            </a:r>
-            <a:endParaRPr lang="en-US" sz="1200" dirty="0"/>
-          </a:p>
-          <a:p>
-            <a:pPr marL="342900" indent="-342900">
-              <a:lnSpc>
-                <a:spcPts val="1600"/>
-              </a:lnSpc>
-              <a:spcAft>
-                <a:spcPts val="900"/>
-              </a:spcAft>
-              <a:buSzPct val="100000"/>
-              <a:buChar char="●"/>
-            </a:pPr>
-            <a:r>
-              <a:rPr lang="en-US" sz="1200" dirty="0">
-                <a:solidFill>
-                  <a:srgbClr val="E6EDF3"/>
-                </a:solidFill>
-                <a:latin typeface="Calibri" pitchFamily="34" charset="0"/>
-                <a:ea typeface="Calibri" pitchFamily="34" charset="-122"/>
-                <a:cs typeface="Calibri" pitchFamily="34" charset="-120"/>
-              </a:rPr>
-              <a:t>Cards and tables stay solid on top of it</a:t>
-            </a:r>
-            <a:endParaRPr lang="en-US" sz="1200" dirty="0"/>
-          </a:p>
-          <a:p>
-            <a:pPr marL="342900" indent="-342900">
-              <a:lnSpc>
-                <a:spcPts val="1600"/>
-              </a:lnSpc>
-              <a:spcAft>
-                <a:spcPts val="900"/>
-              </a:spcAft>
-              <a:buSzPct val="100000"/>
-              <a:buChar char="●"/>
-            </a:pPr>
-            <a:r>
-              <a:rPr lang="en-US" sz="1200" dirty="0">
-                <a:solidFill>
-                  <a:srgbClr val="E6EDF3"/>
-                </a:solidFill>
-                <a:latin typeface="Calibri" pitchFamily="34" charset="0"/>
-                <a:ea typeface="Calibri" pitchFamily="34" charset="-122"/>
-                <a:cs typeface="Calibri" pitchFamily="34" charset="-120"/>
-              </a:rPr>
-              <a:t>None puts the plain canvas back</a:t>
-            </a:r>
-            <a:endParaRPr lang="en-US" sz="1200" dirty="0"/>
-          </a:p>
-        </p:txBody>
-      </p:sp>
-      <p:sp>
-        <p:nvSpPr>
-          <p:cNvPr id="11" name="Text 9"/>
-          <p:cNvSpPr/>
-          <p:nvPr/>
-        </p:nvSpPr>
-        <p:spPr>
-          <a:xfrm>
-            <a:off x="566928" y="6437376"/>
-            <a:ext cx="5486400" cy="237744"/>
-          </a:xfrm>
-          <a:prstGeom prst="rect">
-            <a:avLst/>
-          </a:prstGeom>
-          <a:noFill/>
-          <a:ln/>
-        </p:spPr>
-        <p:txBody>
-          <a:bodyPr wrap="square" lIns="0" tIns="0" rIns="0" bIns="0" rtlCol="0" anchor="ctr"/>
-          <a:lstStyle/>
-          <a:p>
-            <a:pPr indent="0" marL="0">
-              <a:buNone/>
-            </a:pPr>
-            <a:r>
-              <a:rPr lang="en-US" sz="900" dirty="0">
-                <a:solidFill>
-                  <a:srgbClr val="6E7681"/>
-                </a:solidFill>
-                <a:latin typeface="Calibri" pitchFamily="34" charset="0"/>
-                <a:ea typeface="Calibri" pitchFamily="34" charset="-122"/>
-                <a:cs typeface="Calibri" pitchFamily="34" charset="-120"/>
-              </a:rPr>
-              <a:t>SHIC Cost Estimator — End-User Manual</a:t>
-            </a:r>
-            <a:endParaRPr lang="en-US" sz="900" dirty="0"/>
-          </a:p>
-        </p:txBody>
-      </p:sp>
-      <p:sp>
-        <p:nvSpPr>
-          <p:cNvPr id="12" name="Text 10"/>
-          <p:cNvSpPr/>
-          <p:nvPr/>
-        </p:nvSpPr>
-        <p:spPr>
-          <a:xfrm>
-            <a:off x="10981944" y="6437376"/>
-            <a:ext cx="640080" cy="237744"/>
-          </a:xfrm>
-          <a:prstGeom prst="rect">
-            <a:avLst/>
-          </a:prstGeom>
-          <a:noFill/>
-          <a:ln/>
-        </p:spPr>
-        <p:txBody>
-          <a:bodyPr wrap="square" lIns="0" tIns="0" rIns="0" bIns="0" rtlCol="0" anchor="ctr"/>
-          <a:lstStyle/>
-          <a:p>
-            <a:pPr algn="r" indent="0" marL="0">
-              <a:buNone/>
-            </a:pPr>
-            <a:r>
-              <a:rPr lang="en-US" sz="900" dirty="0">
-                <a:solidFill>
-                  <a:srgbClr val="6E7681"/>
-                </a:solidFill>
-                <a:latin typeface="Calibri" pitchFamily="34" charset="0"/>
-                <a:ea typeface="Calibri" pitchFamily="34" charset="-122"/>
-                <a:cs typeface="Calibri" pitchFamily="34" charset="-120"/>
-              </a:rPr>
-              <a:t>31</a:t>
             </a:r>
             <a:endParaRPr lang="en-US" sz="900" dirty="0"/>
           </a:p>

</xml_diff>

<commit_message>
Manual: builds 242-244 -- new slides for the Shop + Site CE type and Import tool list, SOW Breakdown unassigned manpower by shift, quick reference updated; slides 18 onward renumbered
Co-Authored-By: Claude Opus 5 <noreply@anthropic.com>
</commit_message>
<xml_diff>
--- a/docs/SHIC-Cost-Estimator-User-Manual.pptx
+++ b/docs/SHIC-Cost-Estimator-User-Manual.pptx
@@ -22,6 +22,8 @@
     <p:sldId id="266" r:id="rId12"/>
     <p:sldId id="277" r:id="rId28"/>
     <p:sldId id="278" r:id="rId29"/>
+    <p:sldId id="288" r:id="rId39"/>
+    <p:sldId id="289" r:id="rId40"/>
     <p:sldId id="267" r:id="rId13"/>
     <p:sldId id="268" r:id="rId14"/>
     <p:sldId id="281" r:id="rId32"/>
@@ -14969,7 +14971,7 @@
                 <a:ea typeface="Calibri" pitchFamily="34" charset="-122"/>
                 <a:cs typeface="Calibri" pitchFamily="34" charset="-120"/>
               </a:rPr>
-              <a:t>18</a:t>
+              <a:t>20</a:t>
             </a:r>
             <a:endParaRPr lang="en-US" sz="900" dirty="0"/>
           </a:p>
@@ -16997,7 +16999,7 @@
                 <a:ea typeface="Calibri" pitchFamily="34" charset="-122"/>
                 <a:cs typeface="Calibri" pitchFamily="34" charset="-120"/>
               </a:rPr>
-              <a:t>19</a:t>
+              <a:t>21</a:t>
             </a:r>
             <a:endParaRPr lang="en-US" sz="900" dirty="0"/>
           </a:p>
@@ -18491,7 +18493,7 @@
                 <a:ea typeface="Calibri" pitchFamily="34" charset="-122"/>
                 <a:cs typeface="Calibri" pitchFamily="34" charset="-120"/>
               </a:rPr>
-              <a:t>20</a:t>
+              <a:t>22</a:t>
             </a:r>
             <a:endParaRPr lang="en-US" sz="900" dirty="0"/>
           </a:p>
@@ -19230,7 +19232,7 @@
                 <a:ea typeface="Calibri" pitchFamily="34" charset="-122"/>
                 <a:cs typeface="Calibri" pitchFamily="34" charset="-120"/>
               </a:rPr>
-              <a:t>21</a:t>
+              <a:t>23</a:t>
             </a:r>
             <a:endParaRPr lang="en-US" sz="900" dirty="0"/>
           </a:p>
@@ -20484,7 +20486,7 @@
                 <a:ea typeface="Calibri" pitchFamily="34" charset="-122"/>
                 <a:cs typeface="Calibri" pitchFamily="34" charset="-120"/>
               </a:rPr>
-              <a:t>22</a:t>
+              <a:t>24</a:t>
             </a:r>
             <a:endParaRPr lang="en-US" sz="900" dirty="0"/>
           </a:p>
@@ -21248,7 +21250,7 @@
                 <a:ea typeface="Calibri" pitchFamily="34" charset="-122"/>
                 <a:cs typeface="Calibri" pitchFamily="34" charset="-120"/>
               </a:rPr>
-              <a:t>23</a:t>
+              <a:t>25</a:t>
             </a:r>
             <a:endParaRPr lang="en-US" sz="900" dirty="0"/>
           </a:p>
@@ -21909,7 +21911,7 @@
                 <a:ea typeface="Calibri" pitchFamily="34" charset="-122"/>
                 <a:cs typeface="Calibri" pitchFamily="34" charset="-120"/>
               </a:rPr>
-              <a:t>24</a:t>
+              <a:t>26</a:t>
             </a:r>
             <a:endParaRPr lang="en-US" sz="900" dirty="0"/>
           </a:p>
@@ -23596,7 +23598,7 @@
                 <a:ea typeface="Calibri" pitchFamily="34" charset="-122"/>
                 <a:cs typeface="Calibri" pitchFamily="34" charset="-120"/>
               </a:rPr>
-              <a:t>25</a:t>
+              <a:t>27</a:t>
             </a:r>
             <a:endParaRPr lang="en-US" sz="900" dirty="0"/>
           </a:p>
@@ -24216,7 +24218,7 @@
                 <a:ea typeface="Calibri" pitchFamily="34" charset="-122"/>
                 <a:cs typeface="Calibri" pitchFamily="34" charset="-120"/>
               </a:rPr>
-              <a:t>26</a:t>
+              <a:t>28</a:t>
             </a:r>
             <a:endParaRPr lang="en-US" sz="900" dirty="0"/>
           </a:p>
@@ -24853,7 +24855,7 @@
                 <a:ea typeface="Calibri" pitchFamily="34" charset="-122"/>
                 <a:cs typeface="Calibri" pitchFamily="34" charset="-120"/>
               </a:rPr>
-              <a:t>27</a:t>
+              <a:t>29</a:t>
             </a:r>
             <a:endParaRPr lang="en-US" sz="900" dirty="0"/>
           </a:p>
@@ -25763,7 +25765,7 @@
                 <a:ea typeface="Calibri" pitchFamily="34" charset="-122"/>
                 <a:cs typeface="Calibri" pitchFamily="34" charset="-120"/>
               </a:rPr>
-              <a:t>28</a:t>
+              <a:t>30</a:t>
             </a:r>
             <a:endParaRPr lang="en-US" sz="900" dirty="0"/>
           </a:p>
@@ -26982,7 +26984,7 @@
                 <a:ea typeface="Calibri" pitchFamily="34" charset="-122"/>
                 <a:cs typeface="Calibri" pitchFamily="34" charset="-120"/>
               </a:rPr>
-              <a:t>29</a:t>
+              <a:t>31</a:t>
             </a:r>
             <a:endParaRPr lang="en-US" sz="900" dirty="0"/>
           </a:p>
@@ -29782,7 +29784,7 @@
                 <a:ea typeface="Calibri" pitchFamily="34" charset="-122"/>
                 <a:cs typeface="Calibri" pitchFamily="34" charset="-120"/>
               </a:rPr>
-              <a:t>30</a:t>
+              <a:t>32</a:t>
             </a:r>
             <a:endParaRPr lang="en-US" sz="900" dirty="0"/>
           </a:p>
@@ -30371,7 +30373,7 @@
                 <a:ea typeface="Calibri" pitchFamily="34" charset="-122"/>
                 <a:cs typeface="Calibri" pitchFamily="34" charset="-120"/>
               </a:rPr>
-              <a:t>31</a:t>
+              <a:t>33</a:t>
             </a:r>
             <a:endParaRPr lang="en-US" sz="900" dirty="0"/>
           </a:p>
@@ -30724,7 +30726,7 @@
                 <a:ea typeface="Calibri" pitchFamily="34" charset="-122"/>
                 <a:cs typeface="Calibri" pitchFamily="34" charset="-120"/>
               </a:rPr>
-              <a:t>ShopWorks: power is charged, Incentive is not</a:t>
+              <a:t>ShopWorks: power, no Incentive. Shop + Site: split by task</a:t>
             </a:r>
             <a:endParaRPr lang="en-US" sz="1150" dirty="0"/>
           </a:p>
@@ -31388,7 +31390,2875 @@
                 <a:ea typeface="Calibri" pitchFamily="34" charset="-122"/>
                 <a:cs typeface="Calibri" pitchFamily="34" charset="-120"/>
               </a:rPr>
-              <a:t>32</a:t>
+              <a:t>34</a:t>
+            </a:r>
+            <a:endParaRPr lang="en-US" sz="900" dirty="0"/>
+          </a:p>
+        </p:txBody>
+      </p:sp>
+    </p:spTree>
+  </p:cSld>
+  <p:clrMapOvr>
+    <a:masterClrMapping/>
+  </p:clrMapOvr>
+</p:sld>
+</file>
+
+<file path=ppt/slides/slide33.xml><?xml version="1.0" encoding="utf-8"?>
+<p:sld xmlns:a="http://schemas.openxmlformats.org/drawingml/2006/main" xmlns:r="http://schemas.openxmlformats.org/officeDocument/2006/relationships" xmlns:p="http://schemas.openxmlformats.org/presentationml/2006/main">
+  <p:cSld name="Slide 11">
+    <p:bg>
+      <p:bgPr>
+        <a:solidFill>
+          <a:srgbClr val="161B22"/>
+        </a:solidFill>
+      </p:bgPr>
+    </p:bg>
+    <p:spTree>
+      <p:nvGrpSpPr>
+        <p:cNvPr id="1" name=""/>
+        <p:cNvGrpSpPr/>
+        <p:nvPr/>
+      </p:nvGrpSpPr>
+      <p:grpSpPr>
+        <a:xfrm>
+          <a:off x="0" y="0"/>
+          <a:ext cx="0" cy="0"/>
+          <a:chOff x="0" y="0"/>
+          <a:chExt cx="0" cy="0"/>
+        </a:xfrm>
+      </p:grpSpPr>
+      <p:sp>
+        <p:nvSpPr>
+          <p:cNvPr id="2" name="Text 0"/>
+          <p:cNvSpPr/>
+          <p:nvPr/>
+        </p:nvSpPr>
+        <p:spPr>
+          <a:xfrm>
+            <a:off x="566928" y="384048"/>
+            <a:ext cx="8229600" cy="256032"/>
+          </a:xfrm>
+          <a:prstGeom prst="rect">
+            <a:avLst/>
+          </a:prstGeom>
+          <a:noFill/>
+          <a:ln/>
+        </p:spPr>
+        <p:txBody>
+          <a:bodyPr wrap="square" lIns="0" tIns="0" rIns="0" bIns="0" rtlCol="0" anchor="ctr"/>
+          <a:lstStyle/>
+          <a:p>
+            <a:pPr indent="0" marL="0">
+              <a:buNone/>
+            </a:pPr>
+            <a:r>
+              <a:rPr lang="en-US" sz="1100" b="1" spc="200" kern="0" dirty="0">
+                <a:solidFill>
+                  <a:srgbClr val="F0A429"/>
+                </a:solidFill>
+                <a:latin typeface="Arial" pitchFamily="34" charset="0"/>
+                <a:ea typeface="Arial" pitchFamily="34" charset="-122"/>
+                <a:cs typeface="Arial" pitchFamily="34" charset="-120"/>
+              </a:rPr>
+              <a:t>CE TYPE · SHOP + SITE</a:t>
+            </a:r>
+            <a:endParaRPr lang="en-US" sz="1100" dirty="0"/>
+          </a:p>
+        </p:txBody>
+      </p:sp>
+      <p:sp>
+        <p:nvSpPr>
+          <p:cNvPr id="3" name="Text 1"/>
+          <p:cNvSpPr/>
+          <p:nvPr/>
+        </p:nvSpPr>
+        <p:spPr>
+          <a:xfrm>
+            <a:off x="566928" y="694944"/>
+            <a:ext cx="11055096" cy="566928"/>
+          </a:xfrm>
+          <a:prstGeom prst="rect">
+            <a:avLst/>
+          </a:prstGeom>
+          <a:noFill/>
+          <a:ln/>
+        </p:spPr>
+        <p:txBody>
+          <a:bodyPr wrap="square" lIns="0" tIns="0" rIns="0" bIns="0" rtlCol="0" anchor="ctr"/>
+          <a:lstStyle/>
+          <a:p>
+            <a:pPr indent="0" marL="0">
+              <a:buNone/>
+            </a:pPr>
+            <a:r>
+              <a:rPr lang="en-US" sz="3200" b="1" dirty="0">
+                <a:solidFill>
+                  <a:srgbClr val="E6EDF3"/>
+                </a:solidFill>
+                <a:latin typeface="Arial" pitchFamily="34" charset="0"/>
+                <a:ea typeface="Arial" pitchFamily="34" charset="-122"/>
+                <a:cs typeface="Arial" pitchFamily="34" charset="-120"/>
+              </a:rPr>
+              <a:t>One job, part in the shop, part on site</a:t>
+            </a:r>
+            <a:endParaRPr lang="en-US" sz="3200" dirty="0"/>
+          </a:p>
+        </p:txBody>
+      </p:sp>
+      <p:sp>
+        <p:nvSpPr>
+          <p:cNvPr id="4" name="Shape 2"/>
+          <p:cNvSpPr/>
+          <p:nvPr/>
+        </p:nvSpPr>
+        <p:spPr>
+          <a:xfrm>
+            <a:off x="566928" y="1362456"/>
+            <a:ext cx="11055096" cy="420624"/>
+          </a:xfrm>
+          <a:prstGeom prst="roundRect">
+            <a:avLst>
+              <a:gd name="adj" fmla="val 13043"/>
+            </a:avLst>
+          </a:prstGeom>
+          <a:solidFill>
+            <a:srgbClr val="161B22"/>
+          </a:solidFill>
+          <a:ln w="12700">
+            <a:solidFill>
+              <a:srgbClr val="30363D"/>
+            </a:solidFill>
+            <a:prstDash val="solid"/>
+          </a:ln>
+        </p:spPr>
+        <p:txBody>
+          <a:bodyPr/>
+          <a:p/>
+        </p:txBody>
+      </p:sp>
+      <p:sp>
+        <p:nvSpPr>
+          <p:cNvPr id="5" name="Text 3"/>
+          <p:cNvSpPr/>
+          <p:nvPr/>
+        </p:nvSpPr>
+        <p:spPr>
+          <a:xfrm>
+            <a:off x="566928" y="1408176"/>
+            <a:ext cx="1228344" cy="329184"/>
+          </a:xfrm>
+          <a:prstGeom prst="rect">
+            <a:avLst/>
+          </a:prstGeom>
+          <a:noFill/>
+          <a:ln/>
+        </p:spPr>
+        <p:txBody>
+          <a:bodyPr wrap="square" lIns="0" tIns="0" rIns="0" bIns="0" rtlCol="0" anchor="ctr"/>
+          <a:lstStyle/>
+          <a:p>
+            <a:pPr algn="ctr" indent="0" marL="0">
+              <a:buNone/>
+            </a:pPr>
+            <a:r>
+              <a:rPr lang="en-US" sz="900" dirty="0">
+                <a:solidFill>
+                  <a:srgbClr val="9AA4AF"/>
+                </a:solidFill>
+                <a:latin typeface="Calibri" pitchFamily="34" charset="0"/>
+                <a:ea typeface="Calibri" pitchFamily="34" charset="-122"/>
+                <a:cs typeface="Calibri" pitchFamily="34" charset="-120"/>
+              </a:rPr>
+              <a:t>Project Info</a:t>
+            </a:r>
+            <a:endParaRPr lang="en-US" sz="900" dirty="0"/>
+          </a:p>
+        </p:txBody>
+      </p:sp>
+      <p:sp>
+        <p:nvSpPr>
+          <p:cNvPr id="6" name="Text 4"/>
+          <p:cNvSpPr/>
+          <p:nvPr/>
+        </p:nvSpPr>
+        <p:spPr>
+          <a:xfrm>
+            <a:off x="1795272" y="1408176"/>
+            <a:ext cx="1228344" cy="329184"/>
+          </a:xfrm>
+          <a:prstGeom prst="rect">
+            <a:avLst/>
+          </a:prstGeom>
+          <a:noFill/>
+          <a:ln/>
+        </p:spPr>
+        <p:txBody>
+          <a:bodyPr wrap="square" lIns="0" tIns="0" rIns="0" bIns="0" rtlCol="0" anchor="ctr"/>
+          <a:lstStyle/>
+          <a:p>
+            <a:pPr algn="ctr" indent="0" marL="0">
+              <a:buNone/>
+            </a:pPr>
+            <a:r>
+              <a:rPr lang="en-US" sz="900" dirty="0">
+                <a:solidFill>
+                  <a:srgbClr val="9AA4AF"/>
+                </a:solidFill>
+                <a:latin typeface="Calibri" pitchFamily="34" charset="0"/>
+                <a:ea typeface="Calibri" pitchFamily="34" charset="-122"/>
+                <a:cs typeface="Calibri" pitchFamily="34" charset="-120"/>
+              </a:rPr>
+              <a:t>Scope of Work</a:t>
+            </a:r>
+            <a:endParaRPr lang="en-US" sz="900" dirty="0"/>
+          </a:p>
+        </p:txBody>
+      </p:sp>
+      <p:sp>
+        <p:nvSpPr>
+          <p:cNvPr id="7" name="Text 5"/>
+          <p:cNvSpPr/>
+          <p:nvPr/>
+        </p:nvSpPr>
+        <p:spPr>
+          <a:xfrm>
+            <a:off x="3023616" y="1408176"/>
+            <a:ext cx="1228344" cy="329184"/>
+          </a:xfrm>
+          <a:prstGeom prst="rect">
+            <a:avLst/>
+          </a:prstGeom>
+          <a:noFill/>
+          <a:ln/>
+        </p:spPr>
+        <p:txBody>
+          <a:bodyPr wrap="square" lIns="0" tIns="0" rIns="0" bIns="0" rtlCol="0" anchor="ctr"/>
+          <a:lstStyle/>
+          <a:p>
+            <a:pPr algn="ctr" indent="0" marL="0">
+              <a:buNone/>
+            </a:pPr>
+            <a:r>
+              <a:rPr lang="en-US" sz="900" dirty="0">
+                <a:solidFill>
+                  <a:srgbClr val="9AA4AF"/>
+                </a:solidFill>
+                <a:latin typeface="Calibri" pitchFamily="34" charset="0"/>
+                <a:ea typeface="Calibri" pitchFamily="34" charset="-122"/>
+                <a:cs typeface="Calibri" pitchFamily="34" charset="-120"/>
+              </a:rPr>
+              <a:t>SOW Breakdown</a:t>
+            </a:r>
+            <a:endParaRPr lang="en-US" sz="900" dirty="0"/>
+          </a:p>
+        </p:txBody>
+      </p:sp>
+      <p:sp>
+        <p:nvSpPr>
+          <p:cNvPr id="8" name="Text 6"/>
+          <p:cNvSpPr/>
+          <p:nvPr/>
+        </p:nvSpPr>
+        <p:spPr>
+          <a:xfrm>
+            <a:off x="4251960" y="1408176"/>
+            <a:ext cx="1228344" cy="329184"/>
+          </a:xfrm>
+          <a:prstGeom prst="rect">
+            <a:avLst/>
+          </a:prstGeom>
+          <a:noFill/>
+          <a:ln/>
+        </p:spPr>
+        <p:txBody>
+          <a:bodyPr wrap="square" lIns="0" tIns="0" rIns="0" bIns="0" rtlCol="0" anchor="ctr"/>
+          <a:lstStyle/>
+          <a:p>
+            <a:pPr algn="ctr" indent="0" marL="0">
+              <a:buNone/>
+            </a:pPr>
+            <a:r>
+              <a:rPr lang="en-US" sz="900" dirty="0">
+                <a:solidFill>
+                  <a:srgbClr val="9AA4AF"/>
+                </a:solidFill>
+                <a:latin typeface="Calibri" pitchFamily="34" charset="0"/>
+                <a:ea typeface="Calibri" pitchFamily="34" charset="-122"/>
+                <a:cs typeface="Calibri" pitchFamily="34" charset="-120"/>
+              </a:rPr>
+              <a:t>Manpower</a:t>
+            </a:r>
+            <a:endParaRPr lang="en-US" sz="900" dirty="0"/>
+          </a:p>
+        </p:txBody>
+      </p:sp>
+      <p:sp>
+        <p:nvSpPr>
+          <p:cNvPr id="9" name="Shape 7"/>
+          <p:cNvSpPr/>
+          <p:nvPr/>
+        </p:nvSpPr>
+        <p:spPr>
+          <a:xfrm>
+            <a:off x="5507736" y="1408176"/>
+            <a:ext cx="1173480" cy="329184"/>
+          </a:xfrm>
+          <a:prstGeom prst="roundRect">
+            <a:avLst>
+              <a:gd name="adj" fmla="val 13889"/>
+            </a:avLst>
+          </a:prstGeom>
+          <a:solidFill>
+            <a:srgbClr val="F0A429"/>
+          </a:solidFill>
+          <a:ln w="12700">
+            <a:solidFill>
+              <a:srgbClr val="F0A429"/>
+            </a:solidFill>
+            <a:prstDash val="solid"/>
+          </a:ln>
+        </p:spPr>
+        <p:txBody>
+          <a:bodyPr/>
+          <a:p/>
+        </p:txBody>
+      </p:sp>
+      <p:sp>
+        <p:nvSpPr>
+          <p:cNvPr id="10" name="Text 8"/>
+          <p:cNvSpPr/>
+          <p:nvPr/>
+        </p:nvSpPr>
+        <p:spPr>
+          <a:xfrm>
+            <a:off x="5480304" y="1408176"/>
+            <a:ext cx="1228344" cy="329184"/>
+          </a:xfrm>
+          <a:prstGeom prst="rect">
+            <a:avLst/>
+          </a:prstGeom>
+          <a:noFill/>
+          <a:ln/>
+        </p:spPr>
+        <p:txBody>
+          <a:bodyPr wrap="square" lIns="0" tIns="0" rIns="0" bIns="0" rtlCol="0" anchor="ctr"/>
+          <a:lstStyle/>
+          <a:p>
+            <a:pPr algn="ctr" indent="0" marL="0">
+              <a:buNone/>
+            </a:pPr>
+            <a:r>
+              <a:rPr lang="en-US" sz="900" b="1" dirty="0">
+                <a:solidFill>
+                  <a:srgbClr val="000000"/>
+                </a:solidFill>
+                <a:latin typeface="Calibri" pitchFamily="34" charset="0"/>
+                <a:ea typeface="Calibri" pitchFamily="34" charset="-122"/>
+                <a:cs typeface="Calibri" pitchFamily="34" charset="-120"/>
+              </a:rPr>
+              <a:t>Tools</a:t>
+            </a:r>
+            <a:endParaRPr lang="en-US" sz="900" dirty="0"/>
+          </a:p>
+        </p:txBody>
+      </p:sp>
+      <p:sp>
+        <p:nvSpPr>
+          <p:cNvPr id="11" name="Text 9"/>
+          <p:cNvSpPr/>
+          <p:nvPr/>
+        </p:nvSpPr>
+        <p:spPr>
+          <a:xfrm>
+            <a:off x="6708648" y="1408176"/>
+            <a:ext cx="1228344" cy="329184"/>
+          </a:xfrm>
+          <a:prstGeom prst="rect">
+            <a:avLst/>
+          </a:prstGeom>
+          <a:noFill/>
+          <a:ln/>
+        </p:spPr>
+        <p:txBody>
+          <a:bodyPr wrap="square" lIns="0" tIns="0" rIns="0" bIns="0" rtlCol="0" anchor="ctr"/>
+          <a:lstStyle/>
+          <a:p>
+            <a:pPr algn="ctr" indent="0" marL="0">
+              <a:buNone/>
+            </a:pPr>
+            <a:r>
+              <a:rPr lang="en-US" sz="900" dirty="0">
+                <a:solidFill>
+                  <a:srgbClr val="9AA4AF"/>
+                </a:solidFill>
+                <a:latin typeface="Calibri" pitchFamily="34" charset="0"/>
+                <a:ea typeface="Calibri" pitchFamily="34" charset="-122"/>
+                <a:cs typeface="Calibri" pitchFamily="34" charset="-120"/>
+              </a:rPr>
+              <a:t>Materials</a:t>
+            </a:r>
+            <a:endParaRPr lang="en-US" sz="900" dirty="0"/>
+          </a:p>
+        </p:txBody>
+      </p:sp>
+      <p:sp>
+        <p:nvSpPr>
+          <p:cNvPr id="12" name="Text 10"/>
+          <p:cNvSpPr/>
+          <p:nvPr/>
+        </p:nvSpPr>
+        <p:spPr>
+          <a:xfrm>
+            <a:off x="7936992" y="1408176"/>
+            <a:ext cx="1228344" cy="329184"/>
+          </a:xfrm>
+          <a:prstGeom prst="rect">
+            <a:avLst/>
+          </a:prstGeom>
+          <a:noFill/>
+          <a:ln/>
+        </p:spPr>
+        <p:txBody>
+          <a:bodyPr wrap="square" lIns="0" tIns="0" rIns="0" bIns="0" rtlCol="0" anchor="ctr"/>
+          <a:lstStyle/>
+          <a:p>
+            <a:pPr algn="ctr" indent="0" marL="0">
+              <a:buNone/>
+            </a:pPr>
+            <a:r>
+              <a:rPr lang="en-US" sz="900" dirty="0">
+                <a:solidFill>
+                  <a:srgbClr val="9AA4AF"/>
+                </a:solidFill>
+                <a:latin typeface="Calibri" pitchFamily="34" charset="0"/>
+                <a:ea typeface="Calibri" pitchFamily="34" charset="-122"/>
+                <a:cs typeface="Calibri" pitchFamily="34" charset="-120"/>
+              </a:rPr>
+              <a:t>PPE</a:t>
+            </a:r>
+            <a:endParaRPr lang="en-US" sz="900" dirty="0"/>
+          </a:p>
+        </p:txBody>
+      </p:sp>
+      <p:sp>
+        <p:nvSpPr>
+          <p:cNvPr id="13" name="Text 11"/>
+          <p:cNvSpPr/>
+          <p:nvPr/>
+        </p:nvSpPr>
+        <p:spPr>
+          <a:xfrm>
+            <a:off x="9165336" y="1408176"/>
+            <a:ext cx="1228344" cy="329184"/>
+          </a:xfrm>
+          <a:prstGeom prst="rect">
+            <a:avLst/>
+          </a:prstGeom>
+          <a:noFill/>
+          <a:ln/>
+        </p:spPr>
+        <p:txBody>
+          <a:bodyPr wrap="square" lIns="0" tIns="0" rIns="0" bIns="0" rtlCol="0" anchor="ctr"/>
+          <a:lstStyle/>
+          <a:p>
+            <a:pPr algn="ctr" indent="0" marL="0">
+              <a:buNone/>
+            </a:pPr>
+            <a:r>
+              <a:rPr lang="en-US" sz="900" dirty="0">
+                <a:solidFill>
+                  <a:srgbClr val="9AA4AF"/>
+                </a:solidFill>
+                <a:latin typeface="Calibri" pitchFamily="34" charset="0"/>
+                <a:ea typeface="Calibri" pitchFamily="34" charset="-122"/>
+                <a:cs typeface="Calibri" pitchFamily="34" charset="-120"/>
+              </a:rPr>
+              <a:t>Misc.</a:t>
+            </a:r>
+            <a:endParaRPr lang="en-US" sz="900" dirty="0"/>
+          </a:p>
+        </p:txBody>
+      </p:sp>
+      <p:sp>
+        <p:nvSpPr>
+          <p:cNvPr id="14" name="Text 12"/>
+          <p:cNvSpPr/>
+          <p:nvPr/>
+        </p:nvSpPr>
+        <p:spPr>
+          <a:xfrm>
+            <a:off x="10393680" y="1408176"/>
+            <a:ext cx="1228344" cy="329184"/>
+          </a:xfrm>
+          <a:prstGeom prst="rect">
+            <a:avLst/>
+          </a:prstGeom>
+          <a:noFill/>
+          <a:ln/>
+        </p:spPr>
+        <p:txBody>
+          <a:bodyPr wrap="square" lIns="0" tIns="0" rIns="0" bIns="0" rtlCol="0" anchor="ctr"/>
+          <a:lstStyle/>
+          <a:p>
+            <a:pPr algn="ctr" indent="0" marL="0">
+              <a:buNone/>
+            </a:pPr>
+            <a:r>
+              <a:rPr lang="en-US" sz="900" dirty="0">
+                <a:solidFill>
+                  <a:srgbClr val="9AA4AF"/>
+                </a:solidFill>
+                <a:latin typeface="Calibri" pitchFamily="34" charset="0"/>
+                <a:ea typeface="Calibri" pitchFamily="34" charset="-122"/>
+                <a:cs typeface="Calibri" pitchFamily="34" charset="-120"/>
+              </a:rPr>
+              <a:t>Summary</a:t>
+            </a:r>
+            <a:endParaRPr lang="en-US" sz="900" dirty="0"/>
+          </a:p>
+        </p:txBody>
+      </p:sp>
+      <p:sp>
+        <p:nvSpPr>
+          <p:cNvPr id="15" name="Shape 13"/>
+          <p:cNvSpPr/>
+          <p:nvPr/>
+        </p:nvSpPr>
+        <p:spPr>
+          <a:xfrm>
+            <a:off x="566928" y="2002536"/>
+            <a:ext cx="3566160" cy="1463040"/>
+          </a:xfrm>
+          <a:prstGeom prst="roundRect">
+            <a:avLst>
+              <a:gd name="adj" fmla="val 5000"/>
+            </a:avLst>
+          </a:prstGeom>
+          <a:solidFill>
+            <a:srgbClr val="1C2128"/>
+          </a:solidFill>
+          <a:ln w="12700">
+            <a:solidFill>
+              <a:srgbClr val="30363D"/>
+            </a:solidFill>
+            <a:prstDash val="solid"/>
+          </a:ln>
+          <a:effectLst>
+            <a:outerShdw sx="100000" sy="100000" kx="0" ky="0" algn="bl" rotWithShape="0" blurRad="152400" dist="38100" dir="5400000">
+              <a:srgbClr val="000000">
+                <a:alpha val="45000"/>
+              </a:srgbClr>
+            </a:outerShdw>
+          </a:effectLst>
+        </p:spPr>
+        <p:txBody>
+          <a:bodyPr/>
+          <a:p/>
+        </p:txBody>
+      </p:sp>
+      <p:sp>
+        <p:nvSpPr>
+          <p:cNvPr id="16" name="Text 14"/>
+          <p:cNvSpPr/>
+          <p:nvPr/>
+        </p:nvSpPr>
+        <p:spPr>
+          <a:xfrm>
+            <a:off x="804672" y="2185416"/>
+            <a:ext cx="3108960" cy="310896"/>
+          </a:xfrm>
+          <a:prstGeom prst="rect">
+            <a:avLst/>
+          </a:prstGeom>
+          <a:noFill/>
+          <a:ln/>
+        </p:spPr>
+        <p:txBody>
+          <a:bodyPr wrap="square" lIns="0" tIns="0" rIns="0" bIns="0" rtlCol="0" anchor="ctr"/>
+          <a:lstStyle/>
+          <a:p>
+            <a:pPr indent="0" marL="0">
+              <a:buNone/>
+            </a:pPr>
+            <a:r>
+              <a:rPr lang="en-US" sz="1450" b="1" dirty="0">
+                <a:solidFill>
+                  <a:srgbClr val="F0A429"/>
+                </a:solidFill>
+                <a:latin typeface="Arial" pitchFamily="34" charset="0"/>
+                <a:ea typeface="Arial" pitchFamily="34" charset="-122"/>
+                <a:cs typeface="Arial" pitchFamily="34" charset="-120"/>
+              </a:rPr>
+              <a:t>Pick it on Project Info</a:t>
+            </a:r>
+            <a:endParaRPr lang="en-US" sz="1450" dirty="0"/>
+          </a:p>
+        </p:txBody>
+      </p:sp>
+      <p:sp>
+        <p:nvSpPr>
+          <p:cNvPr id="17" name="Text 15"/>
+          <p:cNvSpPr/>
+          <p:nvPr/>
+        </p:nvSpPr>
+        <p:spPr>
+          <a:xfrm>
+            <a:off x="804672" y="2542032"/>
+            <a:ext cx="3108960" cy="822960"/>
+          </a:xfrm>
+          <a:prstGeom prst="rect">
+            <a:avLst/>
+          </a:prstGeom>
+          <a:noFill/>
+          <a:ln/>
+        </p:spPr>
+        <p:txBody>
+          <a:bodyPr wrap="square" lIns="0" tIns="0" rIns="0" bIns="0" rtlCol="0" anchor="ctr"/>
+          <a:lstStyle/>
+          <a:p>
+            <a:pPr indent="0" marL="0">
+              <a:lnSpc>
+                <a:spcPts val="1500"/>
+              </a:lnSpc>
+              <a:buNone/>
+            </a:pPr>
+            <a:r>
+              <a:rPr lang="en-US" sz="1150" dirty="0">
+                <a:solidFill>
+                  <a:srgbClr val="9AA4AF"/>
+                </a:solidFill>
+                <a:latin typeface="Calibri" pitchFamily="34" charset="0"/>
+                <a:ea typeface="Calibri" pitchFamily="34" charset="-122"/>
+                <a:cs typeface="Calibri" pitchFamily="34" charset="-120"/>
+              </a:rPr>
+              <a:t>For a component pulled, repaired in our shop and reinstalled. It keeps mobilization and the Onsite Miscellaneous categories.</a:t>
+            </a:r>
+            <a:endParaRPr lang="en-US" sz="1150" dirty="0"/>
+          </a:p>
+        </p:txBody>
+      </p:sp>
+      <p:sp>
+        <p:nvSpPr>
+          <p:cNvPr id="18" name="Shape 16"/>
+          <p:cNvSpPr/>
+          <p:nvPr/>
+        </p:nvSpPr>
+        <p:spPr>
+          <a:xfrm>
+            <a:off x="4352544" y="2002536"/>
+            <a:ext cx="3566160" cy="1463040"/>
+          </a:xfrm>
+          <a:prstGeom prst="roundRect">
+            <a:avLst>
+              <a:gd name="adj" fmla="val 5000"/>
+            </a:avLst>
+          </a:prstGeom>
+          <a:solidFill>
+            <a:srgbClr val="1C2128"/>
+          </a:solidFill>
+          <a:ln w="12700">
+            <a:solidFill>
+              <a:srgbClr val="30363D"/>
+            </a:solidFill>
+            <a:prstDash val="solid"/>
+          </a:ln>
+          <a:effectLst>
+            <a:outerShdw sx="100000" sy="100000" kx="0" ky="0" algn="bl" rotWithShape="0" blurRad="152400" dist="38100" dir="5400000">
+              <a:srgbClr val="000000">
+                <a:alpha val="45000"/>
+              </a:srgbClr>
+            </a:outerShdw>
+          </a:effectLst>
+        </p:spPr>
+        <p:txBody>
+          <a:bodyPr/>
+          <a:p/>
+        </p:txBody>
+      </p:sp>
+      <p:sp>
+        <p:nvSpPr>
+          <p:cNvPr id="19" name="Text 17"/>
+          <p:cNvSpPr/>
+          <p:nvPr/>
+        </p:nvSpPr>
+        <p:spPr>
+          <a:xfrm>
+            <a:off x="4590288" y="2185416"/>
+            <a:ext cx="3108960" cy="310896"/>
+          </a:xfrm>
+          <a:prstGeom prst="rect">
+            <a:avLst/>
+          </a:prstGeom>
+          <a:noFill/>
+          <a:ln/>
+        </p:spPr>
+        <p:txBody>
+          <a:bodyPr wrap="square" lIns="0" tIns="0" rIns="0" bIns="0" rtlCol="0" anchor="ctr"/>
+          <a:lstStyle/>
+          <a:p>
+            <a:pPr indent="0" marL="0">
+              <a:buNone/>
+            </a:pPr>
+            <a:r>
+              <a:rPr lang="en-US" sz="1450" b="1" dirty="0">
+                <a:solidFill>
+                  <a:srgbClr val="58A6FF"/>
+                </a:solidFill>
+                <a:latin typeface="Arial" pitchFamily="34" charset="0"/>
+                <a:ea typeface="Arial" pitchFamily="34" charset="-122"/>
+                <a:cs typeface="Arial" pitchFamily="34" charset="-120"/>
+              </a:rPr>
+              <a:t>Tag each scope task</a:t>
+            </a:r>
+            <a:endParaRPr lang="en-US" sz="1450" dirty="0"/>
+          </a:p>
+        </p:txBody>
+      </p:sp>
+      <p:sp>
+        <p:nvSpPr>
+          <p:cNvPr id="20" name="Text 18"/>
+          <p:cNvSpPr/>
+          <p:nvPr/>
+        </p:nvSpPr>
+        <p:spPr>
+          <a:xfrm>
+            <a:off x="4590288" y="2542032"/>
+            <a:ext cx="3108960" cy="822960"/>
+          </a:xfrm>
+          <a:prstGeom prst="rect">
+            <a:avLst/>
+          </a:prstGeom>
+          <a:noFill/>
+          <a:ln/>
+        </p:spPr>
+        <p:txBody>
+          <a:bodyPr wrap="square" lIns="0" tIns="0" rIns="0" bIns="0" rtlCol="0" anchor="ctr"/>
+          <a:lstStyle/>
+          <a:p>
+            <a:pPr indent="0" marL="0">
+              <a:lnSpc>
+                <a:spcPts val="1500"/>
+              </a:lnSpc>
+              <a:buNone/>
+            </a:pPr>
+            <a:r>
+              <a:rPr lang="en-US" sz="1150" dirty="0">
+                <a:solidFill>
+                  <a:srgbClr val="9AA4AF"/>
+                </a:solidFill>
+                <a:latin typeface="Calibri" pitchFamily="34" charset="0"/>
+                <a:ea typeface="Calibri" pitchFamily="34" charset="-122"/>
+                <a:cs typeface="Calibri" pitchFamily="34" charset="-120"/>
+              </a:rPr>
+              <a:t>In SOW Breakdown every main task has a 🏗 Site / 🏭 Shop button. Sub-tasks follow their main task. Untagged counts as Site.</a:t>
+            </a:r>
+            <a:endParaRPr lang="en-US" sz="1150" dirty="0"/>
+          </a:p>
+        </p:txBody>
+      </p:sp>
+      <p:sp>
+        <p:nvSpPr>
+          <p:cNvPr id="21" name="Shape 19"/>
+          <p:cNvSpPr/>
+          <p:nvPr/>
+        </p:nvSpPr>
+        <p:spPr>
+          <a:xfrm>
+            <a:off x="8138160" y="2002536"/>
+            <a:ext cx="3566160" cy="1463040"/>
+          </a:xfrm>
+          <a:prstGeom prst="roundRect">
+            <a:avLst>
+              <a:gd name="adj" fmla="val 5000"/>
+            </a:avLst>
+          </a:prstGeom>
+          <a:solidFill>
+            <a:srgbClr val="1C2128"/>
+          </a:solidFill>
+          <a:ln w="12700">
+            <a:solidFill>
+              <a:srgbClr val="30363D"/>
+            </a:solidFill>
+            <a:prstDash val="solid"/>
+          </a:ln>
+          <a:effectLst>
+            <a:outerShdw sx="100000" sy="100000" kx="0" ky="0" algn="bl" rotWithShape="0" blurRad="152400" dist="38100" dir="5400000">
+              <a:srgbClr val="000000">
+                <a:alpha val="45000"/>
+              </a:srgbClr>
+            </a:outerShdw>
+          </a:effectLst>
+        </p:spPr>
+        <p:txBody>
+          <a:bodyPr/>
+          <a:p/>
+        </p:txBody>
+      </p:sp>
+      <p:sp>
+        <p:nvSpPr>
+          <p:cNvPr id="22" name="Text 20"/>
+          <p:cNvSpPr/>
+          <p:nvPr/>
+        </p:nvSpPr>
+        <p:spPr>
+          <a:xfrm>
+            <a:off x="8375904" y="2185416"/>
+            <a:ext cx="3108960" cy="310896"/>
+          </a:xfrm>
+          <a:prstGeom prst="rect">
+            <a:avLst/>
+          </a:prstGeom>
+          <a:noFill/>
+          <a:ln/>
+        </p:spPr>
+        <p:txBody>
+          <a:bodyPr wrap="square" lIns="0" tIns="0" rIns="0" bIns="0" rtlCol="0" anchor="ctr"/>
+          <a:lstStyle/>
+          <a:p>
+            <a:pPr indent="0" marL="0">
+              <a:buNone/>
+            </a:pPr>
+            <a:r>
+              <a:rPr lang="en-US" sz="1450" b="1" dirty="0">
+                <a:solidFill>
+                  <a:srgbClr val="3FB950"/>
+                </a:solidFill>
+                <a:latin typeface="Arial" pitchFamily="34" charset="0"/>
+                <a:ea typeface="Arial" pitchFamily="34" charset="-122"/>
+                <a:cs typeface="Arial" pitchFamily="34" charset="-120"/>
+              </a:rPr>
+              <a:t>File the crew and tools</a:t>
+            </a:r>
+            <a:endParaRPr lang="en-US" sz="1450" dirty="0"/>
+          </a:p>
+        </p:txBody>
+      </p:sp>
+      <p:sp>
+        <p:nvSpPr>
+          <p:cNvPr id="23" name="Text 21"/>
+          <p:cNvSpPr/>
+          <p:nvPr/>
+        </p:nvSpPr>
+        <p:spPr>
+          <a:xfrm>
+            <a:off x="8375904" y="2542032"/>
+            <a:ext cx="3108960" cy="822960"/>
+          </a:xfrm>
+          <a:prstGeom prst="rect">
+            <a:avLst/>
+          </a:prstGeom>
+          <a:noFill/>
+          <a:ln/>
+        </p:spPr>
+        <p:txBody>
+          <a:bodyPr wrap="square" lIns="0" tIns="0" rIns="0" bIns="0" rtlCol="0" anchor="ctr"/>
+          <a:lstStyle/>
+          <a:p>
+            <a:pPr indent="0" marL="0">
+              <a:lnSpc>
+                <a:spcPts val="1500"/>
+              </a:lnSpc>
+              <a:buNone/>
+            </a:pPr>
+            <a:r>
+              <a:rPr lang="en-US" sz="1150" dirty="0">
+                <a:solidFill>
+                  <a:srgbClr val="9AA4AF"/>
+                </a:solidFill>
+                <a:latin typeface="Calibri" pitchFamily="34" charset="0"/>
+                <a:ea typeface="Calibri" pitchFamily="34" charset="-122"/>
+                <a:cs typeface="Calibri" pitchFamily="34" charset="-120"/>
+              </a:rPr>
+              <a:t>Assign manpower and tools to their tasks. That link is how the app knows which days are site days and which tools run on shop power.</a:t>
+            </a:r>
+            <a:endParaRPr lang="en-US" sz="1150" dirty="0"/>
+          </a:p>
+        </p:txBody>
+      </p:sp>
+      <p:sp>
+        <p:nvSpPr>
+          <p:cNvPr id="24" name="Shape 22"/>
+          <p:cNvSpPr/>
+          <p:nvPr/>
+        </p:nvSpPr>
+        <p:spPr>
+          <a:xfrm>
+            <a:off x="566928" y="3648456"/>
+            <a:ext cx="5532120" cy="1042416"/>
+          </a:xfrm>
+          <a:prstGeom prst="roundRect">
+            <a:avLst>
+              <a:gd name="adj" fmla="val 7018"/>
+            </a:avLst>
+          </a:prstGeom>
+          <a:solidFill>
+            <a:srgbClr val="161B22"/>
+          </a:solidFill>
+          <a:ln w="12700">
+            <a:solidFill>
+              <a:srgbClr val="30363D"/>
+            </a:solidFill>
+            <a:prstDash val="solid"/>
+          </a:ln>
+          <a:effectLst>
+            <a:outerShdw sx="100000" sy="100000" kx="0" ky="0" algn="bl" rotWithShape="0" blurRad="152400" dist="38100" dir="5400000">
+              <a:srgbClr val="000000">
+                <a:alpha val="45000"/>
+              </a:srgbClr>
+            </a:outerShdw>
+          </a:effectLst>
+        </p:spPr>
+        <p:txBody>
+          <a:bodyPr/>
+          <a:p/>
+        </p:txBody>
+      </p:sp>
+      <p:sp>
+        <p:nvSpPr>
+          <p:cNvPr id="25" name="Text 23"/>
+          <p:cNvSpPr/>
+          <p:nvPr/>
+        </p:nvSpPr>
+        <p:spPr>
+          <a:xfrm>
+            <a:off x="804672" y="3767328"/>
+            <a:ext cx="5029200" cy="274320"/>
+          </a:xfrm>
+          <a:prstGeom prst="rect">
+            <a:avLst/>
+          </a:prstGeom>
+          <a:noFill/>
+          <a:ln/>
+        </p:spPr>
+        <p:txBody>
+          <a:bodyPr wrap="square" lIns="0" tIns="0" rIns="0" bIns="0" rtlCol="0" anchor="ctr"/>
+          <a:lstStyle/>
+          <a:p>
+            <a:pPr indent="0" marL="0">
+              <a:buNone/>
+            </a:pPr>
+            <a:r>
+              <a:rPr lang="en-US" sz="1350" b="1" dirty="0">
+                <a:solidFill>
+                  <a:srgbClr val="E6EDF3"/>
+                </a:solidFill>
+                <a:latin typeface="Arial" pitchFamily="34" charset="0"/>
+                <a:ea typeface="Arial" pitchFamily="34" charset="-122"/>
+                <a:cs typeface="Arial" pitchFamily="34" charset="-120"/>
+              </a:rPr>
+              <a:t>Incentive: site days only</a:t>
+            </a:r>
+            <a:endParaRPr lang="en-US" sz="1350" dirty="0"/>
+          </a:p>
+        </p:txBody>
+      </p:sp>
+      <p:sp>
+        <p:nvSpPr>
+          <p:cNvPr id="26" name="Text 24"/>
+          <p:cNvSpPr/>
+          <p:nvPr/>
+        </p:nvSpPr>
+        <p:spPr>
+          <a:xfrm>
+            <a:off x="804672" y="4069080"/>
+            <a:ext cx="5074920" cy="566928"/>
+          </a:xfrm>
+          <a:prstGeom prst="rect">
+            <a:avLst/>
+          </a:prstGeom>
+          <a:noFill/>
+          <a:ln/>
+        </p:spPr>
+        <p:txBody>
+          <a:bodyPr wrap="square" lIns="0" tIns="0" rIns="0" bIns="0" rtlCol="0" anchor="ctr"/>
+          <a:lstStyle/>
+          <a:p>
+            <a:pPr indent="0" marL="0">
+              <a:lnSpc>
+                <a:spcPts val="1400"/>
+              </a:lnSpc>
+              <a:buNone/>
+            </a:pPr>
+            <a:r>
+              <a:rPr lang="en-US" sz="1100" dirty="0">
+                <a:solidFill>
+                  <a:srgbClr val="9AA4AF"/>
+                </a:solidFill>
+                <a:latin typeface="Calibri" pitchFamily="34" charset="0"/>
+                <a:ea typeface="Calibri" pitchFamily="34" charset="-122"/>
+                <a:cs typeface="Calibri" pitchFamily="34" charset="-120"/>
+              </a:rPr>
+              <a:t>A crew row on a Site task earns the Incentive; on a Shop task it earns none. A row shared by both is split by its share.</a:t>
+            </a:r>
+            <a:endParaRPr lang="en-US" sz="1100" dirty="0"/>
+          </a:p>
+        </p:txBody>
+      </p:sp>
+      <p:sp>
+        <p:nvSpPr>
+          <p:cNvPr id="27" name="Shape 25"/>
+          <p:cNvSpPr/>
+          <p:nvPr/>
+        </p:nvSpPr>
+        <p:spPr>
+          <a:xfrm>
+            <a:off x="6309360" y="3648456"/>
+            <a:ext cx="5532120" cy="1042416"/>
+          </a:xfrm>
+          <a:prstGeom prst="roundRect">
+            <a:avLst>
+              <a:gd name="adj" fmla="val 7018"/>
+            </a:avLst>
+          </a:prstGeom>
+          <a:solidFill>
+            <a:srgbClr val="161B22"/>
+          </a:solidFill>
+          <a:ln w="12700">
+            <a:solidFill>
+              <a:srgbClr val="30363D"/>
+            </a:solidFill>
+            <a:prstDash val="solid"/>
+          </a:ln>
+          <a:effectLst>
+            <a:outerShdw sx="100000" sy="100000" kx="0" ky="0" algn="bl" rotWithShape="0" blurRad="152400" dist="38100" dir="5400000">
+              <a:srgbClr val="000000">
+                <a:alpha val="45000"/>
+              </a:srgbClr>
+            </a:outerShdw>
+          </a:effectLst>
+        </p:spPr>
+        <p:txBody>
+          <a:bodyPr/>
+          <a:p/>
+        </p:txBody>
+      </p:sp>
+      <p:sp>
+        <p:nvSpPr>
+          <p:cNvPr id="28" name="Text 26"/>
+          <p:cNvSpPr/>
+          <p:nvPr/>
+        </p:nvSpPr>
+        <p:spPr>
+          <a:xfrm>
+            <a:off x="6547104" y="3767328"/>
+            <a:ext cx="5029200" cy="274320"/>
+          </a:xfrm>
+          <a:prstGeom prst="rect">
+            <a:avLst/>
+          </a:prstGeom>
+          <a:noFill/>
+          <a:ln/>
+        </p:spPr>
+        <p:txBody>
+          <a:bodyPr wrap="square" lIns="0" tIns="0" rIns="0" bIns="0" rtlCol="0" anchor="ctr"/>
+          <a:lstStyle/>
+          <a:p>
+            <a:pPr indent="0" marL="0">
+              <a:buNone/>
+            </a:pPr>
+            <a:r>
+              <a:rPr lang="en-US" sz="1350" b="1" dirty="0">
+                <a:solidFill>
+                  <a:srgbClr val="E6EDF3"/>
+                </a:solidFill>
+                <a:latin typeface="Arial" pitchFamily="34" charset="0"/>
+                <a:ea typeface="Arial" pitchFamily="34" charset="-122"/>
+                <a:cs typeface="Arial" pitchFamily="34" charset="-120"/>
+              </a:rPr>
+              <a:t>Power: shop tasks only</a:t>
+            </a:r>
+            <a:endParaRPr lang="en-US" sz="1350" dirty="0"/>
+          </a:p>
+        </p:txBody>
+      </p:sp>
+      <p:sp>
+        <p:nvSpPr>
+          <p:cNvPr id="29" name="Text 27"/>
+          <p:cNvSpPr/>
+          <p:nvPr/>
+        </p:nvSpPr>
+        <p:spPr>
+          <a:xfrm>
+            <a:off x="6547104" y="4069080"/>
+            <a:ext cx="5074920" cy="566928"/>
+          </a:xfrm>
+          <a:prstGeom prst="rect">
+            <a:avLst/>
+          </a:prstGeom>
+          <a:noFill/>
+          <a:ln/>
+        </p:spPr>
+        <p:txBody>
+          <a:bodyPr wrap="square" lIns="0" tIns="0" rIns="0" bIns="0" rtlCol="0" anchor="ctr"/>
+          <a:lstStyle/>
+          <a:p>
+            <a:pPr indent="0" marL="0">
+              <a:lnSpc>
+                <a:spcPts val="1400"/>
+              </a:lnSpc>
+              <a:buNone/>
+            </a:pPr>
+            <a:r>
+              <a:rPr lang="en-US" sz="1100" dirty="0">
+                <a:solidFill>
+                  <a:srgbClr val="9AA4AF"/>
+                </a:solidFill>
+                <a:latin typeface="Calibri" pitchFamily="34" charset="0"/>
+                <a:ea typeface="Calibri" pitchFamily="34" charset="-122"/>
+                <a:cs typeface="Calibri" pitchFamily="34" charset="-120"/>
+              </a:rPr>
+              <a:t>A tool’s electricity is charged only for its Shop share. On site the client supplies the power, as on an Onsite CE.</a:t>
+            </a:r>
+            <a:endParaRPr lang="en-US" sz="1100" dirty="0"/>
+          </a:p>
+        </p:txBody>
+      </p:sp>
+      <p:sp>
+        <p:nvSpPr>
+          <p:cNvPr id="30" name="Shape 28"/>
+          <p:cNvSpPr/>
+          <p:nvPr/>
+        </p:nvSpPr>
+        <p:spPr>
+          <a:xfrm>
+            <a:off x="566928" y="4818888"/>
+            <a:ext cx="5532120" cy="1042416"/>
+          </a:xfrm>
+          <a:prstGeom prst="roundRect">
+            <a:avLst>
+              <a:gd name="adj" fmla="val 7018"/>
+            </a:avLst>
+          </a:prstGeom>
+          <a:solidFill>
+            <a:srgbClr val="161B22"/>
+          </a:solidFill>
+          <a:ln w="12700">
+            <a:solidFill>
+              <a:srgbClr val="30363D"/>
+            </a:solidFill>
+            <a:prstDash val="solid"/>
+          </a:ln>
+          <a:effectLst>
+            <a:outerShdw sx="100000" sy="100000" kx="0" ky="0" algn="bl" rotWithShape="0" blurRad="152400" dist="38100" dir="5400000">
+              <a:srgbClr val="000000">
+                <a:alpha val="45000"/>
+              </a:srgbClr>
+            </a:outerShdw>
+          </a:effectLst>
+        </p:spPr>
+        <p:txBody>
+          <a:bodyPr/>
+          <a:p/>
+        </p:txBody>
+      </p:sp>
+      <p:sp>
+        <p:nvSpPr>
+          <p:cNvPr id="31" name="Text 29"/>
+          <p:cNvSpPr/>
+          <p:nvPr/>
+        </p:nvSpPr>
+        <p:spPr>
+          <a:xfrm>
+            <a:off x="804672" y="4937760"/>
+            <a:ext cx="5029200" cy="274320"/>
+          </a:xfrm>
+          <a:prstGeom prst="rect">
+            <a:avLst/>
+          </a:prstGeom>
+          <a:noFill/>
+          <a:ln/>
+        </p:spPr>
+        <p:txBody>
+          <a:bodyPr wrap="square" lIns="0" tIns="0" rIns="0" bIns="0" rtlCol="0" anchor="ctr"/>
+          <a:lstStyle/>
+          <a:p>
+            <a:pPr indent="0" marL="0">
+              <a:buNone/>
+            </a:pPr>
+            <a:r>
+              <a:rPr lang="en-US" sz="1350" b="1" dirty="0">
+                <a:solidFill>
+                  <a:srgbClr val="E6EDF3"/>
+                </a:solidFill>
+                <a:latin typeface="Arial" pitchFamily="34" charset="0"/>
+                <a:ea typeface="Arial" pitchFamily="34" charset="-122"/>
+                <a:cs typeface="Arial" pitchFamily="34" charset="-120"/>
+              </a:rPr>
+              <a:t>Unassigned rows count as Site</a:t>
+            </a:r>
+            <a:endParaRPr lang="en-US" sz="1350" dirty="0"/>
+          </a:p>
+        </p:txBody>
+      </p:sp>
+      <p:sp>
+        <p:nvSpPr>
+          <p:cNvPr id="32" name="Text 30"/>
+          <p:cNvSpPr/>
+          <p:nvPr/>
+        </p:nvSpPr>
+        <p:spPr>
+          <a:xfrm>
+            <a:off x="804672" y="5239512"/>
+            <a:ext cx="5074920" cy="566928"/>
+          </a:xfrm>
+          <a:prstGeom prst="rect">
+            <a:avLst/>
+          </a:prstGeom>
+          <a:noFill/>
+          <a:ln/>
+        </p:spPr>
+        <p:txBody>
+          <a:bodyPr wrap="square" lIns="0" tIns="0" rIns="0" bIns="0" rtlCol="0" anchor="ctr"/>
+          <a:lstStyle/>
+          <a:p>
+            <a:pPr indent="0" marL="0">
+              <a:lnSpc>
+                <a:spcPts val="1400"/>
+              </a:lnSpc>
+              <a:buNone/>
+            </a:pPr>
+            <a:r>
+              <a:rPr lang="en-US" sz="1100" dirty="0">
+                <a:solidFill>
+                  <a:srgbClr val="9AA4AF"/>
+                </a:solidFill>
+                <a:latin typeface="Calibri" pitchFamily="34" charset="0"/>
+                <a:ea typeface="Calibri" pitchFamily="34" charset="-122"/>
+                <a:cs typeface="Calibri" pitchFamily="34" charset="-120"/>
+              </a:rPr>
+              <a:t>A row filed to no task earns the Incentive and draws no power. File every row before you generate.</a:t>
+            </a:r>
+            <a:endParaRPr lang="en-US" sz="1100" dirty="0"/>
+          </a:p>
+        </p:txBody>
+      </p:sp>
+      <p:sp>
+        <p:nvSpPr>
+          <p:cNvPr id="33" name="Shape 31"/>
+          <p:cNvSpPr/>
+          <p:nvPr/>
+        </p:nvSpPr>
+        <p:spPr>
+          <a:xfrm>
+            <a:off x="6309360" y="4818888"/>
+            <a:ext cx="5532120" cy="1042416"/>
+          </a:xfrm>
+          <a:prstGeom prst="roundRect">
+            <a:avLst>
+              <a:gd name="adj" fmla="val 7018"/>
+            </a:avLst>
+          </a:prstGeom>
+          <a:solidFill>
+            <a:srgbClr val="161B22"/>
+          </a:solidFill>
+          <a:ln w="12700">
+            <a:solidFill>
+              <a:srgbClr val="30363D"/>
+            </a:solidFill>
+            <a:prstDash val="solid"/>
+          </a:ln>
+          <a:effectLst>
+            <a:outerShdw sx="100000" sy="100000" kx="0" ky="0" algn="bl" rotWithShape="0" blurRad="152400" dist="38100" dir="5400000">
+              <a:srgbClr val="000000">
+                <a:alpha val="45000"/>
+              </a:srgbClr>
+            </a:outerShdw>
+          </a:effectLst>
+        </p:spPr>
+        <p:txBody>
+          <a:bodyPr/>
+          <a:p/>
+        </p:txBody>
+      </p:sp>
+      <p:sp>
+        <p:nvSpPr>
+          <p:cNvPr id="34" name="Text 32"/>
+          <p:cNvSpPr/>
+          <p:nvPr/>
+        </p:nvSpPr>
+        <p:spPr>
+          <a:xfrm>
+            <a:off x="6547104" y="4937760"/>
+            <a:ext cx="5029200" cy="274320"/>
+          </a:xfrm>
+          <a:prstGeom prst="rect">
+            <a:avLst/>
+          </a:prstGeom>
+          <a:noFill/>
+          <a:ln/>
+        </p:spPr>
+        <p:txBody>
+          <a:bodyPr wrap="square" lIns="0" tIns="0" rIns="0" bIns="0" rtlCol="0" anchor="ctr"/>
+          <a:lstStyle/>
+          <a:p>
+            <a:pPr indent="0" marL="0">
+              <a:buNone/>
+            </a:pPr>
+            <a:r>
+              <a:rPr lang="en-US" sz="1350" b="1" dirty="0">
+                <a:solidFill>
+                  <a:srgbClr val="E6EDF3"/>
+                </a:solidFill>
+                <a:latin typeface="Arial" pitchFamily="34" charset="0"/>
+                <a:ea typeface="Arial" pitchFamily="34" charset="-122"/>
+                <a:cs typeface="Arial" pitchFamily="34" charset="-120"/>
+              </a:rPr>
+              <a:t>On the printed CE</a:t>
+            </a:r>
+            <a:endParaRPr lang="en-US" sz="1350" dirty="0"/>
+          </a:p>
+        </p:txBody>
+      </p:sp>
+      <p:sp>
+        <p:nvSpPr>
+          <p:cNvPr id="35" name="Text 33"/>
+          <p:cNvSpPr/>
+          <p:nvPr/>
+        </p:nvSpPr>
+        <p:spPr>
+          <a:xfrm>
+            <a:off x="6547104" y="5239512"/>
+            <a:ext cx="5074920" cy="566928"/>
+          </a:xfrm>
+          <a:prstGeom prst="rect">
+            <a:avLst/>
+          </a:prstGeom>
+          <a:noFill/>
+          <a:ln/>
+        </p:spPr>
+        <p:txBody>
+          <a:bodyPr wrap="square" lIns="0" tIns="0" rIns="0" bIns="0" rtlCol="0" anchor="ctr"/>
+          <a:lstStyle/>
+          <a:p>
+            <a:pPr indent="0" marL="0">
+              <a:lnSpc>
+                <a:spcPts val="1400"/>
+              </a:lnSpc>
+              <a:buNone/>
+            </a:pPr>
+            <a:r>
+              <a:rPr lang="en-US" sz="1100" dirty="0">
+                <a:solidFill>
+                  <a:srgbClr val="9AA4AF"/>
+                </a:solidFill>
+                <a:latin typeface="Calibri" pitchFamily="34" charset="0"/>
+                <a:ea typeface="Calibri" pitchFamily="34" charset="-122"/>
+                <a:cs typeface="Calibri" pitchFamily="34" charset="-120"/>
+              </a:rPr>
+              <a:t>CE TYPE prints as SHOP + SITE. The totals already apply both rules; there is no separate shop and site section.</a:t>
+            </a:r>
+            <a:endParaRPr lang="en-US" sz="1100" dirty="0"/>
+          </a:p>
+        </p:txBody>
+      </p:sp>
+      <p:sp>
+        <p:nvSpPr>
+          <p:cNvPr id="36" name="Text 34"/>
+          <p:cNvSpPr/>
+          <p:nvPr/>
+        </p:nvSpPr>
+        <p:spPr>
+          <a:xfrm>
+            <a:off x="566928" y="6437376"/>
+            <a:ext cx="5486400" cy="237744"/>
+          </a:xfrm>
+          <a:prstGeom prst="rect">
+            <a:avLst/>
+          </a:prstGeom>
+          <a:noFill/>
+          <a:ln/>
+        </p:spPr>
+        <p:txBody>
+          <a:bodyPr wrap="square" lIns="0" tIns="0" rIns="0" bIns="0" rtlCol="0" anchor="ctr"/>
+          <a:lstStyle/>
+          <a:p>
+            <a:pPr indent="0" marL="0">
+              <a:buNone/>
+            </a:pPr>
+            <a:r>
+              <a:rPr lang="en-US" sz="900" dirty="0">
+                <a:solidFill>
+                  <a:srgbClr val="6E7681"/>
+                </a:solidFill>
+                <a:latin typeface="Calibri" pitchFamily="34" charset="0"/>
+                <a:ea typeface="Calibri" pitchFamily="34" charset="-122"/>
+                <a:cs typeface="Calibri" pitchFamily="34" charset="-120"/>
+              </a:rPr>
+              <a:t>SHIC Cost Estimator — End-User Manual</a:t>
+            </a:r>
+            <a:endParaRPr lang="en-US" sz="900" dirty="0"/>
+          </a:p>
+        </p:txBody>
+      </p:sp>
+      <p:sp>
+        <p:nvSpPr>
+          <p:cNvPr id="37" name="Text 35"/>
+          <p:cNvSpPr/>
+          <p:nvPr/>
+        </p:nvSpPr>
+        <p:spPr>
+          <a:xfrm>
+            <a:off x="10981944" y="6437376"/>
+            <a:ext cx="640080" cy="237744"/>
+          </a:xfrm>
+          <a:prstGeom prst="rect">
+            <a:avLst/>
+          </a:prstGeom>
+          <a:noFill/>
+          <a:ln/>
+        </p:spPr>
+        <p:txBody>
+          <a:bodyPr wrap="square" lIns="0" tIns="0" rIns="0" bIns="0" rtlCol="0" anchor="ctr"/>
+          <a:lstStyle/>
+          <a:p>
+            <a:pPr algn="r" indent="0" marL="0">
+              <a:buNone/>
+            </a:pPr>
+            <a:r>
+              <a:rPr lang="en-US" sz="900" dirty="0">
+                <a:solidFill>
+                  <a:srgbClr val="6E7681"/>
+                </a:solidFill>
+                <a:latin typeface="Calibri" pitchFamily="34" charset="0"/>
+                <a:ea typeface="Calibri" pitchFamily="34" charset="-122"/>
+                <a:cs typeface="Calibri" pitchFamily="34" charset="-120"/>
+              </a:rPr>
+              <a:t>18</a:t>
+            </a:r>
+            <a:endParaRPr lang="en-US" sz="900" dirty="0"/>
+          </a:p>
+        </p:txBody>
+      </p:sp>
+    </p:spTree>
+  </p:cSld>
+  <p:clrMapOvr>
+    <a:masterClrMapping/>
+  </p:clrMapOvr>
+</p:sld>
+</file>
+
+<file path=ppt/slides/slide34.xml><?xml version="1.0" encoding="utf-8"?>
+<p:sld xmlns:a="http://schemas.openxmlformats.org/drawingml/2006/main" xmlns:r="http://schemas.openxmlformats.org/officeDocument/2006/relationships" xmlns:p="http://schemas.openxmlformats.org/presentationml/2006/main">
+  <p:cSld name="Slide 11">
+    <p:bg>
+      <p:bgPr>
+        <a:solidFill>
+          <a:srgbClr val="161B22"/>
+        </a:solidFill>
+      </p:bgPr>
+    </p:bg>
+    <p:spTree>
+      <p:nvGrpSpPr>
+        <p:cNvPr id="1" name=""/>
+        <p:cNvGrpSpPr/>
+        <p:nvPr/>
+      </p:nvGrpSpPr>
+      <p:grpSpPr>
+        <a:xfrm>
+          <a:off x="0" y="0"/>
+          <a:ext cx="0" cy="0"/>
+          <a:chOff x="0" y="0"/>
+          <a:chExt cx="0" cy="0"/>
+        </a:xfrm>
+      </p:grpSpPr>
+      <p:sp>
+        <p:nvSpPr>
+          <p:cNvPr id="2" name="Text 0"/>
+          <p:cNvSpPr/>
+          <p:nvPr/>
+        </p:nvSpPr>
+        <p:spPr>
+          <a:xfrm>
+            <a:off x="566928" y="384048"/>
+            <a:ext cx="8229600" cy="256032"/>
+          </a:xfrm>
+          <a:prstGeom prst="rect">
+            <a:avLst/>
+          </a:prstGeom>
+          <a:noFill/>
+          <a:ln/>
+        </p:spPr>
+        <p:txBody>
+          <a:bodyPr wrap="square" lIns="0" tIns="0" rIns="0" bIns="0" rtlCol="0" anchor="ctr"/>
+          <a:lstStyle/>
+          <a:p>
+            <a:pPr indent="0" marL="0">
+              <a:buNone/>
+            </a:pPr>
+            <a:r>
+              <a:rPr lang="en-US" sz="1100" b="1" spc="200" kern="0" dirty="0">
+                <a:solidFill>
+                  <a:srgbClr val="F0A429"/>
+                </a:solidFill>
+                <a:latin typeface="Arial" pitchFamily="34" charset="0"/>
+                <a:ea typeface="Arial" pitchFamily="34" charset="-122"/>
+                <a:cs typeface="Arial" pitchFamily="34" charset="-120"/>
+              </a:rPr>
+              <a:t>STEP 5 · IMPORT A TOOL LIST</a:t>
+            </a:r>
+            <a:endParaRPr lang="en-US" sz="1100" dirty="0"/>
+          </a:p>
+        </p:txBody>
+      </p:sp>
+      <p:sp>
+        <p:nvSpPr>
+          <p:cNvPr id="3" name="Text 1"/>
+          <p:cNvSpPr/>
+          <p:nvPr/>
+        </p:nvSpPr>
+        <p:spPr>
+          <a:xfrm>
+            <a:off x="566928" y="694944"/>
+            <a:ext cx="11055096" cy="566928"/>
+          </a:xfrm>
+          <a:prstGeom prst="rect">
+            <a:avLst/>
+          </a:prstGeom>
+          <a:noFill/>
+          <a:ln/>
+        </p:spPr>
+        <p:txBody>
+          <a:bodyPr wrap="square" lIns="0" tIns="0" rIns="0" bIns="0" rtlCol="0" anchor="ctr"/>
+          <a:lstStyle/>
+          <a:p>
+            <a:pPr indent="0" marL="0">
+              <a:buNone/>
+            </a:pPr>
+            <a:r>
+              <a:rPr lang="en-US" sz="3200" b="1" dirty="0">
+                <a:solidFill>
+                  <a:srgbClr val="E6EDF3"/>
+                </a:solidFill>
+                <a:latin typeface="Arial" pitchFamily="34" charset="0"/>
+                <a:ea typeface="Arial" pitchFamily="34" charset="-122"/>
+                <a:cs typeface="Arial" pitchFamily="34" charset="-120"/>
+              </a:rPr>
+              <a:t>A supplier’s kit list in one go</a:t>
+            </a:r>
+            <a:endParaRPr lang="en-US" sz="3200" dirty="0"/>
+          </a:p>
+        </p:txBody>
+      </p:sp>
+      <p:sp>
+        <p:nvSpPr>
+          <p:cNvPr id="4" name="Shape 2"/>
+          <p:cNvSpPr/>
+          <p:nvPr/>
+        </p:nvSpPr>
+        <p:spPr>
+          <a:xfrm>
+            <a:off x="566928" y="1362456"/>
+            <a:ext cx="11055096" cy="420624"/>
+          </a:xfrm>
+          <a:prstGeom prst="roundRect">
+            <a:avLst>
+              <a:gd name="adj" fmla="val 13043"/>
+            </a:avLst>
+          </a:prstGeom>
+          <a:solidFill>
+            <a:srgbClr val="161B22"/>
+          </a:solidFill>
+          <a:ln w="12700">
+            <a:solidFill>
+              <a:srgbClr val="30363D"/>
+            </a:solidFill>
+            <a:prstDash val="solid"/>
+          </a:ln>
+        </p:spPr>
+        <p:txBody>
+          <a:bodyPr/>
+          <a:p/>
+        </p:txBody>
+      </p:sp>
+      <p:sp>
+        <p:nvSpPr>
+          <p:cNvPr id="5" name="Text 3"/>
+          <p:cNvSpPr/>
+          <p:nvPr/>
+        </p:nvSpPr>
+        <p:spPr>
+          <a:xfrm>
+            <a:off x="566928" y="1408176"/>
+            <a:ext cx="1228344" cy="329184"/>
+          </a:xfrm>
+          <a:prstGeom prst="rect">
+            <a:avLst/>
+          </a:prstGeom>
+          <a:noFill/>
+          <a:ln/>
+        </p:spPr>
+        <p:txBody>
+          <a:bodyPr wrap="square" lIns="0" tIns="0" rIns="0" bIns="0" rtlCol="0" anchor="ctr"/>
+          <a:lstStyle/>
+          <a:p>
+            <a:pPr algn="ctr" indent="0" marL="0">
+              <a:buNone/>
+            </a:pPr>
+            <a:r>
+              <a:rPr lang="en-US" sz="900" dirty="0">
+                <a:solidFill>
+                  <a:srgbClr val="9AA4AF"/>
+                </a:solidFill>
+                <a:latin typeface="Calibri" pitchFamily="34" charset="0"/>
+                <a:ea typeface="Calibri" pitchFamily="34" charset="-122"/>
+                <a:cs typeface="Calibri" pitchFamily="34" charset="-120"/>
+              </a:rPr>
+              <a:t>Project Info</a:t>
+            </a:r>
+            <a:endParaRPr lang="en-US" sz="900" dirty="0"/>
+          </a:p>
+        </p:txBody>
+      </p:sp>
+      <p:sp>
+        <p:nvSpPr>
+          <p:cNvPr id="6" name="Text 4"/>
+          <p:cNvSpPr/>
+          <p:nvPr/>
+        </p:nvSpPr>
+        <p:spPr>
+          <a:xfrm>
+            <a:off x="1795272" y="1408176"/>
+            <a:ext cx="1228344" cy="329184"/>
+          </a:xfrm>
+          <a:prstGeom prst="rect">
+            <a:avLst/>
+          </a:prstGeom>
+          <a:noFill/>
+          <a:ln/>
+        </p:spPr>
+        <p:txBody>
+          <a:bodyPr wrap="square" lIns="0" tIns="0" rIns="0" bIns="0" rtlCol="0" anchor="ctr"/>
+          <a:lstStyle/>
+          <a:p>
+            <a:pPr algn="ctr" indent="0" marL="0">
+              <a:buNone/>
+            </a:pPr>
+            <a:r>
+              <a:rPr lang="en-US" sz="900" dirty="0">
+                <a:solidFill>
+                  <a:srgbClr val="9AA4AF"/>
+                </a:solidFill>
+                <a:latin typeface="Calibri" pitchFamily="34" charset="0"/>
+                <a:ea typeface="Calibri" pitchFamily="34" charset="-122"/>
+                <a:cs typeface="Calibri" pitchFamily="34" charset="-120"/>
+              </a:rPr>
+              <a:t>Scope of Work</a:t>
+            </a:r>
+            <a:endParaRPr lang="en-US" sz="900" dirty="0"/>
+          </a:p>
+        </p:txBody>
+      </p:sp>
+      <p:sp>
+        <p:nvSpPr>
+          <p:cNvPr id="7" name="Text 5"/>
+          <p:cNvSpPr/>
+          <p:nvPr/>
+        </p:nvSpPr>
+        <p:spPr>
+          <a:xfrm>
+            <a:off x="3023616" y="1408176"/>
+            <a:ext cx="1228344" cy="329184"/>
+          </a:xfrm>
+          <a:prstGeom prst="rect">
+            <a:avLst/>
+          </a:prstGeom>
+          <a:noFill/>
+          <a:ln/>
+        </p:spPr>
+        <p:txBody>
+          <a:bodyPr wrap="square" lIns="0" tIns="0" rIns="0" bIns="0" rtlCol="0" anchor="ctr"/>
+          <a:lstStyle/>
+          <a:p>
+            <a:pPr algn="ctr" indent="0" marL="0">
+              <a:buNone/>
+            </a:pPr>
+            <a:r>
+              <a:rPr lang="en-US" sz="900" dirty="0">
+                <a:solidFill>
+                  <a:srgbClr val="9AA4AF"/>
+                </a:solidFill>
+                <a:latin typeface="Calibri" pitchFamily="34" charset="0"/>
+                <a:ea typeface="Calibri" pitchFamily="34" charset="-122"/>
+                <a:cs typeface="Calibri" pitchFamily="34" charset="-120"/>
+              </a:rPr>
+              <a:t>SOW Breakdown</a:t>
+            </a:r>
+            <a:endParaRPr lang="en-US" sz="900" dirty="0"/>
+          </a:p>
+        </p:txBody>
+      </p:sp>
+      <p:sp>
+        <p:nvSpPr>
+          <p:cNvPr id="8" name="Text 6"/>
+          <p:cNvSpPr/>
+          <p:nvPr/>
+        </p:nvSpPr>
+        <p:spPr>
+          <a:xfrm>
+            <a:off x="4251960" y="1408176"/>
+            <a:ext cx="1228344" cy="329184"/>
+          </a:xfrm>
+          <a:prstGeom prst="rect">
+            <a:avLst/>
+          </a:prstGeom>
+          <a:noFill/>
+          <a:ln/>
+        </p:spPr>
+        <p:txBody>
+          <a:bodyPr wrap="square" lIns="0" tIns="0" rIns="0" bIns="0" rtlCol="0" anchor="ctr"/>
+          <a:lstStyle/>
+          <a:p>
+            <a:pPr algn="ctr" indent="0" marL="0">
+              <a:buNone/>
+            </a:pPr>
+            <a:r>
+              <a:rPr lang="en-US" sz="900" dirty="0">
+                <a:solidFill>
+                  <a:srgbClr val="9AA4AF"/>
+                </a:solidFill>
+                <a:latin typeface="Calibri" pitchFamily="34" charset="0"/>
+                <a:ea typeface="Calibri" pitchFamily="34" charset="-122"/>
+                <a:cs typeface="Calibri" pitchFamily="34" charset="-120"/>
+              </a:rPr>
+              <a:t>Manpower</a:t>
+            </a:r>
+            <a:endParaRPr lang="en-US" sz="900" dirty="0"/>
+          </a:p>
+        </p:txBody>
+      </p:sp>
+      <p:sp>
+        <p:nvSpPr>
+          <p:cNvPr id="9" name="Shape 7"/>
+          <p:cNvSpPr/>
+          <p:nvPr/>
+        </p:nvSpPr>
+        <p:spPr>
+          <a:xfrm>
+            <a:off x="5507736" y="1408176"/>
+            <a:ext cx="1173480" cy="329184"/>
+          </a:xfrm>
+          <a:prstGeom prst="roundRect">
+            <a:avLst>
+              <a:gd name="adj" fmla="val 13889"/>
+            </a:avLst>
+          </a:prstGeom>
+          <a:solidFill>
+            <a:srgbClr val="F0A429"/>
+          </a:solidFill>
+          <a:ln w="12700">
+            <a:solidFill>
+              <a:srgbClr val="F0A429"/>
+            </a:solidFill>
+            <a:prstDash val="solid"/>
+          </a:ln>
+        </p:spPr>
+        <p:txBody>
+          <a:bodyPr/>
+          <a:p/>
+        </p:txBody>
+      </p:sp>
+      <p:sp>
+        <p:nvSpPr>
+          <p:cNvPr id="10" name="Text 8"/>
+          <p:cNvSpPr/>
+          <p:nvPr/>
+        </p:nvSpPr>
+        <p:spPr>
+          <a:xfrm>
+            <a:off x="5480304" y="1408176"/>
+            <a:ext cx="1228344" cy="329184"/>
+          </a:xfrm>
+          <a:prstGeom prst="rect">
+            <a:avLst/>
+          </a:prstGeom>
+          <a:noFill/>
+          <a:ln/>
+        </p:spPr>
+        <p:txBody>
+          <a:bodyPr wrap="square" lIns="0" tIns="0" rIns="0" bIns="0" rtlCol="0" anchor="ctr"/>
+          <a:lstStyle/>
+          <a:p>
+            <a:pPr algn="ctr" indent="0" marL="0">
+              <a:buNone/>
+            </a:pPr>
+            <a:r>
+              <a:rPr lang="en-US" sz="900" b="1" dirty="0">
+                <a:solidFill>
+                  <a:srgbClr val="000000"/>
+                </a:solidFill>
+                <a:latin typeface="Calibri" pitchFamily="34" charset="0"/>
+                <a:ea typeface="Calibri" pitchFamily="34" charset="-122"/>
+                <a:cs typeface="Calibri" pitchFamily="34" charset="-120"/>
+              </a:rPr>
+              <a:t>Tools</a:t>
+            </a:r>
+            <a:endParaRPr lang="en-US" sz="900" dirty="0"/>
+          </a:p>
+        </p:txBody>
+      </p:sp>
+      <p:sp>
+        <p:nvSpPr>
+          <p:cNvPr id="11" name="Text 9"/>
+          <p:cNvSpPr/>
+          <p:nvPr/>
+        </p:nvSpPr>
+        <p:spPr>
+          <a:xfrm>
+            <a:off x="6708648" y="1408176"/>
+            <a:ext cx="1228344" cy="329184"/>
+          </a:xfrm>
+          <a:prstGeom prst="rect">
+            <a:avLst/>
+          </a:prstGeom>
+          <a:noFill/>
+          <a:ln/>
+        </p:spPr>
+        <p:txBody>
+          <a:bodyPr wrap="square" lIns="0" tIns="0" rIns="0" bIns="0" rtlCol="0" anchor="ctr"/>
+          <a:lstStyle/>
+          <a:p>
+            <a:pPr algn="ctr" indent="0" marL="0">
+              <a:buNone/>
+            </a:pPr>
+            <a:r>
+              <a:rPr lang="en-US" sz="900" dirty="0">
+                <a:solidFill>
+                  <a:srgbClr val="9AA4AF"/>
+                </a:solidFill>
+                <a:latin typeface="Calibri" pitchFamily="34" charset="0"/>
+                <a:ea typeface="Calibri" pitchFamily="34" charset="-122"/>
+                <a:cs typeface="Calibri" pitchFamily="34" charset="-120"/>
+              </a:rPr>
+              <a:t>Materials</a:t>
+            </a:r>
+            <a:endParaRPr lang="en-US" sz="900" dirty="0"/>
+          </a:p>
+        </p:txBody>
+      </p:sp>
+      <p:sp>
+        <p:nvSpPr>
+          <p:cNvPr id="12" name="Text 10"/>
+          <p:cNvSpPr/>
+          <p:nvPr/>
+        </p:nvSpPr>
+        <p:spPr>
+          <a:xfrm>
+            <a:off x="7936992" y="1408176"/>
+            <a:ext cx="1228344" cy="329184"/>
+          </a:xfrm>
+          <a:prstGeom prst="rect">
+            <a:avLst/>
+          </a:prstGeom>
+          <a:noFill/>
+          <a:ln/>
+        </p:spPr>
+        <p:txBody>
+          <a:bodyPr wrap="square" lIns="0" tIns="0" rIns="0" bIns="0" rtlCol="0" anchor="ctr"/>
+          <a:lstStyle/>
+          <a:p>
+            <a:pPr algn="ctr" indent="0" marL="0">
+              <a:buNone/>
+            </a:pPr>
+            <a:r>
+              <a:rPr lang="en-US" sz="900" dirty="0">
+                <a:solidFill>
+                  <a:srgbClr val="9AA4AF"/>
+                </a:solidFill>
+                <a:latin typeface="Calibri" pitchFamily="34" charset="0"/>
+                <a:ea typeface="Calibri" pitchFamily="34" charset="-122"/>
+                <a:cs typeface="Calibri" pitchFamily="34" charset="-120"/>
+              </a:rPr>
+              <a:t>PPE</a:t>
+            </a:r>
+            <a:endParaRPr lang="en-US" sz="900" dirty="0"/>
+          </a:p>
+        </p:txBody>
+      </p:sp>
+      <p:sp>
+        <p:nvSpPr>
+          <p:cNvPr id="13" name="Text 11"/>
+          <p:cNvSpPr/>
+          <p:nvPr/>
+        </p:nvSpPr>
+        <p:spPr>
+          <a:xfrm>
+            <a:off x="9165336" y="1408176"/>
+            <a:ext cx="1228344" cy="329184"/>
+          </a:xfrm>
+          <a:prstGeom prst="rect">
+            <a:avLst/>
+          </a:prstGeom>
+          <a:noFill/>
+          <a:ln/>
+        </p:spPr>
+        <p:txBody>
+          <a:bodyPr wrap="square" lIns="0" tIns="0" rIns="0" bIns="0" rtlCol="0" anchor="ctr"/>
+          <a:lstStyle/>
+          <a:p>
+            <a:pPr algn="ctr" indent="0" marL="0">
+              <a:buNone/>
+            </a:pPr>
+            <a:r>
+              <a:rPr lang="en-US" sz="900" dirty="0">
+                <a:solidFill>
+                  <a:srgbClr val="9AA4AF"/>
+                </a:solidFill>
+                <a:latin typeface="Calibri" pitchFamily="34" charset="0"/>
+                <a:ea typeface="Calibri" pitchFamily="34" charset="-122"/>
+                <a:cs typeface="Calibri" pitchFamily="34" charset="-120"/>
+              </a:rPr>
+              <a:t>Misc.</a:t>
+            </a:r>
+            <a:endParaRPr lang="en-US" sz="900" dirty="0"/>
+          </a:p>
+        </p:txBody>
+      </p:sp>
+      <p:sp>
+        <p:nvSpPr>
+          <p:cNvPr id="14" name="Text 12"/>
+          <p:cNvSpPr/>
+          <p:nvPr/>
+        </p:nvSpPr>
+        <p:spPr>
+          <a:xfrm>
+            <a:off x="10393680" y="1408176"/>
+            <a:ext cx="1228344" cy="329184"/>
+          </a:xfrm>
+          <a:prstGeom prst="rect">
+            <a:avLst/>
+          </a:prstGeom>
+          <a:noFill/>
+          <a:ln/>
+        </p:spPr>
+        <p:txBody>
+          <a:bodyPr wrap="square" lIns="0" tIns="0" rIns="0" bIns="0" rtlCol="0" anchor="ctr"/>
+          <a:lstStyle/>
+          <a:p>
+            <a:pPr algn="ctr" indent="0" marL="0">
+              <a:buNone/>
+            </a:pPr>
+            <a:r>
+              <a:rPr lang="en-US" sz="900" dirty="0">
+                <a:solidFill>
+                  <a:srgbClr val="9AA4AF"/>
+                </a:solidFill>
+                <a:latin typeface="Calibri" pitchFamily="34" charset="0"/>
+                <a:ea typeface="Calibri" pitchFamily="34" charset="-122"/>
+                <a:cs typeface="Calibri" pitchFamily="34" charset="-120"/>
+              </a:rPr>
+              <a:t>Summary</a:t>
+            </a:r>
+            <a:endParaRPr lang="en-US" sz="900" dirty="0"/>
+          </a:p>
+        </p:txBody>
+      </p:sp>
+      <p:sp>
+        <p:nvSpPr>
+          <p:cNvPr id="15" name="Shape 13"/>
+          <p:cNvSpPr/>
+          <p:nvPr/>
+        </p:nvSpPr>
+        <p:spPr>
+          <a:xfrm>
+            <a:off x="566928" y="2002536"/>
+            <a:ext cx="3566160" cy="1463040"/>
+          </a:xfrm>
+          <a:prstGeom prst="roundRect">
+            <a:avLst>
+              <a:gd name="adj" fmla="val 5000"/>
+            </a:avLst>
+          </a:prstGeom>
+          <a:solidFill>
+            <a:srgbClr val="1C2128"/>
+          </a:solidFill>
+          <a:ln w="12700">
+            <a:solidFill>
+              <a:srgbClr val="30363D"/>
+            </a:solidFill>
+            <a:prstDash val="solid"/>
+          </a:ln>
+          <a:effectLst>
+            <a:outerShdw sx="100000" sy="100000" kx="0" ky="0" algn="bl" rotWithShape="0" blurRad="152400" dist="38100" dir="5400000">
+              <a:srgbClr val="000000">
+                <a:alpha val="45000"/>
+              </a:srgbClr>
+            </a:outerShdw>
+          </a:effectLst>
+        </p:spPr>
+        <p:txBody>
+          <a:bodyPr/>
+          <a:p/>
+        </p:txBody>
+      </p:sp>
+      <p:sp>
+        <p:nvSpPr>
+          <p:cNvPr id="16" name="Text 14"/>
+          <p:cNvSpPr/>
+          <p:nvPr/>
+        </p:nvSpPr>
+        <p:spPr>
+          <a:xfrm>
+            <a:off x="804672" y="2185416"/>
+            <a:ext cx="3108960" cy="310896"/>
+          </a:xfrm>
+          <a:prstGeom prst="rect">
+            <a:avLst/>
+          </a:prstGeom>
+          <a:noFill/>
+          <a:ln/>
+        </p:spPr>
+        <p:txBody>
+          <a:bodyPr wrap="square" lIns="0" tIns="0" rIns="0" bIns="0" rtlCol="0" anchor="ctr"/>
+          <a:lstStyle/>
+          <a:p>
+            <a:pPr indent="0" marL="0">
+              <a:buNone/>
+            </a:pPr>
+            <a:r>
+              <a:rPr lang="en-US" sz="1450" b="1" dirty="0">
+                <a:solidFill>
+                  <a:srgbClr val="F0A429"/>
+                </a:solidFill>
+                <a:latin typeface="Arial" pitchFamily="34" charset="0"/>
+                <a:ea typeface="Arial" pitchFamily="34" charset="-122"/>
+                <a:cs typeface="Arial" pitchFamily="34" charset="-120"/>
+              </a:rPr>
+              <a:t>⇪ Import list</a:t>
+            </a:r>
+            <a:endParaRPr lang="en-US" sz="1450" dirty="0"/>
+          </a:p>
+        </p:txBody>
+      </p:sp>
+      <p:sp>
+        <p:nvSpPr>
+          <p:cNvPr id="17" name="Text 15"/>
+          <p:cNvSpPr/>
+          <p:nvPr/>
+        </p:nvSpPr>
+        <p:spPr>
+          <a:xfrm>
+            <a:off x="804672" y="2542032"/>
+            <a:ext cx="3108960" cy="822960"/>
+          </a:xfrm>
+          <a:prstGeom prst="rect">
+            <a:avLst/>
+          </a:prstGeom>
+          <a:noFill/>
+          <a:ln/>
+        </p:spPr>
+        <p:txBody>
+          <a:bodyPr wrap="square" lIns="0" tIns="0" rIns="0" bIns="0" rtlCol="0" anchor="ctr"/>
+          <a:lstStyle/>
+          <a:p>
+            <a:pPr indent="0" marL="0">
+              <a:lnSpc>
+                <a:spcPts val="1500"/>
+              </a:lnSpc>
+              <a:buNone/>
+            </a:pPr>
+            <a:r>
+              <a:rPr lang="en-US" sz="1150" dirty="0">
+                <a:solidFill>
+                  <a:srgbClr val="9AA4AF"/>
+                </a:solidFill>
+                <a:latin typeface="Calibri" pitchFamily="34" charset="0"/>
+                <a:ea typeface="Calibri" pitchFamily="34" charset="-122"/>
+                <a:cs typeface="Calibri" pitchFamily="34" charset="-120"/>
+              </a:rPr>
+              <a:t>In the Tools &amp; Equipment toolbar. Takes a PDF kit report, an Excel or CSV list, or a Word or text file.</a:t>
+            </a:r>
+            <a:endParaRPr lang="en-US" sz="1150" dirty="0"/>
+          </a:p>
+        </p:txBody>
+      </p:sp>
+      <p:sp>
+        <p:nvSpPr>
+          <p:cNvPr id="18" name="Shape 16"/>
+          <p:cNvSpPr/>
+          <p:nvPr/>
+        </p:nvSpPr>
+        <p:spPr>
+          <a:xfrm>
+            <a:off x="4352544" y="2002536"/>
+            <a:ext cx="3566160" cy="1463040"/>
+          </a:xfrm>
+          <a:prstGeom prst="roundRect">
+            <a:avLst>
+              <a:gd name="adj" fmla="val 5000"/>
+            </a:avLst>
+          </a:prstGeom>
+          <a:solidFill>
+            <a:srgbClr val="1C2128"/>
+          </a:solidFill>
+          <a:ln w="12700">
+            <a:solidFill>
+              <a:srgbClr val="30363D"/>
+            </a:solidFill>
+            <a:prstDash val="solid"/>
+          </a:ln>
+          <a:effectLst>
+            <a:outerShdw sx="100000" sy="100000" kx="0" ky="0" algn="bl" rotWithShape="0" blurRad="152400" dist="38100" dir="5400000">
+              <a:srgbClr val="000000">
+                <a:alpha val="45000"/>
+              </a:srgbClr>
+            </a:outerShdw>
+          </a:effectLst>
+        </p:spPr>
+        <p:txBody>
+          <a:bodyPr/>
+          <a:p/>
+        </p:txBody>
+      </p:sp>
+      <p:sp>
+        <p:nvSpPr>
+          <p:cNvPr id="19" name="Text 17"/>
+          <p:cNvSpPr/>
+          <p:nvPr/>
+        </p:nvSpPr>
+        <p:spPr>
+          <a:xfrm>
+            <a:off x="4590288" y="2185416"/>
+            <a:ext cx="3108960" cy="310896"/>
+          </a:xfrm>
+          <a:prstGeom prst="rect">
+            <a:avLst/>
+          </a:prstGeom>
+          <a:noFill/>
+          <a:ln/>
+        </p:spPr>
+        <p:txBody>
+          <a:bodyPr wrap="square" lIns="0" tIns="0" rIns="0" bIns="0" rtlCol="0" anchor="ctr"/>
+          <a:lstStyle/>
+          <a:p>
+            <a:pPr indent="0" marL="0">
+              <a:buNone/>
+            </a:pPr>
+            <a:r>
+              <a:rPr lang="en-US" sz="1450" b="1" dirty="0">
+                <a:solidFill>
+                  <a:srgbClr val="58A6FF"/>
+                </a:solidFill>
+                <a:latin typeface="Arial" pitchFamily="34" charset="0"/>
+                <a:ea typeface="Arial" pitchFamily="34" charset="-122"/>
+                <a:cs typeface="Arial" pitchFamily="34" charset="-120"/>
+              </a:rPr>
+              <a:t>What it reads</a:t>
+            </a:r>
+            <a:endParaRPr lang="en-US" sz="1450" dirty="0"/>
+          </a:p>
+        </p:txBody>
+      </p:sp>
+      <p:sp>
+        <p:nvSpPr>
+          <p:cNvPr id="20" name="Text 18"/>
+          <p:cNvSpPr/>
+          <p:nvPr/>
+        </p:nvSpPr>
+        <p:spPr>
+          <a:xfrm>
+            <a:off x="4590288" y="2542032"/>
+            <a:ext cx="3108960" cy="822960"/>
+          </a:xfrm>
+          <a:prstGeom prst="rect">
+            <a:avLst/>
+          </a:prstGeom>
+          <a:noFill/>
+          <a:ln/>
+        </p:spPr>
+        <p:txBody>
+          <a:bodyPr wrap="square" lIns="0" tIns="0" rIns="0" bIns="0" rtlCol="0" anchor="ctr"/>
+          <a:lstStyle/>
+          <a:p>
+            <a:pPr indent="0" marL="0">
+              <a:lnSpc>
+                <a:spcPts val="1500"/>
+              </a:lnSpc>
+              <a:buNone/>
+            </a:pPr>
+            <a:r>
+              <a:rPr lang="en-US" sz="1150" dirty="0">
+                <a:solidFill>
+                  <a:srgbClr val="9AA4AF"/>
+                </a:solidFill>
+                <a:latin typeface="Calibri" pitchFamily="34" charset="0"/>
+                <a:ea typeface="Calibri" pitchFamily="34" charset="-122"/>
+                <a:cs typeface="Calibri" pitchFamily="34" charset="-120"/>
+              </a:rPr>
+              <a:t>Numbered lines (item, part no., qty, unit) or a table headed Description and Qty. Wrapped names and part numbers stay with their item.</a:t>
+            </a:r>
+            <a:endParaRPr lang="en-US" sz="1150" dirty="0"/>
+          </a:p>
+        </p:txBody>
+      </p:sp>
+      <p:sp>
+        <p:nvSpPr>
+          <p:cNvPr id="21" name="Shape 19"/>
+          <p:cNvSpPr/>
+          <p:nvPr/>
+        </p:nvSpPr>
+        <p:spPr>
+          <a:xfrm>
+            <a:off x="8138160" y="2002536"/>
+            <a:ext cx="3566160" cy="1463040"/>
+          </a:xfrm>
+          <a:prstGeom prst="roundRect">
+            <a:avLst>
+              <a:gd name="adj" fmla="val 5000"/>
+            </a:avLst>
+          </a:prstGeom>
+          <a:solidFill>
+            <a:srgbClr val="1C2128"/>
+          </a:solidFill>
+          <a:ln w="12700">
+            <a:solidFill>
+              <a:srgbClr val="30363D"/>
+            </a:solidFill>
+            <a:prstDash val="solid"/>
+          </a:ln>
+          <a:effectLst>
+            <a:outerShdw sx="100000" sy="100000" kx="0" ky="0" algn="bl" rotWithShape="0" blurRad="152400" dist="38100" dir="5400000">
+              <a:srgbClr val="000000">
+                <a:alpha val="45000"/>
+              </a:srgbClr>
+            </a:outerShdw>
+          </a:effectLst>
+        </p:spPr>
+        <p:txBody>
+          <a:bodyPr/>
+          <a:p/>
+        </p:txBody>
+      </p:sp>
+      <p:sp>
+        <p:nvSpPr>
+          <p:cNvPr id="22" name="Text 20"/>
+          <p:cNvSpPr/>
+          <p:nvPr/>
+        </p:nvSpPr>
+        <p:spPr>
+          <a:xfrm>
+            <a:off x="8375904" y="2185416"/>
+            <a:ext cx="3108960" cy="310896"/>
+          </a:xfrm>
+          <a:prstGeom prst="rect">
+            <a:avLst/>
+          </a:prstGeom>
+          <a:noFill/>
+          <a:ln/>
+        </p:spPr>
+        <p:txBody>
+          <a:bodyPr wrap="square" lIns="0" tIns="0" rIns="0" bIns="0" rtlCol="0" anchor="ctr"/>
+          <a:lstStyle/>
+          <a:p>
+            <a:pPr indent="0" marL="0">
+              <a:buNone/>
+            </a:pPr>
+            <a:r>
+              <a:rPr lang="en-US" sz="1450" b="1" dirty="0">
+                <a:solidFill>
+                  <a:srgbClr val="3FB950"/>
+                </a:solidFill>
+                <a:latin typeface="Arial" pitchFamily="34" charset="0"/>
+                <a:ea typeface="Arial" pitchFamily="34" charset="-122"/>
+                <a:cs typeface="Arial" pitchFamily="34" charset="-120"/>
+              </a:rPr>
+              <a:t>Check before it lands</a:t>
+            </a:r>
+            <a:endParaRPr lang="en-US" sz="1450" dirty="0"/>
+          </a:p>
+        </p:txBody>
+      </p:sp>
+      <p:sp>
+        <p:nvSpPr>
+          <p:cNvPr id="23" name="Text 21"/>
+          <p:cNvSpPr/>
+          <p:nvPr/>
+        </p:nvSpPr>
+        <p:spPr>
+          <a:xfrm>
+            <a:off x="8375904" y="2542032"/>
+            <a:ext cx="3108960" cy="822960"/>
+          </a:xfrm>
+          <a:prstGeom prst="rect">
+            <a:avLst/>
+          </a:prstGeom>
+          <a:noFill/>
+          <a:ln/>
+        </p:spPr>
+        <p:txBody>
+          <a:bodyPr wrap="square" lIns="0" tIns="0" rIns="0" bIns="0" rtlCol="0" anchor="ctr"/>
+          <a:lstStyle/>
+          <a:p>
+            <a:pPr indent="0" marL="0">
+              <a:lnSpc>
+                <a:spcPts val="1500"/>
+              </a:lnSpc>
+              <a:buNone/>
+            </a:pPr>
+            <a:r>
+              <a:rPr lang="en-US" sz="1150" dirty="0">
+                <a:solidFill>
+                  <a:srgbClr val="9AA4AF"/>
+                </a:solidFill>
+                <a:latin typeface="Calibri" pitchFamily="34" charset="0"/>
+                <a:ea typeface="Calibri" pitchFamily="34" charset="-122"/>
+                <a:cs typeface="Calibri" pitchFamily="34" charset="-120"/>
+              </a:rPr>
+              <a:t>A preview lists every item, all ticked. Untick what the job does not need, and fix a name or quantity before adding.</a:t>
+            </a:r>
+            <a:endParaRPr lang="en-US" sz="1150" dirty="0"/>
+          </a:p>
+        </p:txBody>
+      </p:sp>
+      <p:sp>
+        <p:nvSpPr>
+          <p:cNvPr id="24" name="Shape 22"/>
+          <p:cNvSpPr/>
+          <p:nvPr/>
+        </p:nvSpPr>
+        <p:spPr>
+          <a:xfrm>
+            <a:off x="566928" y="3648456"/>
+            <a:ext cx="5532120" cy="1042416"/>
+          </a:xfrm>
+          <a:prstGeom prst="roundRect">
+            <a:avLst>
+              <a:gd name="adj" fmla="val 7018"/>
+            </a:avLst>
+          </a:prstGeom>
+          <a:solidFill>
+            <a:srgbClr val="161B22"/>
+          </a:solidFill>
+          <a:ln w="12700">
+            <a:solidFill>
+              <a:srgbClr val="30363D"/>
+            </a:solidFill>
+            <a:prstDash val="solid"/>
+          </a:ln>
+          <a:effectLst>
+            <a:outerShdw sx="100000" sy="100000" kx="0" ky="0" algn="bl" rotWithShape="0" blurRad="152400" dist="38100" dir="5400000">
+              <a:srgbClr val="000000">
+                <a:alpha val="45000"/>
+              </a:srgbClr>
+            </a:outerShdw>
+          </a:effectLst>
+        </p:spPr>
+        <p:txBody>
+          <a:bodyPr/>
+          <a:p/>
+        </p:txBody>
+      </p:sp>
+      <p:sp>
+        <p:nvSpPr>
+          <p:cNvPr id="25" name="Text 23"/>
+          <p:cNvSpPr/>
+          <p:nvPr/>
+        </p:nvSpPr>
+        <p:spPr>
+          <a:xfrm>
+            <a:off x="804672" y="3767328"/>
+            <a:ext cx="5029200" cy="274320"/>
+          </a:xfrm>
+          <a:prstGeom prst="rect">
+            <a:avLst/>
+          </a:prstGeom>
+          <a:noFill/>
+          <a:ln/>
+        </p:spPr>
+        <p:txBody>
+          <a:bodyPr wrap="square" lIns="0" tIns="0" rIns="0" bIns="0" rtlCol="0" anchor="ctr"/>
+          <a:lstStyle/>
+          <a:p>
+            <a:pPr indent="0" marL="0">
+              <a:buNone/>
+            </a:pPr>
+            <a:r>
+              <a:rPr lang="en-US" sz="1350" b="1" dirty="0">
+                <a:solidFill>
+                  <a:srgbClr val="E6EDF3"/>
+                </a:solidFill>
+                <a:latin typeface="Arial" pitchFamily="34" charset="0"/>
+                <a:ea typeface="Arial" pitchFamily="34" charset="-122"/>
+                <a:cs typeface="Arial" pitchFamily="34" charset="-120"/>
+              </a:rPr>
+              <a:t>Priced from the Masterlist</a:t>
+            </a:r>
+            <a:endParaRPr lang="en-US" sz="1350" dirty="0"/>
+          </a:p>
+        </p:txBody>
+      </p:sp>
+      <p:sp>
+        <p:nvSpPr>
+          <p:cNvPr id="26" name="Text 24"/>
+          <p:cNvSpPr/>
+          <p:nvPr/>
+        </p:nvSpPr>
+        <p:spPr>
+          <a:xfrm>
+            <a:off x="804672" y="4069080"/>
+            <a:ext cx="5074920" cy="566928"/>
+          </a:xfrm>
+          <a:prstGeom prst="rect">
+            <a:avLst/>
+          </a:prstGeom>
+          <a:noFill/>
+          <a:ln/>
+        </p:spPr>
+        <p:txBody>
+          <a:bodyPr wrap="square" lIns="0" tIns="0" rIns="0" bIns="0" rtlCol="0" anchor="ctr"/>
+          <a:lstStyle/>
+          <a:p>
+            <a:pPr indent="0" marL="0">
+              <a:lnSpc>
+                <a:spcPts val="1400"/>
+              </a:lnSpc>
+              <a:buNone/>
+            </a:pPr>
+            <a:r>
+              <a:rPr lang="en-US" sz="1100" dirty="0">
+                <a:solidFill>
+                  <a:srgbClr val="9AA4AF"/>
+                </a:solidFill>
+                <a:latin typeface="Calibri" pitchFamily="34" charset="0"/>
+                <a:ea typeface="Calibri" pitchFamily="34" charset="-122"/>
+                <a:cs typeface="Calibri" pitchFamily="34" charset="-120"/>
+              </a:rPr>
+              <a:t>An item the Masterlist has comes in at its rate and unit. The preview shows which ones are on the list.</a:t>
+            </a:r>
+            <a:endParaRPr lang="en-US" sz="1100" dirty="0"/>
+          </a:p>
+        </p:txBody>
+      </p:sp>
+      <p:sp>
+        <p:nvSpPr>
+          <p:cNvPr id="27" name="Shape 25"/>
+          <p:cNvSpPr/>
+          <p:nvPr/>
+        </p:nvSpPr>
+        <p:spPr>
+          <a:xfrm>
+            <a:off x="6309360" y="3648456"/>
+            <a:ext cx="5532120" cy="1042416"/>
+          </a:xfrm>
+          <a:prstGeom prst="roundRect">
+            <a:avLst>
+              <a:gd name="adj" fmla="val 7018"/>
+            </a:avLst>
+          </a:prstGeom>
+          <a:solidFill>
+            <a:srgbClr val="161B22"/>
+          </a:solidFill>
+          <a:ln w="12700">
+            <a:solidFill>
+              <a:srgbClr val="30363D"/>
+            </a:solidFill>
+            <a:prstDash val="solid"/>
+          </a:ln>
+          <a:effectLst>
+            <a:outerShdw sx="100000" sy="100000" kx="0" ky="0" algn="bl" rotWithShape="0" blurRad="152400" dist="38100" dir="5400000">
+              <a:srgbClr val="000000">
+                <a:alpha val="45000"/>
+              </a:srgbClr>
+            </a:outerShdw>
+          </a:effectLst>
+        </p:spPr>
+        <p:txBody>
+          <a:bodyPr/>
+          <a:p/>
+        </p:txBody>
+      </p:sp>
+      <p:sp>
+        <p:nvSpPr>
+          <p:cNvPr id="28" name="Text 26"/>
+          <p:cNvSpPr/>
+          <p:nvPr/>
+        </p:nvSpPr>
+        <p:spPr>
+          <a:xfrm>
+            <a:off x="6547104" y="3767328"/>
+            <a:ext cx="5029200" cy="274320"/>
+          </a:xfrm>
+          <a:prstGeom prst="rect">
+            <a:avLst/>
+          </a:prstGeom>
+          <a:noFill/>
+          <a:ln/>
+        </p:spPr>
+        <p:txBody>
+          <a:bodyPr wrap="square" lIns="0" tIns="0" rIns="0" bIns="0" rtlCol="0" anchor="ctr"/>
+          <a:lstStyle/>
+          <a:p>
+            <a:pPr indent="0" marL="0">
+              <a:buNone/>
+            </a:pPr>
+            <a:r>
+              <a:rPr lang="en-US" sz="1350" b="1" dirty="0">
+                <a:solidFill>
+                  <a:srgbClr val="E6EDF3"/>
+                </a:solidFill>
+                <a:latin typeface="Arial" pitchFamily="34" charset="0"/>
+                <a:ea typeface="Arial" pitchFamily="34" charset="-122"/>
+                <a:cs typeface="Arial" pitchFamily="34" charset="-120"/>
+              </a:rPr>
+              <a:t>The rest come in at ₱0</a:t>
+            </a:r>
+            <a:endParaRPr lang="en-US" sz="1350" dirty="0"/>
+          </a:p>
+        </p:txBody>
+      </p:sp>
+      <p:sp>
+        <p:nvSpPr>
+          <p:cNvPr id="29" name="Text 27"/>
+          <p:cNvSpPr/>
+          <p:nvPr/>
+        </p:nvSpPr>
+        <p:spPr>
+          <a:xfrm>
+            <a:off x="6547104" y="4069080"/>
+            <a:ext cx="5074920" cy="566928"/>
+          </a:xfrm>
+          <a:prstGeom prst="rect">
+            <a:avLst/>
+          </a:prstGeom>
+          <a:noFill/>
+          <a:ln/>
+        </p:spPr>
+        <p:txBody>
+          <a:bodyPr wrap="square" lIns="0" tIns="0" rIns="0" bIns="0" rtlCol="0" anchor="ctr"/>
+          <a:lstStyle/>
+          <a:p>
+            <a:pPr indent="0" marL="0">
+              <a:lnSpc>
+                <a:spcPts val="1400"/>
+              </a:lnSpc>
+              <a:buNone/>
+            </a:pPr>
+            <a:r>
+              <a:rPr lang="en-US" sz="1100" dirty="0">
+                <a:solidFill>
+                  <a:srgbClr val="9AA4AF"/>
+                </a:solidFill>
+                <a:latin typeface="Calibri" pitchFamily="34" charset="0"/>
+                <a:ea typeface="Calibri" pitchFamily="34" charset="-122"/>
+                <a:cs typeface="Calibri" pitchFamily="34" charset="-120"/>
+              </a:rPr>
+              <a:t>The message after adding says how many need a rate. Type it on the row, or add the items with ＋ Masterlist.</a:t>
+            </a:r>
+            <a:endParaRPr lang="en-US" sz="1100" dirty="0"/>
+          </a:p>
+        </p:txBody>
+      </p:sp>
+      <p:sp>
+        <p:nvSpPr>
+          <p:cNvPr id="30" name="Shape 28"/>
+          <p:cNvSpPr/>
+          <p:nvPr/>
+        </p:nvSpPr>
+        <p:spPr>
+          <a:xfrm>
+            <a:off x="566928" y="4818888"/>
+            <a:ext cx="5532120" cy="1042416"/>
+          </a:xfrm>
+          <a:prstGeom prst="roundRect">
+            <a:avLst>
+              <a:gd name="adj" fmla="val 7018"/>
+            </a:avLst>
+          </a:prstGeom>
+          <a:solidFill>
+            <a:srgbClr val="161B22"/>
+          </a:solidFill>
+          <a:ln w="12700">
+            <a:solidFill>
+              <a:srgbClr val="30363D"/>
+            </a:solidFill>
+            <a:prstDash val="solid"/>
+          </a:ln>
+          <a:effectLst>
+            <a:outerShdw sx="100000" sy="100000" kx="0" ky="0" algn="bl" rotWithShape="0" blurRad="152400" dist="38100" dir="5400000">
+              <a:srgbClr val="000000">
+                <a:alpha val="45000"/>
+              </a:srgbClr>
+            </a:outerShdw>
+          </a:effectLst>
+        </p:spPr>
+        <p:txBody>
+          <a:bodyPr/>
+          <a:p/>
+        </p:txBody>
+      </p:sp>
+      <p:sp>
+        <p:nvSpPr>
+          <p:cNvPr id="31" name="Text 29"/>
+          <p:cNvSpPr/>
+          <p:nvPr/>
+        </p:nvSpPr>
+        <p:spPr>
+          <a:xfrm>
+            <a:off x="804672" y="4937760"/>
+            <a:ext cx="5029200" cy="274320"/>
+          </a:xfrm>
+          <a:prstGeom prst="rect">
+            <a:avLst/>
+          </a:prstGeom>
+          <a:noFill/>
+          <a:ln/>
+        </p:spPr>
+        <p:txBody>
+          <a:bodyPr wrap="square" lIns="0" tIns="0" rIns="0" bIns="0" rtlCol="0" anchor="ctr"/>
+          <a:lstStyle/>
+          <a:p>
+            <a:pPr indent="0" marL="0">
+              <a:buNone/>
+            </a:pPr>
+            <a:r>
+              <a:rPr lang="en-US" sz="1350" b="1" dirty="0">
+                <a:solidFill>
+                  <a:srgbClr val="E6EDF3"/>
+                </a:solidFill>
+                <a:latin typeface="Arial" pitchFamily="34" charset="0"/>
+                <a:ea typeface="Arial" pitchFamily="34" charset="-122"/>
+                <a:cs typeface="Arial" pitchFamily="34" charset="-120"/>
+              </a:rPr>
+              <a:t>Repeats are added up</a:t>
+            </a:r>
+            <a:endParaRPr lang="en-US" sz="1350" dirty="0"/>
+          </a:p>
+        </p:txBody>
+      </p:sp>
+      <p:sp>
+        <p:nvSpPr>
+          <p:cNvPr id="32" name="Text 30"/>
+          <p:cNvSpPr/>
+          <p:nvPr/>
+        </p:nvSpPr>
+        <p:spPr>
+          <a:xfrm>
+            <a:off x="804672" y="5239512"/>
+            <a:ext cx="5074920" cy="566928"/>
+          </a:xfrm>
+          <a:prstGeom prst="rect">
+            <a:avLst/>
+          </a:prstGeom>
+          <a:noFill/>
+          <a:ln/>
+        </p:spPr>
+        <p:txBody>
+          <a:bodyPr wrap="square" lIns="0" tIns="0" rIns="0" bIns="0" rtlCol="0" anchor="ctr"/>
+          <a:lstStyle/>
+          <a:p>
+            <a:pPr indent="0" marL="0">
+              <a:lnSpc>
+                <a:spcPts val="1400"/>
+              </a:lnSpc>
+              <a:buNone/>
+            </a:pPr>
+            <a:r>
+              <a:rPr lang="en-US" sz="1100" dirty="0">
+                <a:solidFill>
+                  <a:srgbClr val="9AA4AF"/>
+                </a:solidFill>
+                <a:latin typeface="Calibri" pitchFamily="34" charset="0"/>
+                <a:ea typeface="Calibri" pitchFamily="34" charset="-122"/>
+                <a:cs typeface="Calibri" pitchFamily="34" charset="-120"/>
+              </a:rPr>
+              <a:t>The same item listed twice becomes one row with both quantities. Page headers and comments are left out.</a:t>
+            </a:r>
+            <a:endParaRPr lang="en-US" sz="1100" dirty="0"/>
+          </a:p>
+        </p:txBody>
+      </p:sp>
+      <p:sp>
+        <p:nvSpPr>
+          <p:cNvPr id="33" name="Shape 31"/>
+          <p:cNvSpPr/>
+          <p:nvPr/>
+        </p:nvSpPr>
+        <p:spPr>
+          <a:xfrm>
+            <a:off x="6309360" y="4818888"/>
+            <a:ext cx="5532120" cy="1042416"/>
+          </a:xfrm>
+          <a:prstGeom prst="roundRect">
+            <a:avLst>
+              <a:gd name="adj" fmla="val 7018"/>
+            </a:avLst>
+          </a:prstGeom>
+          <a:solidFill>
+            <a:srgbClr val="161B22"/>
+          </a:solidFill>
+          <a:ln w="12700">
+            <a:solidFill>
+              <a:srgbClr val="30363D"/>
+            </a:solidFill>
+            <a:prstDash val="solid"/>
+          </a:ln>
+          <a:effectLst>
+            <a:outerShdw sx="100000" sy="100000" kx="0" ky="0" algn="bl" rotWithShape="0" blurRad="152400" dist="38100" dir="5400000">
+              <a:srgbClr val="000000">
+                <a:alpha val="45000"/>
+              </a:srgbClr>
+            </a:outerShdw>
+          </a:effectLst>
+        </p:spPr>
+        <p:txBody>
+          <a:bodyPr/>
+          <a:p/>
+        </p:txBody>
+      </p:sp>
+      <p:sp>
+        <p:nvSpPr>
+          <p:cNvPr id="34" name="Text 32"/>
+          <p:cNvSpPr/>
+          <p:nvPr/>
+        </p:nvSpPr>
+        <p:spPr>
+          <a:xfrm>
+            <a:off x="6547104" y="4937760"/>
+            <a:ext cx="5029200" cy="274320"/>
+          </a:xfrm>
+          <a:prstGeom prst="rect">
+            <a:avLst/>
+          </a:prstGeom>
+          <a:noFill/>
+          <a:ln/>
+        </p:spPr>
+        <p:txBody>
+          <a:bodyPr wrap="square" lIns="0" tIns="0" rIns="0" bIns="0" rtlCol="0" anchor="ctr"/>
+          <a:lstStyle/>
+          <a:p>
+            <a:pPr indent="0" marL="0">
+              <a:buNone/>
+            </a:pPr>
+            <a:r>
+              <a:rPr lang="en-US" sz="1350" b="1" dirty="0">
+                <a:solidFill>
+                  <a:srgbClr val="E6EDF3"/>
+                </a:solidFill>
+                <a:latin typeface="Arial" pitchFamily="34" charset="0"/>
+                <a:ea typeface="Arial" pitchFamily="34" charset="-122"/>
+                <a:cs typeface="Arial" pitchFamily="34" charset="-120"/>
+              </a:rPr>
+              <a:t>Check the tier first</a:t>
+            </a:r>
+            <a:endParaRPr lang="en-US" sz="1350" dirty="0"/>
+          </a:p>
+        </p:txBody>
+      </p:sp>
+      <p:sp>
+        <p:nvSpPr>
+          <p:cNvPr id="35" name="Text 33"/>
+          <p:cNvSpPr/>
+          <p:nvPr/>
+        </p:nvSpPr>
+        <p:spPr>
+          <a:xfrm>
+            <a:off x="6547104" y="5239512"/>
+            <a:ext cx="5074920" cy="566928"/>
+          </a:xfrm>
+          <a:prstGeom prst="rect">
+            <a:avLst/>
+          </a:prstGeom>
+          <a:noFill/>
+          <a:ln/>
+        </p:spPr>
+        <p:txBody>
+          <a:bodyPr wrap="square" lIns="0" tIns="0" rIns="0" bIns="0" rtlCol="0" anchor="ctr"/>
+          <a:lstStyle/>
+          <a:p>
+            <a:pPr indent="0" marL="0">
+              <a:lnSpc>
+                <a:spcPts val="1400"/>
+              </a:lnSpc>
+              <a:buNone/>
+            </a:pPr>
+            <a:r>
+              <a:rPr lang="en-US" sz="1100" dirty="0">
+                <a:solidFill>
+                  <a:srgbClr val="9AA4AF"/>
+                </a:solidFill>
+                <a:latin typeface="Calibri" pitchFamily="34" charset="0"/>
+                <a:ea typeface="Calibri" pitchFamily="34" charset="-122"/>
+                <a:cs typeface="Calibri" pitchFamily="34" charset="-120"/>
+              </a:rPr>
+              <a:t>Imported rows start on the tier set in New rows. A 42-page kit list is about 320 rows, so set it before you import.</a:t>
+            </a:r>
+            <a:endParaRPr lang="en-US" sz="1100" dirty="0"/>
+          </a:p>
+        </p:txBody>
+      </p:sp>
+      <p:sp>
+        <p:nvSpPr>
+          <p:cNvPr id="36" name="Text 34"/>
+          <p:cNvSpPr/>
+          <p:nvPr/>
+        </p:nvSpPr>
+        <p:spPr>
+          <a:xfrm>
+            <a:off x="566928" y="6437376"/>
+            <a:ext cx="5486400" cy="237744"/>
+          </a:xfrm>
+          <a:prstGeom prst="rect">
+            <a:avLst/>
+          </a:prstGeom>
+          <a:noFill/>
+          <a:ln/>
+        </p:spPr>
+        <p:txBody>
+          <a:bodyPr wrap="square" lIns="0" tIns="0" rIns="0" bIns="0" rtlCol="0" anchor="ctr"/>
+          <a:lstStyle/>
+          <a:p>
+            <a:pPr indent="0" marL="0">
+              <a:buNone/>
+            </a:pPr>
+            <a:r>
+              <a:rPr lang="en-US" sz="900" dirty="0">
+                <a:solidFill>
+                  <a:srgbClr val="6E7681"/>
+                </a:solidFill>
+                <a:latin typeface="Calibri" pitchFamily="34" charset="0"/>
+                <a:ea typeface="Calibri" pitchFamily="34" charset="-122"/>
+                <a:cs typeface="Calibri" pitchFamily="34" charset="-120"/>
+              </a:rPr>
+              <a:t>SHIC Cost Estimator — End-User Manual</a:t>
+            </a:r>
+            <a:endParaRPr lang="en-US" sz="900" dirty="0"/>
+          </a:p>
+        </p:txBody>
+      </p:sp>
+      <p:sp>
+        <p:nvSpPr>
+          <p:cNvPr id="37" name="Text 35"/>
+          <p:cNvSpPr/>
+          <p:nvPr/>
+        </p:nvSpPr>
+        <p:spPr>
+          <a:xfrm>
+            <a:off x="10981944" y="6437376"/>
+            <a:ext cx="640080" cy="237744"/>
+          </a:xfrm>
+          <a:prstGeom prst="rect">
+            <a:avLst/>
+          </a:prstGeom>
+          <a:noFill/>
+          <a:ln/>
+        </p:spPr>
+        <p:txBody>
+          <a:bodyPr wrap="square" lIns="0" tIns="0" rIns="0" bIns="0" rtlCol="0" anchor="ctr"/>
+          <a:lstStyle/>
+          <a:p>
+            <a:pPr algn="r" indent="0" marL="0">
+              <a:buNone/>
+            </a:pPr>
+            <a:r>
+              <a:rPr lang="en-US" sz="900" dirty="0">
+                <a:solidFill>
+                  <a:srgbClr val="6E7681"/>
+                </a:solidFill>
+                <a:latin typeface="Calibri" pitchFamily="34" charset="0"/>
+                <a:ea typeface="Calibri" pitchFamily="34" charset="-122"/>
+                <a:cs typeface="Calibri" pitchFamily="34" charset="-120"/>
+              </a:rPr>
+              <a:t>19</a:t>
             </a:r>
             <a:endParaRPr lang="en-US" sz="900" dirty="0"/>
           </a:p>
@@ -38710,7 +41580,7 @@
                 <a:ea typeface="Calibri" pitchFamily="34" charset="-122"/>
                 <a:cs typeface="Calibri" pitchFamily="34" charset="-120"/>
               </a:rPr>
-              <a:t>Rows not linked to a step appear in an amber panel below. Tick several and file them at once. Descriptions pick from the Masterlist, rate and unit included.</a:t>
+              <a:t>Rows not linked to a step appear in an amber panel below, manpower grouped by shift. Tick a whole shift, or file it to a task in one pick.</a:t>
             </a:r>
             <a:endParaRPr lang="en-US" sz="1100" dirty="0"/>
           </a:p>

</xml_diff>

<commit_message>
Manual: builds 245-247 -- Awarded status and Won, RCE No. on requests, Monitoring and the printed CE, Quantity unit, SIL and ECC as separate columns
Co-Authored-By: Claude Opus 5 <noreply@anthropic.com>
</commit_message>
<xml_diff>
--- a/docs/SHIC-Cost-Estimator-User-Manual.pptx
+++ b/docs/SHIC-Cost-Estimator-User-Manual.pptx
@@ -5881,7 +5881,7 @@
                 <a:ea typeface="Calibri" pitchFamily="34" charset="-122"/>
                 <a:cs typeface="Calibri" pitchFamily="34" charset="-120"/>
               </a:rPr>
-              <a:t>ECC is ₱30 per person per month (26 working days, rounded up), shared across the role’s shifts — hover SIL &amp; ECC to see it. Older CEs keep ₱30 per shift line</a:t>
+              <a:t>ECC is ₱30 per person per month (26 working days, rounded up), shared across the role’s shifts — shown in its own ECC column. Older CEs keep ₱30 per shift line</a:t>
             </a:r>
             <a:endParaRPr lang="en-US" sz="1200" dirty="0"/>
           </a:p>
@@ -23873,7 +23873,7 @@
                 <a:ea typeface="Calibri" pitchFamily="34" charset="-122"/>
                 <a:cs typeface="Calibri" pitchFamily="34" charset="-120"/>
               </a:rPr>
-              <a:t>Search matches CE number, customer and job title — filter by Discipline and by Customer beside it</a:t>
+              <a:t>Search matches CE and RCE number, customer and job title — filter by Discipline and by Customer beside it</a:t>
             </a:r>
             <a:endParaRPr lang="en-US" sz="1200" dirty="0"/>
           </a:p>
@@ -23897,7 +23897,7 @@
                 <a:ea typeface="Calibri" pitchFamily="34" charset="-122"/>
                 <a:cs typeface="Calibri" pitchFamily="34" charset="-120"/>
               </a:rPr>
-              <a:t>Open work means work still in play: Approved, Submitted, No Quote and Cancelled count as closed, not open</a:t>
+              <a:t>Open work means work still in play: Approved, Submitted, Awarded, No Quote and Cancelled count as closed, not open</a:t>
             </a:r>
             <a:endParaRPr lang="en-US" sz="1200" dirty="0"/>
           </a:p>
@@ -24510,7 +24510,7 @@
                 <a:ea typeface="Calibri" pitchFamily="34" charset="-122"/>
                 <a:cs typeface="Calibri" pitchFamily="34" charset="-120"/>
               </a:rPr>
-              <a:t>Customer and Assigned to are required; add type, discipline, job title, date received, deadline and remarks</a:t>
+              <a:t>Customer and Assigned to are required; add RCE No., type, discipline, job title, dates and remarks</a:t>
             </a:r>
             <a:endParaRPr lang="en-US" sz="1200" dirty="0"/>
           </a:p>
@@ -34598,7 +34598,7 @@
                 <a:ea typeface="Calibri" pitchFamily="34" charset="-122"/>
                 <a:cs typeface="Calibri" pitchFamily="34" charset="-120"/>
               </a:rPr>
-              <a:t>Submitted this month, with value · On-time rate (red under 80%) · Won this year</a:t>
+              <a:t>Submitted this month, with value · On-time rate (red under 80%) · Won this year (Awarded)</a:t>
             </a:r>
             <a:endParaRPr lang="en-US" sz="1200" dirty="0"/>
           </a:p>
@@ -37108,7 +37108,7 @@
                 <a:ea typeface="Calibri" pitchFamily="34" charset="-122"/>
                 <a:cs typeface="Calibri" pitchFamily="34" charset="-120"/>
               </a:rPr>
-              <a:t>Divides the total into a unit price. Leave it at 1 for a one-off job.</a:t>
+              <a:t>Divides the total into a unit price. Pick its unit: 3 PCS, 1 LOT.</a:t>
             </a:r>
             <a:endParaRPr lang="en-US" sz="1050" dirty="0"/>
           </a:p>
@@ -37340,7 +37340,7 @@
                 <a:ea typeface="Calibri" pitchFamily="34" charset="-122"/>
                 <a:cs typeface="Calibri" pitchFamily="34" charset="-120"/>
               </a:rPr>
-              <a:t>Appear on the printed form.</a:t>
+              <a:t>Appear on the printed form, with the RCE No.</a:t>
             </a:r>
             <a:endParaRPr lang="en-US" sz="1050" dirty="0"/>
           </a:p>

</xml_diff>